<commit_message>
Correct confidence-drift evaluation and align report and slides
</commit_message>
<xml_diff>
--- a/reports/presentation/AI_Confidence_Drift_Presentation.pptx
+++ b/reports/presentation/AI_Confidence_Drift_Presentation.pptx
@@ -2,26 +2,26 @@
 <file path=ppt/presentation.xml><?xml version="1.0" encoding="utf-8"?>
 <p:presentation xmlns:p="http://schemas.openxmlformats.org/presentationml/2006/main">
   <p:sldMasterIdLst>
-    <p:sldMasterId xmlns:r="http://schemas.openxmlformats.org/officeDocument/2006/relationships" id="2147483648" r:id="R0523f2e52c84414c"/>
+    <p:sldMasterId xmlns:r="http://schemas.openxmlformats.org/officeDocument/2006/relationships" id="2147483648" r:id="R8c0759fa6cca425c"/>
   </p:sldMasterIdLst>
   <p:notesMasterIdLst>
-    <p:notesMasterId xmlns:r="http://schemas.openxmlformats.org/officeDocument/2006/relationships" r:id="R7c5e36c103054589"/>
+    <p:notesMasterId xmlns:r="http://schemas.openxmlformats.org/officeDocument/2006/relationships" r:id="R380d611db4b7492c"/>
   </p:notesMasterIdLst>
   <p:sldIdLst>
-    <p:sldId xmlns:r="http://schemas.openxmlformats.org/officeDocument/2006/relationships" id="256" r:id="R6eb25d2ed83a4f11"/>
-    <p:sldId xmlns:r="http://schemas.openxmlformats.org/officeDocument/2006/relationships" id="257" r:id="R3ddb7d41a15c44d4"/>
-    <p:sldId xmlns:r="http://schemas.openxmlformats.org/officeDocument/2006/relationships" id="258" r:id="R553d9894ffef4e55"/>
-    <p:sldId xmlns:r="http://schemas.openxmlformats.org/officeDocument/2006/relationships" id="259" r:id="R90b7df28322a4219"/>
-    <p:sldId xmlns:r="http://schemas.openxmlformats.org/officeDocument/2006/relationships" id="260" r:id="Rc2dae8ce7c9643da"/>
-    <p:sldId xmlns:r="http://schemas.openxmlformats.org/officeDocument/2006/relationships" id="261" r:id="R30b4e1cd62d64853"/>
-    <p:sldId xmlns:r="http://schemas.openxmlformats.org/officeDocument/2006/relationships" id="262" r:id="Ree8c5f48861046fa"/>
-    <p:sldId xmlns:r="http://schemas.openxmlformats.org/officeDocument/2006/relationships" id="263" r:id="R0d3c62aaf4044973"/>
-    <p:sldId xmlns:r="http://schemas.openxmlformats.org/officeDocument/2006/relationships" id="264" r:id="R9aece14b28fd44f6"/>
-    <p:sldId xmlns:r="http://schemas.openxmlformats.org/officeDocument/2006/relationships" id="265" r:id="R4eba29c6b8984b04"/>
-    <p:sldId xmlns:r="http://schemas.openxmlformats.org/officeDocument/2006/relationships" id="266" r:id="R3d026f4e38174c9c"/>
-    <p:sldId xmlns:r="http://schemas.openxmlformats.org/officeDocument/2006/relationships" id="267" r:id="Rd20a0bffd0b445c3"/>
-    <p:sldId xmlns:r="http://schemas.openxmlformats.org/officeDocument/2006/relationships" id="268" r:id="R0b5fba8de551464f"/>
-    <p:sldId xmlns:r="http://schemas.openxmlformats.org/officeDocument/2006/relationships" id="269" r:id="R92f88d2f0cce4ffa"/>
+    <p:sldId xmlns:r="http://schemas.openxmlformats.org/officeDocument/2006/relationships" id="256" r:id="R8a88dd05a94c48a9"/>
+    <p:sldId xmlns:r="http://schemas.openxmlformats.org/officeDocument/2006/relationships" id="257" r:id="Re0c7a9c0b1ba4af0"/>
+    <p:sldId xmlns:r="http://schemas.openxmlformats.org/officeDocument/2006/relationships" id="258" r:id="Re63a6fdabbf444f8"/>
+    <p:sldId xmlns:r="http://schemas.openxmlformats.org/officeDocument/2006/relationships" id="259" r:id="Rcfd9062434bb4efb"/>
+    <p:sldId xmlns:r="http://schemas.openxmlformats.org/officeDocument/2006/relationships" id="260" r:id="R9c790271b1a5484d"/>
+    <p:sldId xmlns:r="http://schemas.openxmlformats.org/officeDocument/2006/relationships" id="261" r:id="R3e2c502b38d14506"/>
+    <p:sldId xmlns:r="http://schemas.openxmlformats.org/officeDocument/2006/relationships" id="262" r:id="Re9d9173f68aa448c"/>
+    <p:sldId xmlns:r="http://schemas.openxmlformats.org/officeDocument/2006/relationships" id="263" r:id="R905d685c4d3a48d6"/>
+    <p:sldId xmlns:r="http://schemas.openxmlformats.org/officeDocument/2006/relationships" id="264" r:id="R4d597cdb46214aff"/>
+    <p:sldId xmlns:r="http://schemas.openxmlformats.org/officeDocument/2006/relationships" id="265" r:id="R39135f3090dd4c48"/>
+    <p:sldId xmlns:r="http://schemas.openxmlformats.org/officeDocument/2006/relationships" id="266" r:id="R0b6355e4948a42e7"/>
+    <p:sldId xmlns:r="http://schemas.openxmlformats.org/officeDocument/2006/relationships" id="267" r:id="R16d12e88f3044fcf"/>
+    <p:sldId xmlns:r="http://schemas.openxmlformats.org/officeDocument/2006/relationships" id="268" r:id="R309190ea914f4aae"/>
+    <p:sldId xmlns:r="http://schemas.openxmlformats.org/officeDocument/2006/relationships" id="269" r:id="Rcb84f6e7d1dc48e4"/>
   </p:sldIdLst>
   <p:sldSz cx="12192000" cy="6858000"/>
   <p:notesSz cx="6858000" cy="9144000"/>
@@ -455,57 +455,7 @@
           <a:lstStyle xmlns:a="http://schemas.openxmlformats.org/drawingml/2006/main"/>
           <a:p xmlns:a="http://schemas.openxmlformats.org/drawingml/2006/main">
             <a:r>
-              <a:t>Source: AI_Confidence_Drift_Presentation.pptx, slide 1.</a:t>
-            </a:r>
-          </a:p>
-          <a:p xmlns:a="http://schemas.openxmlformats.org/drawingml/2006/main">
-            <a:r>
-              <a:t/>
-            </a:r>
-          </a:p>
-          <a:p xmlns:a="http://schemas.openxmlformats.org/drawingml/2006/main">
-            <a:r>
-              <a:t>PranavX Labs  |  AI/ML Internship  |  15-Day Research Project</a:t>
-            </a:r>
-          </a:p>
-          <a:p xmlns:a="http://schemas.openxmlformats.org/drawingml/2006/main">
-            <a:r>
-              <a:t>AI Confidence Drift Detection</a:t>
-            </a:r>
-          </a:p>
-          <a:p xmlns:a="http://schemas.openxmlformats.org/drawingml/2006/main">
-            <a:r>
-              <a:t>Using Machine Learning</a:t>
-            </a:r>
-          </a:p>
-          <a:p xmlns:a="http://schemas.openxmlformats.org/drawingml/2006/main">
-            <a:r>
-              <a:t>A study of whether changes in a model’s confidence, tracked across repeated predictions, can help identify unreliable predictions.</a:t>
-            </a:r>
-          </a:p>
-          <a:p xmlns:a="http://schemas.openxmlformats.org/drawingml/2006/main">
-            <a:r>
-              <a:t>Prepared </a:t>
-            </a:r>
-          </a:p>
-          <a:p xmlns:a="http://schemas.openxmlformats.org/drawingml/2006/main">
-            <a:r>
-              <a:t>by Ahan</a:t>
-            </a:r>
-          </a:p>
-          <a:p xmlns:a="http://schemas.openxmlformats.org/drawingml/2006/main">
-            <a:r>
-              <a:t>github.com/ahansardar/ai-confidence-drift</a:t>
-            </a:r>
-          </a:p>
-          <a:p xmlns:a="http://schemas.openxmlformats.org/drawingml/2006/main">
-            <a:r>
-              <a:t/>
-            </a:r>
-          </a:p>
-          <a:p xmlns:a="http://schemas.openxmlformats.org/drawingml/2006/main">
-            <a:r>
-              <a:t>1</a:t>
+              <a:t>Source: reports/RESEARCH_REPORT.md and results/metrics in the accompanying project repository. The figures describe the corrected, document-grouped evaluation.</a:t>
             </a:r>
           </a:p>
         </p:txBody>
@@ -575,52 +525,7 @@
           <a:lstStyle xmlns:a="http://schemas.openxmlformats.org/drawingml/2006/main"/>
           <a:p xmlns:a="http://schemas.openxmlformats.org/drawingml/2006/main">
             <a:r>
-              <a:t>Source: AI_Confidence_Drift_Presentation.pptx, slide 10.</a:t>
-            </a:r>
-          </a:p>
-          <a:p xmlns:a="http://schemas.openxmlformats.org/drawingml/2006/main">
-            <a:r>
-              <a:t/>
-            </a:r>
-          </a:p>
-          <a:p xmlns:a="http://schemas.openxmlformats.org/drawingml/2006/main">
-            <a:r>
-              <a:t>HIGH-CONFIDENCE ERROR ANALYSIS</a:t>
-            </a:r>
-          </a:p>
-          <a:p xmlns:a="http://schemas.openxmlformats.org/drawingml/2006/main">
-            <a:r>
-              <a:t>When the model is confident, and wrong</a:t>
-            </a:r>
-          </a:p>
-          <a:p xmlns:a="http://schemas.openxmlformats.org/drawingml/2006/main">
-            <a:r>
-              <a:t>100 of 439 step-0 predictions (22.8%) were high confidence, 75% or above.</a:t>
-            </a:r>
-          </a:p>
-          <a:p xmlns:a="http://schemas.openxmlformats.org/drawingml/2006/main">
-            <a:r>
-              <a:t>6 of those 100 (6.0%) were still wrong.</a:t>
-            </a:r>
-          </a:p>
-          <a:p xmlns:a="http://schemas.openxmlformats.org/drawingml/2006/main">
-            <a:r>
-              <a:t>One case: the model was 96.3% confident and completely wrong (doc_00750).</a:t>
-            </a:r>
-          </a:p>
-          <a:p xmlns:a="http://schemas.openxmlformats.org/drawingml/2006/main">
-            <a:r>
-              <a:t>All 6 high-confidence errors went the same direction: true label alt.atheism, predicted soc.religion.christian. My guess is that these posts quote Christian scripture while arguing against it, and a TF-IDF/bigram model cannot tell that apart from someone writing as a believer. A reasonable explanation from what I can see, not something I have proven.</a:t>
-            </a:r>
-          </a:p>
-          <a:p xmlns:a="http://schemas.openxmlformats.org/drawingml/2006/main">
-            <a:r>
-              <a:t/>
-            </a:r>
-          </a:p>
-          <a:p xmlns:a="http://schemas.openxmlformats.org/drawingml/2006/main">
-            <a:r>
-              <a:t>10</a:t>
+              <a:t>Source: reports/RESEARCH_REPORT.md and results/metrics in the accompanying project repository. The figures describe the corrected, document-grouped evaluation.</a:t>
             </a:r>
           </a:p>
         </p:txBody>
@@ -690,147 +595,7 @@
           <a:lstStyle xmlns:a="http://schemas.openxmlformats.org/drawingml/2006/main"/>
           <a:p xmlns:a="http://schemas.openxmlformats.org/drawingml/2006/main">
             <a:r>
-              <a:t>Source: AI_Confidence_Drift_Presentation.pptx, slide 11.</a:t>
-            </a:r>
-          </a:p>
-          <a:p xmlns:a="http://schemas.openxmlformats.org/drawingml/2006/main">
-            <a:r>
-              <a:t/>
-            </a:r>
-          </a:p>
-          <a:p xmlns:a="http://schemas.openxmlformats.org/drawingml/2006/main">
-            <a:r>
-              <a:t>EXPERIMENTS A / B / C</a:t>
-            </a:r>
-          </a:p>
-          <a:p xmlns:a="http://schemas.openxmlformats.org/drawingml/2006/main">
-            <a:r>
-              <a:t>Does confidence drift actually help?</a:t>
-            </a:r>
-          </a:p>
-          <a:p xmlns:a="http://schemas.openxmlformats.org/drawingml/2006/main">
-            <a:r>
-              <a:t>Same document-level train/test split throughout. Task: predict whether a prediction is unreliable.</a:t>
-            </a:r>
-          </a:p>
-          <a:p xmlns:a="http://schemas.openxmlformats.org/drawingml/2006/main">
-            <a:r>
-              <a:t>Experiment</a:t>
-            </a:r>
-          </a:p>
-          <a:p xmlns:a="http://schemas.openxmlformats.org/drawingml/2006/main">
-            <a:r>
-              <a:t>Features</a:t>
-            </a:r>
-          </a:p>
-          <a:p xmlns:a="http://schemas.openxmlformats.org/drawingml/2006/main">
-            <a:r>
-              <a:t>F1</a:t>
-            </a:r>
-          </a:p>
-          <a:p xmlns:a="http://schemas.openxmlformats.org/drawingml/2006/main">
-            <a:r>
-              <a:t>ROC-AUC</a:t>
-            </a:r>
-          </a:p>
-          <a:p xmlns:a="http://schemas.openxmlformats.org/drawingml/2006/main">
-            <a:r>
-              <a:t>A</a:t>
-            </a:r>
-          </a:p>
-          <a:p xmlns:a="http://schemas.openxmlformats.org/drawingml/2006/main">
-            <a:r>
-              <a:t>none (step, corruption level only)</a:t>
-            </a:r>
-          </a:p>
-          <a:p xmlns:a="http://schemas.openxmlformats.org/drawingml/2006/main">
-            <a:r>
-              <a:t>0.253</a:t>
-            </a:r>
-          </a:p>
-          <a:p xmlns:a="http://schemas.openxmlformats.org/drawingml/2006/main">
-            <a:r>
-              <a:t>0.508</a:t>
-            </a:r>
-          </a:p>
-          <a:p xmlns:a="http://schemas.openxmlformats.org/drawingml/2006/main">
-            <a:r>
-              <a:t>B</a:t>
-            </a:r>
-          </a:p>
-          <a:p xmlns:a="http://schemas.openxmlformats.org/drawingml/2006/main">
-            <a:r>
-              <a:t>single-point confidence</a:t>
-            </a:r>
-          </a:p>
-          <a:p xmlns:a="http://schemas.openxmlformats.org/drawingml/2006/main">
-            <a:r>
-              <a:t>0.443</a:t>
-            </a:r>
-          </a:p>
-          <a:p xmlns:a="http://schemas.openxmlformats.org/drawingml/2006/main">
-            <a:r>
-              <a:t>0.741</a:t>
-            </a:r>
-          </a:p>
-          <a:p xmlns:a="http://schemas.openxmlformats.org/drawingml/2006/main">
-            <a:r>
-              <a:t>C</a:t>
-            </a:r>
-          </a:p>
-          <a:p xmlns:a="http://schemas.openxmlformats.org/drawingml/2006/main">
-            <a:r>
-              <a:t>full confidence-drift features</a:t>
-            </a:r>
-          </a:p>
-          <a:p xmlns:a="http://schemas.openxmlformats.org/drawingml/2006/main">
-            <a:r>
-              <a:t>0.483</a:t>
-            </a:r>
-          </a:p>
-          <a:p xmlns:a="http://schemas.openxmlformats.org/drawingml/2006/main">
-            <a:r>
-              <a:t>0.787</a:t>
-            </a:r>
-          </a:p>
-          <a:p xmlns:a="http://schemas.openxmlformats.org/drawingml/2006/main">
-            <a:r>
-              <a:t>+0.230</a:t>
-            </a:r>
-          </a:p>
-          <a:p xmlns:a="http://schemas.openxmlformats.org/drawingml/2006/main">
-            <a:r>
-              <a:t>F1 improvement, A to C</a:t>
-            </a:r>
-          </a:p>
-          <a:p xmlns:a="http://schemas.openxmlformats.org/drawingml/2006/main">
-            <a:r>
-              <a:t>+0.279</a:t>
-            </a:r>
-          </a:p>
-          <a:p xmlns:a="http://schemas.openxmlformats.org/drawingml/2006/main">
-            <a:r>
-              <a:t>ROC-AUC improvement, A to C</a:t>
-            </a:r>
-          </a:p>
-          <a:p xmlns:a="http://schemas.openxmlformats.org/drawingml/2006/main">
-            <a:r>
-              <a:t>Real, measured improvement. F1 of 0.48 still is not great in absolute terms though, this is a meaningful step, not a solved problem.</a:t>
-            </a:r>
-          </a:p>
-          <a:p xmlns:a="http://schemas.openxmlformats.org/drawingml/2006/main">
-            <a:r>
-              <a:t>Logistic Regression results shown; Random Forest and Gradient Boosting gave comparable F1 (0.47-0.49) on the C feature set.</a:t>
-            </a:r>
-          </a:p>
-          <a:p xmlns:a="http://schemas.openxmlformats.org/drawingml/2006/main">
-            <a:r>
-              <a:t/>
-            </a:r>
-          </a:p>
-          <a:p xmlns:a="http://schemas.openxmlformats.org/drawingml/2006/main">
-            <a:r>
-              <a:t>11</a:t>
+              <a:t>A, B and C use the same Logistic Regression method, document-grouped folds, target and 0.5 threshold. A includes corruption step and level; B adds current confidence and margin; C adds nine history features. Results: results/metrics/drift_history_validation.json. Paired document-bootstrap intervals exclude retraining uncertainty.</a:t>
             </a:r>
           </a:p>
         </p:txBody>
@@ -900,52 +665,7 @@
           <a:lstStyle xmlns:a="http://schemas.openxmlformats.org/drawingml/2006/main"/>
           <a:p xmlns:a="http://schemas.openxmlformats.org/drawingml/2006/main">
             <a:r>
-              <a:t>Source: AI_Confidence_Drift_Presentation.pptx, slide 12.</a:t>
-            </a:r>
-          </a:p>
-          <a:p xmlns:a="http://schemas.openxmlformats.org/drawingml/2006/main">
-            <a:r>
-              <a:t/>
-            </a:r>
-          </a:p>
-          <a:p xmlns:a="http://schemas.openxmlformats.org/drawingml/2006/main">
-            <a:r>
-              <a:t>RESULTS SUMMARY</a:t>
-            </a:r>
-          </a:p>
-          <a:p xmlns:a="http://schemas.openxmlformats.org/drawingml/2006/main">
-            <a:r>
-              <a:t>What I found</a:t>
-            </a:r>
-          </a:p>
-          <a:p xmlns:a="http://schemas.openxmlformats.org/drawingml/2006/main">
-            <a:r>
-              <a:t>Confidence carries real signal on average: accuracy rises from 63.5% to 93.3% across confidence bins.</a:t>
-            </a:r>
-          </a:p>
-          <a:p xmlns:a="http://schemas.openxmlformats.org/drawingml/2006/main">
-            <a:r>
-              <a:t>But it is not perfectly calibrated: ECE of 0.153, and 6% of high-confidence predictions are still wrong.</a:t>
-            </a:r>
-          </a:p>
-          <a:p xmlns:a="http://schemas.openxmlformats.org/drawingml/2006/main">
-            <a:r>
-              <a:t>Net confidence drift alone is a weak predictor of error (correlation of about 0.04). I tested this assumption instead of taking it for granted, and it did not hold.</a:t>
-            </a:r>
-          </a:p>
-          <a:p xmlns:a="http://schemas.openxmlformats.org/drawingml/2006/main">
-            <a:r>
-              <a:t>The shape of the drift sequence does help: volatility, moving stats and consecutive drops lifted unreliable-prediction detection from F1 0.25 to 0.48, and ROC-AUC 0.51 to 0.79.</a:t>
-            </a:r>
-          </a:p>
-          <a:p xmlns:a="http://schemas.openxmlformats.org/drawingml/2006/main">
-            <a:r>
-              <a:t/>
-            </a:r>
-          </a:p>
-          <a:p xmlns:a="http://schemas.openxmlformats.org/drawingml/2006/main">
-            <a:r>
-              <a:t>12</a:t>
+              <a:t>Source: reports/RESEARCH_REPORT.md and results/metrics in the accompanying project repository. The figures describe the corrected, document-grouped evaluation.</a:t>
             </a:r>
           </a:p>
         </p:txBody>
@@ -1015,82 +735,7 @@
           <a:lstStyle xmlns:a="http://schemas.openxmlformats.org/drawingml/2006/main"/>
           <a:p xmlns:a="http://schemas.openxmlformats.org/drawingml/2006/main">
             <a:r>
-              <a:t>Source: AI_Confidence_Drift_Presentation.pptx, slide 13.</a:t>
-            </a:r>
-          </a:p>
-          <a:p xmlns:a="http://schemas.openxmlformats.org/drawingml/2006/main">
-            <a:r>
-              <a:t/>
-            </a:r>
-          </a:p>
-          <a:p xmlns:a="http://schemas.openxmlformats.org/drawingml/2006/main">
-            <a:r>
-              <a:t>LIMITATIONS &amp; FUTURE SCOPE</a:t>
-            </a:r>
-          </a:p>
-          <a:p xmlns:a="http://schemas.openxmlformats.org/drawingml/2006/main">
-            <a:r>
-              <a:t>Limitations and what I would try next</a:t>
-            </a:r>
-          </a:p>
-          <a:p xmlns:a="http://schemas.openxmlformats.org/drawingml/2006/main">
-            <a:r>
-              <a:t>Limitations</a:t>
-            </a:r>
-          </a:p>
-          <a:p xmlns:a="http://schemas.openxmlformats.org/drawingml/2006/main">
-            <a:r>
-              <a:t>Sequences are simulated through text corruption, not naturally repeated real-world queries.</a:t>
-            </a:r>
-          </a:p>
-          <a:p xmlns:a="http://schemas.openxmlformats.org/drawingml/2006/main">
-            <a:r>
-              <a:t>Dataset is modest in size (439 test documents), some bins have very few samples.</a:t>
-            </a:r>
-          </a:p>
-          <a:p xmlns:a="http://schemas.openxmlformats.org/drawingml/2006/main">
-            <a:r>
-              <a:t>Only two classes were studied, and only one base model architecture.</a:t>
-            </a:r>
-          </a:p>
-          <a:p xmlns:a="http://schemas.openxmlformats.org/drawingml/2006/main">
-            <a:r>
-              <a:t>Detector F1 of about 0.48 means it still misses or mislabels a fair number of predictions.</a:t>
-            </a:r>
-          </a:p>
-          <a:p xmlns:a="http://schemas.openxmlformats.org/drawingml/2006/main">
-            <a:r>
-              <a:t>What I would try next</a:t>
-            </a:r>
-          </a:p>
-          <a:p xmlns:a="http://schemas.openxmlformats.org/drawingml/2006/main">
-            <a:r>
-              <a:t>Try a different base model, like a neural text classifier, and see if drift features still help.</a:t>
-            </a:r>
-          </a:p>
-          <a:p xmlns:a="http://schemas.openxmlformats.org/drawingml/2006/main">
-            <a:r>
-              <a:t>Use genuinely repeated real-world queries instead of synthetic corruption, if such data becomes available.</a:t>
-            </a:r>
-          </a:p>
-          <a:p xmlns:a="http://schemas.openxmlformats.org/drawingml/2006/main">
-            <a:r>
-              <a:t>Try calibration techniques like temperature scaling and check whether that changes what the drift features add.</a:t>
-            </a:r>
-          </a:p>
-          <a:p xmlns:a="http://schemas.openxmlformats.org/drawingml/2006/main">
-            <a:r>
-              <a:t>Extend to multi-class classification with richer margin and entropy features.</a:t>
-            </a:r>
-          </a:p>
-          <a:p xmlns:a="http://schemas.openxmlformats.org/drawingml/2006/main">
-            <a:r>
-              <a:t/>
-            </a:r>
-          </a:p>
-          <a:p xmlns:a="http://schemas.openxmlformats.org/drawingml/2006/main">
-            <a:r>
-              <a:t>13</a:t>
+              <a:t>Source: reports/RESEARCH_REPORT.md and results/metrics in the accompanying project repository. The figures describe the corrected, document-grouped evaluation.</a:t>
             </a:r>
           </a:p>
         </p:txBody>
@@ -1160,67 +805,7 @@
           <a:lstStyle xmlns:a="http://schemas.openxmlformats.org/drawingml/2006/main"/>
           <a:p xmlns:a="http://schemas.openxmlformats.org/drawingml/2006/main">
             <a:r>
-              <a:t>Source: AI_Confidence_Drift_Presentation.pptx, slide 14.</a:t>
-            </a:r>
-          </a:p>
-          <a:p xmlns:a="http://schemas.openxmlformats.org/drawingml/2006/main">
-            <a:r>
-              <a:t/>
-            </a:r>
-          </a:p>
-          <a:p xmlns:a="http://schemas.openxmlformats.org/drawingml/2006/main">
-            <a:r>
-              <a:t>CONCLUSION</a:t>
-            </a:r>
-          </a:p>
-          <a:p xmlns:a="http://schemas.openxmlformats.org/drawingml/2006/main">
-            <a:r>
-              <a:t>Confidence drift is useful, if you look at its shape</a:t>
-            </a:r>
-          </a:p>
-          <a:p xmlns:a="http://schemas.openxmlformats.org/drawingml/2006/main">
-            <a:r>
-              <a:t>Confidence lines up with correctness on average, but it is not something to trust blindly. 6% of high-confidence predictions were still wrong, and net drift barely predicted error on its own (correlation of about 0.04). A detector trained on the </a:t>
-            </a:r>
-          </a:p>
-          <a:p xmlns:a="http://schemas.openxmlformats.org/drawingml/2006/main">
-            <a:r>
-              <a:t>shape</a:t>
-            </a:r>
-          </a:p>
-          <a:p xmlns:a="http://schemas.openxmlformats.org/drawingml/2006/main">
-            <a:r>
-              <a:t> of the confidence sequence, its volatility, moving statistics, and consecutive drops, gave a real, measured improvement: F1 went from 0.25 to 0.48, ROC-AUC from 0.51 to 0.79.</a:t>
-            </a:r>
-          </a:p>
-          <a:p xmlns:a="http://schemas.openxmlformats.org/drawingml/2006/main">
-            <a:r>
-              <a:t>So my answer to the research question is yes, with a condition I tested rather than assumed: confidence drift is useful when you look at its statistical shape, not just whether it went up or down. There is still real room to improve the detector, which I think is an honest place to end this project.</a:t>
-            </a:r>
-          </a:p>
-          <a:p xmlns:a="http://schemas.openxmlformats.org/drawingml/2006/main">
-            <a:r>
-              <a:t>Code, data, models, figures and the full research report:</a:t>
-            </a:r>
-          </a:p>
-          <a:p xmlns:a="http://schemas.openxmlformats.org/drawingml/2006/main">
-            <a:r>
-              <a:t>github.com/ahansardar/ai-confidence-drift</a:t>
-            </a:r>
-          </a:p>
-          <a:p xmlns:a="http://schemas.openxmlformats.org/drawingml/2006/main">
-            <a:r>
-              <a:t>Thank you.</a:t>
-            </a:r>
-          </a:p>
-          <a:p xmlns:a="http://schemas.openxmlformats.org/drawingml/2006/main">
-            <a:r>
-              <a:t/>
-            </a:r>
-          </a:p>
-          <a:p xmlns:a="http://schemas.openxmlformats.org/drawingml/2006/main">
-            <a:r>
-              <a:t>14</a:t>
+              <a:t>Source: reports/RESEARCH_REPORT.md and results/metrics in the accompanying project repository. The figures describe the corrected, document-grouped evaluation.</a:t>
             </a:r>
           </a:p>
         </p:txBody>
@@ -1290,67 +875,7 @@
           <a:lstStyle xmlns:a="http://schemas.openxmlformats.org/drawingml/2006/main"/>
           <a:p xmlns:a="http://schemas.openxmlformats.org/drawingml/2006/main">
             <a:r>
-              <a:t>Source: AI_Confidence_Drift_Presentation.pptx, slide 2.</a:t>
-            </a:r>
-          </a:p>
-          <a:p xmlns:a="http://schemas.openxmlformats.org/drawingml/2006/main">
-            <a:r>
-              <a:t/>
-            </a:r>
-          </a:p>
-          <a:p xmlns:a="http://schemas.openxmlformats.org/drawingml/2006/main">
-            <a:r>
-              <a:t>PROJECT OVERVIEW</a:t>
-            </a:r>
-          </a:p>
-          <a:p xmlns:a="http://schemas.openxmlformats.org/drawingml/2006/main">
-            <a:r>
-              <a:t>Confidence is not the same as correctness</a:t>
-            </a:r>
-          </a:p>
-          <a:p xmlns:a="http://schemas.openxmlformats.org/drawingml/2006/main">
-            <a:r>
-              <a:t>A model that reports 96% confidence can still be wrong. This project treats confidence as something to test, not something to trust automatically. In practice I saw three recurring issues:</a:t>
-            </a:r>
-          </a:p>
-          <a:p xmlns:a="http://schemas.openxmlformats.org/drawingml/2006/main">
-            <a:r>
-              <a:t>1. Confident, and wrong</a:t>
-            </a:r>
-          </a:p>
-          <a:p xmlns:a="http://schemas.openxmlformats.org/drawingml/2006/main">
-            <a:r>
-              <a:t>A model can stay highly confident while producing an incorrect prediction, with no internal warning sign.</a:t>
-            </a:r>
-          </a:p>
-          <a:p xmlns:a="http://schemas.openxmlformats.org/drawingml/2006/main">
-            <a:r>
-              <a:t>2. Unstable across inputs</a:t>
-            </a:r>
-          </a:p>
-          <a:p xmlns:a="http://schemas.openxmlformats.org/drawingml/2006/main">
-            <a:r>
-              <a:t>Confidence can swing across similar or repeated predictions, for reasons unrelated to correctness.</a:t>
-            </a:r>
-          </a:p>
-          <a:p xmlns:a="http://schemas.openxmlformats.org/drawingml/2006/main">
-            <a:r>
-              <a:t>3. Drift with difficulty</a:t>
-            </a:r>
-          </a:p>
-          <a:p xmlns:a="http://schemas.openxmlformats.org/drawingml/2006/main">
-            <a:r>
-              <a:t>As a problem gets harder, confidence usually drops. Does that always mean accuracy drops too? I tested this instead of assuming it.</a:t>
-            </a:r>
-          </a:p>
-          <a:p xmlns:a="http://schemas.openxmlformats.org/drawingml/2006/main">
-            <a:r>
-              <a:t/>
-            </a:r>
-          </a:p>
-          <a:p xmlns:a="http://schemas.openxmlformats.org/drawingml/2006/main">
-            <a:r>
-              <a:t>2</a:t>
+              <a:t>Source: reports/RESEARCH_REPORT.md and results/metrics in the accompanying project repository. The figures describe the corrected, document-grouped evaluation.</a:t>
             </a:r>
           </a:p>
         </p:txBody>
@@ -1420,52 +945,7 @@
           <a:lstStyle xmlns:a="http://schemas.openxmlformats.org/drawingml/2006/main"/>
           <a:p xmlns:a="http://schemas.openxmlformats.org/drawingml/2006/main">
             <a:r>
-              <a:t>Source: AI_Confidence_Drift_Presentation.pptx, slide 3.</a:t>
-            </a:r>
-          </a:p>
-          <a:p xmlns:a="http://schemas.openxmlformats.org/drawingml/2006/main">
-            <a:r>
-              <a:t/>
-            </a:r>
-          </a:p>
-          <a:p xmlns:a="http://schemas.openxmlformats.org/drawingml/2006/main">
-            <a:r>
-              <a:t>RESEARCH QUESTION</a:t>
-            </a:r>
-          </a:p>
-          <a:p xmlns:a="http://schemas.openxmlformats.org/drawingml/2006/main">
-            <a:r>
-              <a:t>Research question and hypothesis</a:t>
-            </a:r>
-          </a:p>
-          <a:p xmlns:a="http://schemas.openxmlformats.org/drawingml/2006/main">
-            <a:r>
-              <a:t>“Can machine learning detect meaningful changes in an AI model’s confidence, and can those changes be used to identify predictions that are likely unreliable?”</a:t>
-            </a:r>
-          </a:p>
-          <a:p xmlns:a="http://schemas.openxmlformats.org/drawingml/2006/main">
-            <a:r>
-              <a:t>Hypothesis</a:t>
-            </a:r>
-          </a:p>
-          <a:p xmlns:a="http://schemas.openxmlformats.org/drawingml/2006/main">
-            <a:r>
-              <a:t>Statistical features built from a confidence sequence (moving average, volatility, consecutive drops) predict unreliable predictions better than raw confidence alone, and far better than no confidence signal at all.</a:t>
-            </a:r>
-          </a:p>
-          <a:p xmlns:a="http://schemas.openxmlformats.org/drawingml/2006/main">
-            <a:r>
-              <a:t>Tested experimentally, not assumed. Part of it held up, part of it did not (see slides 9 and 11).</a:t>
-            </a:r>
-          </a:p>
-          <a:p xmlns:a="http://schemas.openxmlformats.org/drawingml/2006/main">
-            <a:r>
-              <a:t/>
-            </a:r>
-          </a:p>
-          <a:p xmlns:a="http://schemas.openxmlformats.org/drawingml/2006/main">
-            <a:r>
-              <a:t>3</a:t>
+              <a:t>Source: reports/RESEARCH_REPORT.md and results/metrics in the accompanying project repository. The figures describe the corrected, document-grouped evaluation.</a:t>
             </a:r>
           </a:p>
         </p:txBody>
@@ -1535,87 +1015,7 @@
           <a:lstStyle xmlns:a="http://schemas.openxmlformats.org/drawingml/2006/main"/>
           <a:p xmlns:a="http://schemas.openxmlformats.org/drawingml/2006/main">
             <a:r>
-              <a:t>Source: AI_Confidence_Drift_Presentation.pptx, slide 4.</a:t>
-            </a:r>
-          </a:p>
-          <a:p xmlns:a="http://schemas.openxmlformats.org/drawingml/2006/main">
-            <a:r>
-              <a:t/>
-            </a:r>
-          </a:p>
-          <a:p xmlns:a="http://schemas.openxmlformats.org/drawingml/2006/main">
-            <a:r>
-              <a:t>DATASET</a:t>
-            </a:r>
-          </a:p>
-          <a:p xmlns:a="http://schemas.openxmlformats.org/drawingml/2006/main">
-            <a:r>
-              <a:t>Task and dataset</a:t>
-            </a:r>
-          </a:p>
-          <a:p xmlns:a="http://schemas.openxmlformats.org/drawingml/2006/main">
-            <a:r>
-              <a:t>Binary text classification: alt.atheism vs. soc.religion.christian</a:t>
-            </a:r>
-          </a:p>
-          <a:p xmlns:a="http://schemas.openxmlformats.org/drawingml/2006/main">
-            <a:r>
-              <a:t>Source: scikit-learn’s official 20 Newsgroups mirror (fetch_20newsgroups), public and documented</a:t>
-            </a:r>
-          </a:p>
-          <a:p xmlns:a="http://schemas.openxmlformats.org/drawingml/2006/main">
-            <a:r>
-              <a:t>Chosen because the two categories share overlapping vocabulary, so predictions are not trivially easy</a:t>
-            </a:r>
-          </a:p>
-          <a:p xmlns:a="http://schemas.openxmlformats.org/drawingml/2006/main">
-            <a:r>
-              <a:t>Headers, footers and quoted text stripped from every post to avoid metadata leakage</a:t>
-            </a:r>
-          </a:p>
-          <a:p xmlns:a="http://schemas.openxmlformats.org/drawingml/2006/main">
-            <a:r>
-              <a:t>Ground truth is the newsgroup each post was actually published to</a:t>
-            </a:r>
-          </a:p>
-          <a:p xmlns:a="http://schemas.openxmlformats.org/drawingml/2006/main">
-            <a:r>
-              <a:t>Total documents</a:t>
-            </a:r>
-          </a:p>
-          <a:p xmlns:a="http://schemas.openxmlformats.org/drawingml/2006/main">
-            <a:r>
-              <a:t>1,754</a:t>
-            </a:r>
-          </a:p>
-          <a:p xmlns:a="http://schemas.openxmlformats.org/drawingml/2006/main">
-            <a:r>
-              <a:t>Train / test split</a:t>
-            </a:r>
-          </a:p>
-          <a:p xmlns:a="http://schemas.openxmlformats.org/drawingml/2006/main">
-            <a:r>
-              <a:t>1,315 / 439 (stratified)</a:t>
-            </a:r>
-          </a:p>
-          <a:p xmlns:a="http://schemas.openxmlformats.org/drawingml/2006/main">
-            <a:r>
-              <a:t>Class balance</a:t>
-            </a:r>
-          </a:p>
-          <a:p xmlns:a="http://schemas.openxmlformats.org/drawingml/2006/main">
-            <a:r>
-              <a:t>44.4% / 55.6%</a:t>
-            </a:r>
-          </a:p>
-          <a:p xmlns:a="http://schemas.openxmlformats.org/drawingml/2006/main">
-            <a:r>
-              <a:t/>
-            </a:r>
-          </a:p>
-          <a:p xmlns:a="http://schemas.openxmlformats.org/drawingml/2006/main">
-            <a:r>
-              <a:t>4</a:t>
+              <a:t>Source: reports/RESEARCH_REPORT.md and results/metrics in the accompanying project repository. The figures describe the corrected, document-grouped evaluation.</a:t>
             </a:r>
           </a:p>
         </p:txBody>
@@ -1685,107 +1085,7 @@
           <a:lstStyle xmlns:a="http://schemas.openxmlformats.org/drawingml/2006/main"/>
           <a:p xmlns:a="http://schemas.openxmlformats.org/drawingml/2006/main">
             <a:r>
-              <a:t>Source: AI_Confidence_Drift_Presentation.pptx, slide 5.</a:t>
-            </a:r>
-          </a:p>
-          <a:p xmlns:a="http://schemas.openxmlformats.org/drawingml/2006/main">
-            <a:r>
-              <a:t/>
-            </a:r>
-          </a:p>
-          <a:p xmlns:a="http://schemas.openxmlformats.org/drawingml/2006/main">
-            <a:r>
-              <a:t>METHODOLOGY</a:t>
-            </a:r>
-          </a:p>
-          <a:p xmlns:a="http://schemas.openxmlformats.org/drawingml/2006/main">
-            <a:r>
-              <a:t>How the pipeline works</a:t>
-            </a:r>
-          </a:p>
-          <a:p xmlns:a="http://schemas.openxmlformats.org/drawingml/2006/main">
-            <a:r>
-              <a:t>1.</a:t>
-            </a:r>
-          </a:p>
-          <a:p xmlns:a="http://schemas.openxmlformats.org/drawingml/2006/main">
-            <a:r>
-              <a:t>Train the base classifier</a:t>
-            </a:r>
-          </a:p>
-          <a:p xmlns:a="http://schemas.openxmlformats.org/drawingml/2006/main">
-            <a:r>
-              <a:t>TF-IDF + Logistic Regression on the text classification task</a:t>
-            </a:r>
-          </a:p>
-          <a:p xmlns:a="http://schemas.openxmlformats.org/drawingml/2006/main">
-            <a:r>
-              <a:t>2.</a:t>
-            </a:r>
-          </a:p>
-          <a:p xmlns:a="http://schemas.openxmlformats.org/drawingml/2006/main">
-            <a:r>
-              <a:t>Generate confidence sequences</a:t>
-            </a:r>
-          </a:p>
-          <a:p xmlns:a="http://schemas.openxmlformats.org/drawingml/2006/main">
-            <a:r>
-              <a:t>Re-classify each test document at 6 increasing corruption levels</a:t>
-            </a:r>
-          </a:p>
-          <a:p xmlns:a="http://schemas.openxmlformats.org/drawingml/2006/main">
-            <a:r>
-              <a:t>3.</a:t>
-            </a:r>
-          </a:p>
-          <a:p xmlns:a="http://schemas.openxmlformats.org/drawingml/2006/main">
-            <a:r>
-              <a:t>Engineer drift features</a:t>
-            </a:r>
-          </a:p>
-          <a:p xmlns:a="http://schemas.openxmlformats.org/drawingml/2006/main">
-            <a:r>
-              <a:t>Moving average, volatility, deltas, consecutive drops, margin</a:t>
-            </a:r>
-          </a:p>
-          <a:p xmlns:a="http://schemas.openxmlformats.org/drawingml/2006/main">
-            <a:r>
-              <a:t>4.</a:t>
-            </a:r>
-          </a:p>
-          <a:p xmlns:a="http://schemas.openxmlformats.org/drawingml/2006/main">
-            <a:r>
-              <a:t>Train the confidence drift detector</a:t>
-            </a:r>
-          </a:p>
-          <a:p xmlns:a="http://schemas.openxmlformats.org/drawingml/2006/main">
-            <a:r>
-              <a:t>A second model predicting whether a prediction is unreliable</a:t>
-            </a:r>
-          </a:p>
-          <a:p xmlns:a="http://schemas.openxmlformats.org/drawingml/2006/main">
-            <a:r>
-              <a:t>5.</a:t>
-            </a:r>
-          </a:p>
-          <a:p xmlns:a="http://schemas.openxmlformats.org/drawingml/2006/main">
-            <a:r>
-              <a:t>Evaluate</a:t>
-            </a:r>
-          </a:p>
-          <a:p xmlns:a="http://schemas.openxmlformats.org/drawingml/2006/main">
-            <a:r>
-              <a:t>Calibration, high-confidence errors, and a controlled A/B/C comparison</a:t>
-            </a:r>
-          </a:p>
-          <a:p xmlns:a="http://schemas.openxmlformats.org/drawingml/2006/main">
-            <a:r>
-              <a:t/>
-            </a:r>
-          </a:p>
-          <a:p xmlns:a="http://schemas.openxmlformats.org/drawingml/2006/main">
-            <a:r>
-              <a:t>5</a:t>
+              <a:t>Source: reports/RESEARCH_REPORT.md and results/metrics in the accompanying project repository. The figures describe the corrected, document-grouped evaluation.</a:t>
             </a:r>
           </a:p>
         </p:txBody>
@@ -1855,167 +1155,7 @@
           <a:lstStyle xmlns:a="http://schemas.openxmlformats.org/drawingml/2006/main"/>
           <a:p xmlns:a="http://schemas.openxmlformats.org/drawingml/2006/main">
             <a:r>
-              <a:t>CONFIDENCE-DRIFT SIMULATION</a:t>
-            </a:r>
-          </a:p>
-          <a:p xmlns:a="http://schemas.openxmlformats.org/drawingml/2006/main">
-            <a:r>
-              <a:t>Where the confidence sequences come from</a:t>
-            </a:r>
-          </a:p>
-          <a:p xmlns:a="http://schemas.openxmlformats.org/drawingml/2006/main">
-            <a:r>
-              <a:t>The dataset has no naturally repeated predictions, so I corrupt each test document at 6 levels </a:t>
-            </a:r>
-          </a:p>
-          <a:p xmlns:a="http://schemas.openxmlformats.org/drawingml/2006/main">
-            <a:r>
-              <a:t>(0% up to 50% of words removed and shuffled)</a:t>
-            </a:r>
-          </a:p>
-          <a:p xmlns:a="http://schemas.openxmlformats.org/drawingml/2006/main">
-            <a:r>
-              <a:t> and re-classify it each time. Every confidence value is a real model output, none are fabricated.</a:t>
-            </a:r>
-          </a:p>
-          <a:p xmlns:a="http://schemas.openxmlformats.org/drawingml/2006/main">
-            <a:r>
-              <a:t>Step</a:t>
-            </a:r>
-          </a:p>
-          <a:p xmlns:a="http://schemas.openxmlformats.org/drawingml/2006/main">
-            <a:r>
-              <a:t>doc_00750</a:t>
-            </a:r>
-          </a:p>
-          <a:p xmlns:a="http://schemas.openxmlformats.org/drawingml/2006/main">
-            <a:r>
-              <a:t>(stayed confident, stayed wrong)</a:t>
-            </a:r>
-          </a:p>
-          <a:p xmlns:a="http://schemas.openxmlformats.org/drawingml/2006/main">
-            <a:r>
-              <a:t>doc_01280</a:t>
-            </a:r>
-          </a:p>
-          <a:p xmlns:a="http://schemas.openxmlformats.org/drawingml/2006/main">
-            <a:r>
-              <a:t>(dropped sharply, stayed correct)</a:t>
-            </a:r>
-          </a:p>
-          <a:p xmlns:a="http://schemas.openxmlformats.org/drawingml/2006/main">
-            <a:r>
-              <a:t>0</a:t>
-            </a:r>
-          </a:p>
-          <a:p xmlns:a="http://schemas.openxmlformats.org/drawingml/2006/main">
-            <a:r>
-              <a:t>0.963</a:t>
-            </a:r>
-          </a:p>
-          <a:p xmlns:a="http://schemas.openxmlformats.org/drawingml/2006/main">
-            <a:r>
-              <a:t>0.889</a:t>
-            </a:r>
-          </a:p>
-          <a:p xmlns:a="http://schemas.openxmlformats.org/drawingml/2006/main">
-            <a:r>
-              <a:t>1</a:t>
-            </a:r>
-          </a:p>
-          <a:p xmlns:a="http://schemas.openxmlformats.org/drawingml/2006/main">
-            <a:r>
-              <a:t>0.952</a:t>
-            </a:r>
-          </a:p>
-          <a:p xmlns:a="http://schemas.openxmlformats.org/drawingml/2006/main">
-            <a:r>
-              <a:t>0.771</a:t>
-            </a:r>
-          </a:p>
-          <a:p xmlns:a="http://schemas.openxmlformats.org/drawingml/2006/main">
-            <a:r>
-              <a:t>2</a:t>
-            </a:r>
-          </a:p>
-          <a:p xmlns:a="http://schemas.openxmlformats.org/drawingml/2006/main">
-            <a:r>
-              <a:t>0.951</a:t>
-            </a:r>
-          </a:p>
-          <a:p xmlns:a="http://schemas.openxmlformats.org/drawingml/2006/main">
-            <a:r>
-              <a:t>0.778</a:t>
-            </a:r>
-          </a:p>
-          <a:p xmlns:a="http://schemas.openxmlformats.org/drawingml/2006/main">
-            <a:r>
-              <a:t>3</a:t>
-            </a:r>
-          </a:p>
-          <a:p xmlns:a="http://schemas.openxmlformats.org/drawingml/2006/main">
-            <a:r>
-              <a:t>0.951</a:t>
-            </a:r>
-          </a:p>
-          <a:p xmlns:a="http://schemas.openxmlformats.org/drawingml/2006/main">
-            <a:r>
-              <a:t>0.682</a:t>
-            </a:r>
-          </a:p>
-          <a:p xmlns:a="http://schemas.openxmlformats.org/drawingml/2006/main">
-            <a:r>
-              <a:t>4</a:t>
-            </a:r>
-          </a:p>
-          <a:p xmlns:a="http://schemas.openxmlformats.org/drawingml/2006/main">
-            <a:r>
-              <a:t>0.948</a:t>
-            </a:r>
-          </a:p>
-          <a:p xmlns:a="http://schemas.openxmlformats.org/drawingml/2006/main">
-            <a:r>
-              <a:t>0.842</a:t>
-            </a:r>
-          </a:p>
-          <a:p xmlns:a="http://schemas.openxmlformats.org/drawingml/2006/main">
-            <a:r>
-              <a:t>5</a:t>
-            </a:r>
-          </a:p>
-          <a:p xmlns:a="http://schemas.openxmlformats.org/drawingml/2006/main">
-            <a:r>
-              <a:t>0.949</a:t>
-            </a:r>
-          </a:p>
-          <a:p xmlns:a="http://schemas.openxmlformats.org/drawingml/2006/main">
-            <a:r>
-              <a:t>0.651</a:t>
-            </a:r>
-          </a:p>
-          <a:p xmlns:a="http://schemas.openxmlformats.org/drawingml/2006/main">
-            <a:r>
-              <a:t>Net drift alone turned out to be a weak signal for error, see slide 9.</a:t>
-            </a:r>
-          </a:p>
-          <a:p xmlns:a="http://schemas.openxmlformats.org/drawingml/2006/main">
-            <a:r>
-              <a:t>Figure 1. Confidence trajectories for 12 test documents under increasing corruption. Green ends correct, red ends incorrect.</a:t>
-            </a:r>
-          </a:p>
-          <a:p xmlns:a="http://schemas.openxmlformats.org/drawingml/2006/main">
-            <a:r>
-              <a:t>AI Confidence Drift Detection  ·  Pranav  ·  PranavX Labs AI/ML Internship</a:t>
-            </a:r>
-          </a:p>
-          <a:p xmlns:a="http://schemas.openxmlformats.org/drawingml/2006/main">
-            <a:r>
-              <a:t>6 / 14</a:t>
-            </a:r>
-          </a:p>
-          <a:p xmlns:a="http://schemas.openxmlformats.org/drawingml/2006/main">
-            <a:r>
-              <a:t>Trajectory data: data/processed/confidence_sequences.csv, first 12 unique document IDs, matching src/visualize.py. Net drift alone is a weak error signal. See the results summary.</a:t>
+              <a:t>Trajectory data: data/processed/confidence_sequences.csv. These are actual base-model probabilities on six increasingly corrupted versions of each document. The sequence is simulated rather than naturally repeated.</a:t>
             </a:r>
           </a:p>
         </p:txBody>
@@ -2085,92 +1225,7 @@
           <a:lstStyle xmlns:a="http://schemas.openxmlformats.org/drawingml/2006/main"/>
           <a:p xmlns:a="http://schemas.openxmlformats.org/drawingml/2006/main">
             <a:r>
-              <a:t>Source: AI_Confidence_Drift_Presentation.pptx, slide 7.</a:t>
-            </a:r>
-          </a:p>
-          <a:p xmlns:a="http://schemas.openxmlformats.org/drawingml/2006/main">
-            <a:r>
-              <a:t/>
-            </a:r>
-          </a:p>
-          <a:p xmlns:a="http://schemas.openxmlformats.org/drawingml/2006/main">
-            <a:r>
-              <a:t>FEATURE ENGINEERING</a:t>
-            </a:r>
-          </a:p>
-          <a:p xmlns:a="http://schemas.openxmlformats.org/drawingml/2006/main">
-            <a:r>
-              <a:t>Features I engineered</a:t>
-            </a:r>
-          </a:p>
-          <a:p xmlns:a="http://schemas.openxmlformats.org/drawingml/2006/main">
-            <a:r>
-              <a:t>13 features in total. I did not assume they would all be useful, that is what the experiments on slide 11 test.</a:t>
-            </a:r>
-          </a:p>
-          <a:p xmlns:a="http://schemas.openxmlformats.org/drawingml/2006/main">
-            <a:r>
-              <a:t>Group</a:t>
-            </a:r>
-          </a:p>
-          <a:p xmlns:a="http://schemas.openxmlformats.org/drawingml/2006/main">
-            <a:r>
-              <a:t>Features</a:t>
-            </a:r>
-          </a:p>
-          <a:p xmlns:a="http://schemas.openxmlformats.org/drawingml/2006/main">
-            <a:r>
-              <a:t>Point in time</a:t>
-            </a:r>
-          </a:p>
-          <a:p xmlns:a="http://schemas.openxmlformats.org/drawingml/2006/main">
-            <a:r>
-              <a:t>confidence, prediction_margin, historical_accuracy_for_class</a:t>
-            </a:r>
-          </a:p>
-          <a:p xmlns:a="http://schemas.openxmlformats.org/drawingml/2006/main">
-            <a:r>
-              <a:t>Change</a:t>
-            </a:r>
-          </a:p>
-          <a:p xmlns:a="http://schemas.openxmlformats.org/drawingml/2006/main">
-            <a:r>
-              <a:t>confidence_diff, confidence_pct_change, rate_of_change</a:t>
-            </a:r>
-          </a:p>
-          <a:p xmlns:a="http://schemas.openxmlformats.org/drawingml/2006/main">
-            <a:r>
-              <a:t>Trend / history</a:t>
-            </a:r>
-          </a:p>
-          <a:p xmlns:a="http://schemas.openxmlformats.org/drawingml/2006/main">
-            <a:r>
-              <a:t>moving_avg_confidence, moving_std_confidence, rolling_std_confidence,</a:t>
-            </a:r>
-          </a:p>
-          <a:p xmlns:a="http://schemas.openxmlformats.org/drawingml/2006/main">
-            <a:r>
-              <a:t>confidence_range_so_far</a:t>
-            </a:r>
-          </a:p>
-          <a:p xmlns:a="http://schemas.openxmlformats.org/drawingml/2006/main">
-            <a:r>
-              <a:t>Pattern</a:t>
-            </a:r>
-          </a:p>
-          <a:p xmlns:a="http://schemas.openxmlformats.org/drawingml/2006/main">
-            <a:r>
-              <a:t>consecutive_decreases, step, corruption_level</a:t>
-            </a:r>
-          </a:p>
-          <a:p xmlns:a="http://schemas.openxmlformats.org/drawingml/2006/main">
-            <a:r>
-              <a:t/>
-            </a:r>
-          </a:p>
-          <a:p xmlns:a="http://schemas.openxmlformats.org/drawingml/2006/main">
-            <a:r>
-              <a:t>7</a:t>
+              <a:t>Source: reports/RESEARCH_REPORT.md and results/metrics in the accompanying project repository. The figures describe the corrected, document-grouped evaluation.</a:t>
             </a:r>
           </a:p>
         </p:txBody>
@@ -2240,102 +1295,7 @@
           <a:lstStyle xmlns:a="http://schemas.openxmlformats.org/drawingml/2006/main"/>
           <a:p xmlns:a="http://schemas.openxmlformats.org/drawingml/2006/main">
             <a:r>
-              <a:t>Source: AI_Confidence_Drift_Presentation.pptx, slide 8.</a:t>
-            </a:r>
-          </a:p>
-          <a:p xmlns:a="http://schemas.openxmlformats.org/drawingml/2006/main">
-            <a:r>
-              <a:t/>
-            </a:r>
-          </a:p>
-          <a:p xmlns:a="http://schemas.openxmlformats.org/drawingml/2006/main">
-            <a:r>
-              <a:t>CONFIDENCE VS. ACTUAL CORRECTNESS</a:t>
-            </a:r>
-          </a:p>
-          <a:p xmlns:a="http://schemas.openxmlformats.org/drawingml/2006/main">
-            <a:r>
-              <a:t>Does higher confidence mean higher accuracy?</a:t>
-            </a:r>
-          </a:p>
-          <a:p xmlns:a="http://schemas.openxmlformats.org/drawingml/2006/main">
-            <a:r>
-              <a:t>Figure 2. Accuracy by confidence bin, step-0 test predictions.</a:t>
-            </a:r>
-          </a:p>
-          <a:p xmlns:a="http://schemas.openxmlformats.org/drawingml/2006/main">
-            <a:r>
-              <a:t>Confidence range</a:t>
-            </a:r>
-          </a:p>
-          <a:p xmlns:a="http://schemas.openxmlformats.org/drawingml/2006/main">
-            <a:r>
-              <a:t>n</a:t>
-            </a:r>
-          </a:p>
-          <a:p xmlns:a="http://schemas.openxmlformats.org/drawingml/2006/main">
-            <a:r>
-              <a:t>Accuracy</a:t>
-            </a:r>
-          </a:p>
-          <a:p xmlns:a="http://schemas.openxmlformats.org/drawingml/2006/main">
-            <a:r>
-              <a:t>40-60%</a:t>
-            </a:r>
-          </a:p>
-          <a:p xmlns:a="http://schemas.openxmlformats.org/drawingml/2006/main">
-            <a:r>
-              <a:t>156</a:t>
-            </a:r>
-          </a:p>
-          <a:p xmlns:a="http://schemas.openxmlformats.org/drawingml/2006/main">
-            <a:r>
-              <a:t>63.5%</a:t>
-            </a:r>
-          </a:p>
-          <a:p xmlns:a="http://schemas.openxmlformats.org/drawingml/2006/main">
-            <a:r>
-              <a:t>60-80%</a:t>
-            </a:r>
-          </a:p>
-          <a:p xmlns:a="http://schemas.openxmlformats.org/drawingml/2006/main">
-            <a:r>
-              <a:t>223</a:t>
-            </a:r>
-          </a:p>
-          <a:p xmlns:a="http://schemas.openxmlformats.org/drawingml/2006/main">
-            <a:r>
-              <a:t>90.1%</a:t>
-            </a:r>
-          </a:p>
-          <a:p xmlns:a="http://schemas.openxmlformats.org/drawingml/2006/main">
-            <a:r>
-              <a:t>80-100%</a:t>
-            </a:r>
-          </a:p>
-          <a:p xmlns:a="http://schemas.openxmlformats.org/drawingml/2006/main">
-            <a:r>
-              <a:t>60</a:t>
-            </a:r>
-          </a:p>
-          <a:p xmlns:a="http://schemas.openxmlformats.org/drawingml/2006/main">
-            <a:r>
-              <a:t>93.3%</a:t>
-            </a:r>
-          </a:p>
-          <a:p xmlns:a="http://schemas.openxmlformats.org/drawingml/2006/main">
-            <a:r>
-              <a:t>Accuracy rises with confidence, so confidence carries real signal. But the relationship is not perfectly clean, see calibration next.</a:t>
-            </a:r>
-          </a:p>
-          <a:p xmlns:a="http://schemas.openxmlformats.org/drawingml/2006/main">
-            <a:r>
-              <a:t/>
-            </a:r>
-          </a:p>
-          <a:p xmlns:a="http://schemas.openxmlformats.org/drawingml/2006/main">
-            <a:r>
-              <a:t>8</a:t>
+              <a:t>Source: reports/RESEARCH_REPORT.md and results/metrics in the accompanying project repository. The figures describe the corrected, document-grouped evaluation.</a:t>
             </a:r>
           </a:p>
         </p:txBody>
@@ -2405,57 +1365,7 @@
           <a:lstStyle xmlns:a="http://schemas.openxmlformats.org/drawingml/2006/main"/>
           <a:p xmlns:a="http://schemas.openxmlformats.org/drawingml/2006/main">
             <a:r>
-              <a:t>CALIBRATION ANALYSIS</a:t>
-            </a:r>
-          </a:p>
-          <a:p xmlns:a="http://schemas.openxmlformats.org/drawingml/2006/main">
-            <a:r>
-              <a:t>Confidence is not perfectly calibrated</a:t>
-            </a:r>
-          </a:p>
-          <a:p xmlns:a="http://schemas.openxmlformats.org/drawingml/2006/main">
-            <a:r>
-              <a:t>Figure 3. Reliability diagram, step-0 test predictions.</a:t>
-            </a:r>
-          </a:p>
-          <a:p xmlns:a="http://schemas.openxmlformats.org/drawingml/2006/main">
-            <a:r>
-              <a:t>Expected Calibration Error: 0.153</a:t>
-            </a:r>
-          </a:p>
-          <a:p xmlns:a="http://schemas.openxmlformats.org/drawingml/2006/main">
-            <a:r>
-              <a:t>Brier score: 0.125</a:t>
-            </a:r>
-          </a:p>
-          <a:p xmlns:a="http://schemas.openxmlformats.org/drawingml/2006/main">
-            <a:r>
-              <a:t>The model is a bit under-confident in the 0.6-0.9 range, its accuracy there is higher than its stated confidence.</a:t>
-            </a:r>
-          </a:p>
-          <a:p xmlns:a="http://schemas.openxmlformats.org/drawingml/2006/main">
-            <a:r>
-              <a:t>The top bin (0.9-1.0, only 10 samples) has lower accuracy (80%) than the bin below it (96%). Likely small-sample noise, but a fair reminder that very high confidence is not a guarantee.</a:t>
-            </a:r>
-          </a:p>
-          <a:p xmlns:a="http://schemas.openxmlformats.org/drawingml/2006/main">
-            <a:r>
-              <a:t>This is exactly why I built a separate detector rather than trusting raw confidence on its own (slide 11).</a:t>
-            </a:r>
-          </a:p>
-          <a:p xmlns:a="http://schemas.openxmlformats.org/drawingml/2006/main">
-            <a:r>
-              <a:t>AI Confidence Drift Detection  ·  Pranav  ·  PranavX Labs AI/ML Internship</a:t>
-            </a:r>
-          </a:p>
-          <a:p xmlns:a="http://schemas.openxmlformats.org/drawingml/2006/main">
-            <a:r>
-              <a:t>9 / 14</a:t>
-            </a:r>
-          </a:p>
-          <a:p xmlns:a="http://schemas.openxmlformats.org/drawingml/2006/main">
-            <a:r>
-              <a:t>Exact calibration values: results/metrics/calibration_analysis.json.</a:t>
+              <a:t>Exact values: results/metrics/calibration_analysis.json. The Brier score uses the probability of class 1 against the true binary label; this corrects the earlier maximum-class-probability calculation.</a:t>
             </a:r>
           </a:p>
         </p:txBody>
@@ -2523,7 +1433,7 @@
   </p:cSld>
   <p:clrMap bg1="lt1" tx1="dk1" bg2="lt2" tx2="dk2" accent1="accent1" accent2="accent2" accent3="accent3" accent4="accent4" accent5="accent5" accent6="accent6" hlink="hlink" folHlink="folHlink"/>
   <p:sldLayoutIdLst>
-    <p:sldLayoutId xmlns:r="http://schemas.openxmlformats.org/officeDocument/2006/relationships" id="2147483649" r:id="R50577aa09c0f4226"/>
+    <p:sldLayoutId xmlns:r="http://schemas.openxmlformats.org/officeDocument/2006/relationships" id="2147483649" r:id="R52c0b6e0f5394747"/>
   </p:sldLayoutIdLst>
   <p:txStyles>
     <p:titleStyle>
@@ -4770,7 +3680,7 @@
           <p:cNvPr id="11" name="01">
             <a:extLst xmlns:a="http://schemas.openxmlformats.org/drawingml/2006/main">
               <a:ext uri="{FF2B5EF4-FFF2-40B4-BE49-F238E27FC236}">
-                <a16:creationId xmlns:a16="http://schemas.microsoft.com/office/drawing/2014/main" id="{95E7888E-1768-46AC-96CB-AA0D55528A9E}"/>
+                <a16:creationId xmlns:a16="http://schemas.microsoft.com/office/drawing/2014/main" id="{70540C69-DB98-4B77-94D4-2CE534977EB6}"/>
               </a:ext>
             </a:extLst>
           </p:cNvPr>
@@ -4827,7 +3737,7 @@
           <p:cNvPr id="2" name="PRANAVX LABS">
             <a:extLst xmlns:a="http://schemas.openxmlformats.org/drawingml/2006/main">
               <a:ext uri="{FF2B5EF4-FFF2-40B4-BE49-F238E27FC236}">
-                <a16:creationId xmlns:a16="http://schemas.microsoft.com/office/drawing/2014/main" id="{CFA961AB-9851-4D13-B5D5-6B85410EB229}"/>
+                <a16:creationId xmlns:a16="http://schemas.microsoft.com/office/drawing/2014/main" id="{B2E109E4-4341-4BCD-B72A-6F85A7701485}"/>
               </a:ext>
             </a:extLst>
           </p:cNvPr>
@@ -4884,7 +3794,7 @@
           <p:cNvPr id="3" name="AI/ML Internship">
             <a:extLst xmlns:a="http://schemas.openxmlformats.org/drawingml/2006/main">
               <a:ext uri="{FF2B5EF4-FFF2-40B4-BE49-F238E27FC236}">
-                <a16:creationId xmlns:a16="http://schemas.microsoft.com/office/drawing/2014/main" id="{AE3788EC-B524-443E-966A-6D8BE90ED67E}"/>
+                <a16:creationId xmlns:a16="http://schemas.microsoft.com/office/drawing/2014/main" id="{188737F8-9D9D-47F1-A83E-DBDCDC758AA0}"/>
               </a:ext>
             </a:extLst>
           </p:cNvPr>
@@ -4941,7 +3851,7 @@
           <p:cNvPr id="4" name="AI Confidence">
             <a:extLst xmlns:a="http://schemas.openxmlformats.org/drawingml/2006/main">
               <a:ext uri="{FF2B5EF4-FFF2-40B4-BE49-F238E27FC236}">
-                <a16:creationId xmlns:a16="http://schemas.microsoft.com/office/drawing/2014/main" id="{E1C57EC8-0032-43C2-9DCC-1091DB217DB5}"/>
+                <a16:creationId xmlns:a16="http://schemas.microsoft.com/office/drawing/2014/main" id="{EC853238-F39E-4D6A-9A6D-1C9D0867D828}"/>
               </a:ext>
             </a:extLst>
           </p:cNvPr>
@@ -4998,7 +3908,7 @@
           <p:cNvPr id="5" name="Drift Detection">
             <a:extLst xmlns:a="http://schemas.openxmlformats.org/drawingml/2006/main">
               <a:ext uri="{FF2B5EF4-FFF2-40B4-BE49-F238E27FC236}">
-                <a16:creationId xmlns:a16="http://schemas.microsoft.com/office/drawing/2014/main" id="{FEBE8F4E-3E70-4D15-AD86-4EE79B91D357}"/>
+                <a16:creationId xmlns:a16="http://schemas.microsoft.com/office/drawing/2014/main" id="{E6DA64F8-33EE-4C1C-8C1A-729029D61843}"/>
               </a:ext>
             </a:extLst>
           </p:cNvPr>
@@ -5055,7 +3965,7 @@
           <p:cNvPr id="6" name="Using machine learning">
             <a:extLst xmlns:a="http://schemas.openxmlformats.org/drawingml/2006/main">
               <a:ext uri="{FF2B5EF4-FFF2-40B4-BE49-F238E27FC236}">
-                <a16:creationId xmlns:a16="http://schemas.microsoft.com/office/drawing/2014/main" id="{C6977E4A-4906-4FBF-BB6D-5429908099D1}"/>
+                <a16:creationId xmlns:a16="http://schemas.microsoft.com/office/drawing/2014/main" id="{778ACD99-C406-4400-B0D1-0AF46FBDF219}"/>
               </a:ext>
             </a:extLst>
           </p:cNvPr>
@@ -5112,7 +4022,7 @@
           <p:cNvPr id="7" name="Can changes in confidence help identify&#10;unreliable">
             <a:extLst xmlns:a="http://schemas.openxmlformats.org/drawingml/2006/main">
               <a:ext uri="{FF2B5EF4-FFF2-40B4-BE49-F238E27FC236}">
-                <a16:creationId xmlns:a16="http://schemas.microsoft.com/office/drawing/2014/main" id="{99B63AF8-C21D-4500-9DEF-AAD7FC8EA8F9}"/>
+                <a16:creationId xmlns:a16="http://schemas.microsoft.com/office/drawing/2014/main" id="{E1A101EF-1F75-43D3-9A41-BBD366462620}"/>
               </a:ext>
             </a:extLst>
           </p:cNvPr>
@@ -5189,10 +4099,10 @@
       </p:sp>
       <p:sp>
         <p:nvSpPr>
-          <p:cNvPr id="8" name="15-day research project">
+          <p:cNvPr id="8" name="Research project">
             <a:extLst xmlns:a="http://schemas.openxmlformats.org/drawingml/2006/main">
               <a:ext uri="{FF2B5EF4-FFF2-40B4-BE49-F238E27FC236}">
-                <a16:creationId xmlns:a16="http://schemas.microsoft.com/office/drawing/2014/main" id="{3CE90A15-3F47-4DF0-9218-B034736A332F}"/>
+                <a16:creationId xmlns:a16="http://schemas.microsoft.com/office/drawing/2014/main" id="{2084B47B-9B68-4B4C-9EF3-50FC2BEA0B3B}"/>
               </a:ext>
             </a:extLst>
           </p:cNvPr>
@@ -5239,7 +4149,7 @@
                 <a:ea typeface="Calibri"/>
                 <a:cs typeface="Calibri"/>
               </a:rPr>
-              <a:t>15-day research project</a:t>
+              <a:t>Research project</a:t>
             </a:r>
           </a:p>
         </p:txBody>
@@ -5249,7 +4159,7 @@
           <p:cNvPr id="9" name="Prepared by Ahan">
             <a:extLst xmlns:a="http://schemas.openxmlformats.org/drawingml/2006/main">
               <a:ext uri="{FF2B5EF4-FFF2-40B4-BE49-F238E27FC236}">
-                <a16:creationId xmlns:a16="http://schemas.microsoft.com/office/drawing/2014/main" id="{F8C8B697-71D0-4A12-82E5-D6CE1540FD09}"/>
+                <a16:creationId xmlns:a16="http://schemas.microsoft.com/office/drawing/2014/main" id="{5BE5DF00-AE53-4C82-8270-B1B8530DF267}"/>
               </a:ext>
             </a:extLst>
           </p:cNvPr>
@@ -5306,7 +4216,7 @@
           <p:cNvPr id="10" name="github.com/ahansardar/ai-confidence-drift">
             <a:extLst xmlns:a="http://schemas.openxmlformats.org/drawingml/2006/main">
               <a:ext uri="{FF2B5EF4-FFF2-40B4-BE49-F238E27FC236}">
-                <a16:creationId xmlns:a16="http://schemas.microsoft.com/office/drawing/2014/main" id="{06812810-AF62-42F9-A837-CA5C768759A8}"/>
+                <a16:creationId xmlns:a16="http://schemas.microsoft.com/office/drawing/2014/main" id="{11CA6A37-60C3-48CD-840D-AB89E1BF7DD5}"/>
               </a:ext>
             </a:extLst>
           </p:cNvPr>
@@ -5352,7 +4262,7 @@
                 <a:latin typeface="Calibri"/>
                 <a:ea typeface="Calibri"/>
                 <a:cs typeface="Calibri"/>
-                <a:hlinkClick xmlns:r="http://schemas.openxmlformats.org/officeDocument/2006/relationships" r:id="Ra4d4a3a31ad84d70"/>
+                <a:hlinkClick xmlns:r="http://schemas.openxmlformats.org/officeDocument/2006/relationships" r:id="R535d12874d514332"/>
               </a:rPr>
               <a:t>github.com/ahansardar/ai-confidence-drift</a:t>
             </a:r>
@@ -5362,7 +4272,7 @@
     </p:spTree>
     <p:extLst>
       <p:ext uri="{BB962C8B-B14F-4D97-AF65-F5344CB8AC3E}">
-        <p14:creationId xmlns:p14="http://schemas.microsoft.com/office/powerpoint/2010/main" val="1177793654"/>
+        <p14:creationId xmlns:p14="http://schemas.microsoft.com/office/powerpoint/2010/main" val="126221422"/>
       </p:ext>
     </p:extLst>
   </p:cSld>
@@ -5393,7 +4303,7 @@
           <p:cNvPr id="10" name="Confident errors">
             <a:extLst xmlns:a="http://schemas.openxmlformats.org/drawingml/2006/main">
               <a:ext uri="{FF2B5EF4-FFF2-40B4-BE49-F238E27FC236}">
-                <a16:creationId xmlns:a16="http://schemas.microsoft.com/office/drawing/2014/main" id="{7771F88F-0AA7-4511-BAF5-987D757D5C8A}"/>
+                <a16:creationId xmlns:a16="http://schemas.microsoft.com/office/drawing/2014/main" id="{6B61BBFA-794F-417F-8A97-9C721621ADBF}"/>
               </a:ext>
             </a:extLst>
           </p:cNvPr>
@@ -5450,7 +4360,7 @@
           <p:cNvPr id="2" name="10">
             <a:extLst xmlns:a="http://schemas.openxmlformats.org/drawingml/2006/main">
               <a:ext uri="{FF2B5EF4-FFF2-40B4-BE49-F238E27FC236}">
-                <a16:creationId xmlns:a16="http://schemas.microsoft.com/office/drawing/2014/main" id="{070E258F-568F-430F-8AD0-EE84A8FA1830}"/>
+                <a16:creationId xmlns:a16="http://schemas.microsoft.com/office/drawing/2014/main" id="{940A5B27-CB6C-46AB-B59A-84729A41F4E2}"/>
               </a:ext>
             </a:extLst>
           </p:cNvPr>
@@ -5507,7 +4417,7 @@
           <p:cNvPr id="3" name="6 of 100">
             <a:extLst xmlns:a="http://schemas.openxmlformats.org/drawingml/2006/main">
               <a:ext uri="{FF2B5EF4-FFF2-40B4-BE49-F238E27FC236}">
-                <a16:creationId xmlns:a16="http://schemas.microsoft.com/office/drawing/2014/main" id="{501D24A5-431C-496F-878D-03F110172987}"/>
+                <a16:creationId xmlns:a16="http://schemas.microsoft.com/office/drawing/2014/main" id="{6AA2187C-7D71-42F6-8BBB-38E40523560E}"/>
               </a:ext>
             </a:extLst>
           </p:cNvPr>
@@ -5564,7 +4474,7 @@
           <p:cNvPr id="4" name="high-confidence predictions were wrong">
             <a:extLst xmlns:a="http://schemas.openxmlformats.org/drawingml/2006/main">
               <a:ext uri="{FF2B5EF4-FFF2-40B4-BE49-F238E27FC236}">
-                <a16:creationId xmlns:a16="http://schemas.microsoft.com/office/drawing/2014/main" id="{4446FA19-865C-4844-A195-65B6E462C855}"/>
+                <a16:creationId xmlns:a16="http://schemas.microsoft.com/office/drawing/2014/main" id="{BA82D965-C791-4895-B7A9-A0E7A7F11C1E}"/>
               </a:ext>
             </a:extLst>
           </p:cNvPr>
@@ -5621,7 +4531,7 @@
           <p:cNvPr id="5" name="100 of 439 predictions reached at least 75% confid">
             <a:extLst xmlns:a="http://schemas.openxmlformats.org/drawingml/2006/main">
               <a:ext uri="{FF2B5EF4-FFF2-40B4-BE49-F238E27FC236}">
-                <a16:creationId xmlns:a16="http://schemas.microsoft.com/office/drawing/2014/main" id="{0CCE2CDD-2096-427C-97D1-ACA3A37EFF51}"/>
+                <a16:creationId xmlns:a16="http://schemas.microsoft.com/office/drawing/2014/main" id="{C13C7CCF-F1E3-4EF3-B46E-B1919F3BE5EF}"/>
               </a:ext>
             </a:extLst>
           </p:cNvPr>
@@ -5701,7 +4611,7 @@
           <p:cNvPr id="6" name="All six errors">
             <a:extLst xmlns:a="http://schemas.openxmlformats.org/drawingml/2006/main">
               <a:ext uri="{FF2B5EF4-FFF2-40B4-BE49-F238E27FC236}">
-                <a16:creationId xmlns:a16="http://schemas.microsoft.com/office/drawing/2014/main" id="{3792CA3F-EE7C-48DC-A79E-51AFB9D344AC}"/>
+                <a16:creationId xmlns:a16="http://schemas.microsoft.com/office/drawing/2014/main" id="{3FE7DA8B-E13C-4BDA-B14C-DE467A91322A}"/>
               </a:ext>
             </a:extLst>
           </p:cNvPr>
@@ -5758,7 +4668,7 @@
           <p:cNvPr id="7" name="True label: alt.atheism&#10;Predicted: soc.religion.ch">
             <a:extLst xmlns:a="http://schemas.openxmlformats.org/drawingml/2006/main">
               <a:ext uri="{FF2B5EF4-FFF2-40B4-BE49-F238E27FC236}">
-                <a16:creationId xmlns:a16="http://schemas.microsoft.com/office/drawing/2014/main" id="{0F9D5374-2324-4EE2-96AE-7B4115FEDABE}"/>
+                <a16:creationId xmlns:a16="http://schemas.microsoft.com/office/drawing/2014/main" id="{F0E6F112-6803-43EC-8697-4EAEFC58A7C6}"/>
               </a:ext>
             </a:extLst>
           </p:cNvPr>
@@ -5835,10 +4745,10 @@
       </p:sp>
       <p:sp>
         <p:nvSpPr>
-          <p:cNvPr id="8" name="Possible explanation">
+          <p:cNvPr id="8" name="Detector check">
             <a:extLst xmlns:a="http://schemas.openxmlformats.org/drawingml/2006/main">
               <a:ext uri="{FF2B5EF4-FFF2-40B4-BE49-F238E27FC236}">
-                <a16:creationId xmlns:a16="http://schemas.microsoft.com/office/drawing/2014/main" id="{F9B277EC-9EA0-4B86-BCBE-CFE5641AF92E}"/>
+                <a16:creationId xmlns:a16="http://schemas.microsoft.com/office/drawing/2014/main" id="{903AAD08-9F64-46E9-AB64-35E8DA538EB8}"/>
               </a:ext>
             </a:extLst>
           </p:cNvPr>
@@ -5885,17 +4795,17 @@
                 <a:ea typeface="Calibri"/>
                 <a:cs typeface="Calibri"/>
               </a:rPr>
-              <a:t>Possible explanation</a:t>
-            </a:r>
-          </a:p>
-        </p:txBody>
-      </p:sp>
-      <p:sp>
-        <p:nvSpPr>
-          <p:cNvPr id="9" name="Quoted scripture may confuse TF-IDF/bigrams.&#10;This ">
+              <a:t>Detector check</a:t>
+            </a:r>
+          </a:p>
+        </p:txBody>
+      </p:sp>
+      <p:sp>
+        <p:nvSpPr>
+          <p:cNvPr id="9" name="It caught 0 of these 6 errors in five-fold,&#10;docume">
             <a:extLst xmlns:a="http://schemas.openxmlformats.org/drawingml/2006/main">
               <a:ext uri="{FF2B5EF4-FFF2-40B4-BE49-F238E27FC236}">
-                <a16:creationId xmlns:a16="http://schemas.microsoft.com/office/drawing/2014/main" id="{E24879F6-1ABE-4E45-A1DC-6EF583A8EABC}"/>
+                <a16:creationId xmlns:a16="http://schemas.microsoft.com/office/drawing/2014/main" id="{F7C7C4DF-AB2D-4619-B6A3-A028DFEF7A03}"/>
               </a:ext>
             </a:extLst>
           </p:cNvPr>
@@ -5942,7 +4852,7 @@
                 <a:ea typeface="Calibri"/>
                 <a:cs typeface="Calibri"/>
               </a:rPr>
-              <a:t>Quoted scripture may confuse TF-IDF/bigrams.</a:t>
+              <a:t>It caught 0 of these 6 errors in five-fold,</a:t>
             </a:r>
           </a:p>
           <a:p xmlns:a="http://schemas.openxmlformats.org/drawingml/2006/main">
@@ -5965,7 +4875,7 @@
                 <a:ea typeface="Calibri"/>
                 <a:cs typeface="Calibri"/>
               </a:rPr>
-              <a:t>This explanation remains unproven.</a:t>
+              <a:t>document-grouped out-of-fold testing.</a:t>
             </a:r>
           </a:p>
         </p:txBody>
@@ -5973,7 +4883,7 @@
     </p:spTree>
     <p:extLst>
       <p:ext uri="{BB962C8B-B14F-4D97-AF65-F5344CB8AC3E}">
-        <p14:creationId xmlns:p14="http://schemas.microsoft.com/office/powerpoint/2010/main" val="1750867807"/>
+        <p14:creationId xmlns:p14="http://schemas.microsoft.com/office/powerpoint/2010/main" val="493952526"/>
       </p:ext>
     </p:extLst>
   </p:cSld>
@@ -6004,7 +4914,7 @@
           <p:cNvPr id="11" name="What drift features add">
             <a:extLst xmlns:a="http://schemas.openxmlformats.org/drawingml/2006/main">
               <a:ext uri="{FF2B5EF4-FFF2-40B4-BE49-F238E27FC236}">
-                <a16:creationId xmlns:a16="http://schemas.microsoft.com/office/drawing/2014/main" id="{A3CD9FEF-2A9F-4CF9-9354-D0113B6E6A73}"/>
+                <a16:creationId xmlns:a16="http://schemas.microsoft.com/office/drawing/2014/main" id="{D8D349D9-E637-4496-BED5-CB4E7AF597D8}"/>
               </a:ext>
             </a:extLst>
           </p:cNvPr>
@@ -6061,7 +4971,7 @@
           <p:cNvPr id="2" name="11">
             <a:extLst xmlns:a="http://schemas.openxmlformats.org/drawingml/2006/main">
               <a:ext uri="{FF2B5EF4-FFF2-40B4-BE49-F238E27FC236}">
-                <a16:creationId xmlns:a16="http://schemas.microsoft.com/office/drawing/2014/main" id="{A9146436-335E-4337-8C51-C0E971870977}"/>
+                <a16:creationId xmlns:a16="http://schemas.microsoft.com/office/drawing/2014/main" id="{9B33622D-6443-4734-A70D-06297767A822}"/>
               </a:ext>
             </a:extLst>
           </p:cNvPr>
@@ -6115,10 +5025,10 @@
       </p:sp>
       <p:sp>
         <p:nvSpPr>
-          <p:cNvPr id="3" name="Same document-level train/test split across all th">
+          <p:cNvPr id="3" name="Pooled out-of-fold results · five document-grouped">
             <a:extLst xmlns:a="http://schemas.openxmlformats.org/drawingml/2006/main">
               <a:ext uri="{FF2B5EF4-FFF2-40B4-BE49-F238E27FC236}">
-                <a16:creationId xmlns:a16="http://schemas.microsoft.com/office/drawing/2014/main" id="{5E651469-2104-42E3-8AAB-A54AA4021410}"/>
+                <a16:creationId xmlns:a16="http://schemas.microsoft.com/office/drawing/2014/main" id="{C38E96F8-5420-4071-9833-7E22FA80D6CD}"/>
               </a:ext>
             </a:extLst>
           </p:cNvPr>
@@ -6165,7 +5075,7 @@
                 <a:ea typeface="Calibri"/>
                 <a:cs typeface="Calibri"/>
               </a:rPr>
-              <a:t>Same document-level train/test split across all three experiments</a:t>
+              <a:t>Pooled out-of-fold results · five document-grouped folds</a:t>
             </a:r>
           </a:p>
         </p:txBody>
@@ -6339,7 +5249,7 @@
                           <a:ea typeface="Calibri"/>
                           <a:cs typeface="Calibri"/>
                         </a:rPr>
-                        <a:t>Step + corruption level only</a:t>
+                        <a:t>Corruption context</a:t>
                       </a:r>
                     </a:p>
                   </a:txBody>
@@ -6365,7 +5275,7 @@
                           <a:ea typeface="Calibri"/>
                           <a:cs typeface="Calibri"/>
                         </a:rPr>
-                        <a:t>0.253</a:t>
+                        <a:t>0.296</a:t>
                       </a:r>
                     </a:p>
                   </a:txBody>
@@ -6391,7 +5301,7 @@
                           <a:ea typeface="Calibri"/>
                           <a:cs typeface="Calibri"/>
                         </a:rPr>
-                        <a:t>0.508</a:t>
+                        <a:t>0.509</a:t>
                       </a:r>
                     </a:p>
                   </a:txBody>
@@ -6445,7 +5355,7 @@
                           <a:ea typeface="Calibri"/>
                           <a:cs typeface="Calibri"/>
                         </a:rPr>
-                        <a:t>Single-point confidence</a:t>
+                        <a:t>A + current confidence</a:t>
                       </a:r>
                     </a:p>
                   </a:txBody>
@@ -6471,7 +5381,7 @@
                           <a:ea typeface="Calibri"/>
                           <a:cs typeface="Calibri"/>
                         </a:rPr>
-                        <a:t>0.443</a:t>
+                        <a:t>0.468</a:t>
                       </a:r>
                     </a:p>
                   </a:txBody>
@@ -6497,7 +5407,7 @@
                           <a:ea typeface="Calibri"/>
                           <a:cs typeface="Calibri"/>
                         </a:rPr>
-                        <a:t>0.741</a:t>
+                        <a:t>0.729</a:t>
                       </a:r>
                     </a:p>
                   </a:txBody>
@@ -6551,7 +5461,7 @@
                           <a:ea typeface="Calibri"/>
                           <a:cs typeface="Calibri"/>
                         </a:rPr>
-                        <a:t>Full confidence-drift features</a:t>
+                        <a:t>B + nine history features</a:t>
                       </a:r>
                     </a:p>
                   </a:txBody>
@@ -6577,7 +5487,7 @@
                           <a:ea typeface="Calibri"/>
                           <a:cs typeface="Calibri"/>
                         </a:rPr>
-                        <a:t>0.483</a:t>
+                        <a:t>0.508</a:t>
                       </a:r>
                     </a:p>
                   </a:txBody>
@@ -6603,7 +5513,7 @@
                           <a:ea typeface="Calibri"/>
                           <a:cs typeface="Calibri"/>
                         </a:rPr>
-                        <a:t>0.787</a:t>
+                        <a:t>0.763</a:t>
                       </a:r>
                     </a:p>
                   </a:txBody>
@@ -6620,10 +5530,10 @@
       </p:graphicFrame>
       <p:sp>
         <p:nvSpPr>
-          <p:cNvPr id="5" name="+0.230">
+          <p:cNvPr id="5" name="+0.040">
             <a:extLst xmlns:a="http://schemas.openxmlformats.org/drawingml/2006/main">
               <a:ext uri="{FF2B5EF4-FFF2-40B4-BE49-F238E27FC236}">
-                <a16:creationId xmlns:a16="http://schemas.microsoft.com/office/drawing/2014/main" id="{DC67C38A-562A-4197-A37E-33F9B86384FC}"/>
+                <a16:creationId xmlns:a16="http://schemas.microsoft.com/office/drawing/2014/main" id="{9CD04769-D772-4079-AA2C-537EFFFD27B8}"/>
               </a:ext>
             </a:extLst>
           </p:cNvPr>
@@ -6670,17 +5580,17 @@
                 <a:ea typeface="Georgia"/>
                 <a:cs typeface="Georgia"/>
               </a:rPr>
-              <a:t>+0.230</a:t>
-            </a:r>
-          </a:p>
-        </p:txBody>
-      </p:sp>
-      <p:sp>
-        <p:nvSpPr>
-          <p:cNvPr id="6" name="F1 improvement, A to C">
+              <a:t>+0.040</a:t>
+            </a:r>
+          </a:p>
+        </p:txBody>
+      </p:sp>
+      <p:sp>
+        <p:nvSpPr>
+          <p:cNvPr id="6" name="F1 improvement, B to C">
             <a:extLst xmlns:a="http://schemas.openxmlformats.org/drawingml/2006/main">
               <a:ext uri="{FF2B5EF4-FFF2-40B4-BE49-F238E27FC236}">
-                <a16:creationId xmlns:a16="http://schemas.microsoft.com/office/drawing/2014/main" id="{D0C81AEB-204B-4D9E-A405-F720F31B51A5}"/>
+                <a16:creationId xmlns:a16="http://schemas.microsoft.com/office/drawing/2014/main" id="{CA69062F-BF06-48F0-95EA-A64179EB2CDC}"/>
               </a:ext>
             </a:extLst>
           </p:cNvPr>
@@ -6727,17 +5637,17 @@
                 <a:ea typeface="Calibri"/>
                 <a:cs typeface="Calibri"/>
               </a:rPr>
-              <a:t>F1 improvement, A to C</a:t>
-            </a:r>
-          </a:p>
-        </p:txBody>
-      </p:sp>
-      <p:sp>
-        <p:nvSpPr>
-          <p:cNvPr id="7" name="+0.279">
+              <a:t>F1 improvement, B to C</a:t>
+            </a:r>
+          </a:p>
+        </p:txBody>
+      </p:sp>
+      <p:sp>
+        <p:nvSpPr>
+          <p:cNvPr id="7" name="+0.034">
             <a:extLst xmlns:a="http://schemas.openxmlformats.org/drawingml/2006/main">
               <a:ext uri="{FF2B5EF4-FFF2-40B4-BE49-F238E27FC236}">
-                <a16:creationId xmlns:a16="http://schemas.microsoft.com/office/drawing/2014/main" id="{C87525F8-1CB2-4B57-AF82-FFBAE6F1F0CF}"/>
+                <a16:creationId xmlns:a16="http://schemas.microsoft.com/office/drawing/2014/main" id="{B584DB53-3574-4FA7-8A2A-34DFBE440C89}"/>
               </a:ext>
             </a:extLst>
           </p:cNvPr>
@@ -6784,17 +5694,17 @@
                 <a:ea typeface="Georgia"/>
                 <a:cs typeface="Georgia"/>
               </a:rPr>
-              <a:t>+0.279</a:t>
-            </a:r>
-          </a:p>
-        </p:txBody>
-      </p:sp>
-      <p:sp>
-        <p:nvSpPr>
-          <p:cNvPr id="8" name="ROC-AUC improvement, A to C">
+              <a:t>+0.034</a:t>
+            </a:r>
+          </a:p>
+        </p:txBody>
+      </p:sp>
+      <p:sp>
+        <p:nvSpPr>
+          <p:cNvPr id="8" name="ROC-AUC improvement, B to C">
             <a:extLst xmlns:a="http://schemas.openxmlformats.org/drawingml/2006/main">
               <a:ext uri="{FF2B5EF4-FFF2-40B4-BE49-F238E27FC236}">
-                <a16:creationId xmlns:a16="http://schemas.microsoft.com/office/drawing/2014/main" id="{739A5F43-1DD0-49C9-9466-F2BD5F6BAA07}"/>
+                <a16:creationId xmlns:a16="http://schemas.microsoft.com/office/drawing/2014/main" id="{9B8ACBC2-B0CD-44B1-AF9F-513307B6E821}"/>
               </a:ext>
             </a:extLst>
           </p:cNvPr>
@@ -6841,17 +5751,17 @@
                 <a:ea typeface="Calibri"/>
                 <a:cs typeface="Calibri"/>
               </a:rPr>
-              <a:t>ROC-AUC improvement, A to C</a:t>
-            </a:r>
-          </a:p>
-        </p:txBody>
-      </p:sp>
-      <p:sp>
-        <p:nvSpPr>
-          <p:cNvPr id="9" name="F1 = 0.483&#10;leaves room to improve.">
+              <a:t>ROC-AUC improvement, B to C</a:t>
+            </a:r>
+          </a:p>
+        </p:txBody>
+      </p:sp>
+      <p:sp>
+        <p:nvSpPr>
+          <p:cNvPr id="9" name="History adds a&#10;modest gain.">
             <a:extLst xmlns:a="http://schemas.openxmlformats.org/drawingml/2006/main">
               <a:ext uri="{FF2B5EF4-FFF2-40B4-BE49-F238E27FC236}">
-                <a16:creationId xmlns:a16="http://schemas.microsoft.com/office/drawing/2014/main" id="{3B4458EE-3E94-4D4C-B28B-6AFAE5DB7C64}"/>
+                <a16:creationId xmlns:a16="http://schemas.microsoft.com/office/drawing/2014/main" id="{237E0698-56E7-4550-BAF5-9502C5AB1E5F}"/>
               </a:ext>
             </a:extLst>
           </p:cNvPr>
@@ -6898,7 +5808,7 @@
                 <a:ea typeface="Calibri"/>
                 <a:cs typeface="Calibri"/>
               </a:rPr>
-              <a:t>F1 = 0.483</a:t>
+              <a:t>History adds a</a:t>
             </a:r>
           </a:p>
           <a:p xmlns:a="http://schemas.openxmlformats.org/drawingml/2006/main">
@@ -6921,17 +5831,17 @@
                 <a:ea typeface="Calibri"/>
                 <a:cs typeface="Calibri"/>
               </a:rPr>
-              <a:t>leaves room to improve.</a:t>
-            </a:r>
-          </a:p>
-        </p:txBody>
-      </p:sp>
-      <p:sp>
-        <p:nvSpPr>
-          <p:cNvPr id="10" name="Logistic Regression shown. Random Forest and Gradi">
+              <a:t>modest gain.</a:t>
+            </a:r>
+          </a:p>
+        </p:txBody>
+      </p:sp>
+      <p:sp>
+        <p:nvSpPr>
+          <p:cNvPr id="10" name="The separate 110-document holdout showed a smaller">
             <a:extLst xmlns:a="http://schemas.openxmlformats.org/drawingml/2006/main">
               <a:ext uri="{FF2B5EF4-FFF2-40B4-BE49-F238E27FC236}">
-                <a16:creationId xmlns:a16="http://schemas.microsoft.com/office/drawing/2014/main" id="{CF3441F6-44A1-47F9-9140-A64E84BCD9EF}"/>
+                <a16:creationId xmlns:a16="http://schemas.microsoft.com/office/drawing/2014/main" id="{3E80B188-BB73-419B-9A94-93FDFC6144DF}"/>
               </a:ext>
             </a:extLst>
           </p:cNvPr>
@@ -6960,7 +5870,7 @@
           <a:lstStyle xmlns:a="http://schemas.openxmlformats.org/drawingml/2006/main"/>
           <a:p xmlns:a="http://schemas.openxmlformats.org/drawingml/2006/main">
             <a:pPr algn="l">
-              <a:defRPr sz="1275" b="0" i="0">
+              <a:defRPr sz="1350" b="0" i="0">
                 <a:solidFill>
                   <a:srgbClr val="636761"/>
                 </a:solidFill>
@@ -6970,7 +5880,7 @@
               </a:defRPr>
             </a:pPr>
             <a:r>
-              <a:rPr sz="1275" b="0" i="0">
+              <a:rPr sz="1350" b="0" i="0">
                 <a:solidFill>
                   <a:srgbClr val="636761"/>
                 </a:solidFill>
@@ -6978,7 +5888,7 @@
                 <a:ea typeface="Calibri"/>
                 <a:cs typeface="Calibri"/>
               </a:rPr>
-              <a:t>Logistic Regression shown. Random Forest and Gradient Boosting reached comparable F1 of 0.47–0.49 with the full feature set.</a:t>
+              <a:t>The separate 110-document holdout showed a smaller B-to-C F1 gain: 0.447 to 0.457.</a:t>
             </a:r>
           </a:p>
         </p:txBody>
@@ -6986,7 +5896,7 @@
     </p:spTree>
     <p:extLst>
       <p:ext uri="{BB962C8B-B14F-4D97-AF65-F5344CB8AC3E}">
-        <p14:creationId xmlns:p14="http://schemas.microsoft.com/office/powerpoint/2010/main" val="1640900389"/>
+        <p14:creationId xmlns:p14="http://schemas.microsoft.com/office/powerpoint/2010/main" val="2063240006"/>
       </p:ext>
     </p:extLst>
   </p:cSld>
@@ -7017,7 +5927,7 @@
           <p:cNvPr id="15" name="Four findings">
             <a:extLst xmlns:a="http://schemas.openxmlformats.org/drawingml/2006/main">
               <a:ext uri="{FF2B5EF4-FFF2-40B4-BE49-F238E27FC236}">
-                <a16:creationId xmlns:a16="http://schemas.microsoft.com/office/drawing/2014/main" id="{D5437C93-D33D-403B-9771-210D77B6EADA}"/>
+                <a16:creationId xmlns:a16="http://schemas.microsoft.com/office/drawing/2014/main" id="{69A84393-AB2F-416C-833C-74A2A916121A}"/>
               </a:ext>
             </a:extLst>
           </p:cNvPr>
@@ -7074,7 +5984,7 @@
           <p:cNvPr id="2" name="12">
             <a:extLst xmlns:a="http://schemas.openxmlformats.org/drawingml/2006/main">
               <a:ext uri="{FF2B5EF4-FFF2-40B4-BE49-F238E27FC236}">
-                <a16:creationId xmlns:a16="http://schemas.microsoft.com/office/drawing/2014/main" id="{B721511D-2205-46F8-BC93-A4DE8946018C}"/>
+                <a16:creationId xmlns:a16="http://schemas.microsoft.com/office/drawing/2014/main" id="{9B75AC04-6739-44A2-9A71-7BF6CB7AA6E8}"/>
               </a:ext>
             </a:extLst>
           </p:cNvPr>
@@ -7131,7 +6041,7 @@
           <p:cNvPr id="3" name="63.5–93.3%">
             <a:extLst xmlns:a="http://schemas.openxmlformats.org/drawingml/2006/main">
               <a:ext uri="{FF2B5EF4-FFF2-40B4-BE49-F238E27FC236}">
-                <a16:creationId xmlns:a16="http://schemas.microsoft.com/office/drawing/2014/main" id="{F946196B-A14D-41F3-918B-9FA865018774}"/>
+                <a16:creationId xmlns:a16="http://schemas.microsoft.com/office/drawing/2014/main" id="{77F29170-0B37-49AC-A314-58F98B41B087}"/>
               </a:ext>
             </a:extLst>
           </p:cNvPr>
@@ -7188,7 +6098,7 @@
           <p:cNvPr id="4" name="Confidence carries useful signal">
             <a:extLst xmlns:a="http://schemas.openxmlformats.org/drawingml/2006/main">
               <a:ext uri="{FF2B5EF4-FFF2-40B4-BE49-F238E27FC236}">
-                <a16:creationId xmlns:a16="http://schemas.microsoft.com/office/drawing/2014/main" id="{3959A28C-81D5-4E49-9629-A316989F98D0}"/>
+                <a16:creationId xmlns:a16="http://schemas.microsoft.com/office/drawing/2014/main" id="{ED88334E-18B4-452F-A438-D55CCEFDB888}"/>
               </a:ext>
             </a:extLst>
           </p:cNvPr>
@@ -7245,7 +6155,7 @@
           <p:cNvPr id="5" name="Accuracy rises across the confidence bins.">
             <a:extLst xmlns:a="http://schemas.openxmlformats.org/drawingml/2006/main">
               <a:ext uri="{FF2B5EF4-FFF2-40B4-BE49-F238E27FC236}">
-                <a16:creationId xmlns:a16="http://schemas.microsoft.com/office/drawing/2014/main" id="{299C33E1-6F44-48D5-ACF3-0437E8767C95}"/>
+                <a16:creationId xmlns:a16="http://schemas.microsoft.com/office/drawing/2014/main" id="{2FC3AE8D-9AB6-409B-AAAD-20B654784BBA}"/>
               </a:ext>
             </a:extLst>
           </p:cNvPr>
@@ -7302,7 +6212,7 @@
           <p:cNvPr id="6" name="6%">
             <a:extLst xmlns:a="http://schemas.openxmlformats.org/drawingml/2006/main">
               <a:ext uri="{FF2B5EF4-FFF2-40B4-BE49-F238E27FC236}">
-                <a16:creationId xmlns:a16="http://schemas.microsoft.com/office/drawing/2014/main" id="{5F713238-AC63-4640-A439-A4EAF3BE9095}"/>
+                <a16:creationId xmlns:a16="http://schemas.microsoft.com/office/drawing/2014/main" id="{F643B2AB-B18A-432A-B588-21B005A0B6DE}"/>
               </a:ext>
             </a:extLst>
           </p:cNvPr>
@@ -7359,7 +6269,7 @@
           <p:cNvPr id="7" name="High confidence can still be wrong">
             <a:extLst xmlns:a="http://schemas.openxmlformats.org/drawingml/2006/main">
               <a:ext uri="{FF2B5EF4-FFF2-40B4-BE49-F238E27FC236}">
-                <a16:creationId xmlns:a16="http://schemas.microsoft.com/office/drawing/2014/main" id="{6F199822-7C40-4B40-857C-9BDC4AC1EBAD}"/>
+                <a16:creationId xmlns:a16="http://schemas.microsoft.com/office/drawing/2014/main" id="{9CF76A06-C382-44BE-B4AA-218878DCE815}"/>
               </a:ext>
             </a:extLst>
           </p:cNvPr>
@@ -7413,10 +6323,10 @@
       </p:sp>
       <p:sp>
         <p:nvSpPr>
-          <p:cNvPr id="8" name="Calibration error is 0.153.">
+          <p:cNvPr id="8" name="Six of 100 predictions at 75%+ confidence were wro">
             <a:extLst xmlns:a="http://schemas.openxmlformats.org/drawingml/2006/main">
               <a:ext uri="{FF2B5EF4-FFF2-40B4-BE49-F238E27FC236}">
-                <a16:creationId xmlns:a16="http://schemas.microsoft.com/office/drawing/2014/main" id="{EE50EC52-E149-4780-80CD-DA24DBD34DD5}"/>
+                <a16:creationId xmlns:a16="http://schemas.microsoft.com/office/drawing/2014/main" id="{E950F613-2F76-4495-AAC7-644504ADA4F9}"/>
               </a:ext>
             </a:extLst>
           </p:cNvPr>
@@ -7463,17 +6373,17 @@
                 <a:ea typeface="Calibri"/>
                 <a:cs typeface="Calibri"/>
               </a:rPr>
-              <a:t>Calibration error is 0.153.</a:t>
-            </a:r>
-          </a:p>
-        </p:txBody>
-      </p:sp>
-      <p:sp>
-        <p:nvSpPr>
-          <p:cNvPr id="9" name="≈ 0.04">
+              <a:t>Six of 100 predictions at 75%+ confidence were wrong.</a:t>
+            </a:r>
+          </a:p>
+        </p:txBody>
+      </p:sp>
+      <p:sp>
+        <p:nvSpPr>
+          <p:cNvPr id="9" name="r = 0.09">
             <a:extLst xmlns:a="http://schemas.openxmlformats.org/drawingml/2006/main">
               <a:ext uri="{FF2B5EF4-FFF2-40B4-BE49-F238E27FC236}">
-                <a16:creationId xmlns:a16="http://schemas.microsoft.com/office/drawing/2014/main" id="{B3BECBEC-A8B5-4489-8166-5A4E34DEF6D7}"/>
+                <a16:creationId xmlns:a16="http://schemas.microsoft.com/office/drawing/2014/main" id="{B658530E-F54F-483F-BE73-5AF53A439206}"/>
               </a:ext>
             </a:extLst>
           </p:cNvPr>
@@ -7520,7 +6430,7 @@
                 <a:ea typeface="Georgia"/>
                 <a:cs typeface="Georgia"/>
               </a:rPr>
-              <a:t>≈ 0.04</a:t>
+              <a:t>r = 0.09</a:t>
             </a:r>
           </a:p>
         </p:txBody>
@@ -7530,7 +6440,7 @@
           <p:cNvPr id="10" name="Net drift is a weak predictor">
             <a:extLst xmlns:a="http://schemas.openxmlformats.org/drawingml/2006/main">
               <a:ext uri="{FF2B5EF4-FFF2-40B4-BE49-F238E27FC236}">
-                <a16:creationId xmlns:a16="http://schemas.microsoft.com/office/drawing/2014/main" id="{B845CA41-6BC6-4274-B437-37ED74CBC693}"/>
+                <a16:creationId xmlns:a16="http://schemas.microsoft.com/office/drawing/2014/main" id="{D3EBD776-1D5F-410C-B7DB-6956B8FC0BC2}"/>
               </a:ext>
             </a:extLst>
           </p:cNvPr>
@@ -7584,10 +6494,10 @@
       </p:sp>
       <p:sp>
         <p:nvSpPr>
-          <p:cNvPr id="11" name="Correlation with becoming incorrect is close to ze">
+          <p:cNvPr id="11" name="Correlation with becoming incorrect is small.">
             <a:extLst xmlns:a="http://schemas.openxmlformats.org/drawingml/2006/main">
               <a:ext uri="{FF2B5EF4-FFF2-40B4-BE49-F238E27FC236}">
-                <a16:creationId xmlns:a16="http://schemas.microsoft.com/office/drawing/2014/main" id="{0051E781-94AA-4621-9BD0-B022A80B3CED}"/>
+                <a16:creationId xmlns:a16="http://schemas.microsoft.com/office/drawing/2014/main" id="{5AF479A2-3F12-4CDF-857B-E9AEE9FDC324}"/>
               </a:ext>
             </a:extLst>
           </p:cNvPr>
@@ -7634,17 +6544,17 @@
                 <a:ea typeface="Calibri"/>
                 <a:cs typeface="Calibri"/>
               </a:rPr>
-              <a:t>Correlation with becoming incorrect is close to zero.</a:t>
-            </a:r>
-          </a:p>
-        </p:txBody>
-      </p:sp>
-      <p:sp>
-        <p:nvSpPr>
-          <p:cNvPr id="12" name="0.25 to 0.48">
+              <a:t>Correlation with becoming incorrect is small.</a:t>
+            </a:r>
+          </a:p>
+        </p:txBody>
+      </p:sp>
+      <p:sp>
+        <p:nvSpPr>
+          <p:cNvPr id="12" name="+0.040 F1">
             <a:extLst xmlns:a="http://schemas.openxmlformats.org/drawingml/2006/main">
               <a:ext uri="{FF2B5EF4-FFF2-40B4-BE49-F238E27FC236}">
-                <a16:creationId xmlns:a16="http://schemas.microsoft.com/office/drawing/2014/main" id="{91D393A3-E5B4-4E46-BBE8-4C437D4C91D6}"/>
+                <a16:creationId xmlns:a16="http://schemas.microsoft.com/office/drawing/2014/main" id="{F6EB8811-124E-40FC-B5CC-ACFC54B25C99}"/>
               </a:ext>
             </a:extLst>
           </p:cNvPr>
@@ -7691,17 +6601,17 @@
                 <a:ea typeface="Georgia"/>
                 <a:cs typeface="Georgia"/>
               </a:rPr>
-              <a:t>0.25 to 0.48</a:t>
-            </a:r>
-          </a:p>
-        </p:txBody>
-      </p:sp>
-      <p:sp>
-        <p:nvSpPr>
-          <p:cNvPr id="13" name="The sequence features improve detection">
+              <a:t>+0.040 F1</a:t>
+            </a:r>
+          </a:p>
+        </p:txBody>
+      </p:sp>
+      <p:sp>
+        <p:nvSpPr>
+          <p:cNvPr id="13" name="History adds a modest gain">
             <a:extLst xmlns:a="http://schemas.openxmlformats.org/drawingml/2006/main">
               <a:ext uri="{FF2B5EF4-FFF2-40B4-BE49-F238E27FC236}">
-                <a16:creationId xmlns:a16="http://schemas.microsoft.com/office/drawing/2014/main" id="{16A8B5F6-6AC3-4EBC-AF76-A3248290AB0D}"/>
+                <a16:creationId xmlns:a16="http://schemas.microsoft.com/office/drawing/2014/main" id="{210E52E9-2553-4193-8D14-BC4B59AB56A2}"/>
               </a:ext>
             </a:extLst>
           </p:cNvPr>
@@ -7748,17 +6658,17 @@
                 <a:ea typeface="Calibri"/>
                 <a:cs typeface="Calibri"/>
               </a:rPr>
-              <a:t>The sequence features improve detection</a:t>
-            </a:r>
-          </a:p>
-        </p:txBody>
-      </p:sp>
-      <p:sp>
-        <p:nvSpPr>
-          <p:cNvPr id="14" name="F1 improves across A to C. ROC-AUC rises from 0.51">
+              <a:t>History adds a modest gain</a:t>
+            </a:r>
+          </a:p>
+        </p:txBody>
+      </p:sp>
+      <p:sp>
+        <p:nvSpPr>
+          <p:cNvPr id="14" name="F1 rises from 0.468 to 0.508 after current confide">
             <a:extLst xmlns:a="http://schemas.openxmlformats.org/drawingml/2006/main">
               <a:ext uri="{FF2B5EF4-FFF2-40B4-BE49-F238E27FC236}">
-                <a16:creationId xmlns:a16="http://schemas.microsoft.com/office/drawing/2014/main" id="{79CA6043-A419-4D35-81C1-A5F0209DE4B7}"/>
+                <a16:creationId xmlns:a16="http://schemas.microsoft.com/office/drawing/2014/main" id="{EEA93DE7-118E-454A-A7E6-FBD6FFD6736B}"/>
               </a:ext>
             </a:extLst>
           </p:cNvPr>
@@ -7805,7 +6715,7 @@
                 <a:ea typeface="Calibri"/>
                 <a:cs typeface="Calibri"/>
               </a:rPr>
-              <a:t>F1 improves across A to C. ROC-AUC rises from 0.51 to 0.79.</a:t>
+              <a:t>F1 rises from 0.468 to 0.508 after current confidence.</a:t>
             </a:r>
           </a:p>
         </p:txBody>
@@ -7813,7 +6723,7 @@
     </p:spTree>
     <p:extLst>
       <p:ext uri="{BB962C8B-B14F-4D97-AF65-F5344CB8AC3E}">
-        <p14:creationId xmlns:p14="http://schemas.microsoft.com/office/powerpoint/2010/main" val="1186374813"/>
+        <p14:creationId xmlns:p14="http://schemas.microsoft.com/office/powerpoint/2010/main" val="13959630"/>
       </p:ext>
     </p:extLst>
   </p:cSld>
@@ -7844,7 +6754,7 @@
           <p:cNvPr id="13" name="Limitations and next steps">
             <a:extLst xmlns:a="http://schemas.openxmlformats.org/drawingml/2006/main">
               <a:ext uri="{FF2B5EF4-FFF2-40B4-BE49-F238E27FC236}">
-                <a16:creationId xmlns:a16="http://schemas.microsoft.com/office/drawing/2014/main" id="{2424214C-6B3F-4F58-A1CA-BEC43F8E0662}"/>
+                <a16:creationId xmlns:a16="http://schemas.microsoft.com/office/drawing/2014/main" id="{E6524154-0498-4CD5-BF81-C69EB0025537}"/>
               </a:ext>
             </a:extLst>
           </p:cNvPr>
@@ -7901,7 +6811,7 @@
           <p:cNvPr id="2" name="13">
             <a:extLst xmlns:a="http://schemas.openxmlformats.org/drawingml/2006/main">
               <a:ext uri="{FF2B5EF4-FFF2-40B4-BE49-F238E27FC236}">
-                <a16:creationId xmlns:a16="http://schemas.microsoft.com/office/drawing/2014/main" id="{C9E68E0F-2EBA-4D8A-A26F-92FC398ACCE4}"/>
+                <a16:creationId xmlns:a16="http://schemas.microsoft.com/office/drawing/2014/main" id="{7B32C710-1802-4762-BF81-46F29F2CE6AF}"/>
               </a:ext>
             </a:extLst>
           </p:cNvPr>
@@ -7958,7 +6868,7 @@
           <p:cNvPr id="3" name="Limits of this study">
             <a:extLst xmlns:a="http://schemas.openxmlformats.org/drawingml/2006/main">
               <a:ext uri="{FF2B5EF4-FFF2-40B4-BE49-F238E27FC236}">
-                <a16:creationId xmlns:a16="http://schemas.microsoft.com/office/drawing/2014/main" id="{E8543C95-7443-4A1C-A5AD-DC614576A7C8}"/>
+                <a16:creationId xmlns:a16="http://schemas.microsoft.com/office/drawing/2014/main" id="{553F5ABE-B03B-4748-A62F-58CBE398661F}"/>
               </a:ext>
             </a:extLst>
           </p:cNvPr>
@@ -8015,7 +6925,7 @@
           <p:cNvPr id="4" name="What I would test next">
             <a:extLst xmlns:a="http://schemas.openxmlformats.org/drawingml/2006/main">
               <a:ext uri="{FF2B5EF4-FFF2-40B4-BE49-F238E27FC236}">
-                <a16:creationId xmlns:a16="http://schemas.microsoft.com/office/drawing/2014/main" id="{673FC507-C3EC-4456-85FD-1BA981657681}"/>
+                <a16:creationId xmlns:a16="http://schemas.microsoft.com/office/drawing/2014/main" id="{CEEE6AF2-7B7B-47F9-8203-4A7518BEEA40}"/>
               </a:ext>
             </a:extLst>
           </p:cNvPr>
@@ -8072,7 +6982,7 @@
           <p:cNvPr id="5" name="Text corruption simulates repeated predictions. Re">
             <a:extLst xmlns:a="http://schemas.openxmlformats.org/drawingml/2006/main">
               <a:ext uri="{FF2B5EF4-FFF2-40B4-BE49-F238E27FC236}">
-                <a16:creationId xmlns:a16="http://schemas.microsoft.com/office/drawing/2014/main" id="{8262B59A-1E76-4A6C-9087-EF015A749840}"/>
+                <a16:creationId xmlns:a16="http://schemas.microsoft.com/office/drawing/2014/main" id="{A38D171C-636B-43D3-9412-06F014F433A1}"/>
               </a:ext>
             </a:extLst>
           </p:cNvPr>
@@ -8126,10 +7036,10 @@
       </p:sp>
       <p:sp>
         <p:nvSpPr>
-          <p:cNvPr id="6" name="Only 439 test documents. Some confidence bins cont">
+          <p:cNvPr id="6" name="Only 439 test documents. The top calibration bin h">
             <a:extLst xmlns:a="http://schemas.openxmlformats.org/drawingml/2006/main">
               <a:ext uri="{FF2B5EF4-FFF2-40B4-BE49-F238E27FC236}">
-                <a16:creationId xmlns:a16="http://schemas.microsoft.com/office/drawing/2014/main" id="{6770C4C7-70FC-4797-BEA5-9E399C8E544A}"/>
+                <a16:creationId xmlns:a16="http://schemas.microsoft.com/office/drawing/2014/main" id="{2972B4F4-9777-4C84-BAEE-F8A7782D9035}"/>
               </a:ext>
             </a:extLst>
           </p:cNvPr>
@@ -8176,7 +7086,7 @@
                 <a:ea typeface="Calibri"/>
                 <a:cs typeface="Calibri"/>
               </a:rPr>
-              <a:t>Only 439 test documents. Some confidence bins contain very few samples.</a:t>
+              <a:t>Only 439 test documents. The top calibration bin has 10 predictions.</a:t>
             </a:r>
           </a:p>
         </p:txBody>
@@ -8186,7 +7096,7 @@
           <p:cNvPr id="7" name="Two classes and one base model architecture.">
             <a:extLst xmlns:a="http://schemas.openxmlformats.org/drawingml/2006/main">
               <a:ext uri="{FF2B5EF4-FFF2-40B4-BE49-F238E27FC236}">
-                <a16:creationId xmlns:a16="http://schemas.microsoft.com/office/drawing/2014/main" id="{0E113920-E910-41B3-A71D-FF5D45DE31D6}"/>
+                <a16:creationId xmlns:a16="http://schemas.microsoft.com/office/drawing/2014/main" id="{8EB236B7-6054-4E45-BD65-4797E2A3FC33}"/>
               </a:ext>
             </a:extLst>
           </p:cNvPr>
@@ -8240,10 +7150,10 @@
       </p:sp>
       <p:sp>
         <p:nvSpPr>
-          <p:cNvPr id="8" name="Detector F1 is about 0.48, so many predictions rem">
+          <p:cNvPr id="8" name="The detector missed all six high-confidence errors">
             <a:extLst xmlns:a="http://schemas.openxmlformats.org/drawingml/2006/main">
               <a:ext uri="{FF2B5EF4-FFF2-40B4-BE49-F238E27FC236}">
-                <a16:creationId xmlns:a16="http://schemas.microsoft.com/office/drawing/2014/main" id="{AB52B4CC-4231-4661-8232-A5B25057902A}"/>
+                <a16:creationId xmlns:a16="http://schemas.microsoft.com/office/drawing/2014/main" id="{B215E46C-D8D4-45E8-9CAC-C18A5BE6EE75}"/>
               </a:ext>
             </a:extLst>
           </p:cNvPr>
@@ -8290,17 +7200,17 @@
                 <a:ea typeface="Calibri"/>
                 <a:cs typeface="Calibri"/>
               </a:rPr>
-              <a:t>Detector F1 is about 0.48, so many predictions remain missed or mislabeled.</a:t>
-            </a:r>
-          </a:p>
-        </p:txBody>
-      </p:sp>
-      <p:sp>
-        <p:nvSpPr>
-          <p:cNvPr id="9" name="Evaluate a neural text classifier to test whether ">
+              <a:t>The detector missed all six high-confidence errors on uncorrupted text.</a:t>
+            </a:r>
+          </a:p>
+        </p:txBody>
+      </p:sp>
+      <p:sp>
+        <p:nvSpPr>
+          <p:cNvPr id="9" name="Test a method designed for high-confidence errors ">
             <a:extLst xmlns:a="http://schemas.openxmlformats.org/drawingml/2006/main">
               <a:ext uri="{FF2B5EF4-FFF2-40B4-BE49-F238E27FC236}">
-                <a16:creationId xmlns:a16="http://schemas.microsoft.com/office/drawing/2014/main" id="{3752B308-00F9-4C50-AD9B-9238B005CF7E}"/>
+                <a16:creationId xmlns:a16="http://schemas.microsoft.com/office/drawing/2014/main" id="{20FF5979-F674-45C9-AD9C-19DED937633D}"/>
               </a:ext>
             </a:extLst>
           </p:cNvPr>
@@ -8347,7 +7257,7 @@
                 <a:ea typeface="Calibri"/>
                 <a:cs typeface="Calibri"/>
               </a:rPr>
-              <a:t>Evaluate a neural text classifier to test whether drift features still help.</a:t>
+              <a:t>Test a method designed for high-confidence errors at the uncorrupted step.</a:t>
             </a:r>
           </a:p>
         </p:txBody>
@@ -8357,7 +7267,7 @@
           <p:cNvPr id="10" name="Collect naturally repeated real-world queries when">
             <a:extLst xmlns:a="http://schemas.openxmlformats.org/drawingml/2006/main">
               <a:ext uri="{FF2B5EF4-FFF2-40B4-BE49-F238E27FC236}">
-                <a16:creationId xmlns:a16="http://schemas.microsoft.com/office/drawing/2014/main" id="{CCCBD2A0-9F75-492A-829B-6633F413AF58}"/>
+                <a16:creationId xmlns:a16="http://schemas.microsoft.com/office/drawing/2014/main" id="{F06125FD-7E2A-45B6-9488-43FCB83B4C37}"/>
               </a:ext>
             </a:extLst>
           </p:cNvPr>
@@ -8411,10 +7321,10 @@
       </p:sp>
       <p:sp>
         <p:nvSpPr>
-          <p:cNvPr id="11" name="Apply temperature scaling and measure what drift f">
+          <p:cNvPr id="11" name="Apply temperature scaling and retest whether histo">
             <a:extLst xmlns:a="http://schemas.openxmlformats.org/drawingml/2006/main">
               <a:ext uri="{FF2B5EF4-FFF2-40B4-BE49-F238E27FC236}">
-                <a16:creationId xmlns:a16="http://schemas.microsoft.com/office/drawing/2014/main" id="{BC6AA5AE-3329-4C4C-A165-E9C1DCA70B10}"/>
+                <a16:creationId xmlns:a16="http://schemas.microsoft.com/office/drawing/2014/main" id="{A3B6B378-296C-4E21-9EF4-EC3FD278A8EC}"/>
               </a:ext>
             </a:extLst>
           </p:cNvPr>
@@ -8461,17 +7371,17 @@
                 <a:ea typeface="Calibri"/>
                 <a:cs typeface="Calibri"/>
               </a:rPr>
-              <a:t>Apply temperature scaling and measure what drift features add after calibration.</a:t>
-            </a:r>
-          </a:p>
-        </p:txBody>
-      </p:sp>
-      <p:sp>
-        <p:nvSpPr>
-          <p:cNvPr id="12" name="Extend to multiple classes with richer margin and ">
+              <a:t>Apply temperature scaling and retest whether history adds value.</a:t>
+            </a:r>
+          </a:p>
+        </p:txBody>
+      </p:sp>
+      <p:sp>
+        <p:nvSpPr>
+          <p:cNvPr id="12" name="Extend to multiple classes and another base model.">
             <a:extLst xmlns:a="http://schemas.openxmlformats.org/drawingml/2006/main">
               <a:ext uri="{FF2B5EF4-FFF2-40B4-BE49-F238E27FC236}">
-                <a16:creationId xmlns:a16="http://schemas.microsoft.com/office/drawing/2014/main" id="{7CBB013A-13E8-45A7-AF2E-8F36E5564B13}"/>
+                <a16:creationId xmlns:a16="http://schemas.microsoft.com/office/drawing/2014/main" id="{13DF28F6-B380-4534-9486-A85436EF91F9}"/>
               </a:ext>
             </a:extLst>
           </p:cNvPr>
@@ -8518,7 +7428,7 @@
                 <a:ea typeface="Calibri"/>
                 <a:cs typeface="Calibri"/>
               </a:rPr>
-              <a:t>Extend to multiple classes with richer margin and entropy features.</a:t>
+              <a:t>Extend to multiple classes and another base model.</a:t>
             </a:r>
           </a:p>
         </p:txBody>
@@ -8526,7 +7436,7 @@
     </p:spTree>
     <p:extLst>
       <p:ext uri="{BB962C8B-B14F-4D97-AF65-F5344CB8AC3E}">
-        <p14:creationId xmlns:p14="http://schemas.microsoft.com/office/powerpoint/2010/main" val="2139979184"/>
+        <p14:creationId xmlns:p14="http://schemas.microsoft.com/office/powerpoint/2010/main" val="2073602562"/>
       </p:ext>
     </p:extLst>
   </p:cSld>
@@ -8557,7 +7467,7 @@
           <p:cNvPr id="10" name="14">
             <a:extLst xmlns:a="http://schemas.openxmlformats.org/drawingml/2006/main">
               <a:ext uri="{FF2B5EF4-FFF2-40B4-BE49-F238E27FC236}">
-                <a16:creationId xmlns:a16="http://schemas.microsoft.com/office/drawing/2014/main" id="{823D9931-639E-4B5A-8246-D9782F3C183B}"/>
+                <a16:creationId xmlns:a16="http://schemas.microsoft.com/office/drawing/2014/main" id="{66C7AE21-7BF9-4803-8677-9AF55F0E883C}"/>
               </a:ext>
             </a:extLst>
           </p:cNvPr>
@@ -8614,7 +7524,7 @@
           <p:cNvPr id="2" name="CONCLUSION">
             <a:extLst xmlns:a="http://schemas.openxmlformats.org/drawingml/2006/main">
               <a:ext uri="{FF2B5EF4-FFF2-40B4-BE49-F238E27FC236}">
-                <a16:creationId xmlns:a16="http://schemas.microsoft.com/office/drawing/2014/main" id="{87FF95EE-81A1-4C89-9531-EFACD36130E9}"/>
+                <a16:creationId xmlns:a16="http://schemas.microsoft.com/office/drawing/2014/main" id="{C730E0AE-7E65-4FDB-8F2C-38891A4249B3}"/>
               </a:ext>
             </a:extLst>
           </p:cNvPr>
@@ -8668,10 +7578,10 @@
       </p:sp>
       <p:sp>
         <p:nvSpPr>
-          <p:cNvPr id="3" name="The shape of confidence">
+          <p:cNvPr id="3" name="Confidence history adds">
             <a:extLst xmlns:a="http://schemas.openxmlformats.org/drawingml/2006/main">
               <a:ext uri="{FF2B5EF4-FFF2-40B4-BE49-F238E27FC236}">
-                <a16:creationId xmlns:a16="http://schemas.microsoft.com/office/drawing/2014/main" id="{5E6C7C6B-4C43-4614-9594-3519A6D12456}"/>
+                <a16:creationId xmlns:a16="http://schemas.microsoft.com/office/drawing/2014/main" id="{72919D20-9B99-49B0-A8E5-D227E1471FA7}"/>
               </a:ext>
             </a:extLst>
           </p:cNvPr>
@@ -8718,17 +7628,17 @@
                 <a:ea typeface="Georgia"/>
                 <a:cs typeface="Georgia"/>
               </a:rPr>
-              <a:t>The shape of confidence</a:t>
-            </a:r>
-          </a:p>
-        </p:txBody>
-      </p:sp>
-      <p:sp>
-        <p:nvSpPr>
-          <p:cNvPr id="4" name="helps identify">
+              <a:t>Confidence history adds</a:t>
+            </a:r>
+          </a:p>
+        </p:txBody>
+      </p:sp>
+      <p:sp>
+        <p:nvSpPr>
+          <p:cNvPr id="4" name="a modest signal.">
             <a:extLst xmlns:a="http://schemas.openxmlformats.org/drawingml/2006/main">
               <a:ext uri="{FF2B5EF4-FFF2-40B4-BE49-F238E27FC236}">
-                <a16:creationId xmlns:a16="http://schemas.microsoft.com/office/drawing/2014/main" id="{4EC2D5F6-C098-4129-8B79-61D8ACEEA33E}"/>
+                <a16:creationId xmlns:a16="http://schemas.microsoft.com/office/drawing/2014/main" id="{019B75D6-E0A0-44E5-881A-9DCFCC6595C9}"/>
               </a:ext>
             </a:extLst>
           </p:cNvPr>
@@ -8757,9 +7667,9 @@
           <a:lstStyle xmlns:a="http://schemas.openxmlformats.org/drawingml/2006/main"/>
           <a:p xmlns:a="http://schemas.openxmlformats.org/drawingml/2006/main">
             <a:pPr algn="l">
-              <a:defRPr sz="5025" b="0" i="0">
-                <a:solidFill>
-                  <a:srgbClr val="292B28"/>
+              <a:defRPr sz="5025" b="0" i="1">
+                <a:solidFill>
+                  <a:srgbClr val="8B4C3B"/>
                 </a:solidFill>
                 <a:latin typeface="Georgia"/>
                 <a:ea typeface="Georgia"/>
@@ -8767,25 +7677,25 @@
               </a:defRPr>
             </a:pPr>
             <a:r>
-              <a:rPr sz="5025" b="0" i="0">
-                <a:solidFill>
-                  <a:srgbClr val="292B28"/>
+              <a:rPr sz="5025" b="0" i="1">
+                <a:solidFill>
+                  <a:srgbClr val="8B4C3B"/>
                 </a:solidFill>
                 <a:latin typeface="Georgia"/>
                 <a:ea typeface="Georgia"/>
                 <a:cs typeface="Georgia"/>
               </a:rPr>
-              <a:t>helps identify</a:t>
-            </a:r>
-          </a:p>
-        </p:txBody>
-      </p:sp>
-      <p:sp>
-        <p:nvSpPr>
-          <p:cNvPr id="5" name="unreliable predictions.">
+              <a:t>a modest signal.</a:t>
+            </a:r>
+          </a:p>
+        </p:txBody>
+      </p:sp>
+      <p:sp>
+        <p:nvSpPr>
+          <p:cNvPr id="5" name="The hardest errors remain.">
             <a:extLst xmlns:a="http://schemas.openxmlformats.org/drawingml/2006/main">
               <a:ext uri="{FF2B5EF4-FFF2-40B4-BE49-F238E27FC236}">
-                <a16:creationId xmlns:a16="http://schemas.microsoft.com/office/drawing/2014/main" id="{69658D52-831A-4DFB-8801-964C33596CE4}"/>
+                <a16:creationId xmlns:a16="http://schemas.microsoft.com/office/drawing/2014/main" id="{7BD7430D-DBC7-4E81-960F-9CF5F7A75246}"/>
               </a:ext>
             </a:extLst>
           </p:cNvPr>
@@ -8814,9 +7724,9 @@
           <a:lstStyle xmlns:a="http://schemas.openxmlformats.org/drawingml/2006/main"/>
           <a:p xmlns:a="http://schemas.openxmlformats.org/drawingml/2006/main">
             <a:pPr algn="l">
-              <a:defRPr sz="5400" b="0" i="1">
-                <a:solidFill>
-                  <a:srgbClr val="8B4C3B"/>
+              <a:defRPr sz="4950" b="0" i="0">
+                <a:solidFill>
+                  <a:srgbClr val="292B28"/>
                 </a:solidFill>
                 <a:latin typeface="Georgia"/>
                 <a:ea typeface="Georgia"/>
@@ -8824,25 +7734,25 @@
               </a:defRPr>
             </a:pPr>
             <a:r>
-              <a:rPr sz="5400" b="0" i="1">
-                <a:solidFill>
-                  <a:srgbClr val="8B4C3B"/>
+              <a:rPr sz="4950" b="0" i="0">
+                <a:solidFill>
+                  <a:srgbClr val="292B28"/>
                 </a:solidFill>
                 <a:latin typeface="Georgia"/>
                 <a:ea typeface="Georgia"/>
                 <a:cs typeface="Georgia"/>
               </a:rPr>
-              <a:t>unreliable predictions.</a:t>
-            </a:r>
-          </a:p>
-        </p:txBody>
-      </p:sp>
-      <p:sp>
-        <p:nvSpPr>
-          <p:cNvPr id="6" name="Volatility, moving statistics and consecutive drop">
+              <a:t>The hardest errors remain.</a:t>
+            </a:r>
+          </a:p>
+        </p:txBody>
+      </p:sp>
+      <p:sp>
+        <p:nvSpPr>
+          <p:cNvPr id="6" name="Nine sequence features improve grouped evaluation ">
             <a:extLst xmlns:a="http://schemas.openxmlformats.org/drawingml/2006/main">
               <a:ext uri="{FF2B5EF4-FFF2-40B4-BE49-F238E27FC236}">
-                <a16:creationId xmlns:a16="http://schemas.microsoft.com/office/drawing/2014/main" id="{0E191135-0BB6-432F-AFC0-E7A27F1A49E3}"/>
+                <a16:creationId xmlns:a16="http://schemas.microsoft.com/office/drawing/2014/main" id="{648E94DC-EF98-4C00-82E7-B9524F2E7500}"/>
               </a:ext>
             </a:extLst>
           </p:cNvPr>
@@ -8889,7 +7799,7 @@
                 <a:ea typeface="Calibri"/>
                 <a:cs typeface="Calibri"/>
               </a:rPr>
-              <a:t>Volatility, moving statistics and consecutive drops improve detection.</a:t>
+              <a:t>Nine sequence features improve grouped evaluation over current confidence.</a:t>
             </a:r>
           </a:p>
           <a:p xmlns:a="http://schemas.openxmlformats.org/drawingml/2006/main">
@@ -8912,17 +7822,17 @@
                 <a:ea typeface="Calibri"/>
                 <a:cs typeface="Calibri"/>
               </a:rPr>
-              <a:t>Net drift alone contributes little signal.</a:t>
-            </a:r>
-          </a:p>
-        </p:txBody>
-      </p:sp>
-      <p:sp>
-        <p:nvSpPr>
-          <p:cNvPr id="7" name="F1  0.25 to 0.48">
+              <a:t>The detector caught none of six high-confidence errors.</a:t>
+            </a:r>
+          </a:p>
+        </p:txBody>
+      </p:sp>
+      <p:sp>
+        <p:nvSpPr>
+          <p:cNvPr id="7" name="F1  0.468 to 0.508">
             <a:extLst xmlns:a="http://schemas.openxmlformats.org/drawingml/2006/main">
               <a:ext uri="{FF2B5EF4-FFF2-40B4-BE49-F238E27FC236}">
-                <a16:creationId xmlns:a16="http://schemas.microsoft.com/office/drawing/2014/main" id="{E4A52E5D-952F-4DA8-9019-DB858067C266}"/>
+                <a16:creationId xmlns:a16="http://schemas.microsoft.com/office/drawing/2014/main" id="{A41A6F8C-1A65-4326-B2A8-48AC52A4EDDB}"/>
               </a:ext>
             </a:extLst>
           </p:cNvPr>
@@ -8969,17 +7879,17 @@
                 <a:ea typeface="Georgia"/>
                 <a:cs typeface="Georgia"/>
               </a:rPr>
-              <a:t>F1  0.25 to 0.48</a:t>
-            </a:r>
-          </a:p>
-        </p:txBody>
-      </p:sp>
-      <p:sp>
-        <p:nvSpPr>
-          <p:cNvPr id="8" name="ROC-AUC  0.51 to 0.79">
+              <a:t>F1  0.468 to 0.508</a:t>
+            </a:r>
+          </a:p>
+        </p:txBody>
+      </p:sp>
+      <p:sp>
+        <p:nvSpPr>
+          <p:cNvPr id="8" name="ROC-AUC  0.729 to 0.763">
             <a:extLst xmlns:a="http://schemas.openxmlformats.org/drawingml/2006/main">
               <a:ext uri="{FF2B5EF4-FFF2-40B4-BE49-F238E27FC236}">
-                <a16:creationId xmlns:a16="http://schemas.microsoft.com/office/drawing/2014/main" id="{21391423-CB0A-4883-9DAE-3878BA0A9473}"/>
+                <a16:creationId xmlns:a16="http://schemas.microsoft.com/office/drawing/2014/main" id="{D75EA3E1-8909-4056-80F0-612E7CD77024}"/>
               </a:ext>
             </a:extLst>
           </p:cNvPr>
@@ -9026,7 +7936,7 @@
                 <a:ea typeface="Georgia"/>
                 <a:cs typeface="Georgia"/>
               </a:rPr>
-              <a:t>ROC-AUC  0.51 to 0.79</a:t>
+              <a:t>ROC-AUC  0.729 to 0.763</a:t>
             </a:r>
           </a:p>
         </p:txBody>
@@ -9036,7 +7946,7 @@
           <p:cNvPr id="9" name="Code, data, models and research report: github.com">
             <a:extLst xmlns:a="http://schemas.openxmlformats.org/drawingml/2006/main">
               <a:ext uri="{FF2B5EF4-FFF2-40B4-BE49-F238E27FC236}">
-                <a16:creationId xmlns:a16="http://schemas.microsoft.com/office/drawing/2014/main" id="{D5EBB6A8-C230-43FE-AAFE-465B27659901}"/>
+                <a16:creationId xmlns:a16="http://schemas.microsoft.com/office/drawing/2014/main" id="{55A9E2C2-39E9-4D77-B072-BD6602BD22F9}"/>
               </a:ext>
             </a:extLst>
           </p:cNvPr>
@@ -9093,7 +8003,7 @@
                 <a:latin typeface="Calibri"/>
                 <a:ea typeface="Calibri"/>
                 <a:cs typeface="Calibri"/>
-                <a:hlinkClick xmlns:r="http://schemas.openxmlformats.org/officeDocument/2006/relationships" r:id="R1e50029c3963453f"/>
+                <a:hlinkClick xmlns:r="http://schemas.openxmlformats.org/officeDocument/2006/relationships" r:id="R67b11a05fda04708"/>
               </a:rPr>
               <a:t>github.com/ahansardar/ai-confidence-drift</a:t>
             </a:r>
@@ -9103,7 +8013,7 @@
     </p:spTree>
     <p:extLst>
       <p:ext uri="{BB962C8B-B14F-4D97-AF65-F5344CB8AC3E}">
-        <p14:creationId xmlns:p14="http://schemas.microsoft.com/office/powerpoint/2010/main" val="1444213981"/>
+        <p14:creationId xmlns:p14="http://schemas.microsoft.com/office/powerpoint/2010/main" val="1055261834"/>
       </p:ext>
     </p:extLst>
   </p:cSld>
@@ -9134,7 +8044,7 @@
           <p:cNvPr id="12" name="The confidence problem">
             <a:extLst xmlns:a="http://schemas.openxmlformats.org/drawingml/2006/main">
               <a:ext uri="{FF2B5EF4-FFF2-40B4-BE49-F238E27FC236}">
-                <a16:creationId xmlns:a16="http://schemas.microsoft.com/office/drawing/2014/main" id="{4BA36DDD-D6A8-4414-81F6-3F086D45D805}"/>
+                <a16:creationId xmlns:a16="http://schemas.microsoft.com/office/drawing/2014/main" id="{EDE1C0BE-F1A3-4B0D-A6AD-F5B56C2AC7D7}"/>
               </a:ext>
             </a:extLst>
           </p:cNvPr>
@@ -9191,7 +8101,7 @@
           <p:cNvPr id="2" name="02">
             <a:extLst xmlns:a="http://schemas.openxmlformats.org/drawingml/2006/main">
               <a:ext uri="{FF2B5EF4-FFF2-40B4-BE49-F238E27FC236}">
-                <a16:creationId xmlns:a16="http://schemas.microsoft.com/office/drawing/2014/main" id="{E07B2B3F-E25F-4DD9-9307-AA45DF59F6D6}"/>
+                <a16:creationId xmlns:a16="http://schemas.microsoft.com/office/drawing/2014/main" id="{B1249237-6398-4B93-A2D2-C0F44F59B696}"/>
               </a:ext>
             </a:extLst>
           </p:cNvPr>
@@ -9248,7 +8158,7 @@
           <p:cNvPr id="3" name="96.3%">
             <a:extLst xmlns:a="http://schemas.openxmlformats.org/drawingml/2006/main">
               <a:ext uri="{FF2B5EF4-FFF2-40B4-BE49-F238E27FC236}">
-                <a16:creationId xmlns:a16="http://schemas.microsoft.com/office/drawing/2014/main" id="{A082C642-0751-4FBB-A245-95C074C9F5AD}"/>
+                <a16:creationId xmlns:a16="http://schemas.microsoft.com/office/drawing/2014/main" id="{7981ED07-D296-4EBB-A89E-59FD13E029DE}"/>
               </a:ext>
             </a:extLst>
           </p:cNvPr>
@@ -9305,7 +8215,7 @@
           <p:cNvPr id="4" name="confident. Still wrong.">
             <a:extLst xmlns:a="http://schemas.openxmlformats.org/drawingml/2006/main">
               <a:ext uri="{FF2B5EF4-FFF2-40B4-BE49-F238E27FC236}">
-                <a16:creationId xmlns:a16="http://schemas.microsoft.com/office/drawing/2014/main" id="{24D2DF99-C036-481B-AFE6-BD5538909FBF}"/>
+                <a16:creationId xmlns:a16="http://schemas.microsoft.com/office/drawing/2014/main" id="{5E79AB13-5D64-471B-A773-5724960A7211}"/>
               </a:ext>
             </a:extLst>
           </p:cNvPr>
@@ -9362,7 +8272,7 @@
           <p:cNvPr id="5" name="One observed prediction&#10;Document doc_00750">
             <a:extLst xmlns:a="http://schemas.openxmlformats.org/drawingml/2006/main">
               <a:ext uri="{FF2B5EF4-FFF2-40B4-BE49-F238E27FC236}">
-                <a16:creationId xmlns:a16="http://schemas.microsoft.com/office/drawing/2014/main" id="{1B1E25F1-94ED-430D-9A2B-B685BCBB097F}"/>
+                <a16:creationId xmlns:a16="http://schemas.microsoft.com/office/drawing/2014/main" id="{C4C60060-F820-4275-8907-7522D794A7E4}"/>
               </a:ext>
             </a:extLst>
           </p:cNvPr>
@@ -9442,7 +8352,7 @@
           <p:cNvPr id="6" name="Confident errors">
             <a:extLst xmlns:a="http://schemas.openxmlformats.org/drawingml/2006/main">
               <a:ext uri="{FF2B5EF4-FFF2-40B4-BE49-F238E27FC236}">
-                <a16:creationId xmlns:a16="http://schemas.microsoft.com/office/drawing/2014/main" id="{C768EDEC-530A-4A8F-A5F2-B401862A298E}"/>
+                <a16:creationId xmlns:a16="http://schemas.microsoft.com/office/drawing/2014/main" id="{03DD4331-72D6-4B5C-9A05-845AE0A7CC87}"/>
               </a:ext>
             </a:extLst>
           </p:cNvPr>
@@ -9499,7 +8409,7 @@
           <p:cNvPr id="7" name="A model can be highly confident about an incorrect">
             <a:extLst xmlns:a="http://schemas.openxmlformats.org/drawingml/2006/main">
               <a:ext uri="{FF2B5EF4-FFF2-40B4-BE49-F238E27FC236}">
-                <a16:creationId xmlns:a16="http://schemas.microsoft.com/office/drawing/2014/main" id="{14C27E07-9907-44DF-91A1-C2D58E623C57}"/>
+                <a16:creationId xmlns:a16="http://schemas.microsoft.com/office/drawing/2014/main" id="{B1B2B204-5DF0-46D1-9B9B-BFC772C05DED}"/>
               </a:ext>
             </a:extLst>
           </p:cNvPr>
@@ -9556,7 +8466,7 @@
           <p:cNvPr id="8" name="Unstable confidence">
             <a:extLst xmlns:a="http://schemas.openxmlformats.org/drawingml/2006/main">
               <a:ext uri="{FF2B5EF4-FFF2-40B4-BE49-F238E27FC236}">
-                <a16:creationId xmlns:a16="http://schemas.microsoft.com/office/drawing/2014/main" id="{F72BB235-99E7-4643-AD09-6784CC8D2A02}"/>
+                <a16:creationId xmlns:a16="http://schemas.microsoft.com/office/drawing/2014/main" id="{EAC1EBC5-2E51-440D-8388-439144283196}"/>
               </a:ext>
             </a:extLst>
           </p:cNvPr>
@@ -9613,7 +8523,7 @@
           <p:cNvPr id="9" name="Confidence can change across similar inputs withou">
             <a:extLst xmlns:a="http://schemas.openxmlformats.org/drawingml/2006/main">
               <a:ext uri="{FF2B5EF4-FFF2-40B4-BE49-F238E27FC236}">
-                <a16:creationId xmlns:a16="http://schemas.microsoft.com/office/drawing/2014/main" id="{4BA9E779-8E29-4F52-9188-3EF7336F5D52}"/>
+                <a16:creationId xmlns:a16="http://schemas.microsoft.com/office/drawing/2014/main" id="{AC35C61C-FADD-4BB3-A4A5-E78DE50E6DEC}"/>
               </a:ext>
             </a:extLst>
           </p:cNvPr>
@@ -9670,7 +8580,7 @@
           <p:cNvPr id="10" name="Increasing difficulty">
             <a:extLst xmlns:a="http://schemas.openxmlformats.org/drawingml/2006/main">
               <a:ext uri="{FF2B5EF4-FFF2-40B4-BE49-F238E27FC236}">
-                <a16:creationId xmlns:a16="http://schemas.microsoft.com/office/drawing/2014/main" id="{09C8BDCB-1B14-48A1-BD54-E4C278A13DB6}"/>
+                <a16:creationId xmlns:a16="http://schemas.microsoft.com/office/drawing/2014/main" id="{E1AC62EF-9892-43A2-A531-D12D2C5DBB03}"/>
               </a:ext>
             </a:extLst>
           </p:cNvPr>
@@ -9727,7 +8637,7 @@
           <p:cNvPr id="11" name="Lower confidence may accompany harder inputs. The ">
             <a:extLst xmlns:a="http://schemas.openxmlformats.org/drawingml/2006/main">
               <a:ext uri="{FF2B5EF4-FFF2-40B4-BE49-F238E27FC236}">
-                <a16:creationId xmlns:a16="http://schemas.microsoft.com/office/drawing/2014/main" id="{E9E1C8FE-2306-4FC3-AE06-91727C46E588}"/>
+                <a16:creationId xmlns:a16="http://schemas.microsoft.com/office/drawing/2014/main" id="{7E9F7B7D-AAA6-4899-886C-EA601631EFE9}"/>
               </a:ext>
             </a:extLst>
           </p:cNvPr>
@@ -9782,7 +8692,7 @@
     </p:spTree>
     <p:extLst>
       <p:ext uri="{BB962C8B-B14F-4D97-AF65-F5344CB8AC3E}">
-        <p14:creationId xmlns:p14="http://schemas.microsoft.com/office/powerpoint/2010/main" val="1489014890"/>
+        <p14:creationId xmlns:p14="http://schemas.microsoft.com/office/powerpoint/2010/main" val="104942684"/>
       </p:ext>
     </p:extLst>
   </p:cSld>
@@ -9813,7 +8723,7 @@
           <p:cNvPr id="9" name="Research question">
             <a:extLst xmlns:a="http://schemas.openxmlformats.org/drawingml/2006/main">
               <a:ext uri="{FF2B5EF4-FFF2-40B4-BE49-F238E27FC236}">
-                <a16:creationId xmlns:a16="http://schemas.microsoft.com/office/drawing/2014/main" id="{AB0DC329-EDD5-4B49-85B8-5330D1914296}"/>
+                <a16:creationId xmlns:a16="http://schemas.microsoft.com/office/drawing/2014/main" id="{F87FE71A-24B2-4A8F-B070-09528BFFE35E}"/>
               </a:ext>
             </a:extLst>
           </p:cNvPr>
@@ -9870,7 +8780,7 @@
           <p:cNvPr id="2" name="03">
             <a:extLst xmlns:a="http://schemas.openxmlformats.org/drawingml/2006/main">
               <a:ext uri="{FF2B5EF4-FFF2-40B4-BE49-F238E27FC236}">
-                <a16:creationId xmlns:a16="http://schemas.microsoft.com/office/drawing/2014/main" id="{D1F039A3-D075-427E-859E-9FF7EBB841BE}"/>
+                <a16:creationId xmlns:a16="http://schemas.microsoft.com/office/drawing/2014/main" id="{A4E6D59E-BE80-49C8-85A9-CF1402894D25}"/>
               </a:ext>
             </a:extLst>
           </p:cNvPr>
@@ -9927,7 +8837,7 @@
           <p:cNvPr id="3" name="Can changes in a model’s confidence">
             <a:extLst xmlns:a="http://schemas.openxmlformats.org/drawingml/2006/main">
               <a:ext uri="{FF2B5EF4-FFF2-40B4-BE49-F238E27FC236}">
-                <a16:creationId xmlns:a16="http://schemas.microsoft.com/office/drawing/2014/main" id="{B951DCF4-9C82-4EF2-B948-1F7C73D27302}"/>
+                <a16:creationId xmlns:a16="http://schemas.microsoft.com/office/drawing/2014/main" id="{D1470387-16D9-4D7C-9A68-7767DA6A0DA1}"/>
               </a:ext>
             </a:extLst>
           </p:cNvPr>
@@ -9984,7 +8894,7 @@
           <p:cNvPr id="4" name="help identify predictions that are">
             <a:extLst xmlns:a="http://schemas.openxmlformats.org/drawingml/2006/main">
               <a:ext uri="{FF2B5EF4-FFF2-40B4-BE49-F238E27FC236}">
-                <a16:creationId xmlns:a16="http://schemas.microsoft.com/office/drawing/2014/main" id="{3CC8DCFE-4E28-48E0-BE27-3461CD264A1A}"/>
+                <a16:creationId xmlns:a16="http://schemas.microsoft.com/office/drawing/2014/main" id="{68165677-CC07-4139-8074-75774F88A9CA}"/>
               </a:ext>
             </a:extLst>
           </p:cNvPr>
@@ -10041,7 +8951,7 @@
           <p:cNvPr id="5" name="likely to be unreliable?">
             <a:extLst xmlns:a="http://schemas.openxmlformats.org/drawingml/2006/main">
               <a:ext uri="{FF2B5EF4-FFF2-40B4-BE49-F238E27FC236}">
-                <a16:creationId xmlns:a16="http://schemas.microsoft.com/office/drawing/2014/main" id="{E0687E92-F0D7-4987-8268-F01299F79E71}"/>
+                <a16:creationId xmlns:a16="http://schemas.microsoft.com/office/drawing/2014/main" id="{5EE1F557-B055-4FCD-A7AB-9E6C1AA65DB3}"/>
               </a:ext>
             </a:extLst>
           </p:cNvPr>
@@ -10098,7 +9008,7 @@
           <p:cNvPr id="6" name="The hypothesis">
             <a:extLst xmlns:a="http://schemas.openxmlformats.org/drawingml/2006/main">
               <a:ext uri="{FF2B5EF4-FFF2-40B4-BE49-F238E27FC236}">
-                <a16:creationId xmlns:a16="http://schemas.microsoft.com/office/drawing/2014/main" id="{0F1AA530-75E8-44C8-B06C-1006379A1FD5}"/>
+                <a16:creationId xmlns:a16="http://schemas.microsoft.com/office/drawing/2014/main" id="{7758A7D0-344F-42DA-A4B2-A53DC0ED10E4}"/>
               </a:ext>
             </a:extLst>
           </p:cNvPr>
@@ -10152,10 +9062,10 @@
       </p:sp>
       <p:sp>
         <p:nvSpPr>
-          <p:cNvPr id="7" name="Moving averages, volatility and consecutive drops ">
+          <p:cNvPr id="7" name="Confidence history may help predict errors after a">
             <a:extLst xmlns:a="http://schemas.openxmlformats.org/drawingml/2006/main">
               <a:ext uri="{FF2B5EF4-FFF2-40B4-BE49-F238E27FC236}">
-                <a16:creationId xmlns:a16="http://schemas.microsoft.com/office/drawing/2014/main" id="{E3042C40-18BC-4765-8C93-A4A45F22C4AC}"/>
+                <a16:creationId xmlns:a16="http://schemas.microsoft.com/office/drawing/2014/main" id="{847A2E34-1661-4841-9334-0A60C7F644C8}"/>
               </a:ext>
             </a:extLst>
           </p:cNvPr>
@@ -10202,17 +9112,17 @@
                 <a:ea typeface="Calibri"/>
                 <a:cs typeface="Calibri"/>
               </a:rPr>
-              <a:t>Moving averages, volatility and consecutive drops should outperform a single confidence value and a baseline with no confidence signal.</a:t>
-            </a:r>
-          </a:p>
-        </p:txBody>
-      </p:sp>
-      <p:sp>
-        <p:nvSpPr>
-          <p:cNvPr id="8" name="The experiments test this claim. Net drift and seq">
+              <a:t>Confidence history may help predict errors after accounting for the current confidence value and corruption level.</a:t>
+            </a:r>
+          </a:p>
+        </p:txBody>
+      </p:sp>
+      <p:sp>
+        <p:nvSpPr>
+          <p:cNvPr id="8" name="The A/B/C comparison isolates each additional sour">
             <a:extLst xmlns:a="http://schemas.openxmlformats.org/drawingml/2006/main">
               <a:ext uri="{FF2B5EF4-FFF2-40B4-BE49-F238E27FC236}">
-                <a16:creationId xmlns:a16="http://schemas.microsoft.com/office/drawing/2014/main" id="{6151E42B-7F62-4EBC-A3B2-A430584B12E8}"/>
+                <a16:creationId xmlns:a16="http://schemas.microsoft.com/office/drawing/2014/main" id="{D3310955-0116-4DA0-8660-CBDEC3D0D04B}"/>
               </a:ext>
             </a:extLst>
           </p:cNvPr>
@@ -10259,7 +9169,7 @@
                 <a:ea typeface="Calibri"/>
                 <a:cs typeface="Calibri"/>
               </a:rPr>
-              <a:t>The experiments test this claim. Net drift and sequence shape give different answers.</a:t>
+              <a:t>The A/B/C comparison isolates each additional source of information.</a:t>
             </a:r>
           </a:p>
         </p:txBody>
@@ -10267,7 +9177,7 @@
     </p:spTree>
     <p:extLst>
       <p:ext uri="{BB962C8B-B14F-4D97-AF65-F5344CB8AC3E}">
-        <p14:creationId xmlns:p14="http://schemas.microsoft.com/office/powerpoint/2010/main" val="1160443831"/>
+        <p14:creationId xmlns:p14="http://schemas.microsoft.com/office/powerpoint/2010/main" val="617075785"/>
       </p:ext>
     </p:extLst>
   </p:cSld>
@@ -10298,7 +9208,7 @@
           <p:cNvPr id="13" name="Task and dataset">
             <a:extLst xmlns:a="http://schemas.openxmlformats.org/drawingml/2006/main">
               <a:ext uri="{FF2B5EF4-FFF2-40B4-BE49-F238E27FC236}">
-                <a16:creationId xmlns:a16="http://schemas.microsoft.com/office/drawing/2014/main" id="{10835DB9-2F53-47F6-8056-890CEA3635F1}"/>
+                <a16:creationId xmlns:a16="http://schemas.microsoft.com/office/drawing/2014/main" id="{78053C97-40DD-4E74-B358-7094B38EAF69}"/>
               </a:ext>
             </a:extLst>
           </p:cNvPr>
@@ -10355,7 +9265,7 @@
           <p:cNvPr id="2" name="04">
             <a:extLst xmlns:a="http://schemas.openxmlformats.org/drawingml/2006/main">
               <a:ext uri="{FF2B5EF4-FFF2-40B4-BE49-F238E27FC236}">
-                <a16:creationId xmlns:a16="http://schemas.microsoft.com/office/drawing/2014/main" id="{F44AD48C-6746-4DE1-96C3-28DD87562369}"/>
+                <a16:creationId xmlns:a16="http://schemas.microsoft.com/office/drawing/2014/main" id="{E8F147BB-0690-4A9B-A497-A7B8A32B0DF5}"/>
               </a:ext>
             </a:extLst>
           </p:cNvPr>
@@ -10412,7 +9322,7 @@
           <p:cNvPr id="3" name="1,754">
             <a:extLst xmlns:a="http://schemas.openxmlformats.org/drawingml/2006/main">
               <a:ext uri="{FF2B5EF4-FFF2-40B4-BE49-F238E27FC236}">
-                <a16:creationId xmlns:a16="http://schemas.microsoft.com/office/drawing/2014/main" id="{EB8F8A5F-7B2F-458E-A261-A4618A966224}"/>
+                <a16:creationId xmlns:a16="http://schemas.microsoft.com/office/drawing/2014/main" id="{3B23DDA3-29F4-40C7-B034-87ACB97275E3}"/>
               </a:ext>
             </a:extLst>
           </p:cNvPr>
@@ -10469,7 +9379,7 @@
           <p:cNvPr id="4" name="documents from 20 Newsgroups">
             <a:extLst xmlns:a="http://schemas.openxmlformats.org/drawingml/2006/main">
               <a:ext uri="{FF2B5EF4-FFF2-40B4-BE49-F238E27FC236}">
-                <a16:creationId xmlns:a16="http://schemas.microsoft.com/office/drawing/2014/main" id="{5054450C-2803-4881-90AB-B2D6353F144F}"/>
+                <a16:creationId xmlns:a16="http://schemas.microsoft.com/office/drawing/2014/main" id="{FFB746EF-F497-4716-9907-458F4A9A8592}"/>
               </a:ext>
             </a:extLst>
           </p:cNvPr>
@@ -10526,7 +9436,7 @@
           <p:cNvPr id="5" name="1,315 training / 439 test">
             <a:extLst xmlns:a="http://schemas.openxmlformats.org/drawingml/2006/main">
               <a:ext uri="{FF2B5EF4-FFF2-40B4-BE49-F238E27FC236}">
-                <a16:creationId xmlns:a16="http://schemas.microsoft.com/office/drawing/2014/main" id="{9B8E8353-6995-40FF-BFEC-38ACB8FF1369}"/>
+                <a16:creationId xmlns:a16="http://schemas.microsoft.com/office/drawing/2014/main" id="{B121C03C-5BD6-4AF9-A75B-3FB28D43C7CD}"/>
               </a:ext>
             </a:extLst>
           </p:cNvPr>
@@ -10583,7 +9493,7 @@
           <p:cNvPr id="6" name="Stratified split&#10;44.4% / 55.6% class balance">
             <a:extLst xmlns:a="http://schemas.openxmlformats.org/drawingml/2006/main">
               <a:ext uri="{FF2B5EF4-FFF2-40B4-BE49-F238E27FC236}">
-                <a16:creationId xmlns:a16="http://schemas.microsoft.com/office/drawing/2014/main" id="{9BD638A2-9443-46C7-9CAF-EA3FBBC23FCE}"/>
+                <a16:creationId xmlns:a16="http://schemas.microsoft.com/office/drawing/2014/main" id="{FB942BE4-D181-4505-BCFC-0C48BC98C983}"/>
               </a:ext>
             </a:extLst>
           </p:cNvPr>
@@ -10663,7 +9573,7 @@
           <p:cNvPr id="7" name="Binary text classification">
             <a:extLst xmlns:a="http://schemas.openxmlformats.org/drawingml/2006/main">
               <a:ext uri="{FF2B5EF4-FFF2-40B4-BE49-F238E27FC236}">
-                <a16:creationId xmlns:a16="http://schemas.microsoft.com/office/drawing/2014/main" id="{335BDE31-63CB-4606-AD3D-2CC9B61B9498}"/>
+                <a16:creationId xmlns:a16="http://schemas.microsoft.com/office/drawing/2014/main" id="{F01D5722-3D31-430B-A282-42D43F017BD9}"/>
               </a:ext>
             </a:extLst>
           </p:cNvPr>
@@ -10720,7 +9630,7 @@
           <p:cNvPr id="8" name="alt.atheism&#10;soc.religion.christian">
             <a:extLst xmlns:a="http://schemas.openxmlformats.org/drawingml/2006/main">
               <a:ext uri="{FF2B5EF4-FFF2-40B4-BE49-F238E27FC236}">
-                <a16:creationId xmlns:a16="http://schemas.microsoft.com/office/drawing/2014/main" id="{1E656C05-825A-4BE2-A753-0B7C1BC67B40}"/>
+                <a16:creationId xmlns:a16="http://schemas.microsoft.com/office/drawing/2014/main" id="{935DE137-1184-4614-89B1-19ECBCFF437D}"/>
               </a:ext>
             </a:extLst>
           </p:cNvPr>
@@ -10800,7 +9710,7 @@
           <p:cNvPr id="9" name="Overlapping vocabulary makes the task less trivial">
             <a:extLst xmlns:a="http://schemas.openxmlformats.org/drawingml/2006/main">
               <a:ext uri="{FF2B5EF4-FFF2-40B4-BE49-F238E27FC236}">
-                <a16:creationId xmlns:a16="http://schemas.microsoft.com/office/drawing/2014/main" id="{94AFBDC7-F79C-497D-A72F-6DA2B21D43F9}"/>
+                <a16:creationId xmlns:a16="http://schemas.microsoft.com/office/drawing/2014/main" id="{AB9A64F3-7CCC-480F-8B15-5E6740AE255D}"/>
               </a:ext>
             </a:extLst>
           </p:cNvPr>
@@ -10857,7 +9767,7 @@
           <p:cNvPr id="10" name="Headers, footers and quoted text removed to reduce">
             <a:extLst xmlns:a="http://schemas.openxmlformats.org/drawingml/2006/main">
               <a:ext uri="{FF2B5EF4-FFF2-40B4-BE49-F238E27FC236}">
-                <a16:creationId xmlns:a16="http://schemas.microsoft.com/office/drawing/2014/main" id="{5688CA65-D206-46F9-8ED7-6972F20F425F}"/>
+                <a16:creationId xmlns:a16="http://schemas.microsoft.com/office/drawing/2014/main" id="{00A255C1-9953-4622-93AD-77C10125B485}"/>
               </a:ext>
             </a:extLst>
           </p:cNvPr>
@@ -10914,7 +9824,7 @@
           <p:cNvPr id="11" name="Ground truth: the newsgroup that published each po">
             <a:extLst xmlns:a="http://schemas.openxmlformats.org/drawingml/2006/main">
               <a:ext uri="{FF2B5EF4-FFF2-40B4-BE49-F238E27FC236}">
-                <a16:creationId xmlns:a16="http://schemas.microsoft.com/office/drawing/2014/main" id="{326AEBE7-4D11-4735-9B7C-AA7E53159942}"/>
+                <a16:creationId xmlns:a16="http://schemas.microsoft.com/office/drawing/2014/main" id="{7E05A0B1-ABE1-4899-A48F-B785911732F8}"/>
               </a:ext>
             </a:extLst>
           </p:cNvPr>
@@ -10971,7 +9881,7 @@
           <p:cNvPr id="12" name="Source: scikit-learn’s official 20 Newsgroups mirr">
             <a:extLst xmlns:a="http://schemas.openxmlformats.org/drawingml/2006/main">
               <a:ext uri="{FF2B5EF4-FFF2-40B4-BE49-F238E27FC236}">
-                <a16:creationId xmlns:a16="http://schemas.microsoft.com/office/drawing/2014/main" id="{F47E6505-3D56-4636-811C-ABDC7C2FB313}"/>
+                <a16:creationId xmlns:a16="http://schemas.microsoft.com/office/drawing/2014/main" id="{1AA3A766-5BAD-44DC-A4D1-16388D85FD4B}"/>
               </a:ext>
             </a:extLst>
           </p:cNvPr>
@@ -11026,7 +9936,7 @@
     </p:spTree>
     <p:extLst>
       <p:ext uri="{BB962C8B-B14F-4D97-AF65-F5344CB8AC3E}">
-        <p14:creationId xmlns:p14="http://schemas.microsoft.com/office/powerpoint/2010/main" val="1135624636"/>
+        <p14:creationId xmlns:p14="http://schemas.microsoft.com/office/powerpoint/2010/main" val="1540017393"/>
       </p:ext>
     </p:extLst>
   </p:cSld>
@@ -11057,7 +9967,7 @@
           <p:cNvPr id="18" name="The research pipeline">
             <a:extLst xmlns:a="http://schemas.openxmlformats.org/drawingml/2006/main">
               <a:ext uri="{FF2B5EF4-FFF2-40B4-BE49-F238E27FC236}">
-                <a16:creationId xmlns:a16="http://schemas.microsoft.com/office/drawing/2014/main" id="{43B6839B-0564-4F8C-967E-D295EAD3CB51}"/>
+                <a16:creationId xmlns:a16="http://schemas.microsoft.com/office/drawing/2014/main" id="{22B4A6A4-B504-4249-B16D-9C3A1261F4A1}"/>
               </a:ext>
             </a:extLst>
           </p:cNvPr>
@@ -11114,7 +10024,7 @@
           <p:cNvPr id="2" name="05">
             <a:extLst xmlns:a="http://schemas.openxmlformats.org/drawingml/2006/main">
               <a:ext uri="{FF2B5EF4-FFF2-40B4-BE49-F238E27FC236}">
-                <a16:creationId xmlns:a16="http://schemas.microsoft.com/office/drawing/2014/main" id="{97FA119E-4E23-4247-9796-253D701F1E3F}"/>
+                <a16:creationId xmlns:a16="http://schemas.microsoft.com/office/drawing/2014/main" id="{1C5A271E-18C3-48DC-A622-B1D1E0CCFEF1}"/>
               </a:ext>
             </a:extLst>
           </p:cNvPr>
@@ -11171,7 +10081,7 @@
           <p:cNvPr id="3" name="01">
             <a:extLst xmlns:a="http://schemas.openxmlformats.org/drawingml/2006/main">
               <a:ext uri="{FF2B5EF4-FFF2-40B4-BE49-F238E27FC236}">
-                <a16:creationId xmlns:a16="http://schemas.microsoft.com/office/drawing/2014/main" id="{D6C709F4-6532-4817-9B6C-D72A17AFE03A}"/>
+                <a16:creationId xmlns:a16="http://schemas.microsoft.com/office/drawing/2014/main" id="{A232D765-EE3A-413B-9A5E-440878244717}"/>
               </a:ext>
             </a:extLst>
           </p:cNvPr>
@@ -11228,7 +10138,7 @@
           <p:cNvPr id="4" name="Train the base classifier">
             <a:extLst xmlns:a="http://schemas.openxmlformats.org/drawingml/2006/main">
               <a:ext uri="{FF2B5EF4-FFF2-40B4-BE49-F238E27FC236}">
-                <a16:creationId xmlns:a16="http://schemas.microsoft.com/office/drawing/2014/main" id="{20D7E5DD-529C-4996-AA7F-527260AA7F76}"/>
+                <a16:creationId xmlns:a16="http://schemas.microsoft.com/office/drawing/2014/main" id="{0B3F0E1F-F4A3-4872-88DA-B138427F3A0F}"/>
               </a:ext>
             </a:extLst>
           </p:cNvPr>
@@ -11285,7 +10195,7 @@
           <p:cNvPr id="5" name="TF-IDF + Logistic Regression for text classificati">
             <a:extLst xmlns:a="http://schemas.openxmlformats.org/drawingml/2006/main">
               <a:ext uri="{FF2B5EF4-FFF2-40B4-BE49-F238E27FC236}">
-                <a16:creationId xmlns:a16="http://schemas.microsoft.com/office/drawing/2014/main" id="{449E58F6-C77B-4D57-959A-DA54EBFC2B49}"/>
+                <a16:creationId xmlns:a16="http://schemas.microsoft.com/office/drawing/2014/main" id="{12FEAD71-C409-4E15-8536-FDBA11F472B0}"/>
               </a:ext>
             </a:extLst>
           </p:cNvPr>
@@ -11342,7 +10252,7 @@
           <p:cNvPr id="6" name="02">
             <a:extLst xmlns:a="http://schemas.openxmlformats.org/drawingml/2006/main">
               <a:ext uri="{FF2B5EF4-FFF2-40B4-BE49-F238E27FC236}">
-                <a16:creationId xmlns:a16="http://schemas.microsoft.com/office/drawing/2014/main" id="{BC2B5562-1983-46D3-96AB-DC1C0C1DD66A}"/>
+                <a16:creationId xmlns:a16="http://schemas.microsoft.com/office/drawing/2014/main" id="{B6874D0B-F9C1-4CC8-B896-14CD48EB981C}"/>
               </a:ext>
             </a:extLst>
           </p:cNvPr>
@@ -11399,7 +10309,7 @@
           <p:cNvPr id="7" name="Generate confidence sequences">
             <a:extLst xmlns:a="http://schemas.openxmlformats.org/drawingml/2006/main">
               <a:ext uri="{FF2B5EF4-FFF2-40B4-BE49-F238E27FC236}">
-                <a16:creationId xmlns:a16="http://schemas.microsoft.com/office/drawing/2014/main" id="{A3DCB61B-C5F3-4372-B30A-14DB4DC82715}"/>
+                <a16:creationId xmlns:a16="http://schemas.microsoft.com/office/drawing/2014/main" id="{71DD21EB-3DD7-491C-8564-BB07907E2480}"/>
               </a:ext>
             </a:extLst>
           </p:cNvPr>
@@ -11456,7 +10366,7 @@
           <p:cNvPr id="8" name="Re-classify each test document at six corruption l">
             <a:extLst xmlns:a="http://schemas.openxmlformats.org/drawingml/2006/main">
               <a:ext uri="{FF2B5EF4-FFF2-40B4-BE49-F238E27FC236}">
-                <a16:creationId xmlns:a16="http://schemas.microsoft.com/office/drawing/2014/main" id="{415615E3-132A-432B-9C9E-0F1B8F2488E0}"/>
+                <a16:creationId xmlns:a16="http://schemas.microsoft.com/office/drawing/2014/main" id="{264635BD-73F9-4B66-8DF2-A1950BDD71FA}"/>
               </a:ext>
             </a:extLst>
           </p:cNvPr>
@@ -11513,7 +10423,7 @@
           <p:cNvPr id="9" name="03">
             <a:extLst xmlns:a="http://schemas.openxmlformats.org/drawingml/2006/main">
               <a:ext uri="{FF2B5EF4-FFF2-40B4-BE49-F238E27FC236}">
-                <a16:creationId xmlns:a16="http://schemas.microsoft.com/office/drawing/2014/main" id="{857D702B-A571-4CB7-B1B2-5A4DF49E8D91}"/>
+                <a16:creationId xmlns:a16="http://schemas.microsoft.com/office/drawing/2014/main" id="{7131CB61-16C7-49B7-AFA8-D0ADE053336B}"/>
               </a:ext>
             </a:extLst>
           </p:cNvPr>
@@ -11570,7 +10480,7 @@
           <p:cNvPr id="10" name="Engineer drift features">
             <a:extLst xmlns:a="http://schemas.openxmlformats.org/drawingml/2006/main">
               <a:ext uri="{FF2B5EF4-FFF2-40B4-BE49-F238E27FC236}">
-                <a16:creationId xmlns:a16="http://schemas.microsoft.com/office/drawing/2014/main" id="{3A498911-B0AA-4B9A-909D-D39ABC02F35B}"/>
+                <a16:creationId xmlns:a16="http://schemas.microsoft.com/office/drawing/2014/main" id="{6827626A-1A69-476E-887F-3D11C3CB5E85}"/>
               </a:ext>
             </a:extLst>
           </p:cNvPr>
@@ -11627,7 +10537,7 @@
           <p:cNvPr id="11" name="Moving statistics, deltas, consecutive drops and m">
             <a:extLst xmlns:a="http://schemas.openxmlformats.org/drawingml/2006/main">
               <a:ext uri="{FF2B5EF4-FFF2-40B4-BE49-F238E27FC236}">
-                <a16:creationId xmlns:a16="http://schemas.microsoft.com/office/drawing/2014/main" id="{AD7290B0-ADFE-4235-9669-5DB0AD4503C3}"/>
+                <a16:creationId xmlns:a16="http://schemas.microsoft.com/office/drawing/2014/main" id="{1ED59C98-AB32-4083-9C93-B9B1147BB0D2}"/>
               </a:ext>
             </a:extLst>
           </p:cNvPr>
@@ -11684,7 +10594,7 @@
           <p:cNvPr id="12" name="04">
             <a:extLst xmlns:a="http://schemas.openxmlformats.org/drawingml/2006/main">
               <a:ext uri="{FF2B5EF4-FFF2-40B4-BE49-F238E27FC236}">
-                <a16:creationId xmlns:a16="http://schemas.microsoft.com/office/drawing/2014/main" id="{1ECA1E91-65AF-466B-9643-3152D09123D9}"/>
+                <a16:creationId xmlns:a16="http://schemas.microsoft.com/office/drawing/2014/main" id="{A0992451-7C24-40C0-8CD8-52345904C7A9}"/>
               </a:ext>
             </a:extLst>
           </p:cNvPr>
@@ -11741,7 +10651,7 @@
           <p:cNvPr id="13" name="Train a second model">
             <a:extLst xmlns:a="http://schemas.openxmlformats.org/drawingml/2006/main">
               <a:ext uri="{FF2B5EF4-FFF2-40B4-BE49-F238E27FC236}">
-                <a16:creationId xmlns:a16="http://schemas.microsoft.com/office/drawing/2014/main" id="{ECAA4A6E-C3F1-4BEF-BEB8-40DA5FC4D3BF}"/>
+                <a16:creationId xmlns:a16="http://schemas.microsoft.com/office/drawing/2014/main" id="{402AD468-29EA-4606-96D0-CA1FDDE75127}"/>
               </a:ext>
             </a:extLst>
           </p:cNvPr>
@@ -11798,7 +10708,7 @@
           <p:cNvPr id="14" name="Predict whether a classification is unreliable.">
             <a:extLst xmlns:a="http://schemas.openxmlformats.org/drawingml/2006/main">
               <a:ext uri="{FF2B5EF4-FFF2-40B4-BE49-F238E27FC236}">
-                <a16:creationId xmlns:a16="http://schemas.microsoft.com/office/drawing/2014/main" id="{F231E2E8-6591-40E5-9161-EB81293C86C4}"/>
+                <a16:creationId xmlns:a16="http://schemas.microsoft.com/office/drawing/2014/main" id="{F5D58237-867E-43FF-AD94-A32BE7E92B76}"/>
               </a:ext>
             </a:extLst>
           </p:cNvPr>
@@ -11855,7 +10765,7 @@
           <p:cNvPr id="15" name="05">
             <a:extLst xmlns:a="http://schemas.openxmlformats.org/drawingml/2006/main">
               <a:ext uri="{FF2B5EF4-FFF2-40B4-BE49-F238E27FC236}">
-                <a16:creationId xmlns:a16="http://schemas.microsoft.com/office/drawing/2014/main" id="{11E8FEAD-7A17-424E-82B9-8833C8DFFA6D}"/>
+                <a16:creationId xmlns:a16="http://schemas.microsoft.com/office/drawing/2014/main" id="{F75E3820-5231-4421-8667-FB4FF91E754A}"/>
               </a:ext>
             </a:extLst>
           </p:cNvPr>
@@ -11912,7 +10822,7 @@
           <p:cNvPr id="16" name="Evaluate the detector">
             <a:extLst xmlns:a="http://schemas.openxmlformats.org/drawingml/2006/main">
               <a:ext uri="{FF2B5EF4-FFF2-40B4-BE49-F238E27FC236}">
-                <a16:creationId xmlns:a16="http://schemas.microsoft.com/office/drawing/2014/main" id="{E2170DE3-9DA9-4B97-A8EF-6306CF923FCC}"/>
+                <a16:creationId xmlns:a16="http://schemas.microsoft.com/office/drawing/2014/main" id="{9EAC8CEF-3AF3-4FD4-B887-C3BD2B7EE2BC}"/>
               </a:ext>
             </a:extLst>
           </p:cNvPr>
@@ -11969,7 +10879,7 @@
           <p:cNvPr id="17" name="Calibration, high-confidence errors and an A/B/C c">
             <a:extLst xmlns:a="http://schemas.openxmlformats.org/drawingml/2006/main">
               <a:ext uri="{FF2B5EF4-FFF2-40B4-BE49-F238E27FC236}">
-                <a16:creationId xmlns:a16="http://schemas.microsoft.com/office/drawing/2014/main" id="{B8658900-5A4D-4392-9BDC-2461F5C0E01E}"/>
+                <a16:creationId xmlns:a16="http://schemas.microsoft.com/office/drawing/2014/main" id="{D2852D5C-CBBF-4BE0-94D6-14D310C03ECA}"/>
               </a:ext>
             </a:extLst>
           </p:cNvPr>
@@ -12024,7 +10934,7 @@
     </p:spTree>
     <p:extLst>
       <p:ext uri="{BB962C8B-B14F-4D97-AF65-F5344CB8AC3E}">
-        <p14:creationId xmlns:p14="http://schemas.microsoft.com/office/powerpoint/2010/main" val="1087003788"/>
+        <p14:creationId xmlns:p14="http://schemas.microsoft.com/office/powerpoint/2010/main" val="561444284"/>
       </p:ext>
     </p:extLst>
   </p:cSld>
@@ -12055,7 +10965,7 @@
           <p:cNvPr id="12" name="How confidence changes">
             <a:extLst xmlns:a="http://schemas.openxmlformats.org/drawingml/2006/main">
               <a:ext uri="{FF2B5EF4-FFF2-40B4-BE49-F238E27FC236}">
-                <a16:creationId xmlns:a16="http://schemas.microsoft.com/office/drawing/2014/main" id="{B5888B21-3A40-40C2-9943-A528AA06BD9F}"/>
+                <a16:creationId xmlns:a16="http://schemas.microsoft.com/office/drawing/2014/main" id="{F4E6D642-45D2-4421-8243-36C60C4CE40E}"/>
               </a:ext>
             </a:extLst>
           </p:cNvPr>
@@ -12112,7 +11022,7 @@
           <p:cNvPr id="2" name="06">
             <a:extLst xmlns:a="http://schemas.openxmlformats.org/drawingml/2006/main">
               <a:ext uri="{FF2B5EF4-FFF2-40B4-BE49-F238E27FC236}">
-                <a16:creationId xmlns:a16="http://schemas.microsoft.com/office/drawing/2014/main" id="{6AB0ABCB-74EA-450E-9C63-278F17B4DA68}"/>
+                <a16:creationId xmlns:a16="http://schemas.microsoft.com/office/drawing/2014/main" id="{21481AE8-0248-4DF1-A8A3-715AF45DDA59}"/>
               </a:ext>
             </a:extLst>
           </p:cNvPr>
@@ -12169,7 +11079,7 @@
           <p:cNvPr id="3" name="Six levels, from 0% to 50% of words removed and sh">
             <a:extLst xmlns:a="http://schemas.openxmlformats.org/drawingml/2006/main">
               <a:ext uri="{FF2B5EF4-FFF2-40B4-BE49-F238E27FC236}">
-                <a16:creationId xmlns:a16="http://schemas.microsoft.com/office/drawing/2014/main" id="{A64104DB-009D-4959-BD4F-365B681AEC81}"/>
+                <a16:creationId xmlns:a16="http://schemas.microsoft.com/office/drawing/2014/main" id="{7E46B2DB-8CEB-49C5-9679-C8926435D0D4}"/>
               </a:ext>
             </a:extLst>
           </p:cNvPr>
@@ -12226,7 +11136,7 @@
           <p:cNvPr id="4" name="Two contrasting examples">
             <a:extLst xmlns:a="http://schemas.openxmlformats.org/drawingml/2006/main">
               <a:ext uri="{FF2B5EF4-FFF2-40B4-BE49-F238E27FC236}">
-                <a16:creationId xmlns:a16="http://schemas.microsoft.com/office/drawing/2014/main" id="{4E40EE8C-7998-42D4-BAD1-99746EC10122}"/>
+                <a16:creationId xmlns:a16="http://schemas.microsoft.com/office/drawing/2014/main" id="{DFB0EBB2-67C9-414E-BBD6-57828FD269F2}"/>
               </a:ext>
             </a:extLst>
           </p:cNvPr>
@@ -12866,7 +11776,7 @@
           <p:cNvPr id="6" name="Stayed wrong">
             <a:extLst xmlns:a="http://schemas.openxmlformats.org/drawingml/2006/main">
               <a:ext uri="{FF2B5EF4-FFF2-40B4-BE49-F238E27FC236}">
-                <a16:creationId xmlns:a16="http://schemas.microsoft.com/office/drawing/2014/main" id="{D15F8E13-6447-40E0-BA6A-BC5EEA9D2B31}"/>
+                <a16:creationId xmlns:a16="http://schemas.microsoft.com/office/drawing/2014/main" id="{B30CDB79-BC1E-4B20-9D4B-D0A3E379EBE7}"/>
               </a:ext>
             </a:extLst>
           </p:cNvPr>
@@ -12923,7 +11833,7 @@
           <p:cNvPr id="7" name="Stayed correct">
             <a:extLst xmlns:a="http://schemas.openxmlformats.org/drawingml/2006/main">
               <a:ext uri="{FF2B5EF4-FFF2-40B4-BE49-F238E27FC236}">
-                <a16:creationId xmlns:a16="http://schemas.microsoft.com/office/drawing/2014/main" id="{5EC58096-148A-40AA-A92C-9D570B433679}"/>
+                <a16:creationId xmlns:a16="http://schemas.microsoft.com/office/drawing/2014/main" id="{C91B0D20-4DDA-4D9A-A945-A9870A369963}"/>
               </a:ext>
             </a:extLst>
           </p:cNvPr>
@@ -12980,7 +11890,7 @@
           <p:cNvPr id="8" name="Confidence">
             <a:extLst xmlns:a="http://schemas.openxmlformats.org/drawingml/2006/main">
               <a:ext uri="{FF2B5EF4-FFF2-40B4-BE49-F238E27FC236}">
-                <a16:creationId xmlns:a16="http://schemas.microsoft.com/office/drawing/2014/main" id="{00CAB51C-104D-40BF-85FB-E8D5FBB66237}"/>
+                <a16:creationId xmlns:a16="http://schemas.microsoft.com/office/drawing/2014/main" id="{34E592FB-7FB6-4619-869C-3DDE51D587C5}"/>
               </a:ext>
             </a:extLst>
           </p:cNvPr>
@@ -13044,7 +11954,7 @@
         </p:xfrm>
         <a:graphic xmlns:a="http://schemas.openxmlformats.org/drawingml/2006/main">
           <a:graphicData uri="http://schemas.openxmlformats.org/drawingml/2006/chart">
-            <c:chart xmlns:r="http://schemas.openxmlformats.org/officeDocument/2006/relationships" xmlns:c="http://schemas.openxmlformats.org/drawingml/2006/chart" r:id="R387cf53480b243fa"/>
+            <c:chart xmlns:r="http://schemas.openxmlformats.org/officeDocument/2006/relationships" xmlns:c="http://schemas.openxmlformats.org/drawingml/2006/chart" r:id="R47174d91d40f4cff"/>
           </a:graphicData>
         </a:graphic>
       </p:graphicFrame>
@@ -13053,7 +11963,7 @@
           <p:cNvPr id="10" name="12 test documents. Green: correct at the final ste">
             <a:extLst xmlns:a="http://schemas.openxmlformats.org/drawingml/2006/main">
               <a:ext uri="{FF2B5EF4-FFF2-40B4-BE49-F238E27FC236}">
-                <a16:creationId xmlns:a16="http://schemas.microsoft.com/office/drawing/2014/main" id="{939D565E-B7AE-4BCB-9651-83A1A4F20458}"/>
+                <a16:creationId xmlns:a16="http://schemas.microsoft.com/office/drawing/2014/main" id="{E05D33A0-99F7-4F50-A0AE-F4389E946AEA}"/>
               </a:ext>
             </a:extLst>
           </p:cNvPr>
@@ -13110,7 +12020,7 @@
           <p:cNvPr id="11" name="Sequences simulate repeated predictions through te">
             <a:extLst xmlns:a="http://schemas.openxmlformats.org/drawingml/2006/main">
               <a:ext uri="{FF2B5EF4-FFF2-40B4-BE49-F238E27FC236}">
-                <a16:creationId xmlns:a16="http://schemas.microsoft.com/office/drawing/2014/main" id="{03E47594-6F0B-4B1E-84E9-AAF410A757DE}"/>
+                <a16:creationId xmlns:a16="http://schemas.microsoft.com/office/drawing/2014/main" id="{68BE24BB-E2DE-4683-8F36-B324CE44F9AA}"/>
               </a:ext>
             </a:extLst>
           </p:cNvPr>
@@ -13165,7 +12075,7 @@
     </p:spTree>
     <p:extLst>
       <p:ext uri="{BB962C8B-B14F-4D97-AF65-F5344CB8AC3E}">
-        <p14:creationId xmlns:p14="http://schemas.microsoft.com/office/powerpoint/2010/main" val="259461399"/>
+        <p14:creationId xmlns:p14="http://schemas.microsoft.com/office/powerpoint/2010/main" val="911559577"/>
       </p:ext>
     </p:extLst>
   </p:cSld>
@@ -13196,7 +12106,7 @@
           <p:cNvPr id="5" name="Anatomy of a confidence sequence">
             <a:extLst xmlns:a="http://schemas.openxmlformats.org/drawingml/2006/main">
               <a:ext uri="{FF2B5EF4-FFF2-40B4-BE49-F238E27FC236}">
-                <a16:creationId xmlns:a16="http://schemas.microsoft.com/office/drawing/2014/main" id="{A6AB884A-CA26-40F5-9863-2E3618AA2876}"/>
+                <a16:creationId xmlns:a16="http://schemas.microsoft.com/office/drawing/2014/main" id="{0CBFBA50-3327-4D68-B41C-0F57D64EC505}"/>
               </a:ext>
             </a:extLst>
           </p:cNvPr>
@@ -13253,7 +12163,7 @@
           <p:cNvPr id="2" name="07">
             <a:extLst xmlns:a="http://schemas.openxmlformats.org/drawingml/2006/main">
               <a:ext uri="{FF2B5EF4-FFF2-40B4-BE49-F238E27FC236}">
-                <a16:creationId xmlns:a16="http://schemas.microsoft.com/office/drawing/2014/main" id="{5DE65853-2555-47B8-80BD-C0900B5EC9BB}"/>
+                <a16:creationId xmlns:a16="http://schemas.microsoft.com/office/drawing/2014/main" id="{DAAC50C9-9303-4181-8E1E-DD67BEEBA85B}"/>
               </a:ext>
             </a:extLst>
           </p:cNvPr>
@@ -13310,7 +12220,7 @@
           <p:cNvPr id="3" name="13 features, compared with simpler baselines in th">
             <a:extLst xmlns:a="http://schemas.openxmlformats.org/drawingml/2006/main">
               <a:ext uri="{FF2B5EF4-FFF2-40B4-BE49-F238E27FC236}">
-                <a16:creationId xmlns:a16="http://schemas.microsoft.com/office/drawing/2014/main" id="{6E581173-961C-49CE-AC8B-C47D4DF6E9CC}"/>
+                <a16:creationId xmlns:a16="http://schemas.microsoft.com/office/drawing/2014/main" id="{52ADD828-CE07-485E-AB99-88271DCB823C}"/>
               </a:ext>
             </a:extLst>
           </p:cNvPr>
@@ -13377,8 +12287,8 @@
             <a:tbl>
               <a:tblPr firstRow="0" bandRow="0"/>
               <a:tblGrid>
-                <a:gridCol w="2476500"/>
-                <a:gridCol w="8334375"/>
+                <a:gridCol w="2714625"/>
+                <a:gridCol w="8096250"/>
               </a:tblGrid>
               <a:tr h="476250">
                 <a:tc>
@@ -13389,7 +12299,7 @@
                     <a:lstStyle/>
                     <a:p>
                       <a:r>
-                        <a:rPr sz="1875" b="1">
+                        <a:rPr sz="1725" b="1">
                           <a:solidFill>
                             <a:srgbClr val="636761"/>
                           </a:solidFill>
@@ -13415,7 +12325,7 @@
                     <a:lstStyle/>
                     <a:p>
                       <a:r>
-                        <a:rPr sz="1875" b="1">
+                        <a:rPr sz="1725" b="1">
                           <a:solidFill>
                             <a:srgbClr val="636761"/>
                           </a:solidFill>
@@ -13443,7 +12353,7 @@
                     <a:lstStyle/>
                     <a:p>
                       <a:r>
-                        <a:rPr sz="1875" b="0">
+                        <a:rPr sz="1725" b="0">
                           <a:solidFill>
                             <a:srgbClr val="292B28"/>
                           </a:solidFill>
@@ -13451,7 +12361,7 @@
                           <a:ea typeface="Calibri"/>
                           <a:cs typeface="Calibri"/>
                         </a:rPr>
-                        <a:t>Point in time</a:t>
+                        <a:t>Context (2)</a:t>
                       </a:r>
                     </a:p>
                   </a:txBody>
@@ -13469,7 +12379,7 @@
                     <a:lstStyle/>
                     <a:p>
                       <a:r>
-                        <a:rPr sz="1875" b="0">
+                        <a:rPr sz="1725" b="0">
                           <a:solidFill>
                             <a:srgbClr val="292B28"/>
                           </a:solidFill>
@@ -13477,20 +12387,7 @@
                           <a:ea typeface="Calibri"/>
                           <a:cs typeface="Calibri"/>
                         </a:rPr>
-                        <a:t>confidence, prediction_margin,</a:t>
-                      </a:r>
-                    </a:p>
-                    <a:p>
-                      <a:r>
-                        <a:rPr sz="1875" b="0">
-                          <a:solidFill>
-                            <a:srgbClr val="292B28"/>
-                          </a:solidFill>
-                          <a:latin typeface="Calibri"/>
-                          <a:ea typeface="Calibri"/>
-                          <a:cs typeface="Calibri"/>
-                        </a:rPr>
-                        <a:t>historical_accuracy_for_class</a:t>
+                        <a:t>step, corruption_level</a:t>
                       </a:r>
                     </a:p>
                   </a:txBody>
@@ -13510,7 +12407,7 @@
                     <a:lstStyle/>
                     <a:p>
                       <a:r>
-                        <a:rPr sz="1875" b="0">
+                        <a:rPr sz="1725" b="0">
                           <a:solidFill>
                             <a:srgbClr val="292B28"/>
                           </a:solidFill>
@@ -13518,7 +12415,7 @@
                           <a:ea typeface="Calibri"/>
                           <a:cs typeface="Calibri"/>
                         </a:rPr>
-                        <a:t>Change</a:t>
+                        <a:t>Current (2)</a:t>
                       </a:r>
                     </a:p>
                   </a:txBody>
@@ -13536,7 +12433,7 @@
                     <a:lstStyle/>
                     <a:p>
                       <a:r>
-                        <a:rPr sz="1875" b="0">
+                        <a:rPr sz="1725" b="0">
                           <a:solidFill>
                             <a:srgbClr val="292B28"/>
                           </a:solidFill>
@@ -13544,20 +12441,7 @@
                           <a:ea typeface="Calibri"/>
                           <a:cs typeface="Calibri"/>
                         </a:rPr>
-                        <a:t>confidence_diff, confidence_pct_change,</a:t>
-                      </a:r>
-                    </a:p>
-                    <a:p>
-                      <a:r>
-                        <a:rPr sz="1875" b="0">
-                          <a:solidFill>
-                            <a:srgbClr val="292B28"/>
-                          </a:solidFill>
-                          <a:latin typeface="Calibri"/>
-                          <a:ea typeface="Calibri"/>
-                          <a:cs typeface="Calibri"/>
-                        </a:rPr>
-                        <a:t>rate_of_change</a:t>
+                        <a:t>confidence, prediction_margin</a:t>
                       </a:r>
                     </a:p>
                   </a:txBody>
@@ -13577,7 +12461,7 @@
                     <a:lstStyle/>
                     <a:p>
                       <a:r>
-                        <a:rPr sz="1875" b="0">
+                        <a:rPr sz="1725" b="0">
                           <a:solidFill>
                             <a:srgbClr val="292B28"/>
                           </a:solidFill>
@@ -13585,7 +12469,7 @@
                           <a:ea typeface="Calibri"/>
                           <a:cs typeface="Calibri"/>
                         </a:rPr>
-                        <a:t>Trend and history</a:t>
+                        <a:t>History: change (4)</a:t>
                       </a:r>
                     </a:p>
                   </a:txBody>
@@ -13603,7 +12487,7 @@
                     <a:lstStyle/>
                     <a:p>
                       <a:r>
-                        <a:rPr sz="1875" b="0">
+                        <a:rPr sz="1725" b="0">
                           <a:solidFill>
                             <a:srgbClr val="292B28"/>
                           </a:solidFill>
@@ -13611,12 +12495,12 @@
                           <a:ea typeface="Calibri"/>
                           <a:cs typeface="Calibri"/>
                         </a:rPr>
-                        <a:t>moving_avg_confidence, moving_std_confidence,</a:t>
+                        <a:t>prev_confidence, confidence_diff,</a:t>
                       </a:r>
                     </a:p>
                     <a:p>
                       <a:r>
-                        <a:rPr sz="1875" b="0">
+                        <a:rPr sz="1725" b="0">
                           <a:solidFill>
                             <a:srgbClr val="292B28"/>
                           </a:solidFill>
@@ -13624,7 +12508,7 @@
                           <a:ea typeface="Calibri"/>
                           <a:cs typeface="Calibri"/>
                         </a:rPr>
-                        <a:t>rolling_std_confidence, confidence_range_so_far</a:t>
+                        <a:t>confidence_pct_change, rate_of_change</a:t>
                       </a:r>
                     </a:p>
                   </a:txBody>
@@ -13644,7 +12528,7 @@
                     <a:lstStyle/>
                     <a:p>
                       <a:r>
-                        <a:rPr sz="1875" b="0">
+                        <a:rPr sz="1725" b="0">
                           <a:solidFill>
                             <a:srgbClr val="292B28"/>
                           </a:solidFill>
@@ -13652,7 +12536,7 @@
                           <a:ea typeface="Calibri"/>
                           <a:cs typeface="Calibri"/>
                         </a:rPr>
-                        <a:t>Pattern</a:t>
+                        <a:t>History: pattern (5)</a:t>
                       </a:r>
                     </a:p>
                   </a:txBody>
@@ -13670,7 +12554,7 @@
                     <a:lstStyle/>
                     <a:p>
                       <a:r>
-                        <a:rPr sz="1875" b="0">
+                        <a:rPr sz="1725" b="0">
                           <a:solidFill>
                             <a:srgbClr val="292B28"/>
                           </a:solidFill>
@@ -13678,7 +12562,20 @@
                           <a:ea typeface="Calibri"/>
                           <a:cs typeface="Calibri"/>
                         </a:rPr>
-                        <a:t>consecutive_decreases, step, corruption_level</a:t>
+                        <a:t>moving_avg_confidence, moving_std_confidence,</a:t>
+                      </a:r>
+                    </a:p>
+                    <a:p>
+                      <a:r>
+                        <a:rPr sz="1725" b="0">
+                          <a:solidFill>
+                            <a:srgbClr val="292B28"/>
+                          </a:solidFill>
+                          <a:latin typeface="Calibri"/>
+                          <a:ea typeface="Calibri"/>
+                          <a:cs typeface="Calibri"/>
+                        </a:rPr>
+                        <a:t>rolling_std_confidence, confidence_range_so_far, consecutive_decreases</a:t>
                       </a:r>
                     </a:p>
                   </a:txBody>
@@ -13696,7 +12593,7 @@
     </p:spTree>
     <p:extLst>
       <p:ext uri="{BB962C8B-B14F-4D97-AF65-F5344CB8AC3E}">
-        <p14:creationId xmlns:p14="http://schemas.microsoft.com/office/powerpoint/2010/main" val="1864482368"/>
+        <p14:creationId xmlns:p14="http://schemas.microsoft.com/office/powerpoint/2010/main" val="1437085572"/>
       </p:ext>
     </p:extLst>
   </p:cSld>
@@ -13727,7 +12624,7 @@
           <p:cNvPr id="7" name="Confidence carries signal">
             <a:extLst xmlns:a="http://schemas.openxmlformats.org/drawingml/2006/main">
               <a:ext uri="{FF2B5EF4-FFF2-40B4-BE49-F238E27FC236}">
-                <a16:creationId xmlns:a16="http://schemas.microsoft.com/office/drawing/2014/main" id="{F9313B72-173B-4459-A53E-20DD9FCEC211}"/>
+                <a16:creationId xmlns:a16="http://schemas.microsoft.com/office/drawing/2014/main" id="{F401A666-5C94-4E34-BA1A-C576D3357682}"/>
               </a:ext>
             </a:extLst>
           </p:cNvPr>
@@ -13784,7 +12681,7 @@
           <p:cNvPr id="2" name="08">
             <a:extLst xmlns:a="http://schemas.openxmlformats.org/drawingml/2006/main">
               <a:ext uri="{FF2B5EF4-FFF2-40B4-BE49-F238E27FC236}">
-                <a16:creationId xmlns:a16="http://schemas.microsoft.com/office/drawing/2014/main" id="{33734644-4F3B-4766-8E6D-A4C816B0DB76}"/>
+                <a16:creationId xmlns:a16="http://schemas.microsoft.com/office/drawing/2014/main" id="{C148FB23-E38C-4C2F-9B67-DAE02979D17B}"/>
               </a:ext>
             </a:extLst>
           </p:cNvPr>
@@ -13841,7 +12738,7 @@
           <p:cNvPr id="3" name="Accuracy across 439 uncorrupted test predictions">
             <a:extLst xmlns:a="http://schemas.openxmlformats.org/drawingml/2006/main">
               <a:ext uri="{FF2B5EF4-FFF2-40B4-BE49-F238E27FC236}">
-                <a16:creationId xmlns:a16="http://schemas.microsoft.com/office/drawing/2014/main" id="{D577B5E3-EEF4-4301-8272-79187699C0C8}"/>
+                <a16:creationId xmlns:a16="http://schemas.microsoft.com/office/drawing/2014/main" id="{919E1A65-E436-4870-A82F-CADA5F2E293A}"/>
               </a:ext>
             </a:extLst>
           </p:cNvPr>
@@ -13905,7 +12802,7 @@
         </p:xfrm>
         <a:graphic xmlns:a="http://schemas.openxmlformats.org/drawingml/2006/main">
           <a:graphicData uri="http://schemas.openxmlformats.org/drawingml/2006/chart">
-            <c:chart xmlns:r="http://schemas.openxmlformats.org/officeDocument/2006/relationships" xmlns:c="http://schemas.openxmlformats.org/drawingml/2006/chart" r:id="R6a4f13825d5d4215"/>
+            <c:chart xmlns:r="http://schemas.openxmlformats.org/officeDocument/2006/relationships" xmlns:c="http://schemas.openxmlformats.org/drawingml/2006/chart" r:id="R4d64d363ba0546a6"/>
           </a:graphicData>
         </a:graphic>
       </p:graphicFrame>
@@ -14257,7 +13154,7 @@
           <p:cNvPr id="6" name="Confidence carries signal, but calibration remains">
             <a:extLst xmlns:a="http://schemas.openxmlformats.org/drawingml/2006/main">
               <a:ext uri="{FF2B5EF4-FFF2-40B4-BE49-F238E27FC236}">
-                <a16:creationId xmlns:a16="http://schemas.microsoft.com/office/drawing/2014/main" id="{BA8C8C2F-A42F-48EA-8524-835750226CB6}"/>
+                <a16:creationId xmlns:a16="http://schemas.microsoft.com/office/drawing/2014/main" id="{BF22F8F7-736F-4BC6-94ED-9A884E57F8E2}"/>
               </a:ext>
             </a:extLst>
           </p:cNvPr>
@@ -14312,7 +13209,7 @@
     </p:spTree>
     <p:extLst>
       <p:ext uri="{BB962C8B-B14F-4D97-AF65-F5344CB8AC3E}">
-        <p14:creationId xmlns:p14="http://schemas.microsoft.com/office/powerpoint/2010/main" val="1123470148"/>
+        <p14:creationId xmlns:p14="http://schemas.microsoft.com/office/powerpoint/2010/main" val="1581922426"/>
       </p:ext>
     </p:extLst>
   </p:cSld>
@@ -14343,7 +13240,7 @@
           <p:cNvPr id="12" name="The calibration gap">
             <a:extLst xmlns:a="http://schemas.openxmlformats.org/drawingml/2006/main">
               <a:ext uri="{FF2B5EF4-FFF2-40B4-BE49-F238E27FC236}">
-                <a16:creationId xmlns:a16="http://schemas.microsoft.com/office/drawing/2014/main" id="{51A0162D-8B89-4735-8C4E-1830672ECC0E}"/>
+                <a16:creationId xmlns:a16="http://schemas.microsoft.com/office/drawing/2014/main" id="{7CB028A5-A899-4C8F-A4F1-8AB0BFFC754E}"/>
               </a:ext>
             </a:extLst>
           </p:cNvPr>
@@ -14400,7 +13297,7 @@
           <p:cNvPr id="2" name="09">
             <a:extLst xmlns:a="http://schemas.openxmlformats.org/drawingml/2006/main">
               <a:ext uri="{FF2B5EF4-FFF2-40B4-BE49-F238E27FC236}">
-                <a16:creationId xmlns:a16="http://schemas.microsoft.com/office/drawing/2014/main" id="{0AD2D952-A98F-4DAC-822A-57AB9448412B}"/>
+                <a16:creationId xmlns:a16="http://schemas.microsoft.com/office/drawing/2014/main" id="{3B38A593-F765-405F-80B9-1EBB88BB7719}"/>
               </a:ext>
             </a:extLst>
           </p:cNvPr>
@@ -14457,7 +13354,7 @@
           <p:cNvPr id="3" name="Reliability diagram for uncorrupted test predictio">
             <a:extLst xmlns:a="http://schemas.openxmlformats.org/drawingml/2006/main">
               <a:ext uri="{FF2B5EF4-FFF2-40B4-BE49-F238E27FC236}">
-                <a16:creationId xmlns:a16="http://schemas.microsoft.com/office/drawing/2014/main" id="{486ABC1A-72A5-4F1A-83E0-958422A2B3F3}"/>
+                <a16:creationId xmlns:a16="http://schemas.microsoft.com/office/drawing/2014/main" id="{9842E7BC-AA9F-49D3-8E24-9C34B49EA9B7}"/>
               </a:ext>
             </a:extLst>
           </p:cNvPr>
@@ -14521,7 +13418,7 @@
         </p:xfrm>
         <a:graphic xmlns:a="http://schemas.openxmlformats.org/drawingml/2006/main">
           <a:graphicData uri="http://schemas.openxmlformats.org/drawingml/2006/chart">
-            <c:chart xmlns:r="http://schemas.openxmlformats.org/officeDocument/2006/relationships" xmlns:c="http://schemas.openxmlformats.org/drawingml/2006/chart" r:id="R5a3bc2a13a3047a0"/>
+            <c:chart xmlns:r="http://schemas.openxmlformats.org/officeDocument/2006/relationships" xmlns:c="http://schemas.openxmlformats.org/drawingml/2006/chart" r:id="R9b7875ab74184ee2"/>
           </a:graphicData>
         </a:graphic>
       </p:graphicFrame>
@@ -14530,7 +13427,7 @@
           <p:cNvPr id="5" name="0.153">
             <a:extLst xmlns:a="http://schemas.openxmlformats.org/drawingml/2006/main">
               <a:ext uri="{FF2B5EF4-FFF2-40B4-BE49-F238E27FC236}">
-                <a16:creationId xmlns:a16="http://schemas.microsoft.com/office/drawing/2014/main" id="{9D157D58-DFA2-498A-B85E-724ED689DB6C}"/>
+                <a16:creationId xmlns:a16="http://schemas.microsoft.com/office/drawing/2014/main" id="{2600BF51-3B0E-4E05-AC24-85BC99CFA122}"/>
               </a:ext>
             </a:extLst>
           </p:cNvPr>
@@ -14584,10 +13481,10 @@
       </p:sp>
       <p:sp>
         <p:nvSpPr>
-          <p:cNvPr id="6" name="0.125">
+          <p:cNvPr id="6" name="0.160">
             <a:extLst xmlns:a="http://schemas.openxmlformats.org/drawingml/2006/main">
               <a:ext uri="{FF2B5EF4-FFF2-40B4-BE49-F238E27FC236}">
-                <a16:creationId xmlns:a16="http://schemas.microsoft.com/office/drawing/2014/main" id="{51BD0E3A-2E44-485B-AD92-4A745F6F1ABE}"/>
+                <a16:creationId xmlns:a16="http://schemas.microsoft.com/office/drawing/2014/main" id="{9A183EF1-F70E-4369-8A39-2ACACE623FEF}"/>
               </a:ext>
             </a:extLst>
           </p:cNvPr>
@@ -14634,7 +13531,7 @@
                 <a:ea typeface="Georgia"/>
                 <a:cs typeface="Georgia"/>
               </a:rPr>
-              <a:t>0.125</a:t>
+              <a:t>0.160</a:t>
             </a:r>
           </a:p>
         </p:txBody>
@@ -14644,7 +13541,7 @@
           <p:cNvPr id="7" name="Calibration error">
             <a:extLst xmlns:a="http://schemas.openxmlformats.org/drawingml/2006/main">
               <a:ext uri="{FF2B5EF4-FFF2-40B4-BE49-F238E27FC236}">
-                <a16:creationId xmlns:a16="http://schemas.microsoft.com/office/drawing/2014/main" id="{588912D3-8AC7-44DE-AE74-13B04A576888}"/>
+                <a16:creationId xmlns:a16="http://schemas.microsoft.com/office/drawing/2014/main" id="{18D7D8A2-119A-4E9F-99D1-008B9ED0B92B}"/>
               </a:ext>
             </a:extLst>
           </p:cNvPr>
@@ -14701,7 +13598,7 @@
           <p:cNvPr id="8" name="Brier score">
             <a:extLst xmlns:a="http://schemas.openxmlformats.org/drawingml/2006/main">
               <a:ext uri="{FF2B5EF4-FFF2-40B4-BE49-F238E27FC236}">
-                <a16:creationId xmlns:a16="http://schemas.microsoft.com/office/drawing/2014/main" id="{6034650B-D69E-44D8-A0E6-BCC176AAC33D}"/>
+                <a16:creationId xmlns:a16="http://schemas.microsoft.com/office/drawing/2014/main" id="{0AB3F69E-D520-462F-A1BC-3F9B6A2C4176}"/>
               </a:ext>
             </a:extLst>
           </p:cNvPr>
@@ -14758,7 +13655,7 @@
           <p:cNvPr id="9" name="Under-confident at 0.6–0.9">
             <a:extLst xmlns:a="http://schemas.openxmlformats.org/drawingml/2006/main">
               <a:ext uri="{FF2B5EF4-FFF2-40B4-BE49-F238E27FC236}">
-                <a16:creationId xmlns:a16="http://schemas.microsoft.com/office/drawing/2014/main" id="{73F510C2-EF03-4067-B14F-53D94739BA88}"/>
+                <a16:creationId xmlns:a16="http://schemas.microsoft.com/office/drawing/2014/main" id="{60D4363A-E581-40E0-93BF-721309DCE705}"/>
               </a:ext>
             </a:extLst>
           </p:cNvPr>
@@ -14815,7 +13712,7 @@
           <p:cNvPr id="10" name="Observed accuracy exceeds stated confidence in thi">
             <a:extLst xmlns:a="http://schemas.openxmlformats.org/drawingml/2006/main">
               <a:ext uri="{FF2B5EF4-FFF2-40B4-BE49-F238E27FC236}">
-                <a16:creationId xmlns:a16="http://schemas.microsoft.com/office/drawing/2014/main" id="{7A2400C9-4B50-415F-9037-361FCE4B81E5}"/>
+                <a16:creationId xmlns:a16="http://schemas.microsoft.com/office/drawing/2014/main" id="{19251612-A919-4A20-9E2A-B5CE47D36785}"/>
               </a:ext>
             </a:extLst>
           </p:cNvPr>
@@ -14872,7 +13769,7 @@
           <p:cNvPr id="11" name="The top bin has only 10 samples: 80% accuracy, ver">
             <a:extLst xmlns:a="http://schemas.openxmlformats.org/drawingml/2006/main">
               <a:ext uri="{FF2B5EF4-FFF2-40B4-BE49-F238E27FC236}">
-                <a16:creationId xmlns:a16="http://schemas.microsoft.com/office/drawing/2014/main" id="{929C2540-DC7E-47D4-82F8-8921E828E40F}"/>
+                <a16:creationId xmlns:a16="http://schemas.microsoft.com/office/drawing/2014/main" id="{621364E3-AE0E-430F-BF69-C666A24FBB66}"/>
               </a:ext>
             </a:extLst>
           </p:cNvPr>
@@ -14927,7 +13824,7 @@
     </p:spTree>
     <p:extLst>
       <p:ext uri="{BB962C8B-B14F-4D97-AF65-F5344CB8AC3E}">
-        <p14:creationId xmlns:p14="http://schemas.microsoft.com/office/powerpoint/2010/main" val="446121326"/>
+        <p14:creationId xmlns:p14="http://schemas.microsoft.com/office/powerpoint/2010/main" val="1147364510"/>
       </p:ext>
     </p:extLst>
   </p:cSld>

</xml_diff>

<commit_message>
Route high-confidence errors to conservative review
</commit_message>
<xml_diff>
--- a/reports/presentation/AI_Confidence_Drift_Presentation.pptx
+++ b/reports/presentation/AI_Confidence_Drift_Presentation.pptx
@@ -2,26 +2,26 @@
 <file path=ppt/presentation.xml><?xml version="1.0" encoding="utf-8"?>
 <p:presentation xmlns:p="http://schemas.openxmlformats.org/presentationml/2006/main">
   <p:sldMasterIdLst>
-    <p:sldMasterId xmlns:r="http://schemas.openxmlformats.org/officeDocument/2006/relationships" id="2147483648" r:id="R8c0759fa6cca425c"/>
+    <p:sldMasterId xmlns:r="http://schemas.openxmlformats.org/officeDocument/2006/relationships" id="2147483648" r:id="R5e6a9648767944e7"/>
   </p:sldMasterIdLst>
   <p:notesMasterIdLst>
-    <p:notesMasterId xmlns:r="http://schemas.openxmlformats.org/officeDocument/2006/relationships" r:id="R380d611db4b7492c"/>
+    <p:notesMasterId xmlns:r="http://schemas.openxmlformats.org/officeDocument/2006/relationships" r:id="Rd78422bbb1704fc1"/>
   </p:notesMasterIdLst>
   <p:sldIdLst>
-    <p:sldId xmlns:r="http://schemas.openxmlformats.org/officeDocument/2006/relationships" id="256" r:id="R8a88dd05a94c48a9"/>
-    <p:sldId xmlns:r="http://schemas.openxmlformats.org/officeDocument/2006/relationships" id="257" r:id="Re0c7a9c0b1ba4af0"/>
-    <p:sldId xmlns:r="http://schemas.openxmlformats.org/officeDocument/2006/relationships" id="258" r:id="Re63a6fdabbf444f8"/>
-    <p:sldId xmlns:r="http://schemas.openxmlformats.org/officeDocument/2006/relationships" id="259" r:id="Rcfd9062434bb4efb"/>
-    <p:sldId xmlns:r="http://schemas.openxmlformats.org/officeDocument/2006/relationships" id="260" r:id="R9c790271b1a5484d"/>
-    <p:sldId xmlns:r="http://schemas.openxmlformats.org/officeDocument/2006/relationships" id="261" r:id="R3e2c502b38d14506"/>
-    <p:sldId xmlns:r="http://schemas.openxmlformats.org/officeDocument/2006/relationships" id="262" r:id="Re9d9173f68aa448c"/>
-    <p:sldId xmlns:r="http://schemas.openxmlformats.org/officeDocument/2006/relationships" id="263" r:id="R905d685c4d3a48d6"/>
-    <p:sldId xmlns:r="http://schemas.openxmlformats.org/officeDocument/2006/relationships" id="264" r:id="R4d597cdb46214aff"/>
-    <p:sldId xmlns:r="http://schemas.openxmlformats.org/officeDocument/2006/relationships" id="265" r:id="R39135f3090dd4c48"/>
-    <p:sldId xmlns:r="http://schemas.openxmlformats.org/officeDocument/2006/relationships" id="266" r:id="R0b6355e4948a42e7"/>
-    <p:sldId xmlns:r="http://schemas.openxmlformats.org/officeDocument/2006/relationships" id="267" r:id="R16d12e88f3044fcf"/>
-    <p:sldId xmlns:r="http://schemas.openxmlformats.org/officeDocument/2006/relationships" id="268" r:id="R309190ea914f4aae"/>
-    <p:sldId xmlns:r="http://schemas.openxmlformats.org/officeDocument/2006/relationships" id="269" r:id="Rcb84f6e7d1dc48e4"/>
+    <p:sldId xmlns:r="http://schemas.openxmlformats.org/officeDocument/2006/relationships" id="256" r:id="Rc18d78d87d4347cf"/>
+    <p:sldId xmlns:r="http://schemas.openxmlformats.org/officeDocument/2006/relationships" id="257" r:id="R64c1e854e9cf4d61"/>
+    <p:sldId xmlns:r="http://schemas.openxmlformats.org/officeDocument/2006/relationships" id="258" r:id="R38c8b772d396435e"/>
+    <p:sldId xmlns:r="http://schemas.openxmlformats.org/officeDocument/2006/relationships" id="259" r:id="R9349624286b74d8e"/>
+    <p:sldId xmlns:r="http://schemas.openxmlformats.org/officeDocument/2006/relationships" id="260" r:id="R489edfd2ea2340a6"/>
+    <p:sldId xmlns:r="http://schemas.openxmlformats.org/officeDocument/2006/relationships" id="261" r:id="Rc3d5ee7c71074aaa"/>
+    <p:sldId xmlns:r="http://schemas.openxmlformats.org/officeDocument/2006/relationships" id="262" r:id="Rae97edcb96684c95"/>
+    <p:sldId xmlns:r="http://schemas.openxmlformats.org/officeDocument/2006/relationships" id="263" r:id="Ra0949496f9cd444c"/>
+    <p:sldId xmlns:r="http://schemas.openxmlformats.org/officeDocument/2006/relationships" id="264" r:id="R4f93cdbd3a054ecf"/>
+    <p:sldId xmlns:r="http://schemas.openxmlformats.org/officeDocument/2006/relationships" id="265" r:id="Rb6fb71936bd047fd"/>
+    <p:sldId xmlns:r="http://schemas.openxmlformats.org/officeDocument/2006/relationships" id="266" r:id="R58f427189e1b4f83"/>
+    <p:sldId xmlns:r="http://schemas.openxmlformats.org/officeDocument/2006/relationships" id="267" r:id="R6508e94454ba4128"/>
+    <p:sldId xmlns:r="http://schemas.openxmlformats.org/officeDocument/2006/relationships" id="268" r:id="Rb841911bd183492a"/>
+    <p:sldId xmlns:r="http://schemas.openxmlformats.org/officeDocument/2006/relationships" id="269" r:id="Ra6d45a2ce93a4067"/>
   </p:sldIdLst>
   <p:sldSz cx="12192000" cy="6858000"/>
   <p:notesSz cx="6858000" cy="9144000"/>
@@ -525,7 +525,7 @@
           <a:lstStyle xmlns:a="http://schemas.openxmlformats.org/drawingml/2006/main"/>
           <a:p xmlns:a="http://schemas.openxmlformats.org/drawingml/2006/main">
             <a:r>
-              <a:t>Source: reports/RESEARCH_REPORT.md and results/metrics in the accompanying project repository. The figures describe the corrected, document-grouped evaluation.</a:t>
+              <a:t>The detector result is five-fold document-grouped out-of-fold on the 439-document base test set. The separate review policy was fitted from out-of-fold predictions on the 1,315 base-model training documents. It routed all six test-set errors but also 78 correct high-confidence predictions. See results/metrics/high_confidence_detector_analysis.json and high_confidence_review_analysis.json.</a:t>
             </a:r>
           </a:p>
         </p:txBody>
@@ -1433,7 +1433,7 @@
   </p:cSld>
   <p:clrMap bg1="lt1" tx1="dk1" bg2="lt2" tx2="dk2" accent1="accent1" accent2="accent2" accent3="accent3" accent4="accent4" accent5="accent5" accent6="accent6" hlink="hlink" folHlink="folHlink"/>
   <p:sldLayoutIdLst>
-    <p:sldLayoutId xmlns:r="http://schemas.openxmlformats.org/officeDocument/2006/relationships" id="2147483649" r:id="R52c0b6e0f5394747"/>
+    <p:sldLayoutId xmlns:r="http://schemas.openxmlformats.org/officeDocument/2006/relationships" id="2147483649" r:id="Rd752caa69e09426c"/>
   </p:sldLayoutIdLst>
   <p:txStyles>
     <p:titleStyle>
@@ -3680,7 +3680,7 @@
           <p:cNvPr id="11" name="01">
             <a:extLst xmlns:a="http://schemas.openxmlformats.org/drawingml/2006/main">
               <a:ext uri="{FF2B5EF4-FFF2-40B4-BE49-F238E27FC236}">
-                <a16:creationId xmlns:a16="http://schemas.microsoft.com/office/drawing/2014/main" id="{70540C69-DB98-4B77-94D4-2CE534977EB6}"/>
+                <a16:creationId xmlns:a16="http://schemas.microsoft.com/office/drawing/2014/main" id="{99B95DCF-A90B-4DDA-BBCF-D668BF5FF8CC}"/>
               </a:ext>
             </a:extLst>
           </p:cNvPr>
@@ -3737,7 +3737,7 @@
           <p:cNvPr id="2" name="PRANAVX LABS">
             <a:extLst xmlns:a="http://schemas.openxmlformats.org/drawingml/2006/main">
               <a:ext uri="{FF2B5EF4-FFF2-40B4-BE49-F238E27FC236}">
-                <a16:creationId xmlns:a16="http://schemas.microsoft.com/office/drawing/2014/main" id="{B2E109E4-4341-4BCD-B72A-6F85A7701485}"/>
+                <a16:creationId xmlns:a16="http://schemas.microsoft.com/office/drawing/2014/main" id="{CA10B4B3-6CCB-488A-A538-E4CF23C38467}"/>
               </a:ext>
             </a:extLst>
           </p:cNvPr>
@@ -3794,7 +3794,7 @@
           <p:cNvPr id="3" name="AI/ML Internship">
             <a:extLst xmlns:a="http://schemas.openxmlformats.org/drawingml/2006/main">
               <a:ext uri="{FF2B5EF4-FFF2-40B4-BE49-F238E27FC236}">
-                <a16:creationId xmlns:a16="http://schemas.microsoft.com/office/drawing/2014/main" id="{188737F8-9D9D-47F1-A83E-DBDCDC758AA0}"/>
+                <a16:creationId xmlns:a16="http://schemas.microsoft.com/office/drawing/2014/main" id="{CEC0F9B2-E736-4792-B0B9-63404571DC23}"/>
               </a:ext>
             </a:extLst>
           </p:cNvPr>
@@ -3851,7 +3851,7 @@
           <p:cNvPr id="4" name="AI Confidence">
             <a:extLst xmlns:a="http://schemas.openxmlformats.org/drawingml/2006/main">
               <a:ext uri="{FF2B5EF4-FFF2-40B4-BE49-F238E27FC236}">
-                <a16:creationId xmlns:a16="http://schemas.microsoft.com/office/drawing/2014/main" id="{EC853238-F39E-4D6A-9A6D-1C9D0867D828}"/>
+                <a16:creationId xmlns:a16="http://schemas.microsoft.com/office/drawing/2014/main" id="{18EB3329-4D74-4C3E-9B87-4C4A5533B604}"/>
               </a:ext>
             </a:extLst>
           </p:cNvPr>
@@ -3908,7 +3908,7 @@
           <p:cNvPr id="5" name="Drift Detection">
             <a:extLst xmlns:a="http://schemas.openxmlformats.org/drawingml/2006/main">
               <a:ext uri="{FF2B5EF4-FFF2-40B4-BE49-F238E27FC236}">
-                <a16:creationId xmlns:a16="http://schemas.microsoft.com/office/drawing/2014/main" id="{E6DA64F8-33EE-4C1C-8C1A-729029D61843}"/>
+                <a16:creationId xmlns:a16="http://schemas.microsoft.com/office/drawing/2014/main" id="{3BF11387-87B0-4213-A6C6-5136FCDA2E1B}"/>
               </a:ext>
             </a:extLst>
           </p:cNvPr>
@@ -3965,7 +3965,7 @@
           <p:cNvPr id="6" name="Using machine learning">
             <a:extLst xmlns:a="http://schemas.openxmlformats.org/drawingml/2006/main">
               <a:ext uri="{FF2B5EF4-FFF2-40B4-BE49-F238E27FC236}">
-                <a16:creationId xmlns:a16="http://schemas.microsoft.com/office/drawing/2014/main" id="{778ACD99-C406-4400-B0D1-0AF46FBDF219}"/>
+                <a16:creationId xmlns:a16="http://schemas.microsoft.com/office/drawing/2014/main" id="{B2E1BE2B-234D-4870-9F12-175213F9295A}"/>
               </a:ext>
             </a:extLst>
           </p:cNvPr>
@@ -4022,7 +4022,7 @@
           <p:cNvPr id="7" name="Can changes in confidence help identify&#10;unreliable">
             <a:extLst xmlns:a="http://schemas.openxmlformats.org/drawingml/2006/main">
               <a:ext uri="{FF2B5EF4-FFF2-40B4-BE49-F238E27FC236}">
-                <a16:creationId xmlns:a16="http://schemas.microsoft.com/office/drawing/2014/main" id="{E1A101EF-1F75-43D3-9A41-BBD366462620}"/>
+                <a16:creationId xmlns:a16="http://schemas.microsoft.com/office/drawing/2014/main" id="{6C1AAB3F-E89C-4C07-9E25-1E50114B96CC}"/>
               </a:ext>
             </a:extLst>
           </p:cNvPr>
@@ -4102,7 +4102,7 @@
           <p:cNvPr id="8" name="Research project">
             <a:extLst xmlns:a="http://schemas.openxmlformats.org/drawingml/2006/main">
               <a:ext uri="{FF2B5EF4-FFF2-40B4-BE49-F238E27FC236}">
-                <a16:creationId xmlns:a16="http://schemas.microsoft.com/office/drawing/2014/main" id="{2084B47B-9B68-4B4C-9EF3-50FC2BEA0B3B}"/>
+                <a16:creationId xmlns:a16="http://schemas.microsoft.com/office/drawing/2014/main" id="{08C05B52-338B-4A78-82D5-814C936EA762}"/>
               </a:ext>
             </a:extLst>
           </p:cNvPr>
@@ -4159,7 +4159,7 @@
           <p:cNvPr id="9" name="Prepared by Ahan">
             <a:extLst xmlns:a="http://schemas.openxmlformats.org/drawingml/2006/main">
               <a:ext uri="{FF2B5EF4-FFF2-40B4-BE49-F238E27FC236}">
-                <a16:creationId xmlns:a16="http://schemas.microsoft.com/office/drawing/2014/main" id="{5BE5DF00-AE53-4C82-8270-B1B8530DF267}"/>
+                <a16:creationId xmlns:a16="http://schemas.microsoft.com/office/drawing/2014/main" id="{12C0AACC-A386-4682-BADC-CBAF133B7F45}"/>
               </a:ext>
             </a:extLst>
           </p:cNvPr>
@@ -4216,7 +4216,7 @@
           <p:cNvPr id="10" name="github.com/ahansardar/ai-confidence-drift">
             <a:extLst xmlns:a="http://schemas.openxmlformats.org/drawingml/2006/main">
               <a:ext uri="{FF2B5EF4-FFF2-40B4-BE49-F238E27FC236}">
-                <a16:creationId xmlns:a16="http://schemas.microsoft.com/office/drawing/2014/main" id="{11CA6A37-60C3-48CD-840D-AB89E1BF7DD5}"/>
+                <a16:creationId xmlns:a16="http://schemas.microsoft.com/office/drawing/2014/main" id="{D537BA18-A9BC-4445-8093-8E6DD5DDD517}"/>
               </a:ext>
             </a:extLst>
           </p:cNvPr>
@@ -4262,7 +4262,7 @@
                 <a:latin typeface="Calibri"/>
                 <a:ea typeface="Calibri"/>
                 <a:cs typeface="Calibri"/>
-                <a:hlinkClick xmlns:r="http://schemas.openxmlformats.org/officeDocument/2006/relationships" r:id="R535d12874d514332"/>
+                <a:hlinkClick xmlns:r="http://schemas.openxmlformats.org/officeDocument/2006/relationships" r:id="R6f21438dea9d437d"/>
               </a:rPr>
               <a:t>github.com/ahansardar/ai-confidence-drift</a:t>
             </a:r>
@@ -4272,7 +4272,7 @@
     </p:spTree>
     <p:extLst>
       <p:ext uri="{BB962C8B-B14F-4D97-AF65-F5344CB8AC3E}">
-        <p14:creationId xmlns:p14="http://schemas.microsoft.com/office/powerpoint/2010/main" val="126221422"/>
+        <p14:creationId xmlns:p14="http://schemas.microsoft.com/office/powerpoint/2010/main" val="573504615"/>
       </p:ext>
     </p:extLst>
   </p:cSld>
@@ -4303,7 +4303,7 @@
           <p:cNvPr id="10" name="Confident errors">
             <a:extLst xmlns:a="http://schemas.openxmlformats.org/drawingml/2006/main">
               <a:ext uri="{FF2B5EF4-FFF2-40B4-BE49-F238E27FC236}">
-                <a16:creationId xmlns:a16="http://schemas.microsoft.com/office/drawing/2014/main" id="{6B61BBFA-794F-417F-8A97-9C721621ADBF}"/>
+                <a16:creationId xmlns:a16="http://schemas.microsoft.com/office/drawing/2014/main" id="{1253AF97-2AC0-478D-A9B9-FF18CF00747D}"/>
               </a:ext>
             </a:extLst>
           </p:cNvPr>
@@ -4360,7 +4360,7 @@
           <p:cNvPr id="2" name="10">
             <a:extLst xmlns:a="http://schemas.openxmlformats.org/drawingml/2006/main">
               <a:ext uri="{FF2B5EF4-FFF2-40B4-BE49-F238E27FC236}">
-                <a16:creationId xmlns:a16="http://schemas.microsoft.com/office/drawing/2014/main" id="{940A5B27-CB6C-46AB-B59A-84729A41F4E2}"/>
+                <a16:creationId xmlns:a16="http://schemas.microsoft.com/office/drawing/2014/main" id="{5A57B5F1-E707-4BD2-BF21-07C4903F61D1}"/>
               </a:ext>
             </a:extLst>
           </p:cNvPr>
@@ -4417,7 +4417,7 @@
           <p:cNvPr id="3" name="6 of 100">
             <a:extLst xmlns:a="http://schemas.openxmlformats.org/drawingml/2006/main">
               <a:ext uri="{FF2B5EF4-FFF2-40B4-BE49-F238E27FC236}">
-                <a16:creationId xmlns:a16="http://schemas.microsoft.com/office/drawing/2014/main" id="{6AA2187C-7D71-42F6-8BBB-38E40523560E}"/>
+                <a16:creationId xmlns:a16="http://schemas.microsoft.com/office/drawing/2014/main" id="{C43BCD1C-3D49-4A72-B71E-164710104FB4}"/>
               </a:ext>
             </a:extLst>
           </p:cNvPr>
@@ -4474,7 +4474,7 @@
           <p:cNvPr id="4" name="high-confidence predictions were wrong">
             <a:extLst xmlns:a="http://schemas.openxmlformats.org/drawingml/2006/main">
               <a:ext uri="{FF2B5EF4-FFF2-40B4-BE49-F238E27FC236}">
-                <a16:creationId xmlns:a16="http://schemas.microsoft.com/office/drawing/2014/main" id="{BA82D965-C791-4895-B7A9-A0E7A7F11C1E}"/>
+                <a16:creationId xmlns:a16="http://schemas.microsoft.com/office/drawing/2014/main" id="{DFD6F09E-D2CF-4D28-8C1B-5EB4735367FB}"/>
               </a:ext>
             </a:extLst>
           </p:cNvPr>
@@ -4531,7 +4531,7 @@
           <p:cNvPr id="5" name="100 of 439 predictions reached at least 75% confid">
             <a:extLst xmlns:a="http://schemas.openxmlformats.org/drawingml/2006/main">
               <a:ext uri="{FF2B5EF4-FFF2-40B4-BE49-F238E27FC236}">
-                <a16:creationId xmlns:a16="http://schemas.microsoft.com/office/drawing/2014/main" id="{C13C7CCF-F1E3-4EF3-B46E-B1919F3BE5EF}"/>
+                <a16:creationId xmlns:a16="http://schemas.microsoft.com/office/drawing/2014/main" id="{064F4CA3-316C-45E8-B077-AD4413A99DA9}"/>
               </a:ext>
             </a:extLst>
           </p:cNvPr>
@@ -4608,10 +4608,10 @@
       </p:sp>
       <p:sp>
         <p:nvSpPr>
-          <p:cNvPr id="6" name="All six errors">
+          <p:cNvPr id="6" name="Drift detector: 0/6">
             <a:extLst xmlns:a="http://schemas.openxmlformats.org/drawingml/2006/main">
               <a:ext uri="{FF2B5EF4-FFF2-40B4-BE49-F238E27FC236}">
-                <a16:creationId xmlns:a16="http://schemas.microsoft.com/office/drawing/2014/main" id="{3FE7DA8B-E13C-4BDA-B14C-DE467A91322A}"/>
+                <a16:creationId xmlns:a16="http://schemas.microsoft.com/office/drawing/2014/main" id="{D77935B2-4F8F-4BC8-A6D3-A4889948F84F}"/>
               </a:ext>
             </a:extLst>
           </p:cNvPr>
@@ -4623,7 +4623,7 @@
         <p:spPr>
           <a:xfrm xmlns:a="http://schemas.openxmlformats.org/drawingml/2006/main">
             <a:off x="666750" y="5295900"/>
-            <a:ext cx="2705100" cy="409575"/>
+            <a:ext cx="5095875" cy="409575"/>
           </a:xfrm>
           <a:prstGeom xmlns:a="http://schemas.openxmlformats.org/drawingml/2006/main" prst="rect">
             <a:avLst/>
@@ -4658,17 +4658,17 @@
                 <a:ea typeface="Calibri"/>
                 <a:cs typeface="Calibri"/>
               </a:rPr>
-              <a:t>All six errors</a:t>
-            </a:r>
-          </a:p>
-        </p:txBody>
-      </p:sp>
-      <p:sp>
-        <p:nvSpPr>
-          <p:cNvPr id="7" name="True label: alt.atheism&#10;Predicted: soc.religion.ch">
+              <a:t>Drift detector: 0/6</a:t>
+            </a:r>
+          </a:p>
+        </p:txBody>
+      </p:sp>
+      <p:sp>
+        <p:nvSpPr>
+          <p:cNvPr id="7" name="No history exists at the first prediction.&#10;It flag">
             <a:extLst xmlns:a="http://schemas.openxmlformats.org/drawingml/2006/main">
               <a:ext uri="{FF2B5EF4-FFF2-40B4-BE49-F238E27FC236}">
-                <a16:creationId xmlns:a16="http://schemas.microsoft.com/office/drawing/2014/main" id="{F0E6F112-6803-43EC-8697-4EAEFC58A7C6}"/>
+                <a16:creationId xmlns:a16="http://schemas.microsoft.com/office/drawing/2014/main" id="{AA46181C-1CCE-48AC-8CA9-050DD38F5914}"/>
               </a:ext>
             </a:extLst>
           </p:cNvPr>
@@ -4715,7 +4715,7 @@
                 <a:ea typeface="Calibri"/>
                 <a:cs typeface="Calibri"/>
               </a:rPr>
-              <a:t>True label: alt.atheism</a:t>
+              <a:t>No history exists at the first prediction.</a:t>
             </a:r>
           </a:p>
           <a:p xmlns:a="http://schemas.openxmlformats.org/drawingml/2006/main">
@@ -4738,17 +4738,17 @@
                 <a:ea typeface="Calibri"/>
                 <a:cs typeface="Calibri"/>
               </a:rPr>
-              <a:t>Predicted: soc.religion.christian</a:t>
-            </a:r>
-          </a:p>
-        </p:txBody>
-      </p:sp>
-      <p:sp>
-        <p:nvSpPr>
-          <p:cNvPr id="8" name="Detector check">
+              <a:t>It flagged none of these errors.</a:t>
+            </a:r>
+          </a:p>
+        </p:txBody>
+      </p:sp>
+      <p:sp>
+        <p:nvSpPr>
+          <p:cNvPr id="8" name="Review policy: 6/6">
             <a:extLst xmlns:a="http://schemas.openxmlformats.org/drawingml/2006/main">
               <a:ext uri="{FF2B5EF4-FFF2-40B4-BE49-F238E27FC236}">
-                <a16:creationId xmlns:a16="http://schemas.microsoft.com/office/drawing/2014/main" id="{903AAD08-9F64-46E9-AB64-35E8DA538EB8}"/>
+                <a16:creationId xmlns:a16="http://schemas.microsoft.com/office/drawing/2014/main" id="{AD1272CB-A7FE-47A5-BB59-E7D6E0B4DCB9}"/>
               </a:ext>
             </a:extLst>
           </p:cNvPr>
@@ -4795,17 +4795,17 @@
                 <a:ea typeface="Calibri"/>
                 <a:cs typeface="Calibri"/>
               </a:rPr>
-              <a:t>Detector check</a:t>
-            </a:r>
-          </a:p>
-        </p:txBody>
-      </p:sp>
-      <p:sp>
-        <p:nvSpPr>
-          <p:cNvPr id="9" name="It caught 0 of these 6 errors in five-fold,&#10;docume">
+              <a:t>Review policy: 6/6</a:t>
+            </a:r>
+          </a:p>
+        </p:txBody>
+      </p:sp>
+      <p:sp>
+        <p:nvSpPr>
+          <p:cNvPr id="9" name="It routed 84 cases to review,&#10;including 78 correct">
             <a:extLst xmlns:a="http://schemas.openxmlformats.org/drawingml/2006/main">
               <a:ext uri="{FF2B5EF4-FFF2-40B4-BE49-F238E27FC236}">
-                <a16:creationId xmlns:a16="http://schemas.microsoft.com/office/drawing/2014/main" id="{F7C7C4DF-AB2D-4619-B6A3-A028DFEF7A03}"/>
+                <a16:creationId xmlns:a16="http://schemas.microsoft.com/office/drawing/2014/main" id="{60D209DC-D1B1-4827-8CBE-D81370509440}"/>
               </a:ext>
             </a:extLst>
           </p:cNvPr>
@@ -4852,7 +4852,7 @@
                 <a:ea typeface="Calibri"/>
                 <a:cs typeface="Calibri"/>
               </a:rPr>
-              <a:t>It caught 0 of these 6 errors in five-fold,</a:t>
+              <a:t>It routed 84 cases to review,</a:t>
             </a:r>
           </a:p>
           <a:p xmlns:a="http://schemas.openxmlformats.org/drawingml/2006/main">
@@ -4875,7 +4875,7 @@
                 <a:ea typeface="Calibri"/>
                 <a:cs typeface="Calibri"/>
               </a:rPr>
-              <a:t>document-grouped out-of-fold testing.</a:t>
+              <a:t>including 78 correct predictions.</a:t>
             </a:r>
           </a:p>
         </p:txBody>
@@ -4883,7 +4883,7 @@
     </p:spTree>
     <p:extLst>
       <p:ext uri="{BB962C8B-B14F-4D97-AF65-F5344CB8AC3E}">
-        <p14:creationId xmlns:p14="http://schemas.microsoft.com/office/powerpoint/2010/main" val="493952526"/>
+        <p14:creationId xmlns:p14="http://schemas.microsoft.com/office/powerpoint/2010/main" val="1919534998"/>
       </p:ext>
     </p:extLst>
   </p:cSld>
@@ -4914,7 +4914,7 @@
           <p:cNvPr id="11" name="What drift features add">
             <a:extLst xmlns:a="http://schemas.openxmlformats.org/drawingml/2006/main">
               <a:ext uri="{FF2B5EF4-FFF2-40B4-BE49-F238E27FC236}">
-                <a16:creationId xmlns:a16="http://schemas.microsoft.com/office/drawing/2014/main" id="{D8D349D9-E637-4496-BED5-CB4E7AF597D8}"/>
+                <a16:creationId xmlns:a16="http://schemas.microsoft.com/office/drawing/2014/main" id="{3702A6F5-5BB8-4CB7-8A75-7893A0D0931F}"/>
               </a:ext>
             </a:extLst>
           </p:cNvPr>
@@ -4971,7 +4971,7 @@
           <p:cNvPr id="2" name="11">
             <a:extLst xmlns:a="http://schemas.openxmlformats.org/drawingml/2006/main">
               <a:ext uri="{FF2B5EF4-FFF2-40B4-BE49-F238E27FC236}">
-                <a16:creationId xmlns:a16="http://schemas.microsoft.com/office/drawing/2014/main" id="{9B33622D-6443-4734-A70D-06297767A822}"/>
+                <a16:creationId xmlns:a16="http://schemas.microsoft.com/office/drawing/2014/main" id="{E5D58072-A0E2-4055-B867-D4EB169494DD}"/>
               </a:ext>
             </a:extLst>
           </p:cNvPr>
@@ -5028,7 +5028,7 @@
           <p:cNvPr id="3" name="Pooled out-of-fold results · five document-grouped">
             <a:extLst xmlns:a="http://schemas.openxmlformats.org/drawingml/2006/main">
               <a:ext uri="{FF2B5EF4-FFF2-40B4-BE49-F238E27FC236}">
-                <a16:creationId xmlns:a16="http://schemas.microsoft.com/office/drawing/2014/main" id="{C38E96F8-5420-4071-9833-7E22FA80D6CD}"/>
+                <a16:creationId xmlns:a16="http://schemas.microsoft.com/office/drawing/2014/main" id="{436948D3-B344-4BE7-B3AF-A24FF79B12DE}"/>
               </a:ext>
             </a:extLst>
           </p:cNvPr>
@@ -5533,7 +5533,7 @@
           <p:cNvPr id="5" name="+0.040">
             <a:extLst xmlns:a="http://schemas.openxmlformats.org/drawingml/2006/main">
               <a:ext uri="{FF2B5EF4-FFF2-40B4-BE49-F238E27FC236}">
-                <a16:creationId xmlns:a16="http://schemas.microsoft.com/office/drawing/2014/main" id="{9CD04769-D772-4079-AA2C-537EFFFD27B8}"/>
+                <a16:creationId xmlns:a16="http://schemas.microsoft.com/office/drawing/2014/main" id="{9FC96831-8EED-4342-B31B-5FE329994F72}"/>
               </a:ext>
             </a:extLst>
           </p:cNvPr>
@@ -5590,7 +5590,7 @@
           <p:cNvPr id="6" name="F1 improvement, B to C">
             <a:extLst xmlns:a="http://schemas.openxmlformats.org/drawingml/2006/main">
               <a:ext uri="{FF2B5EF4-FFF2-40B4-BE49-F238E27FC236}">
-                <a16:creationId xmlns:a16="http://schemas.microsoft.com/office/drawing/2014/main" id="{CA69062F-BF06-48F0-95EA-A64179EB2CDC}"/>
+                <a16:creationId xmlns:a16="http://schemas.microsoft.com/office/drawing/2014/main" id="{0AA57B0F-058E-4C29-8D1D-B7AC6ABBB9DF}"/>
               </a:ext>
             </a:extLst>
           </p:cNvPr>
@@ -5647,7 +5647,7 @@
           <p:cNvPr id="7" name="+0.034">
             <a:extLst xmlns:a="http://schemas.openxmlformats.org/drawingml/2006/main">
               <a:ext uri="{FF2B5EF4-FFF2-40B4-BE49-F238E27FC236}">
-                <a16:creationId xmlns:a16="http://schemas.microsoft.com/office/drawing/2014/main" id="{B584DB53-3574-4FA7-8A2A-34DFBE440C89}"/>
+                <a16:creationId xmlns:a16="http://schemas.microsoft.com/office/drawing/2014/main" id="{04A299EE-8D30-41B8-B26A-AFE69B6C96A6}"/>
               </a:ext>
             </a:extLst>
           </p:cNvPr>
@@ -5704,7 +5704,7 @@
           <p:cNvPr id="8" name="ROC-AUC improvement, B to C">
             <a:extLst xmlns:a="http://schemas.openxmlformats.org/drawingml/2006/main">
               <a:ext uri="{FF2B5EF4-FFF2-40B4-BE49-F238E27FC236}">
-                <a16:creationId xmlns:a16="http://schemas.microsoft.com/office/drawing/2014/main" id="{9B8ACBC2-B0CD-44B1-AF9F-513307B6E821}"/>
+                <a16:creationId xmlns:a16="http://schemas.microsoft.com/office/drawing/2014/main" id="{3EC39CF8-6E50-4741-BD0D-F9C8B94F9BDE}"/>
               </a:ext>
             </a:extLst>
           </p:cNvPr>
@@ -5761,7 +5761,7 @@
           <p:cNvPr id="9" name="History adds a&#10;modest gain.">
             <a:extLst xmlns:a="http://schemas.openxmlformats.org/drawingml/2006/main">
               <a:ext uri="{FF2B5EF4-FFF2-40B4-BE49-F238E27FC236}">
-                <a16:creationId xmlns:a16="http://schemas.microsoft.com/office/drawing/2014/main" id="{237E0698-56E7-4550-BAF5-9502C5AB1E5F}"/>
+                <a16:creationId xmlns:a16="http://schemas.microsoft.com/office/drawing/2014/main" id="{4F6409B3-4197-440C-8172-418BE6C839D5}"/>
               </a:ext>
             </a:extLst>
           </p:cNvPr>
@@ -5841,7 +5841,7 @@
           <p:cNvPr id="10" name="The separate 110-document holdout showed a smaller">
             <a:extLst xmlns:a="http://schemas.openxmlformats.org/drawingml/2006/main">
               <a:ext uri="{FF2B5EF4-FFF2-40B4-BE49-F238E27FC236}">
-                <a16:creationId xmlns:a16="http://schemas.microsoft.com/office/drawing/2014/main" id="{3E80B188-BB73-419B-9A94-93FDFC6144DF}"/>
+                <a16:creationId xmlns:a16="http://schemas.microsoft.com/office/drawing/2014/main" id="{8043759D-0CAF-4A07-83F7-29F402B261E7}"/>
               </a:ext>
             </a:extLst>
           </p:cNvPr>
@@ -5896,7 +5896,7 @@
     </p:spTree>
     <p:extLst>
       <p:ext uri="{BB962C8B-B14F-4D97-AF65-F5344CB8AC3E}">
-        <p14:creationId xmlns:p14="http://schemas.microsoft.com/office/powerpoint/2010/main" val="2063240006"/>
+        <p14:creationId xmlns:p14="http://schemas.microsoft.com/office/powerpoint/2010/main" val="686491833"/>
       </p:ext>
     </p:extLst>
   </p:cSld>
@@ -5927,7 +5927,7 @@
           <p:cNvPr id="15" name="Four findings">
             <a:extLst xmlns:a="http://schemas.openxmlformats.org/drawingml/2006/main">
               <a:ext uri="{FF2B5EF4-FFF2-40B4-BE49-F238E27FC236}">
-                <a16:creationId xmlns:a16="http://schemas.microsoft.com/office/drawing/2014/main" id="{69A84393-AB2F-416C-833C-74A2A916121A}"/>
+                <a16:creationId xmlns:a16="http://schemas.microsoft.com/office/drawing/2014/main" id="{CC8CD3AA-23FD-4B2B-92DD-8674CDB4A592}"/>
               </a:ext>
             </a:extLst>
           </p:cNvPr>
@@ -5984,7 +5984,7 @@
           <p:cNvPr id="2" name="12">
             <a:extLst xmlns:a="http://schemas.openxmlformats.org/drawingml/2006/main">
               <a:ext uri="{FF2B5EF4-FFF2-40B4-BE49-F238E27FC236}">
-                <a16:creationId xmlns:a16="http://schemas.microsoft.com/office/drawing/2014/main" id="{9B75AC04-6739-44A2-9A71-7BF6CB7AA6E8}"/>
+                <a16:creationId xmlns:a16="http://schemas.microsoft.com/office/drawing/2014/main" id="{0BEC6B17-42B6-4E25-B668-16527E5295FC}"/>
               </a:ext>
             </a:extLst>
           </p:cNvPr>
@@ -6041,7 +6041,7 @@
           <p:cNvPr id="3" name="63.5–93.3%">
             <a:extLst xmlns:a="http://schemas.openxmlformats.org/drawingml/2006/main">
               <a:ext uri="{FF2B5EF4-FFF2-40B4-BE49-F238E27FC236}">
-                <a16:creationId xmlns:a16="http://schemas.microsoft.com/office/drawing/2014/main" id="{77F29170-0B37-49AC-A314-58F98B41B087}"/>
+                <a16:creationId xmlns:a16="http://schemas.microsoft.com/office/drawing/2014/main" id="{D8AFE0E1-E85E-463C-B943-782EC5113199}"/>
               </a:ext>
             </a:extLst>
           </p:cNvPr>
@@ -6098,7 +6098,7 @@
           <p:cNvPr id="4" name="Confidence carries useful signal">
             <a:extLst xmlns:a="http://schemas.openxmlformats.org/drawingml/2006/main">
               <a:ext uri="{FF2B5EF4-FFF2-40B4-BE49-F238E27FC236}">
-                <a16:creationId xmlns:a16="http://schemas.microsoft.com/office/drawing/2014/main" id="{ED88334E-18B4-452F-A438-D55CCEFDB888}"/>
+                <a16:creationId xmlns:a16="http://schemas.microsoft.com/office/drawing/2014/main" id="{8E718061-E3E4-4CC0-A8FC-DC506974519C}"/>
               </a:ext>
             </a:extLst>
           </p:cNvPr>
@@ -6155,7 +6155,7 @@
           <p:cNvPr id="5" name="Accuracy rises across the confidence bins.">
             <a:extLst xmlns:a="http://schemas.openxmlformats.org/drawingml/2006/main">
               <a:ext uri="{FF2B5EF4-FFF2-40B4-BE49-F238E27FC236}">
-                <a16:creationId xmlns:a16="http://schemas.microsoft.com/office/drawing/2014/main" id="{2FC3AE8D-9AB6-409B-AAAD-20B654784BBA}"/>
+                <a16:creationId xmlns:a16="http://schemas.microsoft.com/office/drawing/2014/main" id="{4F5E5747-884C-4998-94CC-67F4E54E286D}"/>
               </a:ext>
             </a:extLst>
           </p:cNvPr>
@@ -6209,10 +6209,10 @@
       </p:sp>
       <p:sp>
         <p:nvSpPr>
-          <p:cNvPr id="6" name="6%">
+          <p:cNvPr id="6" name="6 of 100">
             <a:extLst xmlns:a="http://schemas.openxmlformats.org/drawingml/2006/main">
               <a:ext uri="{FF2B5EF4-FFF2-40B4-BE49-F238E27FC236}">
-                <a16:creationId xmlns:a16="http://schemas.microsoft.com/office/drawing/2014/main" id="{F643B2AB-B18A-432A-B588-21B005A0B6DE}"/>
+                <a16:creationId xmlns:a16="http://schemas.microsoft.com/office/drawing/2014/main" id="{1FC4DD9C-94D6-4CAE-9DA9-E9FF7E92E69F}"/>
               </a:ext>
             </a:extLst>
           </p:cNvPr>
@@ -6259,7 +6259,7 @@
                 <a:ea typeface="Georgia"/>
                 <a:cs typeface="Georgia"/>
               </a:rPr>
-              <a:t>6%</a:t>
+              <a:t>6 of 100</a:t>
             </a:r>
           </a:p>
         </p:txBody>
@@ -6269,7 +6269,7 @@
           <p:cNvPr id="7" name="High confidence can still be wrong">
             <a:extLst xmlns:a="http://schemas.openxmlformats.org/drawingml/2006/main">
               <a:ext uri="{FF2B5EF4-FFF2-40B4-BE49-F238E27FC236}">
-                <a16:creationId xmlns:a16="http://schemas.microsoft.com/office/drawing/2014/main" id="{9CF76A06-C382-44BE-B4AA-218878DCE815}"/>
+                <a16:creationId xmlns:a16="http://schemas.microsoft.com/office/drawing/2014/main" id="{499540EB-1532-4B49-B9C1-35BD8FE72BF4}"/>
               </a:ext>
             </a:extLst>
           </p:cNvPr>
@@ -6323,10 +6323,10 @@
       </p:sp>
       <p:sp>
         <p:nvSpPr>
-          <p:cNvPr id="8" name="Six of 100 predictions at 75%+ confidence were wro">
+          <p:cNvPr id="8" name="The review rule routed all six, with 78 false alar">
             <a:extLst xmlns:a="http://schemas.openxmlformats.org/drawingml/2006/main">
               <a:ext uri="{FF2B5EF4-FFF2-40B4-BE49-F238E27FC236}">
-                <a16:creationId xmlns:a16="http://schemas.microsoft.com/office/drawing/2014/main" id="{E950F613-2F76-4495-AAC7-644504ADA4F9}"/>
+                <a16:creationId xmlns:a16="http://schemas.microsoft.com/office/drawing/2014/main" id="{92CCC18B-F741-48DE-82F8-74A8239E2169}"/>
               </a:ext>
             </a:extLst>
           </p:cNvPr>
@@ -6373,7 +6373,7 @@
                 <a:ea typeface="Calibri"/>
                 <a:cs typeface="Calibri"/>
               </a:rPr>
-              <a:t>Six of 100 predictions at 75%+ confidence were wrong.</a:t>
+              <a:t>The review rule routed all six, with 78 false alarms.</a:t>
             </a:r>
           </a:p>
         </p:txBody>
@@ -6383,7 +6383,7 @@
           <p:cNvPr id="9" name="r = 0.09">
             <a:extLst xmlns:a="http://schemas.openxmlformats.org/drawingml/2006/main">
               <a:ext uri="{FF2B5EF4-FFF2-40B4-BE49-F238E27FC236}">
-                <a16:creationId xmlns:a16="http://schemas.microsoft.com/office/drawing/2014/main" id="{B658530E-F54F-483F-BE73-5AF53A439206}"/>
+                <a16:creationId xmlns:a16="http://schemas.microsoft.com/office/drawing/2014/main" id="{F1CE36D8-75E9-45F8-A4D2-BF20C7F7A3F2}"/>
               </a:ext>
             </a:extLst>
           </p:cNvPr>
@@ -6440,7 +6440,7 @@
           <p:cNvPr id="10" name="Net drift is a weak predictor">
             <a:extLst xmlns:a="http://schemas.openxmlformats.org/drawingml/2006/main">
               <a:ext uri="{FF2B5EF4-FFF2-40B4-BE49-F238E27FC236}">
-                <a16:creationId xmlns:a16="http://schemas.microsoft.com/office/drawing/2014/main" id="{D3EBD776-1D5F-410C-B7DB-6956B8FC0BC2}"/>
+                <a16:creationId xmlns:a16="http://schemas.microsoft.com/office/drawing/2014/main" id="{1451E937-4A17-46AE-9B1C-A8319D330C78}"/>
               </a:ext>
             </a:extLst>
           </p:cNvPr>
@@ -6497,7 +6497,7 @@
           <p:cNvPr id="11" name="Correlation with becoming incorrect is small.">
             <a:extLst xmlns:a="http://schemas.openxmlformats.org/drawingml/2006/main">
               <a:ext uri="{FF2B5EF4-FFF2-40B4-BE49-F238E27FC236}">
-                <a16:creationId xmlns:a16="http://schemas.microsoft.com/office/drawing/2014/main" id="{5AF479A2-3F12-4CDF-857B-E9AEE9FDC324}"/>
+                <a16:creationId xmlns:a16="http://schemas.microsoft.com/office/drawing/2014/main" id="{38EC159D-3186-43B9-963D-A41259ADE233}"/>
               </a:ext>
             </a:extLst>
           </p:cNvPr>
@@ -6554,7 +6554,7 @@
           <p:cNvPr id="12" name="+0.040 F1">
             <a:extLst xmlns:a="http://schemas.openxmlformats.org/drawingml/2006/main">
               <a:ext uri="{FF2B5EF4-FFF2-40B4-BE49-F238E27FC236}">
-                <a16:creationId xmlns:a16="http://schemas.microsoft.com/office/drawing/2014/main" id="{F6EB8811-124E-40FC-B5CC-ACFC54B25C99}"/>
+                <a16:creationId xmlns:a16="http://schemas.microsoft.com/office/drawing/2014/main" id="{2D543D42-21B5-451E-92DC-2A3CD673B6D6}"/>
               </a:ext>
             </a:extLst>
           </p:cNvPr>
@@ -6611,7 +6611,7 @@
           <p:cNvPr id="13" name="History adds a modest gain">
             <a:extLst xmlns:a="http://schemas.openxmlformats.org/drawingml/2006/main">
               <a:ext uri="{FF2B5EF4-FFF2-40B4-BE49-F238E27FC236}">
-                <a16:creationId xmlns:a16="http://schemas.microsoft.com/office/drawing/2014/main" id="{210E52E9-2553-4193-8D14-BC4B59AB56A2}"/>
+                <a16:creationId xmlns:a16="http://schemas.microsoft.com/office/drawing/2014/main" id="{A750C70A-15D2-49C9-9B04-4FCFEA405232}"/>
               </a:ext>
             </a:extLst>
           </p:cNvPr>
@@ -6668,7 +6668,7 @@
           <p:cNvPr id="14" name="F1 rises from 0.468 to 0.508 after current confide">
             <a:extLst xmlns:a="http://schemas.openxmlformats.org/drawingml/2006/main">
               <a:ext uri="{FF2B5EF4-FFF2-40B4-BE49-F238E27FC236}">
-                <a16:creationId xmlns:a16="http://schemas.microsoft.com/office/drawing/2014/main" id="{EEA93DE7-118E-454A-A7E6-FBD6FFD6736B}"/>
+                <a16:creationId xmlns:a16="http://schemas.microsoft.com/office/drawing/2014/main" id="{ED116966-F1BC-4257-93B5-1BD08E2A11A3}"/>
               </a:ext>
             </a:extLst>
           </p:cNvPr>
@@ -6723,7 +6723,7 @@
     </p:spTree>
     <p:extLst>
       <p:ext uri="{BB962C8B-B14F-4D97-AF65-F5344CB8AC3E}">
-        <p14:creationId xmlns:p14="http://schemas.microsoft.com/office/powerpoint/2010/main" val="13959630"/>
+        <p14:creationId xmlns:p14="http://schemas.microsoft.com/office/powerpoint/2010/main" val="1617487989"/>
       </p:ext>
     </p:extLst>
   </p:cSld>
@@ -6754,7 +6754,7 @@
           <p:cNvPr id="13" name="Limitations and next steps">
             <a:extLst xmlns:a="http://schemas.openxmlformats.org/drawingml/2006/main">
               <a:ext uri="{FF2B5EF4-FFF2-40B4-BE49-F238E27FC236}">
-                <a16:creationId xmlns:a16="http://schemas.microsoft.com/office/drawing/2014/main" id="{E6524154-0498-4CD5-BF81-C69EB0025537}"/>
+                <a16:creationId xmlns:a16="http://schemas.microsoft.com/office/drawing/2014/main" id="{37F69563-E3A4-4FB2-A216-0AA6E65E1A5C}"/>
               </a:ext>
             </a:extLst>
           </p:cNvPr>
@@ -6811,7 +6811,7 @@
           <p:cNvPr id="2" name="13">
             <a:extLst xmlns:a="http://schemas.openxmlformats.org/drawingml/2006/main">
               <a:ext uri="{FF2B5EF4-FFF2-40B4-BE49-F238E27FC236}">
-                <a16:creationId xmlns:a16="http://schemas.microsoft.com/office/drawing/2014/main" id="{7B32C710-1802-4762-BF81-46F29F2CE6AF}"/>
+                <a16:creationId xmlns:a16="http://schemas.microsoft.com/office/drawing/2014/main" id="{8B38E04F-EAAD-45C8-9DBB-65E5A4F9A54F}"/>
               </a:ext>
             </a:extLst>
           </p:cNvPr>
@@ -6868,7 +6868,7 @@
           <p:cNvPr id="3" name="Limits of this study">
             <a:extLst xmlns:a="http://schemas.openxmlformats.org/drawingml/2006/main">
               <a:ext uri="{FF2B5EF4-FFF2-40B4-BE49-F238E27FC236}">
-                <a16:creationId xmlns:a16="http://schemas.microsoft.com/office/drawing/2014/main" id="{553F5ABE-B03B-4748-A62F-58CBE398661F}"/>
+                <a16:creationId xmlns:a16="http://schemas.microsoft.com/office/drawing/2014/main" id="{38DFC128-D8E5-49AE-84C2-2AF791E1FBF0}"/>
               </a:ext>
             </a:extLst>
           </p:cNvPr>
@@ -6925,7 +6925,7 @@
           <p:cNvPr id="4" name="What I would test next">
             <a:extLst xmlns:a="http://schemas.openxmlformats.org/drawingml/2006/main">
               <a:ext uri="{FF2B5EF4-FFF2-40B4-BE49-F238E27FC236}">
-                <a16:creationId xmlns:a16="http://schemas.microsoft.com/office/drawing/2014/main" id="{CEEE6AF2-7B7B-47F9-8203-4A7518BEEA40}"/>
+                <a16:creationId xmlns:a16="http://schemas.microsoft.com/office/drawing/2014/main" id="{BB1D4493-7919-471A-AE64-30AF2C3FB2E3}"/>
               </a:ext>
             </a:extLst>
           </p:cNvPr>
@@ -6982,7 +6982,7 @@
           <p:cNvPr id="5" name="Text corruption simulates repeated predictions. Re">
             <a:extLst xmlns:a="http://schemas.openxmlformats.org/drawingml/2006/main">
               <a:ext uri="{FF2B5EF4-FFF2-40B4-BE49-F238E27FC236}">
-                <a16:creationId xmlns:a16="http://schemas.microsoft.com/office/drawing/2014/main" id="{A38D171C-636B-43D3-9412-06F014F433A1}"/>
+                <a16:creationId xmlns:a16="http://schemas.microsoft.com/office/drawing/2014/main" id="{32C31A99-7D6C-4961-A945-D02E134645EC}"/>
               </a:ext>
             </a:extLst>
           </p:cNvPr>
@@ -7039,7 +7039,7 @@
           <p:cNvPr id="6" name="Only 439 test documents. The top calibration bin h">
             <a:extLst xmlns:a="http://schemas.openxmlformats.org/drawingml/2006/main">
               <a:ext uri="{FF2B5EF4-FFF2-40B4-BE49-F238E27FC236}">
-                <a16:creationId xmlns:a16="http://schemas.microsoft.com/office/drawing/2014/main" id="{2972B4F4-9777-4C84-BAEE-F8A7782D9035}"/>
+                <a16:creationId xmlns:a16="http://schemas.microsoft.com/office/drawing/2014/main" id="{405E515F-7DCD-4F9D-81EE-8D73A6A12D54}"/>
               </a:ext>
             </a:extLst>
           </p:cNvPr>
@@ -7096,7 +7096,7 @@
           <p:cNvPr id="7" name="Two classes and one base model architecture.">
             <a:extLst xmlns:a="http://schemas.openxmlformats.org/drawingml/2006/main">
               <a:ext uri="{FF2B5EF4-FFF2-40B4-BE49-F238E27FC236}">
-                <a16:creationId xmlns:a16="http://schemas.microsoft.com/office/drawing/2014/main" id="{8EB236B7-6054-4E45-BD65-4797E2A3FC33}"/>
+                <a16:creationId xmlns:a16="http://schemas.microsoft.com/office/drawing/2014/main" id="{2D835236-9806-41AB-AB5D-25B4C06E3082}"/>
               </a:ext>
             </a:extLst>
           </p:cNvPr>
@@ -7150,10 +7150,10 @@
       </p:sp>
       <p:sp>
         <p:nvSpPr>
-          <p:cNvPr id="8" name="The detector missed all six high-confidence errors">
+          <p:cNvPr id="8" name="The review rule sent 78 correct predictions to hum">
             <a:extLst xmlns:a="http://schemas.openxmlformats.org/drawingml/2006/main">
               <a:ext uri="{FF2B5EF4-FFF2-40B4-BE49-F238E27FC236}">
-                <a16:creationId xmlns:a16="http://schemas.microsoft.com/office/drawing/2014/main" id="{B215E46C-D8D4-45E8-9CAC-C18A5BE6EE75}"/>
+                <a16:creationId xmlns:a16="http://schemas.microsoft.com/office/drawing/2014/main" id="{A051FF61-53E7-493A-8D10-1445B4C49C0B}"/>
               </a:ext>
             </a:extLst>
           </p:cNvPr>
@@ -7200,17 +7200,17 @@
                 <a:ea typeface="Calibri"/>
                 <a:cs typeface="Calibri"/>
               </a:rPr>
-              <a:t>The detector missed all six high-confidence errors on uncorrupted text.</a:t>
-            </a:r>
-          </a:p>
-        </p:txBody>
-      </p:sp>
-      <p:sp>
-        <p:nvSpPr>
-          <p:cNvPr id="9" name="Test a method designed for high-confidence errors ">
+              <a:t>The review rule sent 78 correct predictions to human review.</a:t>
+            </a:r>
+          </a:p>
+        </p:txBody>
+      </p:sp>
+      <p:sp>
+        <p:nvSpPr>
+          <p:cNvPr id="9" name="Find a more selective way to catch step-0 high-con">
             <a:extLst xmlns:a="http://schemas.openxmlformats.org/drawingml/2006/main">
               <a:ext uri="{FF2B5EF4-FFF2-40B4-BE49-F238E27FC236}">
-                <a16:creationId xmlns:a16="http://schemas.microsoft.com/office/drawing/2014/main" id="{20FF5979-F674-45C9-AD9C-19DED937633D}"/>
+                <a16:creationId xmlns:a16="http://schemas.microsoft.com/office/drawing/2014/main" id="{069FE060-9382-4D25-BB4B-C6E5F74A1C0F}"/>
               </a:ext>
             </a:extLst>
           </p:cNvPr>
@@ -7257,7 +7257,7 @@
                 <a:ea typeface="Calibri"/>
                 <a:cs typeface="Calibri"/>
               </a:rPr>
-              <a:t>Test a method designed for high-confidence errors at the uncorrupted step.</a:t>
+              <a:t>Find a more selective way to catch step-0 high-confidence errors.</a:t>
             </a:r>
           </a:p>
         </p:txBody>
@@ -7267,7 +7267,7 @@
           <p:cNvPr id="10" name="Collect naturally repeated real-world queries when">
             <a:extLst xmlns:a="http://schemas.openxmlformats.org/drawingml/2006/main">
               <a:ext uri="{FF2B5EF4-FFF2-40B4-BE49-F238E27FC236}">
-                <a16:creationId xmlns:a16="http://schemas.microsoft.com/office/drawing/2014/main" id="{F06125FD-7E2A-45B6-9488-43FCB83B4C37}"/>
+                <a16:creationId xmlns:a16="http://schemas.microsoft.com/office/drawing/2014/main" id="{1DC6DBE3-B1B6-47AC-BBCD-9713258D13D1}"/>
               </a:ext>
             </a:extLst>
           </p:cNvPr>
@@ -7324,7 +7324,7 @@
           <p:cNvPr id="11" name="Apply temperature scaling and retest whether histo">
             <a:extLst xmlns:a="http://schemas.openxmlformats.org/drawingml/2006/main">
               <a:ext uri="{FF2B5EF4-FFF2-40B4-BE49-F238E27FC236}">
-                <a16:creationId xmlns:a16="http://schemas.microsoft.com/office/drawing/2014/main" id="{A3B6B378-296C-4E21-9EF4-EC3FD278A8EC}"/>
+                <a16:creationId xmlns:a16="http://schemas.microsoft.com/office/drawing/2014/main" id="{8ED39B30-7794-4F04-AA3F-34CFED34EF75}"/>
               </a:ext>
             </a:extLst>
           </p:cNvPr>
@@ -7381,7 +7381,7 @@
           <p:cNvPr id="12" name="Extend to multiple classes and another base model.">
             <a:extLst xmlns:a="http://schemas.openxmlformats.org/drawingml/2006/main">
               <a:ext uri="{FF2B5EF4-FFF2-40B4-BE49-F238E27FC236}">
-                <a16:creationId xmlns:a16="http://schemas.microsoft.com/office/drawing/2014/main" id="{13DF28F6-B380-4534-9486-A85436EF91F9}"/>
+                <a16:creationId xmlns:a16="http://schemas.microsoft.com/office/drawing/2014/main" id="{C0CC14B7-6D8C-4A91-8402-647A71B62A6F}"/>
               </a:ext>
             </a:extLst>
           </p:cNvPr>
@@ -7436,7 +7436,7 @@
     </p:spTree>
     <p:extLst>
       <p:ext uri="{BB962C8B-B14F-4D97-AF65-F5344CB8AC3E}">
-        <p14:creationId xmlns:p14="http://schemas.microsoft.com/office/powerpoint/2010/main" val="2073602562"/>
+        <p14:creationId xmlns:p14="http://schemas.microsoft.com/office/powerpoint/2010/main" val="355418043"/>
       </p:ext>
     </p:extLst>
   </p:cSld>
@@ -7467,7 +7467,7 @@
           <p:cNvPr id="10" name="14">
             <a:extLst xmlns:a="http://schemas.openxmlformats.org/drawingml/2006/main">
               <a:ext uri="{FF2B5EF4-FFF2-40B4-BE49-F238E27FC236}">
-                <a16:creationId xmlns:a16="http://schemas.microsoft.com/office/drawing/2014/main" id="{66C7AE21-7BF9-4803-8677-9AF55F0E883C}"/>
+                <a16:creationId xmlns:a16="http://schemas.microsoft.com/office/drawing/2014/main" id="{B9651141-DD2E-43C0-B714-5CF0A37948F5}"/>
               </a:ext>
             </a:extLst>
           </p:cNvPr>
@@ -7524,7 +7524,7 @@
           <p:cNvPr id="2" name="CONCLUSION">
             <a:extLst xmlns:a="http://schemas.openxmlformats.org/drawingml/2006/main">
               <a:ext uri="{FF2B5EF4-FFF2-40B4-BE49-F238E27FC236}">
-                <a16:creationId xmlns:a16="http://schemas.microsoft.com/office/drawing/2014/main" id="{C730E0AE-7E65-4FDB-8F2C-38891A4249B3}"/>
+                <a16:creationId xmlns:a16="http://schemas.microsoft.com/office/drawing/2014/main" id="{B72FF8BC-CE8D-40D1-9844-4D52DDEA79E0}"/>
               </a:ext>
             </a:extLst>
           </p:cNvPr>
@@ -7581,7 +7581,7 @@
           <p:cNvPr id="3" name="Confidence history adds">
             <a:extLst xmlns:a="http://schemas.openxmlformats.org/drawingml/2006/main">
               <a:ext uri="{FF2B5EF4-FFF2-40B4-BE49-F238E27FC236}">
-                <a16:creationId xmlns:a16="http://schemas.microsoft.com/office/drawing/2014/main" id="{72919D20-9B99-49B0-A8E5-D227E1471FA7}"/>
+                <a16:creationId xmlns:a16="http://schemas.microsoft.com/office/drawing/2014/main" id="{BEB3A70E-E7EA-4549-8CC1-B2A2D6E67E96}"/>
               </a:ext>
             </a:extLst>
           </p:cNvPr>
@@ -7638,7 +7638,7 @@
           <p:cNvPr id="4" name="a modest signal.">
             <a:extLst xmlns:a="http://schemas.openxmlformats.org/drawingml/2006/main">
               <a:ext uri="{FF2B5EF4-FFF2-40B4-BE49-F238E27FC236}">
-                <a16:creationId xmlns:a16="http://schemas.microsoft.com/office/drawing/2014/main" id="{019B75D6-E0A0-44E5-881A-9DCFCC6595C9}"/>
+                <a16:creationId xmlns:a16="http://schemas.microsoft.com/office/drawing/2014/main" id="{B7DCC727-3A99-447C-915C-95FBB699C7C2}"/>
               </a:ext>
             </a:extLst>
           </p:cNvPr>
@@ -7692,10 +7692,10 @@
       </p:sp>
       <p:sp>
         <p:nvSpPr>
-          <p:cNvPr id="5" name="The hardest errors remain.">
+          <p:cNvPr id="5" name="Review covers the rest—at a cost.">
             <a:extLst xmlns:a="http://schemas.openxmlformats.org/drawingml/2006/main">
               <a:ext uri="{FF2B5EF4-FFF2-40B4-BE49-F238E27FC236}">
-                <a16:creationId xmlns:a16="http://schemas.microsoft.com/office/drawing/2014/main" id="{7BD7430D-DBC7-4E81-960F-9CF5F7A75246}"/>
+                <a16:creationId xmlns:a16="http://schemas.microsoft.com/office/drawing/2014/main" id="{C0C27CE1-873D-441D-B6D1-51BB7DBE21EB}"/>
               </a:ext>
             </a:extLst>
           </p:cNvPr>
@@ -7724,7 +7724,7 @@
           <a:lstStyle xmlns:a="http://schemas.openxmlformats.org/drawingml/2006/main"/>
           <a:p xmlns:a="http://schemas.openxmlformats.org/drawingml/2006/main">
             <a:pPr algn="l">
-              <a:defRPr sz="4950" b="0" i="0">
+              <a:defRPr sz="4650" b="0" i="0">
                 <a:solidFill>
                   <a:srgbClr val="292B28"/>
                 </a:solidFill>
@@ -7734,7 +7734,7 @@
               </a:defRPr>
             </a:pPr>
             <a:r>
-              <a:rPr sz="4950" b="0" i="0">
+              <a:rPr sz="4650" b="0" i="0">
                 <a:solidFill>
                   <a:srgbClr val="292B28"/>
                 </a:solidFill>
@@ -7742,17 +7742,17 @@
                 <a:ea typeface="Georgia"/>
                 <a:cs typeface="Georgia"/>
               </a:rPr>
-              <a:t>The hardest errors remain.</a:t>
-            </a:r>
-          </a:p>
-        </p:txBody>
-      </p:sp>
-      <p:sp>
-        <p:nvSpPr>
-          <p:cNvPr id="6" name="Nine sequence features improve grouped evaluation ">
+              <a:t>Review covers the rest—at a cost.</a:t>
+            </a:r>
+          </a:p>
+        </p:txBody>
+      </p:sp>
+      <p:sp>
+        <p:nvSpPr>
+          <p:cNvPr id="6" name="The drift detector missed all six high-confidence ">
             <a:extLst xmlns:a="http://schemas.openxmlformats.org/drawingml/2006/main">
               <a:ext uri="{FF2B5EF4-FFF2-40B4-BE49-F238E27FC236}">
-                <a16:creationId xmlns:a16="http://schemas.microsoft.com/office/drawing/2014/main" id="{648E94DC-EF98-4C00-82E7-B9524F2E7500}"/>
+                <a16:creationId xmlns:a16="http://schemas.microsoft.com/office/drawing/2014/main" id="{146887E3-D345-49B8-9DB6-419427E09EFD}"/>
               </a:ext>
             </a:extLst>
           </p:cNvPr>
@@ -7799,7 +7799,7 @@
                 <a:ea typeface="Calibri"/>
                 <a:cs typeface="Calibri"/>
               </a:rPr>
-              <a:t>Nine sequence features improve grouped evaluation over current confidence.</a:t>
+              <a:t>The drift detector missed all six high-confidence errors.</a:t>
             </a:r>
           </a:p>
           <a:p xmlns:a="http://schemas.openxmlformats.org/drawingml/2006/main">
@@ -7822,7 +7822,7 @@
                 <a:ea typeface="Calibri"/>
                 <a:cs typeface="Calibri"/>
               </a:rPr>
-              <a:t>The detector caught none of six high-confidence errors.</a:t>
+              <a:t>A separate review rule routed all six, plus 78 correct cases.</a:t>
             </a:r>
           </a:p>
         </p:txBody>
@@ -7832,7 +7832,7 @@
           <p:cNvPr id="7" name="F1  0.468 to 0.508">
             <a:extLst xmlns:a="http://schemas.openxmlformats.org/drawingml/2006/main">
               <a:ext uri="{FF2B5EF4-FFF2-40B4-BE49-F238E27FC236}">
-                <a16:creationId xmlns:a16="http://schemas.microsoft.com/office/drawing/2014/main" id="{A41A6F8C-1A65-4326-B2A8-48AC52A4EDDB}"/>
+                <a16:creationId xmlns:a16="http://schemas.microsoft.com/office/drawing/2014/main" id="{87793C5B-754A-415E-B54D-A303D735B502}"/>
               </a:ext>
             </a:extLst>
           </p:cNvPr>
@@ -7889,7 +7889,7 @@
           <p:cNvPr id="8" name="ROC-AUC  0.729 to 0.763">
             <a:extLst xmlns:a="http://schemas.openxmlformats.org/drawingml/2006/main">
               <a:ext uri="{FF2B5EF4-FFF2-40B4-BE49-F238E27FC236}">
-                <a16:creationId xmlns:a16="http://schemas.microsoft.com/office/drawing/2014/main" id="{D75EA3E1-8909-4056-80F0-612E7CD77024}"/>
+                <a16:creationId xmlns:a16="http://schemas.microsoft.com/office/drawing/2014/main" id="{30C23FA5-6A99-4BD8-91ED-4113818DD134}"/>
               </a:ext>
             </a:extLst>
           </p:cNvPr>
@@ -7946,7 +7946,7 @@
           <p:cNvPr id="9" name="Code, data, models and research report: github.com">
             <a:extLst xmlns:a="http://schemas.openxmlformats.org/drawingml/2006/main">
               <a:ext uri="{FF2B5EF4-FFF2-40B4-BE49-F238E27FC236}">
-                <a16:creationId xmlns:a16="http://schemas.microsoft.com/office/drawing/2014/main" id="{55A9E2C2-39E9-4D77-B072-BD6602BD22F9}"/>
+                <a16:creationId xmlns:a16="http://schemas.microsoft.com/office/drawing/2014/main" id="{247D303D-885B-4898-8C7D-16718F0A9D06}"/>
               </a:ext>
             </a:extLst>
           </p:cNvPr>
@@ -8003,7 +8003,7 @@
                 <a:latin typeface="Calibri"/>
                 <a:ea typeface="Calibri"/>
                 <a:cs typeface="Calibri"/>
-                <a:hlinkClick xmlns:r="http://schemas.openxmlformats.org/officeDocument/2006/relationships" r:id="R67b11a05fda04708"/>
+                <a:hlinkClick xmlns:r="http://schemas.openxmlformats.org/officeDocument/2006/relationships" r:id="R930a417174f947ce"/>
               </a:rPr>
               <a:t>github.com/ahansardar/ai-confidence-drift</a:t>
             </a:r>
@@ -8013,7 +8013,7 @@
     </p:spTree>
     <p:extLst>
       <p:ext uri="{BB962C8B-B14F-4D97-AF65-F5344CB8AC3E}">
-        <p14:creationId xmlns:p14="http://schemas.microsoft.com/office/powerpoint/2010/main" val="1055261834"/>
+        <p14:creationId xmlns:p14="http://schemas.microsoft.com/office/powerpoint/2010/main" val="599556525"/>
       </p:ext>
     </p:extLst>
   </p:cSld>
@@ -8044,7 +8044,7 @@
           <p:cNvPr id="12" name="The confidence problem">
             <a:extLst xmlns:a="http://schemas.openxmlformats.org/drawingml/2006/main">
               <a:ext uri="{FF2B5EF4-FFF2-40B4-BE49-F238E27FC236}">
-                <a16:creationId xmlns:a16="http://schemas.microsoft.com/office/drawing/2014/main" id="{EDE1C0BE-F1A3-4B0D-A6AD-F5B56C2AC7D7}"/>
+                <a16:creationId xmlns:a16="http://schemas.microsoft.com/office/drawing/2014/main" id="{61B16C18-33DD-4C19-8E25-3D5C4FDEE0E1}"/>
               </a:ext>
             </a:extLst>
           </p:cNvPr>
@@ -8101,7 +8101,7 @@
           <p:cNvPr id="2" name="02">
             <a:extLst xmlns:a="http://schemas.openxmlformats.org/drawingml/2006/main">
               <a:ext uri="{FF2B5EF4-FFF2-40B4-BE49-F238E27FC236}">
-                <a16:creationId xmlns:a16="http://schemas.microsoft.com/office/drawing/2014/main" id="{B1249237-6398-4B93-A2D2-C0F44F59B696}"/>
+                <a16:creationId xmlns:a16="http://schemas.microsoft.com/office/drawing/2014/main" id="{38E56B1D-A35C-4432-8187-DE17B8FA9B3B}"/>
               </a:ext>
             </a:extLst>
           </p:cNvPr>
@@ -8158,7 +8158,7 @@
           <p:cNvPr id="3" name="96.3%">
             <a:extLst xmlns:a="http://schemas.openxmlformats.org/drawingml/2006/main">
               <a:ext uri="{FF2B5EF4-FFF2-40B4-BE49-F238E27FC236}">
-                <a16:creationId xmlns:a16="http://schemas.microsoft.com/office/drawing/2014/main" id="{7981ED07-D296-4EBB-A89E-59FD13E029DE}"/>
+                <a16:creationId xmlns:a16="http://schemas.microsoft.com/office/drawing/2014/main" id="{7E98425E-5BDD-48A9-B70A-44A1619024A9}"/>
               </a:ext>
             </a:extLst>
           </p:cNvPr>
@@ -8215,7 +8215,7 @@
           <p:cNvPr id="4" name="confident. Still wrong.">
             <a:extLst xmlns:a="http://schemas.openxmlformats.org/drawingml/2006/main">
               <a:ext uri="{FF2B5EF4-FFF2-40B4-BE49-F238E27FC236}">
-                <a16:creationId xmlns:a16="http://schemas.microsoft.com/office/drawing/2014/main" id="{5E79AB13-5D64-471B-A773-5724960A7211}"/>
+                <a16:creationId xmlns:a16="http://schemas.microsoft.com/office/drawing/2014/main" id="{C5F28DEE-7BF9-4759-B9B9-DEF8955A2C19}"/>
               </a:ext>
             </a:extLst>
           </p:cNvPr>
@@ -8272,7 +8272,7 @@
           <p:cNvPr id="5" name="One observed prediction&#10;Document doc_00750">
             <a:extLst xmlns:a="http://schemas.openxmlformats.org/drawingml/2006/main">
               <a:ext uri="{FF2B5EF4-FFF2-40B4-BE49-F238E27FC236}">
-                <a16:creationId xmlns:a16="http://schemas.microsoft.com/office/drawing/2014/main" id="{C4C60060-F820-4275-8907-7522D794A7E4}"/>
+                <a16:creationId xmlns:a16="http://schemas.microsoft.com/office/drawing/2014/main" id="{BFAEAB5B-00F0-4F3F-ACF1-3E1E3B6DE53D}"/>
               </a:ext>
             </a:extLst>
           </p:cNvPr>
@@ -8352,7 +8352,7 @@
           <p:cNvPr id="6" name="Confident errors">
             <a:extLst xmlns:a="http://schemas.openxmlformats.org/drawingml/2006/main">
               <a:ext uri="{FF2B5EF4-FFF2-40B4-BE49-F238E27FC236}">
-                <a16:creationId xmlns:a16="http://schemas.microsoft.com/office/drawing/2014/main" id="{03DD4331-72D6-4B5C-9A05-845AE0A7CC87}"/>
+                <a16:creationId xmlns:a16="http://schemas.microsoft.com/office/drawing/2014/main" id="{ADF5B278-CAEF-4AED-9933-0116917B46E6}"/>
               </a:ext>
             </a:extLst>
           </p:cNvPr>
@@ -8409,7 +8409,7 @@
           <p:cNvPr id="7" name="A model can be highly confident about an incorrect">
             <a:extLst xmlns:a="http://schemas.openxmlformats.org/drawingml/2006/main">
               <a:ext uri="{FF2B5EF4-FFF2-40B4-BE49-F238E27FC236}">
-                <a16:creationId xmlns:a16="http://schemas.microsoft.com/office/drawing/2014/main" id="{B1B2B204-5DF0-46D1-9B9B-BFC772C05DED}"/>
+                <a16:creationId xmlns:a16="http://schemas.microsoft.com/office/drawing/2014/main" id="{8C3DE774-AE2A-415C-8E15-A783CA75C6F8}"/>
               </a:ext>
             </a:extLst>
           </p:cNvPr>
@@ -8466,7 +8466,7 @@
           <p:cNvPr id="8" name="Unstable confidence">
             <a:extLst xmlns:a="http://schemas.openxmlformats.org/drawingml/2006/main">
               <a:ext uri="{FF2B5EF4-FFF2-40B4-BE49-F238E27FC236}">
-                <a16:creationId xmlns:a16="http://schemas.microsoft.com/office/drawing/2014/main" id="{EAC1EBC5-2E51-440D-8388-439144283196}"/>
+                <a16:creationId xmlns:a16="http://schemas.microsoft.com/office/drawing/2014/main" id="{06546966-1974-4DD2-8448-D8EC33CD1233}"/>
               </a:ext>
             </a:extLst>
           </p:cNvPr>
@@ -8523,7 +8523,7 @@
           <p:cNvPr id="9" name="Confidence can change across similar inputs withou">
             <a:extLst xmlns:a="http://schemas.openxmlformats.org/drawingml/2006/main">
               <a:ext uri="{FF2B5EF4-FFF2-40B4-BE49-F238E27FC236}">
-                <a16:creationId xmlns:a16="http://schemas.microsoft.com/office/drawing/2014/main" id="{AC35C61C-FADD-4BB3-A4A5-E78DE50E6DEC}"/>
+                <a16:creationId xmlns:a16="http://schemas.microsoft.com/office/drawing/2014/main" id="{884B944C-F9C2-40F0-9096-B51B1F9C59BF}"/>
               </a:ext>
             </a:extLst>
           </p:cNvPr>
@@ -8580,7 +8580,7 @@
           <p:cNvPr id="10" name="Increasing difficulty">
             <a:extLst xmlns:a="http://schemas.openxmlformats.org/drawingml/2006/main">
               <a:ext uri="{FF2B5EF4-FFF2-40B4-BE49-F238E27FC236}">
-                <a16:creationId xmlns:a16="http://schemas.microsoft.com/office/drawing/2014/main" id="{E1AC62EF-9892-43A2-A531-D12D2C5DBB03}"/>
+                <a16:creationId xmlns:a16="http://schemas.microsoft.com/office/drawing/2014/main" id="{13A76AD2-3837-4753-A96C-6EE646C45A5D}"/>
               </a:ext>
             </a:extLst>
           </p:cNvPr>
@@ -8637,7 +8637,7 @@
           <p:cNvPr id="11" name="Lower confidence may accompany harder inputs. The ">
             <a:extLst xmlns:a="http://schemas.openxmlformats.org/drawingml/2006/main">
               <a:ext uri="{FF2B5EF4-FFF2-40B4-BE49-F238E27FC236}">
-                <a16:creationId xmlns:a16="http://schemas.microsoft.com/office/drawing/2014/main" id="{7E9F7B7D-AAA6-4899-886C-EA601631EFE9}"/>
+                <a16:creationId xmlns:a16="http://schemas.microsoft.com/office/drawing/2014/main" id="{80FED9E6-0B2F-4D0B-8BD3-BB70E2367C00}"/>
               </a:ext>
             </a:extLst>
           </p:cNvPr>
@@ -8692,7 +8692,7 @@
     </p:spTree>
     <p:extLst>
       <p:ext uri="{BB962C8B-B14F-4D97-AF65-F5344CB8AC3E}">
-        <p14:creationId xmlns:p14="http://schemas.microsoft.com/office/powerpoint/2010/main" val="104942684"/>
+        <p14:creationId xmlns:p14="http://schemas.microsoft.com/office/powerpoint/2010/main" val="1855573096"/>
       </p:ext>
     </p:extLst>
   </p:cSld>
@@ -8723,7 +8723,7 @@
           <p:cNvPr id="9" name="Research question">
             <a:extLst xmlns:a="http://schemas.openxmlformats.org/drawingml/2006/main">
               <a:ext uri="{FF2B5EF4-FFF2-40B4-BE49-F238E27FC236}">
-                <a16:creationId xmlns:a16="http://schemas.microsoft.com/office/drawing/2014/main" id="{F87FE71A-24B2-4A8F-B070-09528BFFE35E}"/>
+                <a16:creationId xmlns:a16="http://schemas.microsoft.com/office/drawing/2014/main" id="{A05534E0-E69F-40A7-A7C1-2A3DE750099D}"/>
               </a:ext>
             </a:extLst>
           </p:cNvPr>
@@ -8780,7 +8780,7 @@
           <p:cNvPr id="2" name="03">
             <a:extLst xmlns:a="http://schemas.openxmlformats.org/drawingml/2006/main">
               <a:ext uri="{FF2B5EF4-FFF2-40B4-BE49-F238E27FC236}">
-                <a16:creationId xmlns:a16="http://schemas.microsoft.com/office/drawing/2014/main" id="{A4E6D59E-BE80-49C8-85A9-CF1402894D25}"/>
+                <a16:creationId xmlns:a16="http://schemas.microsoft.com/office/drawing/2014/main" id="{2DF09F8D-B248-4AF3-81DC-EF59508D8120}"/>
               </a:ext>
             </a:extLst>
           </p:cNvPr>
@@ -8837,7 +8837,7 @@
           <p:cNvPr id="3" name="Can changes in a model’s confidence">
             <a:extLst xmlns:a="http://schemas.openxmlformats.org/drawingml/2006/main">
               <a:ext uri="{FF2B5EF4-FFF2-40B4-BE49-F238E27FC236}">
-                <a16:creationId xmlns:a16="http://schemas.microsoft.com/office/drawing/2014/main" id="{D1470387-16D9-4D7C-9A68-7767DA6A0DA1}"/>
+                <a16:creationId xmlns:a16="http://schemas.microsoft.com/office/drawing/2014/main" id="{F5FF6355-8F71-4A4E-85ED-BA0F968C7ECE}"/>
               </a:ext>
             </a:extLst>
           </p:cNvPr>
@@ -8894,7 +8894,7 @@
           <p:cNvPr id="4" name="help identify predictions that are">
             <a:extLst xmlns:a="http://schemas.openxmlformats.org/drawingml/2006/main">
               <a:ext uri="{FF2B5EF4-FFF2-40B4-BE49-F238E27FC236}">
-                <a16:creationId xmlns:a16="http://schemas.microsoft.com/office/drawing/2014/main" id="{68165677-CC07-4139-8074-75774F88A9CA}"/>
+                <a16:creationId xmlns:a16="http://schemas.microsoft.com/office/drawing/2014/main" id="{F161DBA3-8492-48A3-910F-E28F1ABAC982}"/>
               </a:ext>
             </a:extLst>
           </p:cNvPr>
@@ -8951,7 +8951,7 @@
           <p:cNvPr id="5" name="likely to be unreliable?">
             <a:extLst xmlns:a="http://schemas.openxmlformats.org/drawingml/2006/main">
               <a:ext uri="{FF2B5EF4-FFF2-40B4-BE49-F238E27FC236}">
-                <a16:creationId xmlns:a16="http://schemas.microsoft.com/office/drawing/2014/main" id="{5EE1F557-B055-4FCD-A7AB-9E6C1AA65DB3}"/>
+                <a16:creationId xmlns:a16="http://schemas.microsoft.com/office/drawing/2014/main" id="{DF3F75C4-6677-46BB-A5F0-E50E66EDDA0A}"/>
               </a:ext>
             </a:extLst>
           </p:cNvPr>
@@ -9008,7 +9008,7 @@
           <p:cNvPr id="6" name="The hypothesis">
             <a:extLst xmlns:a="http://schemas.openxmlformats.org/drawingml/2006/main">
               <a:ext uri="{FF2B5EF4-FFF2-40B4-BE49-F238E27FC236}">
-                <a16:creationId xmlns:a16="http://schemas.microsoft.com/office/drawing/2014/main" id="{7758A7D0-344F-42DA-A4B2-A53DC0ED10E4}"/>
+                <a16:creationId xmlns:a16="http://schemas.microsoft.com/office/drawing/2014/main" id="{F835D5A9-2E89-4696-8EAA-52CFEFDE60C8}"/>
               </a:ext>
             </a:extLst>
           </p:cNvPr>
@@ -9065,7 +9065,7 @@
           <p:cNvPr id="7" name="Confidence history may help predict errors after a">
             <a:extLst xmlns:a="http://schemas.openxmlformats.org/drawingml/2006/main">
               <a:ext uri="{FF2B5EF4-FFF2-40B4-BE49-F238E27FC236}">
-                <a16:creationId xmlns:a16="http://schemas.microsoft.com/office/drawing/2014/main" id="{847A2E34-1661-4841-9334-0A60C7F644C8}"/>
+                <a16:creationId xmlns:a16="http://schemas.microsoft.com/office/drawing/2014/main" id="{C1AB28BC-775F-46FB-9A3D-6EF2B27242A3}"/>
               </a:ext>
             </a:extLst>
           </p:cNvPr>
@@ -9122,7 +9122,7 @@
           <p:cNvPr id="8" name="The A/B/C comparison isolates each additional sour">
             <a:extLst xmlns:a="http://schemas.openxmlformats.org/drawingml/2006/main">
               <a:ext uri="{FF2B5EF4-FFF2-40B4-BE49-F238E27FC236}">
-                <a16:creationId xmlns:a16="http://schemas.microsoft.com/office/drawing/2014/main" id="{D3310955-0116-4DA0-8660-CBDEC3D0D04B}"/>
+                <a16:creationId xmlns:a16="http://schemas.microsoft.com/office/drawing/2014/main" id="{117AFA38-F36A-4210-A6D0-BA7450770410}"/>
               </a:ext>
             </a:extLst>
           </p:cNvPr>
@@ -9177,7 +9177,7 @@
     </p:spTree>
     <p:extLst>
       <p:ext uri="{BB962C8B-B14F-4D97-AF65-F5344CB8AC3E}">
-        <p14:creationId xmlns:p14="http://schemas.microsoft.com/office/powerpoint/2010/main" val="617075785"/>
+        <p14:creationId xmlns:p14="http://schemas.microsoft.com/office/powerpoint/2010/main" val="2005935989"/>
       </p:ext>
     </p:extLst>
   </p:cSld>
@@ -9208,7 +9208,7 @@
           <p:cNvPr id="13" name="Task and dataset">
             <a:extLst xmlns:a="http://schemas.openxmlformats.org/drawingml/2006/main">
               <a:ext uri="{FF2B5EF4-FFF2-40B4-BE49-F238E27FC236}">
-                <a16:creationId xmlns:a16="http://schemas.microsoft.com/office/drawing/2014/main" id="{78053C97-40DD-4E74-B358-7094B38EAF69}"/>
+                <a16:creationId xmlns:a16="http://schemas.microsoft.com/office/drawing/2014/main" id="{9723426D-D435-4463-B4A0-F90BC5EFE064}"/>
               </a:ext>
             </a:extLst>
           </p:cNvPr>
@@ -9265,7 +9265,7 @@
           <p:cNvPr id="2" name="04">
             <a:extLst xmlns:a="http://schemas.openxmlformats.org/drawingml/2006/main">
               <a:ext uri="{FF2B5EF4-FFF2-40B4-BE49-F238E27FC236}">
-                <a16:creationId xmlns:a16="http://schemas.microsoft.com/office/drawing/2014/main" id="{E8F147BB-0690-4A9B-A497-A7B8A32B0DF5}"/>
+                <a16:creationId xmlns:a16="http://schemas.microsoft.com/office/drawing/2014/main" id="{7723F7D9-4AAA-4529-AD3F-CEA87D1A6481}"/>
               </a:ext>
             </a:extLst>
           </p:cNvPr>
@@ -9322,7 +9322,7 @@
           <p:cNvPr id="3" name="1,754">
             <a:extLst xmlns:a="http://schemas.openxmlformats.org/drawingml/2006/main">
               <a:ext uri="{FF2B5EF4-FFF2-40B4-BE49-F238E27FC236}">
-                <a16:creationId xmlns:a16="http://schemas.microsoft.com/office/drawing/2014/main" id="{3B23DDA3-29F4-40C7-B034-87ACB97275E3}"/>
+                <a16:creationId xmlns:a16="http://schemas.microsoft.com/office/drawing/2014/main" id="{34E24C4E-74A8-4276-A076-8294081E97DA}"/>
               </a:ext>
             </a:extLst>
           </p:cNvPr>
@@ -9379,7 +9379,7 @@
           <p:cNvPr id="4" name="documents from 20 Newsgroups">
             <a:extLst xmlns:a="http://schemas.openxmlformats.org/drawingml/2006/main">
               <a:ext uri="{FF2B5EF4-FFF2-40B4-BE49-F238E27FC236}">
-                <a16:creationId xmlns:a16="http://schemas.microsoft.com/office/drawing/2014/main" id="{FFB746EF-F497-4716-9907-458F4A9A8592}"/>
+                <a16:creationId xmlns:a16="http://schemas.microsoft.com/office/drawing/2014/main" id="{779814A4-D773-4417-9A9C-8A404BC8B3DF}"/>
               </a:ext>
             </a:extLst>
           </p:cNvPr>
@@ -9436,7 +9436,7 @@
           <p:cNvPr id="5" name="1,315 training / 439 test">
             <a:extLst xmlns:a="http://schemas.openxmlformats.org/drawingml/2006/main">
               <a:ext uri="{FF2B5EF4-FFF2-40B4-BE49-F238E27FC236}">
-                <a16:creationId xmlns:a16="http://schemas.microsoft.com/office/drawing/2014/main" id="{B121C03C-5BD6-4AF9-A75B-3FB28D43C7CD}"/>
+                <a16:creationId xmlns:a16="http://schemas.microsoft.com/office/drawing/2014/main" id="{91EBB7E2-3D79-4E43-A9DD-17B2BA14B7BF}"/>
               </a:ext>
             </a:extLst>
           </p:cNvPr>
@@ -9493,7 +9493,7 @@
           <p:cNvPr id="6" name="Stratified split&#10;44.4% / 55.6% class balance">
             <a:extLst xmlns:a="http://schemas.openxmlformats.org/drawingml/2006/main">
               <a:ext uri="{FF2B5EF4-FFF2-40B4-BE49-F238E27FC236}">
-                <a16:creationId xmlns:a16="http://schemas.microsoft.com/office/drawing/2014/main" id="{FB942BE4-D181-4505-BCFC-0C48BC98C983}"/>
+                <a16:creationId xmlns:a16="http://schemas.microsoft.com/office/drawing/2014/main" id="{08CC263A-817C-4374-9E75-A543CC5D7EF9}"/>
               </a:ext>
             </a:extLst>
           </p:cNvPr>
@@ -9573,7 +9573,7 @@
           <p:cNvPr id="7" name="Binary text classification">
             <a:extLst xmlns:a="http://schemas.openxmlformats.org/drawingml/2006/main">
               <a:ext uri="{FF2B5EF4-FFF2-40B4-BE49-F238E27FC236}">
-                <a16:creationId xmlns:a16="http://schemas.microsoft.com/office/drawing/2014/main" id="{F01D5722-3D31-430B-A282-42D43F017BD9}"/>
+                <a16:creationId xmlns:a16="http://schemas.microsoft.com/office/drawing/2014/main" id="{B6B357A2-1FDD-4249-8A2E-3F874EBAF6C5}"/>
               </a:ext>
             </a:extLst>
           </p:cNvPr>
@@ -9630,7 +9630,7 @@
           <p:cNvPr id="8" name="alt.atheism&#10;soc.religion.christian">
             <a:extLst xmlns:a="http://schemas.openxmlformats.org/drawingml/2006/main">
               <a:ext uri="{FF2B5EF4-FFF2-40B4-BE49-F238E27FC236}">
-                <a16:creationId xmlns:a16="http://schemas.microsoft.com/office/drawing/2014/main" id="{935DE137-1184-4614-89B1-19ECBCFF437D}"/>
+                <a16:creationId xmlns:a16="http://schemas.microsoft.com/office/drawing/2014/main" id="{EFC9EA04-5F21-4732-A2F1-95F14A5094B7}"/>
               </a:ext>
             </a:extLst>
           </p:cNvPr>
@@ -9710,7 +9710,7 @@
           <p:cNvPr id="9" name="Overlapping vocabulary makes the task less trivial">
             <a:extLst xmlns:a="http://schemas.openxmlformats.org/drawingml/2006/main">
               <a:ext uri="{FF2B5EF4-FFF2-40B4-BE49-F238E27FC236}">
-                <a16:creationId xmlns:a16="http://schemas.microsoft.com/office/drawing/2014/main" id="{AB9A64F3-7CCC-480F-8B15-5E6740AE255D}"/>
+                <a16:creationId xmlns:a16="http://schemas.microsoft.com/office/drawing/2014/main" id="{ABC5FA3A-932D-4D5C-AE4B-37BEDB651BEE}"/>
               </a:ext>
             </a:extLst>
           </p:cNvPr>
@@ -9767,7 +9767,7 @@
           <p:cNvPr id="10" name="Headers, footers and quoted text removed to reduce">
             <a:extLst xmlns:a="http://schemas.openxmlformats.org/drawingml/2006/main">
               <a:ext uri="{FF2B5EF4-FFF2-40B4-BE49-F238E27FC236}">
-                <a16:creationId xmlns:a16="http://schemas.microsoft.com/office/drawing/2014/main" id="{00A255C1-9953-4622-93AD-77C10125B485}"/>
+                <a16:creationId xmlns:a16="http://schemas.microsoft.com/office/drawing/2014/main" id="{74C55CBA-3E35-411D-A4AA-80DF8A2C8F09}"/>
               </a:ext>
             </a:extLst>
           </p:cNvPr>
@@ -9824,7 +9824,7 @@
           <p:cNvPr id="11" name="Ground truth: the newsgroup that published each po">
             <a:extLst xmlns:a="http://schemas.openxmlformats.org/drawingml/2006/main">
               <a:ext uri="{FF2B5EF4-FFF2-40B4-BE49-F238E27FC236}">
-                <a16:creationId xmlns:a16="http://schemas.microsoft.com/office/drawing/2014/main" id="{7E05A0B1-ABE1-4899-A48F-B785911732F8}"/>
+                <a16:creationId xmlns:a16="http://schemas.microsoft.com/office/drawing/2014/main" id="{7FF1EBD2-E4CE-465D-8835-820F345F7E82}"/>
               </a:ext>
             </a:extLst>
           </p:cNvPr>
@@ -9881,7 +9881,7 @@
           <p:cNvPr id="12" name="Source: scikit-learn’s official 20 Newsgroups mirr">
             <a:extLst xmlns:a="http://schemas.openxmlformats.org/drawingml/2006/main">
               <a:ext uri="{FF2B5EF4-FFF2-40B4-BE49-F238E27FC236}">
-                <a16:creationId xmlns:a16="http://schemas.microsoft.com/office/drawing/2014/main" id="{1AA3A766-5BAD-44DC-A4D1-16388D85FD4B}"/>
+                <a16:creationId xmlns:a16="http://schemas.microsoft.com/office/drawing/2014/main" id="{42FC575E-7573-4DAB-A4A4-FAB15A37504F}"/>
               </a:ext>
             </a:extLst>
           </p:cNvPr>
@@ -9936,7 +9936,7 @@
     </p:spTree>
     <p:extLst>
       <p:ext uri="{BB962C8B-B14F-4D97-AF65-F5344CB8AC3E}">
-        <p14:creationId xmlns:p14="http://schemas.microsoft.com/office/powerpoint/2010/main" val="1540017393"/>
+        <p14:creationId xmlns:p14="http://schemas.microsoft.com/office/powerpoint/2010/main" val="1333328300"/>
       </p:ext>
     </p:extLst>
   </p:cSld>
@@ -9967,7 +9967,7 @@
           <p:cNvPr id="18" name="The research pipeline">
             <a:extLst xmlns:a="http://schemas.openxmlformats.org/drawingml/2006/main">
               <a:ext uri="{FF2B5EF4-FFF2-40B4-BE49-F238E27FC236}">
-                <a16:creationId xmlns:a16="http://schemas.microsoft.com/office/drawing/2014/main" id="{22B4A6A4-B504-4249-B16D-9C3A1261F4A1}"/>
+                <a16:creationId xmlns:a16="http://schemas.microsoft.com/office/drawing/2014/main" id="{64EF3B96-2822-403D-9C5B-91712B88142D}"/>
               </a:ext>
             </a:extLst>
           </p:cNvPr>
@@ -10024,7 +10024,7 @@
           <p:cNvPr id="2" name="05">
             <a:extLst xmlns:a="http://schemas.openxmlformats.org/drawingml/2006/main">
               <a:ext uri="{FF2B5EF4-FFF2-40B4-BE49-F238E27FC236}">
-                <a16:creationId xmlns:a16="http://schemas.microsoft.com/office/drawing/2014/main" id="{1C5A271E-18C3-48DC-A622-B1D1E0CCFEF1}"/>
+                <a16:creationId xmlns:a16="http://schemas.microsoft.com/office/drawing/2014/main" id="{B84B378B-955C-4137-BE81-75B227815866}"/>
               </a:ext>
             </a:extLst>
           </p:cNvPr>
@@ -10081,7 +10081,7 @@
           <p:cNvPr id="3" name="01">
             <a:extLst xmlns:a="http://schemas.openxmlformats.org/drawingml/2006/main">
               <a:ext uri="{FF2B5EF4-FFF2-40B4-BE49-F238E27FC236}">
-                <a16:creationId xmlns:a16="http://schemas.microsoft.com/office/drawing/2014/main" id="{A232D765-EE3A-413B-9A5E-440878244717}"/>
+                <a16:creationId xmlns:a16="http://schemas.microsoft.com/office/drawing/2014/main" id="{66FD7112-DCC3-4EB7-8289-33C4D29C745E}"/>
               </a:ext>
             </a:extLst>
           </p:cNvPr>
@@ -10138,7 +10138,7 @@
           <p:cNvPr id="4" name="Train the base classifier">
             <a:extLst xmlns:a="http://schemas.openxmlformats.org/drawingml/2006/main">
               <a:ext uri="{FF2B5EF4-FFF2-40B4-BE49-F238E27FC236}">
-                <a16:creationId xmlns:a16="http://schemas.microsoft.com/office/drawing/2014/main" id="{0B3F0E1F-F4A3-4872-88DA-B138427F3A0F}"/>
+                <a16:creationId xmlns:a16="http://schemas.microsoft.com/office/drawing/2014/main" id="{8F9687CD-C0F7-4D92-A288-53FD0E6EA4A3}"/>
               </a:ext>
             </a:extLst>
           </p:cNvPr>
@@ -10195,7 +10195,7 @@
           <p:cNvPr id="5" name="TF-IDF + Logistic Regression for text classificati">
             <a:extLst xmlns:a="http://schemas.openxmlformats.org/drawingml/2006/main">
               <a:ext uri="{FF2B5EF4-FFF2-40B4-BE49-F238E27FC236}">
-                <a16:creationId xmlns:a16="http://schemas.microsoft.com/office/drawing/2014/main" id="{12FEAD71-C409-4E15-8536-FDBA11F472B0}"/>
+                <a16:creationId xmlns:a16="http://schemas.microsoft.com/office/drawing/2014/main" id="{7ACD0602-A6FD-44C5-9025-1958232E6C87}"/>
               </a:ext>
             </a:extLst>
           </p:cNvPr>
@@ -10252,7 +10252,7 @@
           <p:cNvPr id="6" name="02">
             <a:extLst xmlns:a="http://schemas.openxmlformats.org/drawingml/2006/main">
               <a:ext uri="{FF2B5EF4-FFF2-40B4-BE49-F238E27FC236}">
-                <a16:creationId xmlns:a16="http://schemas.microsoft.com/office/drawing/2014/main" id="{B6874D0B-F9C1-4CC8-B896-14CD48EB981C}"/>
+                <a16:creationId xmlns:a16="http://schemas.microsoft.com/office/drawing/2014/main" id="{B8774D1B-D4AE-4B50-84FF-A05B8528AB11}"/>
               </a:ext>
             </a:extLst>
           </p:cNvPr>
@@ -10309,7 +10309,7 @@
           <p:cNvPr id="7" name="Generate confidence sequences">
             <a:extLst xmlns:a="http://schemas.openxmlformats.org/drawingml/2006/main">
               <a:ext uri="{FF2B5EF4-FFF2-40B4-BE49-F238E27FC236}">
-                <a16:creationId xmlns:a16="http://schemas.microsoft.com/office/drawing/2014/main" id="{71DD21EB-3DD7-491C-8564-BB07907E2480}"/>
+                <a16:creationId xmlns:a16="http://schemas.microsoft.com/office/drawing/2014/main" id="{0D737C94-CC54-4318-87D9-BE12EF866087}"/>
               </a:ext>
             </a:extLst>
           </p:cNvPr>
@@ -10366,7 +10366,7 @@
           <p:cNvPr id="8" name="Re-classify each test document at six corruption l">
             <a:extLst xmlns:a="http://schemas.openxmlformats.org/drawingml/2006/main">
               <a:ext uri="{FF2B5EF4-FFF2-40B4-BE49-F238E27FC236}">
-                <a16:creationId xmlns:a16="http://schemas.microsoft.com/office/drawing/2014/main" id="{264635BD-73F9-4B66-8DF2-A1950BDD71FA}"/>
+                <a16:creationId xmlns:a16="http://schemas.microsoft.com/office/drawing/2014/main" id="{1C6FCEE6-6A23-4DFF-B8B6-603E1153691D}"/>
               </a:ext>
             </a:extLst>
           </p:cNvPr>
@@ -10423,7 +10423,7 @@
           <p:cNvPr id="9" name="03">
             <a:extLst xmlns:a="http://schemas.openxmlformats.org/drawingml/2006/main">
               <a:ext uri="{FF2B5EF4-FFF2-40B4-BE49-F238E27FC236}">
-                <a16:creationId xmlns:a16="http://schemas.microsoft.com/office/drawing/2014/main" id="{7131CB61-16C7-49B7-AFA8-D0ADE053336B}"/>
+                <a16:creationId xmlns:a16="http://schemas.microsoft.com/office/drawing/2014/main" id="{4EBB4723-6061-4FBC-A92F-D82DE1CA41F6}"/>
               </a:ext>
             </a:extLst>
           </p:cNvPr>
@@ -10480,7 +10480,7 @@
           <p:cNvPr id="10" name="Engineer drift features">
             <a:extLst xmlns:a="http://schemas.openxmlformats.org/drawingml/2006/main">
               <a:ext uri="{FF2B5EF4-FFF2-40B4-BE49-F238E27FC236}">
-                <a16:creationId xmlns:a16="http://schemas.microsoft.com/office/drawing/2014/main" id="{6827626A-1A69-476E-887F-3D11C3CB5E85}"/>
+                <a16:creationId xmlns:a16="http://schemas.microsoft.com/office/drawing/2014/main" id="{14FF3D1C-4D16-4E56-B8DD-6A8DEFF05A7F}"/>
               </a:ext>
             </a:extLst>
           </p:cNvPr>
@@ -10537,7 +10537,7 @@
           <p:cNvPr id="11" name="Moving statistics, deltas, consecutive drops and m">
             <a:extLst xmlns:a="http://schemas.openxmlformats.org/drawingml/2006/main">
               <a:ext uri="{FF2B5EF4-FFF2-40B4-BE49-F238E27FC236}">
-                <a16:creationId xmlns:a16="http://schemas.microsoft.com/office/drawing/2014/main" id="{1ED59C98-AB32-4083-9C93-B9B1147BB0D2}"/>
+                <a16:creationId xmlns:a16="http://schemas.microsoft.com/office/drawing/2014/main" id="{61C3F93F-7346-4936-B571-73143F36E4E2}"/>
               </a:ext>
             </a:extLst>
           </p:cNvPr>
@@ -10594,7 +10594,7 @@
           <p:cNvPr id="12" name="04">
             <a:extLst xmlns:a="http://schemas.openxmlformats.org/drawingml/2006/main">
               <a:ext uri="{FF2B5EF4-FFF2-40B4-BE49-F238E27FC236}">
-                <a16:creationId xmlns:a16="http://schemas.microsoft.com/office/drawing/2014/main" id="{A0992451-7C24-40C0-8CD8-52345904C7A9}"/>
+                <a16:creationId xmlns:a16="http://schemas.microsoft.com/office/drawing/2014/main" id="{86E40138-5C14-4A6E-8847-16A072D6713E}"/>
               </a:ext>
             </a:extLst>
           </p:cNvPr>
@@ -10651,7 +10651,7 @@
           <p:cNvPr id="13" name="Train a second model">
             <a:extLst xmlns:a="http://schemas.openxmlformats.org/drawingml/2006/main">
               <a:ext uri="{FF2B5EF4-FFF2-40B4-BE49-F238E27FC236}">
-                <a16:creationId xmlns:a16="http://schemas.microsoft.com/office/drawing/2014/main" id="{402AD468-29EA-4606-96D0-CA1FDDE75127}"/>
+                <a16:creationId xmlns:a16="http://schemas.microsoft.com/office/drawing/2014/main" id="{092E855D-DB44-4FF5-9898-0A612ADECB33}"/>
               </a:ext>
             </a:extLst>
           </p:cNvPr>
@@ -10708,7 +10708,7 @@
           <p:cNvPr id="14" name="Predict whether a classification is unreliable.">
             <a:extLst xmlns:a="http://schemas.openxmlformats.org/drawingml/2006/main">
               <a:ext uri="{FF2B5EF4-FFF2-40B4-BE49-F238E27FC236}">
-                <a16:creationId xmlns:a16="http://schemas.microsoft.com/office/drawing/2014/main" id="{F5D58237-867E-43FF-AD94-A32BE7E92B76}"/>
+                <a16:creationId xmlns:a16="http://schemas.microsoft.com/office/drawing/2014/main" id="{FC0525D4-04D0-4E27-95E4-54E1CA7F25F2}"/>
               </a:ext>
             </a:extLst>
           </p:cNvPr>
@@ -10765,7 +10765,7 @@
           <p:cNvPr id="15" name="05">
             <a:extLst xmlns:a="http://schemas.openxmlformats.org/drawingml/2006/main">
               <a:ext uri="{FF2B5EF4-FFF2-40B4-BE49-F238E27FC236}">
-                <a16:creationId xmlns:a16="http://schemas.microsoft.com/office/drawing/2014/main" id="{F75E3820-5231-4421-8667-FB4FF91E754A}"/>
+                <a16:creationId xmlns:a16="http://schemas.microsoft.com/office/drawing/2014/main" id="{D613EDE1-89D9-40C6-8F51-FB00F307C0FE}"/>
               </a:ext>
             </a:extLst>
           </p:cNvPr>
@@ -10822,7 +10822,7 @@
           <p:cNvPr id="16" name="Evaluate the detector">
             <a:extLst xmlns:a="http://schemas.openxmlformats.org/drawingml/2006/main">
               <a:ext uri="{FF2B5EF4-FFF2-40B4-BE49-F238E27FC236}">
-                <a16:creationId xmlns:a16="http://schemas.microsoft.com/office/drawing/2014/main" id="{9EAC8CEF-3AF3-4FD4-B887-C3BD2B7EE2BC}"/>
+                <a16:creationId xmlns:a16="http://schemas.microsoft.com/office/drawing/2014/main" id="{9CF83BE2-B548-4D8A-9C05-7F2D1B25BA75}"/>
               </a:ext>
             </a:extLst>
           </p:cNvPr>
@@ -10879,7 +10879,7 @@
           <p:cNvPr id="17" name="Calibration, high-confidence errors and an A/B/C c">
             <a:extLst xmlns:a="http://schemas.openxmlformats.org/drawingml/2006/main">
               <a:ext uri="{FF2B5EF4-FFF2-40B4-BE49-F238E27FC236}">
-                <a16:creationId xmlns:a16="http://schemas.microsoft.com/office/drawing/2014/main" id="{D2852D5C-CBBF-4BE0-94D6-14D310C03ECA}"/>
+                <a16:creationId xmlns:a16="http://schemas.microsoft.com/office/drawing/2014/main" id="{3F7A34DB-0594-4FDB-941B-FD498EAE8A7D}"/>
               </a:ext>
             </a:extLst>
           </p:cNvPr>
@@ -10934,7 +10934,7 @@
     </p:spTree>
     <p:extLst>
       <p:ext uri="{BB962C8B-B14F-4D97-AF65-F5344CB8AC3E}">
-        <p14:creationId xmlns:p14="http://schemas.microsoft.com/office/powerpoint/2010/main" val="561444284"/>
+        <p14:creationId xmlns:p14="http://schemas.microsoft.com/office/powerpoint/2010/main" val="1469816286"/>
       </p:ext>
     </p:extLst>
   </p:cSld>
@@ -10965,7 +10965,7 @@
           <p:cNvPr id="12" name="How confidence changes">
             <a:extLst xmlns:a="http://schemas.openxmlformats.org/drawingml/2006/main">
               <a:ext uri="{FF2B5EF4-FFF2-40B4-BE49-F238E27FC236}">
-                <a16:creationId xmlns:a16="http://schemas.microsoft.com/office/drawing/2014/main" id="{F4E6D642-45D2-4421-8243-36C60C4CE40E}"/>
+                <a16:creationId xmlns:a16="http://schemas.microsoft.com/office/drawing/2014/main" id="{45B4F50A-730E-4E4A-8FC1-F5F0A2A90C54}"/>
               </a:ext>
             </a:extLst>
           </p:cNvPr>
@@ -11022,7 +11022,7 @@
           <p:cNvPr id="2" name="06">
             <a:extLst xmlns:a="http://schemas.openxmlformats.org/drawingml/2006/main">
               <a:ext uri="{FF2B5EF4-FFF2-40B4-BE49-F238E27FC236}">
-                <a16:creationId xmlns:a16="http://schemas.microsoft.com/office/drawing/2014/main" id="{21481AE8-0248-4DF1-A8A3-715AF45DDA59}"/>
+                <a16:creationId xmlns:a16="http://schemas.microsoft.com/office/drawing/2014/main" id="{5DF74729-A8CD-42D8-B1D5-3CAEEBE81C8B}"/>
               </a:ext>
             </a:extLst>
           </p:cNvPr>
@@ -11079,7 +11079,7 @@
           <p:cNvPr id="3" name="Six levels, from 0% to 50% of words removed and sh">
             <a:extLst xmlns:a="http://schemas.openxmlformats.org/drawingml/2006/main">
               <a:ext uri="{FF2B5EF4-FFF2-40B4-BE49-F238E27FC236}">
-                <a16:creationId xmlns:a16="http://schemas.microsoft.com/office/drawing/2014/main" id="{7E46B2DB-8CEB-49C5-9679-C8926435D0D4}"/>
+                <a16:creationId xmlns:a16="http://schemas.microsoft.com/office/drawing/2014/main" id="{0473F4C1-BCDC-454C-8366-C390C4F57F77}"/>
               </a:ext>
             </a:extLst>
           </p:cNvPr>
@@ -11136,7 +11136,7 @@
           <p:cNvPr id="4" name="Two contrasting examples">
             <a:extLst xmlns:a="http://schemas.openxmlformats.org/drawingml/2006/main">
               <a:ext uri="{FF2B5EF4-FFF2-40B4-BE49-F238E27FC236}">
-                <a16:creationId xmlns:a16="http://schemas.microsoft.com/office/drawing/2014/main" id="{DFB0EBB2-67C9-414E-BBD6-57828FD269F2}"/>
+                <a16:creationId xmlns:a16="http://schemas.microsoft.com/office/drawing/2014/main" id="{13339BE5-429D-438E-B3C0-E46EFD430A15}"/>
               </a:ext>
             </a:extLst>
           </p:cNvPr>
@@ -11776,7 +11776,7 @@
           <p:cNvPr id="6" name="Stayed wrong">
             <a:extLst xmlns:a="http://schemas.openxmlformats.org/drawingml/2006/main">
               <a:ext uri="{FF2B5EF4-FFF2-40B4-BE49-F238E27FC236}">
-                <a16:creationId xmlns:a16="http://schemas.microsoft.com/office/drawing/2014/main" id="{B30CDB79-BC1E-4B20-9D4B-D0A3E379EBE7}"/>
+                <a16:creationId xmlns:a16="http://schemas.microsoft.com/office/drawing/2014/main" id="{70E3991C-61CC-4CE0-86BF-5B6C0FB2F605}"/>
               </a:ext>
             </a:extLst>
           </p:cNvPr>
@@ -11833,7 +11833,7 @@
           <p:cNvPr id="7" name="Stayed correct">
             <a:extLst xmlns:a="http://schemas.openxmlformats.org/drawingml/2006/main">
               <a:ext uri="{FF2B5EF4-FFF2-40B4-BE49-F238E27FC236}">
-                <a16:creationId xmlns:a16="http://schemas.microsoft.com/office/drawing/2014/main" id="{C91B0D20-4DDA-4D9A-A945-A9870A369963}"/>
+                <a16:creationId xmlns:a16="http://schemas.microsoft.com/office/drawing/2014/main" id="{C3D30089-A8CD-421D-A775-0E9A11E7F2AC}"/>
               </a:ext>
             </a:extLst>
           </p:cNvPr>
@@ -11890,7 +11890,7 @@
           <p:cNvPr id="8" name="Confidence">
             <a:extLst xmlns:a="http://schemas.openxmlformats.org/drawingml/2006/main">
               <a:ext uri="{FF2B5EF4-FFF2-40B4-BE49-F238E27FC236}">
-                <a16:creationId xmlns:a16="http://schemas.microsoft.com/office/drawing/2014/main" id="{34E592FB-7FB6-4619-869C-3DDE51D587C5}"/>
+                <a16:creationId xmlns:a16="http://schemas.microsoft.com/office/drawing/2014/main" id="{3C9A08FB-6BDB-468F-B7DC-64297599F872}"/>
               </a:ext>
             </a:extLst>
           </p:cNvPr>
@@ -11954,7 +11954,7 @@
         </p:xfrm>
         <a:graphic xmlns:a="http://schemas.openxmlformats.org/drawingml/2006/main">
           <a:graphicData uri="http://schemas.openxmlformats.org/drawingml/2006/chart">
-            <c:chart xmlns:r="http://schemas.openxmlformats.org/officeDocument/2006/relationships" xmlns:c="http://schemas.openxmlformats.org/drawingml/2006/chart" r:id="R47174d91d40f4cff"/>
+            <c:chart xmlns:r="http://schemas.openxmlformats.org/officeDocument/2006/relationships" xmlns:c="http://schemas.openxmlformats.org/drawingml/2006/chart" r:id="Rf42209b59aee4f6b"/>
           </a:graphicData>
         </a:graphic>
       </p:graphicFrame>
@@ -11963,7 +11963,7 @@
           <p:cNvPr id="10" name="12 test documents. Green: correct at the final ste">
             <a:extLst xmlns:a="http://schemas.openxmlformats.org/drawingml/2006/main">
               <a:ext uri="{FF2B5EF4-FFF2-40B4-BE49-F238E27FC236}">
-                <a16:creationId xmlns:a16="http://schemas.microsoft.com/office/drawing/2014/main" id="{E05D33A0-99F7-4F50-A0AE-F4389E946AEA}"/>
+                <a16:creationId xmlns:a16="http://schemas.microsoft.com/office/drawing/2014/main" id="{90D55853-655C-4DB7-B74B-04D64E6B9B36}"/>
               </a:ext>
             </a:extLst>
           </p:cNvPr>
@@ -12020,7 +12020,7 @@
           <p:cNvPr id="11" name="Sequences simulate repeated predictions through te">
             <a:extLst xmlns:a="http://schemas.openxmlformats.org/drawingml/2006/main">
               <a:ext uri="{FF2B5EF4-FFF2-40B4-BE49-F238E27FC236}">
-                <a16:creationId xmlns:a16="http://schemas.microsoft.com/office/drawing/2014/main" id="{68BE24BB-E2DE-4683-8F36-B324CE44F9AA}"/>
+                <a16:creationId xmlns:a16="http://schemas.microsoft.com/office/drawing/2014/main" id="{250D3194-7C6B-47BA-88D4-42671313BE5A}"/>
               </a:ext>
             </a:extLst>
           </p:cNvPr>
@@ -12075,7 +12075,7 @@
     </p:spTree>
     <p:extLst>
       <p:ext uri="{BB962C8B-B14F-4D97-AF65-F5344CB8AC3E}">
-        <p14:creationId xmlns:p14="http://schemas.microsoft.com/office/powerpoint/2010/main" val="911559577"/>
+        <p14:creationId xmlns:p14="http://schemas.microsoft.com/office/powerpoint/2010/main" val="537329521"/>
       </p:ext>
     </p:extLst>
   </p:cSld>
@@ -12106,7 +12106,7 @@
           <p:cNvPr id="5" name="Anatomy of a confidence sequence">
             <a:extLst xmlns:a="http://schemas.openxmlformats.org/drawingml/2006/main">
               <a:ext uri="{FF2B5EF4-FFF2-40B4-BE49-F238E27FC236}">
-                <a16:creationId xmlns:a16="http://schemas.microsoft.com/office/drawing/2014/main" id="{0CBFBA50-3327-4D68-B41C-0F57D64EC505}"/>
+                <a16:creationId xmlns:a16="http://schemas.microsoft.com/office/drawing/2014/main" id="{E96F04CE-64B2-4968-BEAC-C11B97C4CAC8}"/>
               </a:ext>
             </a:extLst>
           </p:cNvPr>
@@ -12163,7 +12163,7 @@
           <p:cNvPr id="2" name="07">
             <a:extLst xmlns:a="http://schemas.openxmlformats.org/drawingml/2006/main">
               <a:ext uri="{FF2B5EF4-FFF2-40B4-BE49-F238E27FC236}">
-                <a16:creationId xmlns:a16="http://schemas.microsoft.com/office/drawing/2014/main" id="{DAAC50C9-9303-4181-8E1E-DD67BEEBA85B}"/>
+                <a16:creationId xmlns:a16="http://schemas.microsoft.com/office/drawing/2014/main" id="{42F2F7F6-E73B-448E-9CED-673EAF60BBB9}"/>
               </a:ext>
             </a:extLst>
           </p:cNvPr>
@@ -12220,7 +12220,7 @@
           <p:cNvPr id="3" name="13 features, compared with simpler baselines in th">
             <a:extLst xmlns:a="http://schemas.openxmlformats.org/drawingml/2006/main">
               <a:ext uri="{FF2B5EF4-FFF2-40B4-BE49-F238E27FC236}">
-                <a16:creationId xmlns:a16="http://schemas.microsoft.com/office/drawing/2014/main" id="{52ADD828-CE07-485E-AB99-88271DCB823C}"/>
+                <a16:creationId xmlns:a16="http://schemas.microsoft.com/office/drawing/2014/main" id="{1C916293-6DEF-4C9A-A3CD-BFAF8FB7D871}"/>
               </a:ext>
             </a:extLst>
           </p:cNvPr>
@@ -12593,7 +12593,7 @@
     </p:spTree>
     <p:extLst>
       <p:ext uri="{BB962C8B-B14F-4D97-AF65-F5344CB8AC3E}">
-        <p14:creationId xmlns:p14="http://schemas.microsoft.com/office/powerpoint/2010/main" val="1437085572"/>
+        <p14:creationId xmlns:p14="http://schemas.microsoft.com/office/powerpoint/2010/main" val="107394275"/>
       </p:ext>
     </p:extLst>
   </p:cSld>
@@ -12624,7 +12624,7 @@
           <p:cNvPr id="7" name="Confidence carries signal">
             <a:extLst xmlns:a="http://schemas.openxmlformats.org/drawingml/2006/main">
               <a:ext uri="{FF2B5EF4-FFF2-40B4-BE49-F238E27FC236}">
-                <a16:creationId xmlns:a16="http://schemas.microsoft.com/office/drawing/2014/main" id="{F401A666-5C94-4E34-BA1A-C576D3357682}"/>
+                <a16:creationId xmlns:a16="http://schemas.microsoft.com/office/drawing/2014/main" id="{43946350-C3BF-4804-B1F5-A6CB3F3C1B5D}"/>
               </a:ext>
             </a:extLst>
           </p:cNvPr>
@@ -12681,7 +12681,7 @@
           <p:cNvPr id="2" name="08">
             <a:extLst xmlns:a="http://schemas.openxmlformats.org/drawingml/2006/main">
               <a:ext uri="{FF2B5EF4-FFF2-40B4-BE49-F238E27FC236}">
-                <a16:creationId xmlns:a16="http://schemas.microsoft.com/office/drawing/2014/main" id="{C148FB23-E38C-4C2F-9B67-DAE02979D17B}"/>
+                <a16:creationId xmlns:a16="http://schemas.microsoft.com/office/drawing/2014/main" id="{3BFBF29E-947A-46E4-BE26-496A7644C909}"/>
               </a:ext>
             </a:extLst>
           </p:cNvPr>
@@ -12738,7 +12738,7 @@
           <p:cNvPr id="3" name="Accuracy across 439 uncorrupted test predictions">
             <a:extLst xmlns:a="http://schemas.openxmlformats.org/drawingml/2006/main">
               <a:ext uri="{FF2B5EF4-FFF2-40B4-BE49-F238E27FC236}">
-                <a16:creationId xmlns:a16="http://schemas.microsoft.com/office/drawing/2014/main" id="{919E1A65-E436-4870-A82F-CADA5F2E293A}"/>
+                <a16:creationId xmlns:a16="http://schemas.microsoft.com/office/drawing/2014/main" id="{E9C1DAB3-FD46-4A95-AE91-86BDE6A7670D}"/>
               </a:ext>
             </a:extLst>
           </p:cNvPr>
@@ -12802,7 +12802,7 @@
         </p:xfrm>
         <a:graphic xmlns:a="http://schemas.openxmlformats.org/drawingml/2006/main">
           <a:graphicData uri="http://schemas.openxmlformats.org/drawingml/2006/chart">
-            <c:chart xmlns:r="http://schemas.openxmlformats.org/officeDocument/2006/relationships" xmlns:c="http://schemas.openxmlformats.org/drawingml/2006/chart" r:id="R4d64d363ba0546a6"/>
+            <c:chart xmlns:r="http://schemas.openxmlformats.org/officeDocument/2006/relationships" xmlns:c="http://schemas.openxmlformats.org/drawingml/2006/chart" r:id="Re0a2de3c257849d2"/>
           </a:graphicData>
         </a:graphic>
       </p:graphicFrame>
@@ -13154,7 +13154,7 @@
           <p:cNvPr id="6" name="Confidence carries signal, but calibration remains">
             <a:extLst xmlns:a="http://schemas.openxmlformats.org/drawingml/2006/main">
               <a:ext uri="{FF2B5EF4-FFF2-40B4-BE49-F238E27FC236}">
-                <a16:creationId xmlns:a16="http://schemas.microsoft.com/office/drawing/2014/main" id="{BF22F8F7-736F-4BC6-94ED-9A884E57F8E2}"/>
+                <a16:creationId xmlns:a16="http://schemas.microsoft.com/office/drawing/2014/main" id="{F53062C9-02AE-41F9-A89C-4F3A208600FF}"/>
               </a:ext>
             </a:extLst>
           </p:cNvPr>
@@ -13209,7 +13209,7 @@
     </p:spTree>
     <p:extLst>
       <p:ext uri="{BB962C8B-B14F-4D97-AF65-F5344CB8AC3E}">
-        <p14:creationId xmlns:p14="http://schemas.microsoft.com/office/powerpoint/2010/main" val="1581922426"/>
+        <p14:creationId xmlns:p14="http://schemas.microsoft.com/office/powerpoint/2010/main" val="1045404719"/>
       </p:ext>
     </p:extLst>
   </p:cSld>
@@ -13240,7 +13240,7 @@
           <p:cNvPr id="12" name="The calibration gap">
             <a:extLst xmlns:a="http://schemas.openxmlformats.org/drawingml/2006/main">
               <a:ext uri="{FF2B5EF4-FFF2-40B4-BE49-F238E27FC236}">
-                <a16:creationId xmlns:a16="http://schemas.microsoft.com/office/drawing/2014/main" id="{7CB028A5-A899-4C8F-A4F1-8AB0BFFC754E}"/>
+                <a16:creationId xmlns:a16="http://schemas.microsoft.com/office/drawing/2014/main" id="{D76204E0-DB84-4FA4-B626-F5F217A583DF}"/>
               </a:ext>
             </a:extLst>
           </p:cNvPr>
@@ -13297,7 +13297,7 @@
           <p:cNvPr id="2" name="09">
             <a:extLst xmlns:a="http://schemas.openxmlformats.org/drawingml/2006/main">
               <a:ext uri="{FF2B5EF4-FFF2-40B4-BE49-F238E27FC236}">
-                <a16:creationId xmlns:a16="http://schemas.microsoft.com/office/drawing/2014/main" id="{3B38A593-F765-405F-80B9-1EBB88BB7719}"/>
+                <a16:creationId xmlns:a16="http://schemas.microsoft.com/office/drawing/2014/main" id="{E1B9E5D0-D874-4709-88FC-487A29FE534A}"/>
               </a:ext>
             </a:extLst>
           </p:cNvPr>
@@ -13354,7 +13354,7 @@
           <p:cNvPr id="3" name="Reliability diagram for uncorrupted test predictio">
             <a:extLst xmlns:a="http://schemas.openxmlformats.org/drawingml/2006/main">
               <a:ext uri="{FF2B5EF4-FFF2-40B4-BE49-F238E27FC236}">
-                <a16:creationId xmlns:a16="http://schemas.microsoft.com/office/drawing/2014/main" id="{9842E7BC-AA9F-49D3-8E24-9C34B49EA9B7}"/>
+                <a16:creationId xmlns:a16="http://schemas.microsoft.com/office/drawing/2014/main" id="{8321F386-8EB3-41E9-8A92-6EA3B52BED66}"/>
               </a:ext>
             </a:extLst>
           </p:cNvPr>
@@ -13418,7 +13418,7 @@
         </p:xfrm>
         <a:graphic xmlns:a="http://schemas.openxmlformats.org/drawingml/2006/main">
           <a:graphicData uri="http://schemas.openxmlformats.org/drawingml/2006/chart">
-            <c:chart xmlns:r="http://schemas.openxmlformats.org/officeDocument/2006/relationships" xmlns:c="http://schemas.openxmlformats.org/drawingml/2006/chart" r:id="R9b7875ab74184ee2"/>
+            <c:chart xmlns:r="http://schemas.openxmlformats.org/officeDocument/2006/relationships" xmlns:c="http://schemas.openxmlformats.org/drawingml/2006/chart" r:id="Rbf71e881d7934c67"/>
           </a:graphicData>
         </a:graphic>
       </p:graphicFrame>
@@ -13427,7 +13427,7 @@
           <p:cNvPr id="5" name="0.153">
             <a:extLst xmlns:a="http://schemas.openxmlformats.org/drawingml/2006/main">
               <a:ext uri="{FF2B5EF4-FFF2-40B4-BE49-F238E27FC236}">
-                <a16:creationId xmlns:a16="http://schemas.microsoft.com/office/drawing/2014/main" id="{2600BF51-3B0E-4E05-AC24-85BC99CFA122}"/>
+                <a16:creationId xmlns:a16="http://schemas.microsoft.com/office/drawing/2014/main" id="{D76D3B2D-520C-4E0E-89B9-F04EF9CD0B63}"/>
               </a:ext>
             </a:extLst>
           </p:cNvPr>
@@ -13484,7 +13484,7 @@
           <p:cNvPr id="6" name="0.160">
             <a:extLst xmlns:a="http://schemas.openxmlformats.org/drawingml/2006/main">
               <a:ext uri="{FF2B5EF4-FFF2-40B4-BE49-F238E27FC236}">
-                <a16:creationId xmlns:a16="http://schemas.microsoft.com/office/drawing/2014/main" id="{9A183EF1-F70E-4369-8A39-2ACACE623FEF}"/>
+                <a16:creationId xmlns:a16="http://schemas.microsoft.com/office/drawing/2014/main" id="{99553CC2-7F62-4C96-8EA7-4EA6A718416A}"/>
               </a:ext>
             </a:extLst>
           </p:cNvPr>
@@ -13541,7 +13541,7 @@
           <p:cNvPr id="7" name="Calibration error">
             <a:extLst xmlns:a="http://schemas.openxmlformats.org/drawingml/2006/main">
               <a:ext uri="{FF2B5EF4-FFF2-40B4-BE49-F238E27FC236}">
-                <a16:creationId xmlns:a16="http://schemas.microsoft.com/office/drawing/2014/main" id="{18D7D8A2-119A-4E9F-99D1-008B9ED0B92B}"/>
+                <a16:creationId xmlns:a16="http://schemas.microsoft.com/office/drawing/2014/main" id="{09C57C2B-3AF9-49FF-BCC9-2DF25EAA9B88}"/>
               </a:ext>
             </a:extLst>
           </p:cNvPr>
@@ -13598,7 +13598,7 @@
           <p:cNvPr id="8" name="Brier score">
             <a:extLst xmlns:a="http://schemas.openxmlformats.org/drawingml/2006/main">
               <a:ext uri="{FF2B5EF4-FFF2-40B4-BE49-F238E27FC236}">
-                <a16:creationId xmlns:a16="http://schemas.microsoft.com/office/drawing/2014/main" id="{0AB3F69E-D520-462F-A1BC-3F9B6A2C4176}"/>
+                <a16:creationId xmlns:a16="http://schemas.microsoft.com/office/drawing/2014/main" id="{016DF768-F2E6-43E6-96A8-3B395BE34FE1}"/>
               </a:ext>
             </a:extLst>
           </p:cNvPr>
@@ -13655,7 +13655,7 @@
           <p:cNvPr id="9" name="Under-confident at 0.6–0.9">
             <a:extLst xmlns:a="http://schemas.openxmlformats.org/drawingml/2006/main">
               <a:ext uri="{FF2B5EF4-FFF2-40B4-BE49-F238E27FC236}">
-                <a16:creationId xmlns:a16="http://schemas.microsoft.com/office/drawing/2014/main" id="{60D4363A-E581-40E0-93BF-721309DCE705}"/>
+                <a16:creationId xmlns:a16="http://schemas.microsoft.com/office/drawing/2014/main" id="{53598615-2936-4B01-98E9-ED882814D105}"/>
               </a:ext>
             </a:extLst>
           </p:cNvPr>
@@ -13712,7 +13712,7 @@
           <p:cNvPr id="10" name="Observed accuracy exceeds stated confidence in thi">
             <a:extLst xmlns:a="http://schemas.openxmlformats.org/drawingml/2006/main">
               <a:ext uri="{FF2B5EF4-FFF2-40B4-BE49-F238E27FC236}">
-                <a16:creationId xmlns:a16="http://schemas.microsoft.com/office/drawing/2014/main" id="{19251612-A919-4A20-9E2A-B5CE47D36785}"/>
+                <a16:creationId xmlns:a16="http://schemas.microsoft.com/office/drawing/2014/main" id="{2784F026-A670-4C25-92BE-3F9D01DF2013}"/>
               </a:ext>
             </a:extLst>
           </p:cNvPr>
@@ -13769,7 +13769,7 @@
           <p:cNvPr id="11" name="The top bin has only 10 samples: 80% accuracy, ver">
             <a:extLst xmlns:a="http://schemas.openxmlformats.org/drawingml/2006/main">
               <a:ext uri="{FF2B5EF4-FFF2-40B4-BE49-F238E27FC236}">
-                <a16:creationId xmlns:a16="http://schemas.microsoft.com/office/drawing/2014/main" id="{621364E3-AE0E-430F-BF69-C666A24FBB66}"/>
+                <a16:creationId xmlns:a16="http://schemas.microsoft.com/office/drawing/2014/main" id="{7D626259-80E2-4076-91BF-6D0CAEF92264}"/>
               </a:ext>
             </a:extLst>
           </p:cNvPr>
@@ -13824,7 +13824,7 @@
     </p:spTree>
     <p:extLst>
       <p:ext uri="{BB962C8B-B14F-4D97-AF65-F5344CB8AC3E}">
-        <p14:creationId xmlns:p14="http://schemas.microsoft.com/office/powerpoint/2010/main" val="1147364510"/>
+        <p14:creationId xmlns:p14="http://schemas.microsoft.com/office/powerpoint/2010/main" val="127335551"/>
       </p:ext>
     </p:extLst>
   </p:cSld>

</xml_diff>

<commit_message>
Train sequence detector for original high-confidence errors
</commit_message>
<xml_diff>
--- a/reports/presentation/AI_Confidence_Drift_Presentation.pptx
+++ b/reports/presentation/AI_Confidence_Drift_Presentation.pptx
@@ -2,26 +2,26 @@
 <file path=ppt/presentation.xml><?xml version="1.0" encoding="utf-8"?>
 <p:presentation xmlns:p="http://schemas.openxmlformats.org/presentationml/2006/main">
   <p:sldMasterIdLst>
-    <p:sldMasterId xmlns:r="http://schemas.openxmlformats.org/officeDocument/2006/relationships" id="2147483648" r:id="R5e6a9648767944e7"/>
+    <p:sldMasterId xmlns:r="http://schemas.openxmlformats.org/officeDocument/2006/relationships" id="2147483648" r:id="R66e401c8be0e49ff"/>
   </p:sldMasterIdLst>
   <p:notesMasterIdLst>
-    <p:notesMasterId xmlns:r="http://schemas.openxmlformats.org/officeDocument/2006/relationships" r:id="Rd78422bbb1704fc1"/>
+    <p:notesMasterId xmlns:r="http://schemas.openxmlformats.org/officeDocument/2006/relationships" r:id="R6266f7ca77b542f8"/>
   </p:notesMasterIdLst>
   <p:sldIdLst>
-    <p:sldId xmlns:r="http://schemas.openxmlformats.org/officeDocument/2006/relationships" id="256" r:id="Rc18d78d87d4347cf"/>
-    <p:sldId xmlns:r="http://schemas.openxmlformats.org/officeDocument/2006/relationships" id="257" r:id="R64c1e854e9cf4d61"/>
-    <p:sldId xmlns:r="http://schemas.openxmlformats.org/officeDocument/2006/relationships" id="258" r:id="R38c8b772d396435e"/>
-    <p:sldId xmlns:r="http://schemas.openxmlformats.org/officeDocument/2006/relationships" id="259" r:id="R9349624286b74d8e"/>
-    <p:sldId xmlns:r="http://schemas.openxmlformats.org/officeDocument/2006/relationships" id="260" r:id="R489edfd2ea2340a6"/>
-    <p:sldId xmlns:r="http://schemas.openxmlformats.org/officeDocument/2006/relationships" id="261" r:id="Rc3d5ee7c71074aaa"/>
-    <p:sldId xmlns:r="http://schemas.openxmlformats.org/officeDocument/2006/relationships" id="262" r:id="Rae97edcb96684c95"/>
-    <p:sldId xmlns:r="http://schemas.openxmlformats.org/officeDocument/2006/relationships" id="263" r:id="Ra0949496f9cd444c"/>
-    <p:sldId xmlns:r="http://schemas.openxmlformats.org/officeDocument/2006/relationships" id="264" r:id="R4f93cdbd3a054ecf"/>
-    <p:sldId xmlns:r="http://schemas.openxmlformats.org/officeDocument/2006/relationships" id="265" r:id="Rb6fb71936bd047fd"/>
-    <p:sldId xmlns:r="http://schemas.openxmlformats.org/officeDocument/2006/relationships" id="266" r:id="R58f427189e1b4f83"/>
-    <p:sldId xmlns:r="http://schemas.openxmlformats.org/officeDocument/2006/relationships" id="267" r:id="R6508e94454ba4128"/>
-    <p:sldId xmlns:r="http://schemas.openxmlformats.org/officeDocument/2006/relationships" id="268" r:id="Rb841911bd183492a"/>
-    <p:sldId xmlns:r="http://schemas.openxmlformats.org/officeDocument/2006/relationships" id="269" r:id="Ra6d45a2ce93a4067"/>
+    <p:sldId xmlns:r="http://schemas.openxmlformats.org/officeDocument/2006/relationships" id="256" r:id="Re9b6a42d583f4bab"/>
+    <p:sldId xmlns:r="http://schemas.openxmlformats.org/officeDocument/2006/relationships" id="257" r:id="R07e3c6f4489b4bdd"/>
+    <p:sldId xmlns:r="http://schemas.openxmlformats.org/officeDocument/2006/relationships" id="258" r:id="R41455d954ad54732"/>
+    <p:sldId xmlns:r="http://schemas.openxmlformats.org/officeDocument/2006/relationships" id="259" r:id="R90eb2d64fc3e4a00"/>
+    <p:sldId xmlns:r="http://schemas.openxmlformats.org/officeDocument/2006/relationships" id="260" r:id="R0fe644e7549040eb"/>
+    <p:sldId xmlns:r="http://schemas.openxmlformats.org/officeDocument/2006/relationships" id="261" r:id="R725dadb58e7d4f35"/>
+    <p:sldId xmlns:r="http://schemas.openxmlformats.org/officeDocument/2006/relationships" id="262" r:id="R1ebbce98d86d4d5d"/>
+    <p:sldId xmlns:r="http://schemas.openxmlformats.org/officeDocument/2006/relationships" id="263" r:id="Rfcafa25e1ac74dac"/>
+    <p:sldId xmlns:r="http://schemas.openxmlformats.org/officeDocument/2006/relationships" id="264" r:id="Rdacf977131a948f3"/>
+    <p:sldId xmlns:r="http://schemas.openxmlformats.org/officeDocument/2006/relationships" id="265" r:id="R05f9aaed2b6a4e12"/>
+    <p:sldId xmlns:r="http://schemas.openxmlformats.org/officeDocument/2006/relationships" id="266" r:id="R245609117c4349ce"/>
+    <p:sldId xmlns:r="http://schemas.openxmlformats.org/officeDocument/2006/relationships" id="267" r:id="R3a1b7eddeded48d4"/>
+    <p:sldId xmlns:r="http://schemas.openxmlformats.org/officeDocument/2006/relationships" id="268" r:id="R4407b838237342d8"/>
+    <p:sldId xmlns:r="http://schemas.openxmlformats.org/officeDocument/2006/relationships" id="269" r:id="Raf39a42b54d34a25"/>
   </p:sldIdLst>
   <p:sldSz cx="12192000" cy="6858000"/>
   <p:notesSz cx="6858000" cy="9144000"/>
@@ -525,7 +525,7 @@
           <a:lstStyle xmlns:a="http://schemas.openxmlformats.org/drawingml/2006/main"/>
           <a:p xmlns:a="http://schemas.openxmlformats.org/drawingml/2006/main">
             <a:r>
-              <a:t>The detector result is five-fold document-grouped out-of-fold on the 439-document base test set. The separate review policy was fitted from out-of-fold predictions on the 1,315 base-model training documents. It routed all six test-set errors but also 78 correct high-confidence predictions. See results/metrics/high_confidence_detector_analysis.json and high_confidence_review_analysis.json.</a:t>
+              <a:t>The original per-step C detector caught 0/6 at the uncorrupted step. A separate sequence-level Logistic Regression model predicts original correctness after six deterministic text probes. It was fitted on out-of-fold base-model sequences from the 1,315 base-training documents and flagged 6/6 high-confidence errors plus 50 correct cases on the 439-document test set. A start-only ablation flagged 5/6 plus 43 correct cases. This is retrospective and needs a new dataset. See results/metrics/sequence_error_detector_analysis.json.</a:t>
             </a:r>
           </a:p>
         </p:txBody>
@@ -1433,7 +1433,7 @@
   </p:cSld>
   <p:clrMap bg1="lt1" tx1="dk1" bg2="lt2" tx2="dk2" accent1="accent1" accent2="accent2" accent3="accent3" accent4="accent4" accent5="accent5" accent6="accent6" hlink="hlink" folHlink="folHlink"/>
   <p:sldLayoutIdLst>
-    <p:sldLayoutId xmlns:r="http://schemas.openxmlformats.org/officeDocument/2006/relationships" id="2147483649" r:id="Rd752caa69e09426c"/>
+    <p:sldLayoutId xmlns:r="http://schemas.openxmlformats.org/officeDocument/2006/relationships" id="2147483649" r:id="Rd93fdf05cb0a4ca4"/>
   </p:sldLayoutIdLst>
   <p:txStyles>
     <p:titleStyle>
@@ -3680,7 +3680,7 @@
           <p:cNvPr id="11" name="01">
             <a:extLst xmlns:a="http://schemas.openxmlformats.org/drawingml/2006/main">
               <a:ext uri="{FF2B5EF4-FFF2-40B4-BE49-F238E27FC236}">
-                <a16:creationId xmlns:a16="http://schemas.microsoft.com/office/drawing/2014/main" id="{99B95DCF-A90B-4DDA-BBCF-D668BF5FF8CC}"/>
+                <a16:creationId xmlns:a16="http://schemas.microsoft.com/office/drawing/2014/main" id="{71D16FAE-2BB8-4E3E-92BD-4D468AEC1EBF}"/>
               </a:ext>
             </a:extLst>
           </p:cNvPr>
@@ -3737,7 +3737,7 @@
           <p:cNvPr id="2" name="PRANAVX LABS">
             <a:extLst xmlns:a="http://schemas.openxmlformats.org/drawingml/2006/main">
               <a:ext uri="{FF2B5EF4-FFF2-40B4-BE49-F238E27FC236}">
-                <a16:creationId xmlns:a16="http://schemas.microsoft.com/office/drawing/2014/main" id="{CA10B4B3-6CCB-488A-A538-E4CF23C38467}"/>
+                <a16:creationId xmlns:a16="http://schemas.microsoft.com/office/drawing/2014/main" id="{7C38DCCF-01AF-4EBA-AD56-BE554E93E66C}"/>
               </a:ext>
             </a:extLst>
           </p:cNvPr>
@@ -3794,7 +3794,7 @@
           <p:cNvPr id="3" name="AI/ML Internship">
             <a:extLst xmlns:a="http://schemas.openxmlformats.org/drawingml/2006/main">
               <a:ext uri="{FF2B5EF4-FFF2-40B4-BE49-F238E27FC236}">
-                <a16:creationId xmlns:a16="http://schemas.microsoft.com/office/drawing/2014/main" id="{CEC0F9B2-E736-4792-B0B9-63404571DC23}"/>
+                <a16:creationId xmlns:a16="http://schemas.microsoft.com/office/drawing/2014/main" id="{66325646-0385-42BC-9C9C-31E306CF3471}"/>
               </a:ext>
             </a:extLst>
           </p:cNvPr>
@@ -3851,7 +3851,7 @@
           <p:cNvPr id="4" name="AI Confidence">
             <a:extLst xmlns:a="http://schemas.openxmlformats.org/drawingml/2006/main">
               <a:ext uri="{FF2B5EF4-FFF2-40B4-BE49-F238E27FC236}">
-                <a16:creationId xmlns:a16="http://schemas.microsoft.com/office/drawing/2014/main" id="{18EB3329-4D74-4C3E-9B87-4C4A5533B604}"/>
+                <a16:creationId xmlns:a16="http://schemas.microsoft.com/office/drawing/2014/main" id="{971773B8-40F4-44A8-A813-A48F566C6584}"/>
               </a:ext>
             </a:extLst>
           </p:cNvPr>
@@ -3908,7 +3908,7 @@
           <p:cNvPr id="5" name="Drift Detection">
             <a:extLst xmlns:a="http://schemas.openxmlformats.org/drawingml/2006/main">
               <a:ext uri="{FF2B5EF4-FFF2-40B4-BE49-F238E27FC236}">
-                <a16:creationId xmlns:a16="http://schemas.microsoft.com/office/drawing/2014/main" id="{3BF11387-87B0-4213-A6C6-5136FCDA2E1B}"/>
+                <a16:creationId xmlns:a16="http://schemas.microsoft.com/office/drawing/2014/main" id="{41340B23-BD18-4F92-8DEB-ADC8131EDE60}"/>
               </a:ext>
             </a:extLst>
           </p:cNvPr>
@@ -3965,7 +3965,7 @@
           <p:cNvPr id="6" name="Using machine learning">
             <a:extLst xmlns:a="http://schemas.openxmlformats.org/drawingml/2006/main">
               <a:ext uri="{FF2B5EF4-FFF2-40B4-BE49-F238E27FC236}">
-                <a16:creationId xmlns:a16="http://schemas.microsoft.com/office/drawing/2014/main" id="{B2E1BE2B-234D-4870-9F12-175213F9295A}"/>
+                <a16:creationId xmlns:a16="http://schemas.microsoft.com/office/drawing/2014/main" id="{86AF68D6-7CEE-4D80-9964-4E7598E8BF06}"/>
               </a:ext>
             </a:extLst>
           </p:cNvPr>
@@ -4022,7 +4022,7 @@
           <p:cNvPr id="7" name="Can changes in confidence help identify&#10;unreliable">
             <a:extLst xmlns:a="http://schemas.openxmlformats.org/drawingml/2006/main">
               <a:ext uri="{FF2B5EF4-FFF2-40B4-BE49-F238E27FC236}">
-                <a16:creationId xmlns:a16="http://schemas.microsoft.com/office/drawing/2014/main" id="{6C1AAB3F-E89C-4C07-9E25-1E50114B96CC}"/>
+                <a16:creationId xmlns:a16="http://schemas.microsoft.com/office/drawing/2014/main" id="{1E21ECE7-DE29-4C49-90C0-14B79EE48FCA}"/>
               </a:ext>
             </a:extLst>
           </p:cNvPr>
@@ -4102,7 +4102,7 @@
           <p:cNvPr id="8" name="Research project">
             <a:extLst xmlns:a="http://schemas.openxmlformats.org/drawingml/2006/main">
               <a:ext uri="{FF2B5EF4-FFF2-40B4-BE49-F238E27FC236}">
-                <a16:creationId xmlns:a16="http://schemas.microsoft.com/office/drawing/2014/main" id="{08C05B52-338B-4A78-82D5-814C936EA762}"/>
+                <a16:creationId xmlns:a16="http://schemas.microsoft.com/office/drawing/2014/main" id="{D457C1BB-DC61-401C-9A17-AD4C3F274048}"/>
               </a:ext>
             </a:extLst>
           </p:cNvPr>
@@ -4159,7 +4159,7 @@
           <p:cNvPr id="9" name="Prepared by Ahan">
             <a:extLst xmlns:a="http://schemas.openxmlformats.org/drawingml/2006/main">
               <a:ext uri="{FF2B5EF4-FFF2-40B4-BE49-F238E27FC236}">
-                <a16:creationId xmlns:a16="http://schemas.microsoft.com/office/drawing/2014/main" id="{12C0AACC-A386-4682-BADC-CBAF133B7F45}"/>
+                <a16:creationId xmlns:a16="http://schemas.microsoft.com/office/drawing/2014/main" id="{543238AF-6750-4F70-99C0-4F4C94F36E12}"/>
               </a:ext>
             </a:extLst>
           </p:cNvPr>
@@ -4216,7 +4216,7 @@
           <p:cNvPr id="10" name="github.com/ahansardar/ai-confidence-drift">
             <a:extLst xmlns:a="http://schemas.openxmlformats.org/drawingml/2006/main">
               <a:ext uri="{FF2B5EF4-FFF2-40B4-BE49-F238E27FC236}">
-                <a16:creationId xmlns:a16="http://schemas.microsoft.com/office/drawing/2014/main" id="{D537BA18-A9BC-4445-8093-8E6DD5DDD517}"/>
+                <a16:creationId xmlns:a16="http://schemas.microsoft.com/office/drawing/2014/main" id="{53344CDC-C192-47E0-B90E-03023C0A98DF}"/>
               </a:ext>
             </a:extLst>
           </p:cNvPr>
@@ -4262,7 +4262,7 @@
                 <a:latin typeface="Calibri"/>
                 <a:ea typeface="Calibri"/>
                 <a:cs typeface="Calibri"/>
-                <a:hlinkClick xmlns:r="http://schemas.openxmlformats.org/officeDocument/2006/relationships" r:id="R6f21438dea9d437d"/>
+                <a:hlinkClick xmlns:r="http://schemas.openxmlformats.org/officeDocument/2006/relationships" r:id="R0761bea4929e49f7"/>
               </a:rPr>
               <a:t>github.com/ahansardar/ai-confidence-drift</a:t>
             </a:r>
@@ -4272,7 +4272,7 @@
     </p:spTree>
     <p:extLst>
       <p:ext uri="{BB962C8B-B14F-4D97-AF65-F5344CB8AC3E}">
-        <p14:creationId xmlns:p14="http://schemas.microsoft.com/office/powerpoint/2010/main" val="573504615"/>
+        <p14:creationId xmlns:p14="http://schemas.microsoft.com/office/powerpoint/2010/main" val="1371038004"/>
       </p:ext>
     </p:extLst>
   </p:cSld>
@@ -4303,7 +4303,7 @@
           <p:cNvPr id="10" name="Confident errors">
             <a:extLst xmlns:a="http://schemas.openxmlformats.org/drawingml/2006/main">
               <a:ext uri="{FF2B5EF4-FFF2-40B4-BE49-F238E27FC236}">
-                <a16:creationId xmlns:a16="http://schemas.microsoft.com/office/drawing/2014/main" id="{1253AF97-2AC0-478D-A9B9-FF18CF00747D}"/>
+                <a16:creationId xmlns:a16="http://schemas.microsoft.com/office/drawing/2014/main" id="{958F3A03-041C-416F-BFAF-1F869AA2E3E1}"/>
               </a:ext>
             </a:extLst>
           </p:cNvPr>
@@ -4360,7 +4360,7 @@
           <p:cNvPr id="2" name="10">
             <a:extLst xmlns:a="http://schemas.openxmlformats.org/drawingml/2006/main">
               <a:ext uri="{FF2B5EF4-FFF2-40B4-BE49-F238E27FC236}">
-                <a16:creationId xmlns:a16="http://schemas.microsoft.com/office/drawing/2014/main" id="{5A57B5F1-E707-4BD2-BF21-07C4903F61D1}"/>
+                <a16:creationId xmlns:a16="http://schemas.microsoft.com/office/drawing/2014/main" id="{9BDDEBCE-345E-4011-A834-BD1F439834F1}"/>
               </a:ext>
             </a:extLst>
           </p:cNvPr>
@@ -4417,7 +4417,7 @@
           <p:cNvPr id="3" name="6 of 100">
             <a:extLst xmlns:a="http://schemas.openxmlformats.org/drawingml/2006/main">
               <a:ext uri="{FF2B5EF4-FFF2-40B4-BE49-F238E27FC236}">
-                <a16:creationId xmlns:a16="http://schemas.microsoft.com/office/drawing/2014/main" id="{C43BCD1C-3D49-4A72-B71E-164710104FB4}"/>
+                <a16:creationId xmlns:a16="http://schemas.microsoft.com/office/drawing/2014/main" id="{D3C508C3-6B39-41D1-81F4-295562576A25}"/>
               </a:ext>
             </a:extLst>
           </p:cNvPr>
@@ -4474,7 +4474,7 @@
           <p:cNvPr id="4" name="high-confidence predictions were wrong">
             <a:extLst xmlns:a="http://schemas.openxmlformats.org/drawingml/2006/main">
               <a:ext uri="{FF2B5EF4-FFF2-40B4-BE49-F238E27FC236}">
-                <a16:creationId xmlns:a16="http://schemas.microsoft.com/office/drawing/2014/main" id="{DFD6F09E-D2CF-4D28-8C1B-5EB4735367FB}"/>
+                <a16:creationId xmlns:a16="http://schemas.microsoft.com/office/drawing/2014/main" id="{38A5EFAA-DECD-45E5-8FD6-21244CF6D20D}"/>
               </a:ext>
             </a:extLst>
           </p:cNvPr>
@@ -4531,7 +4531,7 @@
           <p:cNvPr id="5" name="100 of 439 predictions reached at least 75% confid">
             <a:extLst xmlns:a="http://schemas.openxmlformats.org/drawingml/2006/main">
               <a:ext uri="{FF2B5EF4-FFF2-40B4-BE49-F238E27FC236}">
-                <a16:creationId xmlns:a16="http://schemas.microsoft.com/office/drawing/2014/main" id="{064F4CA3-316C-45E8-B077-AD4413A99DA9}"/>
+                <a16:creationId xmlns:a16="http://schemas.microsoft.com/office/drawing/2014/main" id="{6AECEEB9-0DD1-481E-9995-E1F501E98ABE}"/>
               </a:ext>
             </a:extLst>
           </p:cNvPr>
@@ -4608,10 +4608,10 @@
       </p:sp>
       <p:sp>
         <p:nvSpPr>
-          <p:cNvPr id="6" name="Drift detector: 0/6">
+          <p:cNvPr id="6" name="At step 0: 0/6">
             <a:extLst xmlns:a="http://schemas.openxmlformats.org/drawingml/2006/main">
               <a:ext uri="{FF2B5EF4-FFF2-40B4-BE49-F238E27FC236}">
-                <a16:creationId xmlns:a16="http://schemas.microsoft.com/office/drawing/2014/main" id="{D77935B2-4F8F-4BC8-A6D3-A4889948F84F}"/>
+                <a16:creationId xmlns:a16="http://schemas.microsoft.com/office/drawing/2014/main" id="{E0F02FC8-8CCA-4A11-AA93-E0E91004757F}"/>
               </a:ext>
             </a:extLst>
           </p:cNvPr>
@@ -4658,17 +4658,17 @@
                 <a:ea typeface="Calibri"/>
                 <a:cs typeface="Calibri"/>
               </a:rPr>
-              <a:t>Drift detector: 0/6</a:t>
-            </a:r>
-          </a:p>
-        </p:txBody>
-      </p:sp>
-      <p:sp>
-        <p:nvSpPr>
-          <p:cNvPr id="7" name="No history exists at the first prediction.&#10;It flag">
+              <a:t>At step 0: 0/6</a:t>
+            </a:r>
+          </a:p>
+        </p:txBody>
+      </p:sp>
+      <p:sp>
+        <p:nvSpPr>
+          <p:cNvPr id="7" name="The per-step model has no history yet.&#10;It flagged ">
             <a:extLst xmlns:a="http://schemas.openxmlformats.org/drawingml/2006/main">
               <a:ext uri="{FF2B5EF4-FFF2-40B4-BE49-F238E27FC236}">
-                <a16:creationId xmlns:a16="http://schemas.microsoft.com/office/drawing/2014/main" id="{AA46181C-1CCE-48AC-8CA9-050DD38F5914}"/>
+                <a16:creationId xmlns:a16="http://schemas.microsoft.com/office/drawing/2014/main" id="{55F3FC1F-D317-4186-9F1B-C069CC5BEE0A}"/>
               </a:ext>
             </a:extLst>
           </p:cNvPr>
@@ -4715,7 +4715,7 @@
                 <a:ea typeface="Calibri"/>
                 <a:cs typeface="Calibri"/>
               </a:rPr>
-              <a:t>No history exists at the first prediction.</a:t>
+              <a:t>The per-step model has no history yet.</a:t>
             </a:r>
           </a:p>
           <a:p xmlns:a="http://schemas.openxmlformats.org/drawingml/2006/main">
@@ -4745,10 +4745,10 @@
       </p:sp>
       <p:sp>
         <p:nvSpPr>
-          <p:cNvPr id="8" name="Review policy: 6/6">
+          <p:cNvPr id="8" name="After six probes: 6/6">
             <a:extLst xmlns:a="http://schemas.openxmlformats.org/drawingml/2006/main">
               <a:ext uri="{FF2B5EF4-FFF2-40B4-BE49-F238E27FC236}">
-                <a16:creationId xmlns:a16="http://schemas.microsoft.com/office/drawing/2014/main" id="{AD1272CB-A7FE-47A5-BB59-E7D6E0B4DCB9}"/>
+                <a16:creationId xmlns:a16="http://schemas.microsoft.com/office/drawing/2014/main" id="{D132E2A3-A496-4910-BE74-92E5007DC039}"/>
               </a:ext>
             </a:extLst>
           </p:cNvPr>
@@ -4795,17 +4795,17 @@
                 <a:ea typeface="Calibri"/>
                 <a:cs typeface="Calibri"/>
               </a:rPr>
-              <a:t>Review policy: 6/6</a:t>
-            </a:r>
-          </a:p>
-        </p:txBody>
-      </p:sp>
-      <p:sp>
-        <p:nvSpPr>
-          <p:cNvPr id="9" name="It routed 84 cases to review,&#10;including 78 correct">
+              <a:t>After six probes: 6/6</a:t>
+            </a:r>
+          </a:p>
+        </p:txBody>
+      </p:sp>
+      <p:sp>
+        <p:nvSpPr>
+          <p:cNvPr id="9" name="The sequence model flagged all six,&#10;plus 50 correc">
             <a:extLst xmlns:a="http://schemas.openxmlformats.org/drawingml/2006/main">
               <a:ext uri="{FF2B5EF4-FFF2-40B4-BE49-F238E27FC236}">
-                <a16:creationId xmlns:a16="http://schemas.microsoft.com/office/drawing/2014/main" id="{60D209DC-D1B1-4827-8CBE-D81370509440}"/>
+                <a16:creationId xmlns:a16="http://schemas.microsoft.com/office/drawing/2014/main" id="{4E754E4D-D830-4B5E-B185-89E177020996}"/>
               </a:ext>
             </a:extLst>
           </p:cNvPr>
@@ -4852,7 +4852,7 @@
                 <a:ea typeface="Calibri"/>
                 <a:cs typeface="Calibri"/>
               </a:rPr>
-              <a:t>It routed 84 cases to review,</a:t>
+              <a:t>The sequence model flagged all six,</a:t>
             </a:r>
           </a:p>
           <a:p xmlns:a="http://schemas.openxmlformats.org/drawingml/2006/main">
@@ -4875,7 +4875,7 @@
                 <a:ea typeface="Calibri"/>
                 <a:cs typeface="Calibri"/>
               </a:rPr>
-              <a:t>including 78 correct predictions.</a:t>
+              <a:t>plus 50 correct predictions.</a:t>
             </a:r>
           </a:p>
         </p:txBody>
@@ -4883,7 +4883,7 @@
     </p:spTree>
     <p:extLst>
       <p:ext uri="{BB962C8B-B14F-4D97-AF65-F5344CB8AC3E}">
-        <p14:creationId xmlns:p14="http://schemas.microsoft.com/office/powerpoint/2010/main" val="1919534998"/>
+        <p14:creationId xmlns:p14="http://schemas.microsoft.com/office/powerpoint/2010/main" val="1680052171"/>
       </p:ext>
     </p:extLst>
   </p:cSld>
@@ -4914,7 +4914,7 @@
           <p:cNvPr id="11" name="What drift features add">
             <a:extLst xmlns:a="http://schemas.openxmlformats.org/drawingml/2006/main">
               <a:ext uri="{FF2B5EF4-FFF2-40B4-BE49-F238E27FC236}">
-                <a16:creationId xmlns:a16="http://schemas.microsoft.com/office/drawing/2014/main" id="{3702A6F5-5BB8-4CB7-8A75-7893A0D0931F}"/>
+                <a16:creationId xmlns:a16="http://schemas.microsoft.com/office/drawing/2014/main" id="{BB373C25-33E4-4723-99A2-D272B79B9F74}"/>
               </a:ext>
             </a:extLst>
           </p:cNvPr>
@@ -4971,7 +4971,7 @@
           <p:cNvPr id="2" name="11">
             <a:extLst xmlns:a="http://schemas.openxmlformats.org/drawingml/2006/main">
               <a:ext uri="{FF2B5EF4-FFF2-40B4-BE49-F238E27FC236}">
-                <a16:creationId xmlns:a16="http://schemas.microsoft.com/office/drawing/2014/main" id="{E5D58072-A0E2-4055-B867-D4EB169494DD}"/>
+                <a16:creationId xmlns:a16="http://schemas.microsoft.com/office/drawing/2014/main" id="{B123AEDE-5889-4B66-B38D-4C5A8F835F33}"/>
               </a:ext>
             </a:extLst>
           </p:cNvPr>
@@ -5028,7 +5028,7 @@
           <p:cNvPr id="3" name="Pooled out-of-fold results · five document-grouped">
             <a:extLst xmlns:a="http://schemas.openxmlformats.org/drawingml/2006/main">
               <a:ext uri="{FF2B5EF4-FFF2-40B4-BE49-F238E27FC236}">
-                <a16:creationId xmlns:a16="http://schemas.microsoft.com/office/drawing/2014/main" id="{436948D3-B344-4BE7-B3AF-A24FF79B12DE}"/>
+                <a16:creationId xmlns:a16="http://schemas.microsoft.com/office/drawing/2014/main" id="{5A83598A-00AD-4F98-95E2-A0EE86F037B8}"/>
               </a:ext>
             </a:extLst>
           </p:cNvPr>
@@ -5533,7 +5533,7 @@
           <p:cNvPr id="5" name="+0.040">
             <a:extLst xmlns:a="http://schemas.openxmlformats.org/drawingml/2006/main">
               <a:ext uri="{FF2B5EF4-FFF2-40B4-BE49-F238E27FC236}">
-                <a16:creationId xmlns:a16="http://schemas.microsoft.com/office/drawing/2014/main" id="{9FC96831-8EED-4342-B31B-5FE329994F72}"/>
+                <a16:creationId xmlns:a16="http://schemas.microsoft.com/office/drawing/2014/main" id="{53DE2980-C15B-4AF6-90B4-71357953D18C}"/>
               </a:ext>
             </a:extLst>
           </p:cNvPr>
@@ -5590,7 +5590,7 @@
           <p:cNvPr id="6" name="F1 improvement, B to C">
             <a:extLst xmlns:a="http://schemas.openxmlformats.org/drawingml/2006/main">
               <a:ext uri="{FF2B5EF4-FFF2-40B4-BE49-F238E27FC236}">
-                <a16:creationId xmlns:a16="http://schemas.microsoft.com/office/drawing/2014/main" id="{0AA57B0F-058E-4C29-8D1D-B7AC6ABBB9DF}"/>
+                <a16:creationId xmlns:a16="http://schemas.microsoft.com/office/drawing/2014/main" id="{B828A482-2628-4D6A-8FB3-64013686DC67}"/>
               </a:ext>
             </a:extLst>
           </p:cNvPr>
@@ -5647,7 +5647,7 @@
           <p:cNvPr id="7" name="+0.034">
             <a:extLst xmlns:a="http://schemas.openxmlformats.org/drawingml/2006/main">
               <a:ext uri="{FF2B5EF4-FFF2-40B4-BE49-F238E27FC236}">
-                <a16:creationId xmlns:a16="http://schemas.microsoft.com/office/drawing/2014/main" id="{04A299EE-8D30-41B8-B26A-AFE69B6C96A6}"/>
+                <a16:creationId xmlns:a16="http://schemas.microsoft.com/office/drawing/2014/main" id="{C9EA730C-1EE7-47AA-8905-E39AED8898E2}"/>
               </a:ext>
             </a:extLst>
           </p:cNvPr>
@@ -5704,7 +5704,7 @@
           <p:cNvPr id="8" name="ROC-AUC improvement, B to C">
             <a:extLst xmlns:a="http://schemas.openxmlformats.org/drawingml/2006/main">
               <a:ext uri="{FF2B5EF4-FFF2-40B4-BE49-F238E27FC236}">
-                <a16:creationId xmlns:a16="http://schemas.microsoft.com/office/drawing/2014/main" id="{3EC39CF8-6E50-4741-BD0D-F9C8B94F9BDE}"/>
+                <a16:creationId xmlns:a16="http://schemas.microsoft.com/office/drawing/2014/main" id="{1EB1D9A2-B3EB-4671-AC48-08DC9EA16280}"/>
               </a:ext>
             </a:extLst>
           </p:cNvPr>
@@ -5761,7 +5761,7 @@
           <p:cNvPr id="9" name="History adds a&#10;modest gain.">
             <a:extLst xmlns:a="http://schemas.openxmlformats.org/drawingml/2006/main">
               <a:ext uri="{FF2B5EF4-FFF2-40B4-BE49-F238E27FC236}">
-                <a16:creationId xmlns:a16="http://schemas.microsoft.com/office/drawing/2014/main" id="{4F6409B3-4197-440C-8172-418BE6C839D5}"/>
+                <a16:creationId xmlns:a16="http://schemas.microsoft.com/office/drawing/2014/main" id="{ACE29775-13FC-46F4-9808-F9B783549C2E}"/>
               </a:ext>
             </a:extLst>
           </p:cNvPr>
@@ -5841,7 +5841,7 @@
           <p:cNvPr id="10" name="The separate 110-document holdout showed a smaller">
             <a:extLst xmlns:a="http://schemas.openxmlformats.org/drawingml/2006/main">
               <a:ext uri="{FF2B5EF4-FFF2-40B4-BE49-F238E27FC236}">
-                <a16:creationId xmlns:a16="http://schemas.microsoft.com/office/drawing/2014/main" id="{8043759D-0CAF-4A07-83F7-29F402B261E7}"/>
+                <a16:creationId xmlns:a16="http://schemas.microsoft.com/office/drawing/2014/main" id="{A172E6BA-2579-41E2-B685-7D19BB2FC8AC}"/>
               </a:ext>
             </a:extLst>
           </p:cNvPr>
@@ -5896,7 +5896,7 @@
     </p:spTree>
     <p:extLst>
       <p:ext uri="{BB962C8B-B14F-4D97-AF65-F5344CB8AC3E}">
-        <p14:creationId xmlns:p14="http://schemas.microsoft.com/office/powerpoint/2010/main" val="686491833"/>
+        <p14:creationId xmlns:p14="http://schemas.microsoft.com/office/powerpoint/2010/main" val="860137954"/>
       </p:ext>
     </p:extLst>
   </p:cSld>
@@ -5927,7 +5927,7 @@
           <p:cNvPr id="15" name="Four findings">
             <a:extLst xmlns:a="http://schemas.openxmlformats.org/drawingml/2006/main">
               <a:ext uri="{FF2B5EF4-FFF2-40B4-BE49-F238E27FC236}">
-                <a16:creationId xmlns:a16="http://schemas.microsoft.com/office/drawing/2014/main" id="{CC8CD3AA-23FD-4B2B-92DD-8674CDB4A592}"/>
+                <a16:creationId xmlns:a16="http://schemas.microsoft.com/office/drawing/2014/main" id="{269D3555-16B9-4604-8BE5-3C7923B77B04}"/>
               </a:ext>
             </a:extLst>
           </p:cNvPr>
@@ -5984,7 +5984,7 @@
           <p:cNvPr id="2" name="12">
             <a:extLst xmlns:a="http://schemas.openxmlformats.org/drawingml/2006/main">
               <a:ext uri="{FF2B5EF4-FFF2-40B4-BE49-F238E27FC236}">
-                <a16:creationId xmlns:a16="http://schemas.microsoft.com/office/drawing/2014/main" id="{0BEC6B17-42B6-4E25-B668-16527E5295FC}"/>
+                <a16:creationId xmlns:a16="http://schemas.microsoft.com/office/drawing/2014/main" id="{4B701A13-EC3C-4D81-85A7-21A17311C33A}"/>
               </a:ext>
             </a:extLst>
           </p:cNvPr>
@@ -6041,7 +6041,7 @@
           <p:cNvPr id="3" name="63.5–93.3%">
             <a:extLst xmlns:a="http://schemas.openxmlformats.org/drawingml/2006/main">
               <a:ext uri="{FF2B5EF4-FFF2-40B4-BE49-F238E27FC236}">
-                <a16:creationId xmlns:a16="http://schemas.microsoft.com/office/drawing/2014/main" id="{D8AFE0E1-E85E-463C-B943-782EC5113199}"/>
+                <a16:creationId xmlns:a16="http://schemas.microsoft.com/office/drawing/2014/main" id="{CABA10A6-A2A3-4AEC-91F0-16BC116D5301}"/>
               </a:ext>
             </a:extLst>
           </p:cNvPr>
@@ -6098,7 +6098,7 @@
           <p:cNvPr id="4" name="Confidence carries useful signal">
             <a:extLst xmlns:a="http://schemas.openxmlformats.org/drawingml/2006/main">
               <a:ext uri="{FF2B5EF4-FFF2-40B4-BE49-F238E27FC236}">
-                <a16:creationId xmlns:a16="http://schemas.microsoft.com/office/drawing/2014/main" id="{8E718061-E3E4-4CC0-A8FC-DC506974519C}"/>
+                <a16:creationId xmlns:a16="http://schemas.microsoft.com/office/drawing/2014/main" id="{34B4BE10-DE11-4E5A-8924-D250EB7D8E6C}"/>
               </a:ext>
             </a:extLst>
           </p:cNvPr>
@@ -6155,7 +6155,7 @@
           <p:cNvPr id="5" name="Accuracy rises across the confidence bins.">
             <a:extLst xmlns:a="http://schemas.openxmlformats.org/drawingml/2006/main">
               <a:ext uri="{FF2B5EF4-FFF2-40B4-BE49-F238E27FC236}">
-                <a16:creationId xmlns:a16="http://schemas.microsoft.com/office/drawing/2014/main" id="{4F5E5747-884C-4998-94CC-67F4E54E286D}"/>
+                <a16:creationId xmlns:a16="http://schemas.microsoft.com/office/drawing/2014/main" id="{680F4911-19B6-4114-93A1-78FB7AD51D1A}"/>
               </a:ext>
             </a:extLst>
           </p:cNvPr>
@@ -6212,7 +6212,7 @@
           <p:cNvPr id="6" name="6 of 100">
             <a:extLst xmlns:a="http://schemas.openxmlformats.org/drawingml/2006/main">
               <a:ext uri="{FF2B5EF4-FFF2-40B4-BE49-F238E27FC236}">
-                <a16:creationId xmlns:a16="http://schemas.microsoft.com/office/drawing/2014/main" id="{1FC4DD9C-94D6-4CAE-9DA9-E9FF7E92E69F}"/>
+                <a16:creationId xmlns:a16="http://schemas.microsoft.com/office/drawing/2014/main" id="{3B9992A8-D5EA-412F-829A-B6163E6A75C6}"/>
               </a:ext>
             </a:extLst>
           </p:cNvPr>
@@ -6269,7 +6269,7 @@
           <p:cNvPr id="7" name="High confidence can still be wrong">
             <a:extLst xmlns:a="http://schemas.openxmlformats.org/drawingml/2006/main">
               <a:ext uri="{FF2B5EF4-FFF2-40B4-BE49-F238E27FC236}">
-                <a16:creationId xmlns:a16="http://schemas.microsoft.com/office/drawing/2014/main" id="{499540EB-1532-4B49-B9C1-35BD8FE72BF4}"/>
+                <a16:creationId xmlns:a16="http://schemas.microsoft.com/office/drawing/2014/main" id="{C2ABE0DC-FAC6-42C1-963C-0B47D6297624}"/>
               </a:ext>
             </a:extLst>
           </p:cNvPr>
@@ -6323,10 +6323,10 @@
       </p:sp>
       <p:sp>
         <p:nvSpPr>
-          <p:cNvPr id="8" name="The review rule routed all six, with 78 false alar">
+          <p:cNvPr id="8" name="After six probes: 6 flagged, with 50 false alarms.">
             <a:extLst xmlns:a="http://schemas.openxmlformats.org/drawingml/2006/main">
               <a:ext uri="{FF2B5EF4-FFF2-40B4-BE49-F238E27FC236}">
-                <a16:creationId xmlns:a16="http://schemas.microsoft.com/office/drawing/2014/main" id="{92CCC18B-F741-48DE-82F8-74A8239E2169}"/>
+                <a16:creationId xmlns:a16="http://schemas.microsoft.com/office/drawing/2014/main" id="{37CF480C-CFFA-43C4-A797-74BD8428AAF0}"/>
               </a:ext>
             </a:extLst>
           </p:cNvPr>
@@ -6373,7 +6373,7 @@
                 <a:ea typeface="Calibri"/>
                 <a:cs typeface="Calibri"/>
               </a:rPr>
-              <a:t>The review rule routed all six, with 78 false alarms.</a:t>
+              <a:t>After six probes: 6 flagged, with 50 false alarms.</a:t>
             </a:r>
           </a:p>
         </p:txBody>
@@ -6383,7 +6383,7 @@
           <p:cNvPr id="9" name="r = 0.09">
             <a:extLst xmlns:a="http://schemas.openxmlformats.org/drawingml/2006/main">
               <a:ext uri="{FF2B5EF4-FFF2-40B4-BE49-F238E27FC236}">
-                <a16:creationId xmlns:a16="http://schemas.microsoft.com/office/drawing/2014/main" id="{F1CE36D8-75E9-45F8-A4D2-BF20C7F7A3F2}"/>
+                <a16:creationId xmlns:a16="http://schemas.microsoft.com/office/drawing/2014/main" id="{5A14CB2A-2337-46D4-AAF0-B4F75DC4F7DC}"/>
               </a:ext>
             </a:extLst>
           </p:cNvPr>
@@ -6440,7 +6440,7 @@
           <p:cNvPr id="10" name="Net drift is a weak predictor">
             <a:extLst xmlns:a="http://schemas.openxmlformats.org/drawingml/2006/main">
               <a:ext uri="{FF2B5EF4-FFF2-40B4-BE49-F238E27FC236}">
-                <a16:creationId xmlns:a16="http://schemas.microsoft.com/office/drawing/2014/main" id="{1451E937-4A17-46AE-9B1C-A8319D330C78}"/>
+                <a16:creationId xmlns:a16="http://schemas.microsoft.com/office/drawing/2014/main" id="{34112BB8-64C9-473B-AB87-161B77B82746}"/>
               </a:ext>
             </a:extLst>
           </p:cNvPr>
@@ -6497,7 +6497,7 @@
           <p:cNvPr id="11" name="Correlation with becoming incorrect is small.">
             <a:extLst xmlns:a="http://schemas.openxmlformats.org/drawingml/2006/main">
               <a:ext uri="{FF2B5EF4-FFF2-40B4-BE49-F238E27FC236}">
-                <a16:creationId xmlns:a16="http://schemas.microsoft.com/office/drawing/2014/main" id="{38EC159D-3186-43B9-963D-A41259ADE233}"/>
+                <a16:creationId xmlns:a16="http://schemas.microsoft.com/office/drawing/2014/main" id="{602B133E-085B-4209-9B7D-35120235DFED}"/>
               </a:ext>
             </a:extLst>
           </p:cNvPr>
@@ -6554,7 +6554,7 @@
           <p:cNvPr id="12" name="+0.040 F1">
             <a:extLst xmlns:a="http://schemas.openxmlformats.org/drawingml/2006/main">
               <a:ext uri="{FF2B5EF4-FFF2-40B4-BE49-F238E27FC236}">
-                <a16:creationId xmlns:a16="http://schemas.microsoft.com/office/drawing/2014/main" id="{2D543D42-21B5-451E-92DC-2A3CD673B6D6}"/>
+                <a16:creationId xmlns:a16="http://schemas.microsoft.com/office/drawing/2014/main" id="{C4574EAF-2EB9-4CB4-9431-005E462F15B3}"/>
               </a:ext>
             </a:extLst>
           </p:cNvPr>
@@ -6611,7 +6611,7 @@
           <p:cNvPr id="13" name="History adds a modest gain">
             <a:extLst xmlns:a="http://schemas.openxmlformats.org/drawingml/2006/main">
               <a:ext uri="{FF2B5EF4-FFF2-40B4-BE49-F238E27FC236}">
-                <a16:creationId xmlns:a16="http://schemas.microsoft.com/office/drawing/2014/main" id="{A750C70A-15D2-49C9-9B04-4FCFEA405232}"/>
+                <a16:creationId xmlns:a16="http://schemas.microsoft.com/office/drawing/2014/main" id="{66D77C71-6F5E-425A-8503-9AEA035DA09C}"/>
               </a:ext>
             </a:extLst>
           </p:cNvPr>
@@ -6668,7 +6668,7 @@
           <p:cNvPr id="14" name="F1 rises from 0.468 to 0.508 after current confide">
             <a:extLst xmlns:a="http://schemas.openxmlformats.org/drawingml/2006/main">
               <a:ext uri="{FF2B5EF4-FFF2-40B4-BE49-F238E27FC236}">
-                <a16:creationId xmlns:a16="http://schemas.microsoft.com/office/drawing/2014/main" id="{ED116966-F1BC-4257-93B5-1BD08E2A11A3}"/>
+                <a16:creationId xmlns:a16="http://schemas.microsoft.com/office/drawing/2014/main" id="{3A5AEF10-0905-413B-AFA2-330130630C29}"/>
               </a:ext>
             </a:extLst>
           </p:cNvPr>
@@ -6723,7 +6723,7 @@
     </p:spTree>
     <p:extLst>
       <p:ext uri="{BB962C8B-B14F-4D97-AF65-F5344CB8AC3E}">
-        <p14:creationId xmlns:p14="http://schemas.microsoft.com/office/powerpoint/2010/main" val="1617487989"/>
+        <p14:creationId xmlns:p14="http://schemas.microsoft.com/office/powerpoint/2010/main" val="1912111692"/>
       </p:ext>
     </p:extLst>
   </p:cSld>
@@ -6754,7 +6754,7 @@
           <p:cNvPr id="13" name="Limitations and next steps">
             <a:extLst xmlns:a="http://schemas.openxmlformats.org/drawingml/2006/main">
               <a:ext uri="{FF2B5EF4-FFF2-40B4-BE49-F238E27FC236}">
-                <a16:creationId xmlns:a16="http://schemas.microsoft.com/office/drawing/2014/main" id="{37F69563-E3A4-4FB2-A216-0AA6E65E1A5C}"/>
+                <a16:creationId xmlns:a16="http://schemas.microsoft.com/office/drawing/2014/main" id="{6C154B8C-CB83-45BF-B76B-0E9D0D614849}"/>
               </a:ext>
             </a:extLst>
           </p:cNvPr>
@@ -6811,7 +6811,7 @@
           <p:cNvPr id="2" name="13">
             <a:extLst xmlns:a="http://schemas.openxmlformats.org/drawingml/2006/main">
               <a:ext uri="{FF2B5EF4-FFF2-40B4-BE49-F238E27FC236}">
-                <a16:creationId xmlns:a16="http://schemas.microsoft.com/office/drawing/2014/main" id="{8B38E04F-EAAD-45C8-9DBB-65E5A4F9A54F}"/>
+                <a16:creationId xmlns:a16="http://schemas.microsoft.com/office/drawing/2014/main" id="{AC08C0FA-301D-4B24-BE59-86C0306E8F38}"/>
               </a:ext>
             </a:extLst>
           </p:cNvPr>
@@ -6868,7 +6868,7 @@
           <p:cNvPr id="3" name="Limits of this study">
             <a:extLst xmlns:a="http://schemas.openxmlformats.org/drawingml/2006/main">
               <a:ext uri="{FF2B5EF4-FFF2-40B4-BE49-F238E27FC236}">
-                <a16:creationId xmlns:a16="http://schemas.microsoft.com/office/drawing/2014/main" id="{38DFC128-D8E5-49AE-84C2-2AF791E1FBF0}"/>
+                <a16:creationId xmlns:a16="http://schemas.microsoft.com/office/drawing/2014/main" id="{3BFAF0D3-178D-45F1-8B28-1CDA434BAA2D}"/>
               </a:ext>
             </a:extLst>
           </p:cNvPr>
@@ -6925,7 +6925,7 @@
           <p:cNvPr id="4" name="What I would test next">
             <a:extLst xmlns:a="http://schemas.openxmlformats.org/drawingml/2006/main">
               <a:ext uri="{FF2B5EF4-FFF2-40B4-BE49-F238E27FC236}">
-                <a16:creationId xmlns:a16="http://schemas.microsoft.com/office/drawing/2014/main" id="{BB1D4493-7919-471A-AE64-30AF2C3FB2E3}"/>
+                <a16:creationId xmlns:a16="http://schemas.microsoft.com/office/drawing/2014/main" id="{4BF09ADE-D448-4B04-BCAA-445E5862A1FD}"/>
               </a:ext>
             </a:extLst>
           </p:cNvPr>
@@ -6982,7 +6982,7 @@
           <p:cNvPr id="5" name="Text corruption simulates repeated predictions. Re">
             <a:extLst xmlns:a="http://schemas.openxmlformats.org/drawingml/2006/main">
               <a:ext uri="{FF2B5EF4-FFF2-40B4-BE49-F238E27FC236}">
-                <a16:creationId xmlns:a16="http://schemas.microsoft.com/office/drawing/2014/main" id="{32C31A99-7D6C-4961-A945-D02E134645EC}"/>
+                <a16:creationId xmlns:a16="http://schemas.microsoft.com/office/drawing/2014/main" id="{0CFAE954-250E-406B-9EB7-C93E9DD916E0}"/>
               </a:ext>
             </a:extLst>
           </p:cNvPr>
@@ -7039,7 +7039,7 @@
           <p:cNvPr id="6" name="Only 439 test documents. The top calibration bin h">
             <a:extLst xmlns:a="http://schemas.openxmlformats.org/drawingml/2006/main">
               <a:ext uri="{FF2B5EF4-FFF2-40B4-BE49-F238E27FC236}">
-                <a16:creationId xmlns:a16="http://schemas.microsoft.com/office/drawing/2014/main" id="{405E515F-7DCD-4F9D-81EE-8D73A6A12D54}"/>
+                <a16:creationId xmlns:a16="http://schemas.microsoft.com/office/drawing/2014/main" id="{8F4DD7E9-50F4-422C-ADC7-FEB053CC4EFC}"/>
               </a:ext>
             </a:extLst>
           </p:cNvPr>
@@ -7096,7 +7096,7 @@
           <p:cNvPr id="7" name="Two classes and one base model architecture.">
             <a:extLst xmlns:a="http://schemas.openxmlformats.org/drawingml/2006/main">
               <a:ext uri="{FF2B5EF4-FFF2-40B4-BE49-F238E27FC236}">
-                <a16:creationId xmlns:a16="http://schemas.microsoft.com/office/drawing/2014/main" id="{2D835236-9806-41AB-AB5D-25B4C06E3082}"/>
+                <a16:creationId xmlns:a16="http://schemas.microsoft.com/office/drawing/2014/main" id="{89211080-609A-4E89-846E-2D087192632E}"/>
               </a:ext>
             </a:extLst>
           </p:cNvPr>
@@ -7150,10 +7150,10 @@
       </p:sp>
       <p:sp>
         <p:nvSpPr>
-          <p:cNvPr id="8" name="The review rule sent 78 correct predictions to hum">
+          <p:cNvPr id="8" name="Six probes are required; 50 correct high-confidenc">
             <a:extLst xmlns:a="http://schemas.openxmlformats.org/drawingml/2006/main">
               <a:ext uri="{FF2B5EF4-FFF2-40B4-BE49-F238E27FC236}">
-                <a16:creationId xmlns:a16="http://schemas.microsoft.com/office/drawing/2014/main" id="{A051FF61-53E7-493A-8D10-1445B4C49C0B}"/>
+                <a16:creationId xmlns:a16="http://schemas.microsoft.com/office/drawing/2014/main" id="{256FDDFB-CA49-469A-BC84-6ABC1B3D8EBF}"/>
               </a:ext>
             </a:extLst>
           </p:cNvPr>
@@ -7200,17 +7200,17 @@
                 <a:ea typeface="Calibri"/>
                 <a:cs typeface="Calibri"/>
               </a:rPr>
-              <a:t>The review rule sent 78 correct predictions to human review.</a:t>
-            </a:r>
-          </a:p>
-        </p:txBody>
-      </p:sp>
-      <p:sp>
-        <p:nvSpPr>
-          <p:cNvPr id="9" name="Find a more selective way to catch step-0 high-con">
+              <a:t>Six probes are required; 50 correct high-confidence cases were flagged.</a:t>
+            </a:r>
+          </a:p>
+        </p:txBody>
+      </p:sp>
+      <p:sp>
+        <p:nvSpPr>
+          <p:cNvPr id="9" name="Reduce false alarms, then test on a new corpus.">
             <a:extLst xmlns:a="http://schemas.openxmlformats.org/drawingml/2006/main">
               <a:ext uri="{FF2B5EF4-FFF2-40B4-BE49-F238E27FC236}">
-                <a16:creationId xmlns:a16="http://schemas.microsoft.com/office/drawing/2014/main" id="{069FE060-9382-4D25-BB4B-C6E5F74A1C0F}"/>
+                <a16:creationId xmlns:a16="http://schemas.microsoft.com/office/drawing/2014/main" id="{3060CFE0-9E05-4411-9688-266359647658}"/>
               </a:ext>
             </a:extLst>
           </p:cNvPr>
@@ -7257,7 +7257,7 @@
                 <a:ea typeface="Calibri"/>
                 <a:cs typeface="Calibri"/>
               </a:rPr>
-              <a:t>Find a more selective way to catch step-0 high-confidence errors.</a:t>
+              <a:t>Reduce false alarms, then test on a new corpus.</a:t>
             </a:r>
           </a:p>
         </p:txBody>
@@ -7267,7 +7267,7 @@
           <p:cNvPr id="10" name="Collect naturally repeated real-world queries when">
             <a:extLst xmlns:a="http://schemas.openxmlformats.org/drawingml/2006/main">
               <a:ext uri="{FF2B5EF4-FFF2-40B4-BE49-F238E27FC236}">
-                <a16:creationId xmlns:a16="http://schemas.microsoft.com/office/drawing/2014/main" id="{1DC6DBE3-B1B6-47AC-BBCD-9713258D13D1}"/>
+                <a16:creationId xmlns:a16="http://schemas.microsoft.com/office/drawing/2014/main" id="{1096AB0C-B482-4BA6-95BB-5B1FD6B9E102}"/>
               </a:ext>
             </a:extLst>
           </p:cNvPr>
@@ -7324,7 +7324,7 @@
           <p:cNvPr id="11" name="Apply temperature scaling and retest whether histo">
             <a:extLst xmlns:a="http://schemas.openxmlformats.org/drawingml/2006/main">
               <a:ext uri="{FF2B5EF4-FFF2-40B4-BE49-F238E27FC236}">
-                <a16:creationId xmlns:a16="http://schemas.microsoft.com/office/drawing/2014/main" id="{8ED39B30-7794-4F04-AA3F-34CFED34EF75}"/>
+                <a16:creationId xmlns:a16="http://schemas.microsoft.com/office/drawing/2014/main" id="{7145663E-050C-4363-B1BF-0A37719277A4}"/>
               </a:ext>
             </a:extLst>
           </p:cNvPr>
@@ -7381,7 +7381,7 @@
           <p:cNvPr id="12" name="Extend to multiple classes and another base model.">
             <a:extLst xmlns:a="http://schemas.openxmlformats.org/drawingml/2006/main">
               <a:ext uri="{FF2B5EF4-FFF2-40B4-BE49-F238E27FC236}">
-                <a16:creationId xmlns:a16="http://schemas.microsoft.com/office/drawing/2014/main" id="{C0CC14B7-6D8C-4A91-8402-647A71B62A6F}"/>
+                <a16:creationId xmlns:a16="http://schemas.microsoft.com/office/drawing/2014/main" id="{3A04E935-0CB0-4D96-8ED5-2FA391C3D86F}"/>
               </a:ext>
             </a:extLst>
           </p:cNvPr>
@@ -7436,7 +7436,7 @@
     </p:spTree>
     <p:extLst>
       <p:ext uri="{BB962C8B-B14F-4D97-AF65-F5344CB8AC3E}">
-        <p14:creationId xmlns:p14="http://schemas.microsoft.com/office/powerpoint/2010/main" val="355418043"/>
+        <p14:creationId xmlns:p14="http://schemas.microsoft.com/office/powerpoint/2010/main" val="1724524872"/>
       </p:ext>
     </p:extLst>
   </p:cSld>
@@ -7467,7 +7467,7 @@
           <p:cNvPr id="10" name="14">
             <a:extLst xmlns:a="http://schemas.openxmlformats.org/drawingml/2006/main">
               <a:ext uri="{FF2B5EF4-FFF2-40B4-BE49-F238E27FC236}">
-                <a16:creationId xmlns:a16="http://schemas.microsoft.com/office/drawing/2014/main" id="{B9651141-DD2E-43C0-B714-5CF0A37948F5}"/>
+                <a16:creationId xmlns:a16="http://schemas.microsoft.com/office/drawing/2014/main" id="{12511F6A-D921-42EC-90A1-957567BEEE88}"/>
               </a:ext>
             </a:extLst>
           </p:cNvPr>
@@ -7524,7 +7524,7 @@
           <p:cNvPr id="2" name="CONCLUSION">
             <a:extLst xmlns:a="http://schemas.openxmlformats.org/drawingml/2006/main">
               <a:ext uri="{FF2B5EF4-FFF2-40B4-BE49-F238E27FC236}">
-                <a16:creationId xmlns:a16="http://schemas.microsoft.com/office/drawing/2014/main" id="{B72FF8BC-CE8D-40D1-9844-4D52DDEA79E0}"/>
+                <a16:creationId xmlns:a16="http://schemas.microsoft.com/office/drawing/2014/main" id="{21B70AED-C5E3-451C-B017-882C0D8A1500}"/>
               </a:ext>
             </a:extLst>
           </p:cNvPr>
@@ -7581,7 +7581,7 @@
           <p:cNvPr id="3" name="Confidence history adds">
             <a:extLst xmlns:a="http://schemas.openxmlformats.org/drawingml/2006/main">
               <a:ext uri="{FF2B5EF4-FFF2-40B4-BE49-F238E27FC236}">
-                <a16:creationId xmlns:a16="http://schemas.microsoft.com/office/drawing/2014/main" id="{BEB3A70E-E7EA-4549-8CC1-B2A2D6E67E96}"/>
+                <a16:creationId xmlns:a16="http://schemas.microsoft.com/office/drawing/2014/main" id="{FEBFDEEA-65BA-459F-8B9E-4881C7E039B6}"/>
               </a:ext>
             </a:extLst>
           </p:cNvPr>
@@ -7638,7 +7638,7 @@
           <p:cNvPr id="4" name="a modest signal.">
             <a:extLst xmlns:a="http://schemas.openxmlformats.org/drawingml/2006/main">
               <a:ext uri="{FF2B5EF4-FFF2-40B4-BE49-F238E27FC236}">
-                <a16:creationId xmlns:a16="http://schemas.microsoft.com/office/drawing/2014/main" id="{B7DCC727-3A99-447C-915C-95FBB699C7C2}"/>
+                <a16:creationId xmlns:a16="http://schemas.microsoft.com/office/drawing/2014/main" id="{4517EFB3-3675-4AC3-B885-48DEDE673526}"/>
               </a:ext>
             </a:extLst>
           </p:cNvPr>
@@ -7692,10 +7692,10 @@
       </p:sp>
       <p:sp>
         <p:nvSpPr>
-          <p:cNvPr id="5" name="Review covers the rest—at a cost.">
+          <p:cNvPr id="5" name="Six flagged. Fifty false alarms.">
             <a:extLst xmlns:a="http://schemas.openxmlformats.org/drawingml/2006/main">
               <a:ext uri="{FF2B5EF4-FFF2-40B4-BE49-F238E27FC236}">
-                <a16:creationId xmlns:a16="http://schemas.microsoft.com/office/drawing/2014/main" id="{C0C27CE1-873D-441D-B6D1-51BB7DBE21EB}"/>
+                <a16:creationId xmlns:a16="http://schemas.microsoft.com/office/drawing/2014/main" id="{F63B554E-9A39-428A-8ECB-ED195B279712}"/>
               </a:ext>
             </a:extLst>
           </p:cNvPr>
@@ -7742,17 +7742,17 @@
                 <a:ea typeface="Georgia"/>
                 <a:cs typeface="Georgia"/>
               </a:rPr>
-              <a:t>Review covers the rest—at a cost.</a:t>
-            </a:r>
-          </a:p>
-        </p:txBody>
-      </p:sp>
-      <p:sp>
-        <p:nvSpPr>
-          <p:cNvPr id="6" name="The drift detector missed all six high-confidence ">
+              <a:t>Six flagged. Fifty false alarms.</a:t>
+            </a:r>
+          </a:p>
+        </p:txBody>
+      </p:sp>
+      <p:sp>
+        <p:nvSpPr>
+          <p:cNvPr id="6" name="The per-step detector missed all six at the first ">
             <a:extLst xmlns:a="http://schemas.openxmlformats.org/drawingml/2006/main">
               <a:ext uri="{FF2B5EF4-FFF2-40B4-BE49-F238E27FC236}">
-                <a16:creationId xmlns:a16="http://schemas.microsoft.com/office/drawing/2014/main" id="{146887E3-D345-49B8-9DB6-419427E09EFD}"/>
+                <a16:creationId xmlns:a16="http://schemas.microsoft.com/office/drawing/2014/main" id="{23C3DDB9-9214-4A59-B653-5D711CF9FA3F}"/>
               </a:ext>
             </a:extLst>
           </p:cNvPr>
@@ -7799,7 +7799,7 @@
                 <a:ea typeface="Calibri"/>
                 <a:cs typeface="Calibri"/>
               </a:rPr>
-              <a:t>The drift detector missed all six high-confidence errors.</a:t>
+              <a:t>The per-step detector missed all six at the first prediction.</a:t>
             </a:r>
           </a:p>
           <a:p xmlns:a="http://schemas.openxmlformats.org/drawingml/2006/main">
@@ -7822,7 +7822,7 @@
                 <a:ea typeface="Calibri"/>
                 <a:cs typeface="Calibri"/>
               </a:rPr>
-              <a:t>A separate review rule routed all six, plus 78 correct cases.</a:t>
+              <a:t>After six probes, the sequence model flagged all six plus 50 correct cases.</a:t>
             </a:r>
           </a:p>
         </p:txBody>
@@ -7832,7 +7832,7 @@
           <p:cNvPr id="7" name="F1  0.468 to 0.508">
             <a:extLst xmlns:a="http://schemas.openxmlformats.org/drawingml/2006/main">
               <a:ext uri="{FF2B5EF4-FFF2-40B4-BE49-F238E27FC236}">
-                <a16:creationId xmlns:a16="http://schemas.microsoft.com/office/drawing/2014/main" id="{87793C5B-754A-415E-B54D-A303D735B502}"/>
+                <a16:creationId xmlns:a16="http://schemas.microsoft.com/office/drawing/2014/main" id="{00A61AAA-C52D-4A42-B9B8-21D06A384D8B}"/>
               </a:ext>
             </a:extLst>
           </p:cNvPr>
@@ -7889,7 +7889,7 @@
           <p:cNvPr id="8" name="ROC-AUC  0.729 to 0.763">
             <a:extLst xmlns:a="http://schemas.openxmlformats.org/drawingml/2006/main">
               <a:ext uri="{FF2B5EF4-FFF2-40B4-BE49-F238E27FC236}">
-                <a16:creationId xmlns:a16="http://schemas.microsoft.com/office/drawing/2014/main" id="{30C23FA5-6A99-4BD8-91ED-4113818DD134}"/>
+                <a16:creationId xmlns:a16="http://schemas.microsoft.com/office/drawing/2014/main" id="{7BA7C57E-50A9-4546-9069-80D4D6FD2123}"/>
               </a:ext>
             </a:extLst>
           </p:cNvPr>
@@ -7946,7 +7946,7 @@
           <p:cNvPr id="9" name="Code, data, models and research report: github.com">
             <a:extLst xmlns:a="http://schemas.openxmlformats.org/drawingml/2006/main">
               <a:ext uri="{FF2B5EF4-FFF2-40B4-BE49-F238E27FC236}">
-                <a16:creationId xmlns:a16="http://schemas.microsoft.com/office/drawing/2014/main" id="{247D303D-885B-4898-8C7D-16718F0A9D06}"/>
+                <a16:creationId xmlns:a16="http://schemas.microsoft.com/office/drawing/2014/main" id="{C463656E-6112-4BFC-B2FF-172DDA6DA137}"/>
               </a:ext>
             </a:extLst>
           </p:cNvPr>
@@ -8003,7 +8003,7 @@
                 <a:latin typeface="Calibri"/>
                 <a:ea typeface="Calibri"/>
                 <a:cs typeface="Calibri"/>
-                <a:hlinkClick xmlns:r="http://schemas.openxmlformats.org/officeDocument/2006/relationships" r:id="R930a417174f947ce"/>
+                <a:hlinkClick xmlns:r="http://schemas.openxmlformats.org/officeDocument/2006/relationships" r:id="R6ce4387a781d48f6"/>
               </a:rPr>
               <a:t>github.com/ahansardar/ai-confidence-drift</a:t>
             </a:r>
@@ -8013,7 +8013,7 @@
     </p:spTree>
     <p:extLst>
       <p:ext uri="{BB962C8B-B14F-4D97-AF65-F5344CB8AC3E}">
-        <p14:creationId xmlns:p14="http://schemas.microsoft.com/office/powerpoint/2010/main" val="599556525"/>
+        <p14:creationId xmlns:p14="http://schemas.microsoft.com/office/powerpoint/2010/main" val="1477101725"/>
       </p:ext>
     </p:extLst>
   </p:cSld>
@@ -8044,7 +8044,7 @@
           <p:cNvPr id="12" name="The confidence problem">
             <a:extLst xmlns:a="http://schemas.openxmlformats.org/drawingml/2006/main">
               <a:ext uri="{FF2B5EF4-FFF2-40B4-BE49-F238E27FC236}">
-                <a16:creationId xmlns:a16="http://schemas.microsoft.com/office/drawing/2014/main" id="{61B16C18-33DD-4C19-8E25-3D5C4FDEE0E1}"/>
+                <a16:creationId xmlns:a16="http://schemas.microsoft.com/office/drawing/2014/main" id="{C544689A-B8FE-4722-9F6F-95C2FFF8E94A}"/>
               </a:ext>
             </a:extLst>
           </p:cNvPr>
@@ -8101,7 +8101,7 @@
           <p:cNvPr id="2" name="02">
             <a:extLst xmlns:a="http://schemas.openxmlformats.org/drawingml/2006/main">
               <a:ext uri="{FF2B5EF4-FFF2-40B4-BE49-F238E27FC236}">
-                <a16:creationId xmlns:a16="http://schemas.microsoft.com/office/drawing/2014/main" id="{38E56B1D-A35C-4432-8187-DE17B8FA9B3B}"/>
+                <a16:creationId xmlns:a16="http://schemas.microsoft.com/office/drawing/2014/main" id="{04771171-DA36-46E2-A6C6-EFCD7DB54845}"/>
               </a:ext>
             </a:extLst>
           </p:cNvPr>
@@ -8158,7 +8158,7 @@
           <p:cNvPr id="3" name="96.3%">
             <a:extLst xmlns:a="http://schemas.openxmlformats.org/drawingml/2006/main">
               <a:ext uri="{FF2B5EF4-FFF2-40B4-BE49-F238E27FC236}">
-                <a16:creationId xmlns:a16="http://schemas.microsoft.com/office/drawing/2014/main" id="{7E98425E-5BDD-48A9-B70A-44A1619024A9}"/>
+                <a16:creationId xmlns:a16="http://schemas.microsoft.com/office/drawing/2014/main" id="{FC012203-B4DD-41BB-BC0E-5204A78E1006}"/>
               </a:ext>
             </a:extLst>
           </p:cNvPr>
@@ -8215,7 +8215,7 @@
           <p:cNvPr id="4" name="confident. Still wrong.">
             <a:extLst xmlns:a="http://schemas.openxmlformats.org/drawingml/2006/main">
               <a:ext uri="{FF2B5EF4-FFF2-40B4-BE49-F238E27FC236}">
-                <a16:creationId xmlns:a16="http://schemas.microsoft.com/office/drawing/2014/main" id="{C5F28DEE-7BF9-4759-B9B9-DEF8955A2C19}"/>
+                <a16:creationId xmlns:a16="http://schemas.microsoft.com/office/drawing/2014/main" id="{735BC8AE-79F5-4A1F-BC83-1A5AF63ACA21}"/>
               </a:ext>
             </a:extLst>
           </p:cNvPr>
@@ -8272,7 +8272,7 @@
           <p:cNvPr id="5" name="One observed prediction&#10;Document doc_00750">
             <a:extLst xmlns:a="http://schemas.openxmlformats.org/drawingml/2006/main">
               <a:ext uri="{FF2B5EF4-FFF2-40B4-BE49-F238E27FC236}">
-                <a16:creationId xmlns:a16="http://schemas.microsoft.com/office/drawing/2014/main" id="{BFAEAB5B-00F0-4F3F-ACF1-3E1E3B6DE53D}"/>
+                <a16:creationId xmlns:a16="http://schemas.microsoft.com/office/drawing/2014/main" id="{FF4EB140-F2A6-465F-9386-945927EB5CAA}"/>
               </a:ext>
             </a:extLst>
           </p:cNvPr>
@@ -8352,7 +8352,7 @@
           <p:cNvPr id="6" name="Confident errors">
             <a:extLst xmlns:a="http://schemas.openxmlformats.org/drawingml/2006/main">
               <a:ext uri="{FF2B5EF4-FFF2-40B4-BE49-F238E27FC236}">
-                <a16:creationId xmlns:a16="http://schemas.microsoft.com/office/drawing/2014/main" id="{ADF5B278-CAEF-4AED-9933-0116917B46E6}"/>
+                <a16:creationId xmlns:a16="http://schemas.microsoft.com/office/drawing/2014/main" id="{344BC25B-0B37-4E20-B067-C03D0489772C}"/>
               </a:ext>
             </a:extLst>
           </p:cNvPr>
@@ -8409,7 +8409,7 @@
           <p:cNvPr id="7" name="A model can be highly confident about an incorrect">
             <a:extLst xmlns:a="http://schemas.openxmlformats.org/drawingml/2006/main">
               <a:ext uri="{FF2B5EF4-FFF2-40B4-BE49-F238E27FC236}">
-                <a16:creationId xmlns:a16="http://schemas.microsoft.com/office/drawing/2014/main" id="{8C3DE774-AE2A-415C-8E15-A783CA75C6F8}"/>
+                <a16:creationId xmlns:a16="http://schemas.microsoft.com/office/drawing/2014/main" id="{72921DCB-CA45-49BB-830C-158CB7EF23E4}"/>
               </a:ext>
             </a:extLst>
           </p:cNvPr>
@@ -8466,7 +8466,7 @@
           <p:cNvPr id="8" name="Unstable confidence">
             <a:extLst xmlns:a="http://schemas.openxmlformats.org/drawingml/2006/main">
               <a:ext uri="{FF2B5EF4-FFF2-40B4-BE49-F238E27FC236}">
-                <a16:creationId xmlns:a16="http://schemas.microsoft.com/office/drawing/2014/main" id="{06546966-1974-4DD2-8448-D8EC33CD1233}"/>
+                <a16:creationId xmlns:a16="http://schemas.microsoft.com/office/drawing/2014/main" id="{D4154C3F-86E1-4754-A721-BD6FDB2FE7FE}"/>
               </a:ext>
             </a:extLst>
           </p:cNvPr>
@@ -8523,7 +8523,7 @@
           <p:cNvPr id="9" name="Confidence can change across similar inputs withou">
             <a:extLst xmlns:a="http://schemas.openxmlformats.org/drawingml/2006/main">
               <a:ext uri="{FF2B5EF4-FFF2-40B4-BE49-F238E27FC236}">
-                <a16:creationId xmlns:a16="http://schemas.microsoft.com/office/drawing/2014/main" id="{884B944C-F9C2-40F0-9096-B51B1F9C59BF}"/>
+                <a16:creationId xmlns:a16="http://schemas.microsoft.com/office/drawing/2014/main" id="{E373731F-A363-415E-AA8A-BE99BC712304}"/>
               </a:ext>
             </a:extLst>
           </p:cNvPr>
@@ -8580,7 +8580,7 @@
           <p:cNvPr id="10" name="Increasing difficulty">
             <a:extLst xmlns:a="http://schemas.openxmlformats.org/drawingml/2006/main">
               <a:ext uri="{FF2B5EF4-FFF2-40B4-BE49-F238E27FC236}">
-                <a16:creationId xmlns:a16="http://schemas.microsoft.com/office/drawing/2014/main" id="{13A76AD2-3837-4753-A96C-6EE646C45A5D}"/>
+                <a16:creationId xmlns:a16="http://schemas.microsoft.com/office/drawing/2014/main" id="{10851FBE-B36D-4E54-8D2C-8F0A287F4BB7}"/>
               </a:ext>
             </a:extLst>
           </p:cNvPr>
@@ -8637,7 +8637,7 @@
           <p:cNvPr id="11" name="Lower confidence may accompany harder inputs. The ">
             <a:extLst xmlns:a="http://schemas.openxmlformats.org/drawingml/2006/main">
               <a:ext uri="{FF2B5EF4-FFF2-40B4-BE49-F238E27FC236}">
-                <a16:creationId xmlns:a16="http://schemas.microsoft.com/office/drawing/2014/main" id="{80FED9E6-0B2F-4D0B-8BD3-BB70E2367C00}"/>
+                <a16:creationId xmlns:a16="http://schemas.microsoft.com/office/drawing/2014/main" id="{0093AA87-1CFE-4891-BF20-31B6408AB7F6}"/>
               </a:ext>
             </a:extLst>
           </p:cNvPr>
@@ -8692,7 +8692,7 @@
     </p:spTree>
     <p:extLst>
       <p:ext uri="{BB962C8B-B14F-4D97-AF65-F5344CB8AC3E}">
-        <p14:creationId xmlns:p14="http://schemas.microsoft.com/office/powerpoint/2010/main" val="1855573096"/>
+        <p14:creationId xmlns:p14="http://schemas.microsoft.com/office/powerpoint/2010/main" val="427418657"/>
       </p:ext>
     </p:extLst>
   </p:cSld>
@@ -8723,7 +8723,7 @@
           <p:cNvPr id="9" name="Research question">
             <a:extLst xmlns:a="http://schemas.openxmlformats.org/drawingml/2006/main">
               <a:ext uri="{FF2B5EF4-FFF2-40B4-BE49-F238E27FC236}">
-                <a16:creationId xmlns:a16="http://schemas.microsoft.com/office/drawing/2014/main" id="{A05534E0-E69F-40A7-A7C1-2A3DE750099D}"/>
+                <a16:creationId xmlns:a16="http://schemas.microsoft.com/office/drawing/2014/main" id="{CBB5DDEB-E77B-4D13-97E7-2E0092522A49}"/>
               </a:ext>
             </a:extLst>
           </p:cNvPr>
@@ -8780,7 +8780,7 @@
           <p:cNvPr id="2" name="03">
             <a:extLst xmlns:a="http://schemas.openxmlformats.org/drawingml/2006/main">
               <a:ext uri="{FF2B5EF4-FFF2-40B4-BE49-F238E27FC236}">
-                <a16:creationId xmlns:a16="http://schemas.microsoft.com/office/drawing/2014/main" id="{2DF09F8D-B248-4AF3-81DC-EF59508D8120}"/>
+                <a16:creationId xmlns:a16="http://schemas.microsoft.com/office/drawing/2014/main" id="{E0D49C05-D6BC-4FBD-A956-462312659FB7}"/>
               </a:ext>
             </a:extLst>
           </p:cNvPr>
@@ -8837,7 +8837,7 @@
           <p:cNvPr id="3" name="Can changes in a model’s confidence">
             <a:extLst xmlns:a="http://schemas.openxmlformats.org/drawingml/2006/main">
               <a:ext uri="{FF2B5EF4-FFF2-40B4-BE49-F238E27FC236}">
-                <a16:creationId xmlns:a16="http://schemas.microsoft.com/office/drawing/2014/main" id="{F5FF6355-8F71-4A4E-85ED-BA0F968C7ECE}"/>
+                <a16:creationId xmlns:a16="http://schemas.microsoft.com/office/drawing/2014/main" id="{D44C6F25-E668-4590-897B-39AD320E4595}"/>
               </a:ext>
             </a:extLst>
           </p:cNvPr>
@@ -8894,7 +8894,7 @@
           <p:cNvPr id="4" name="help identify predictions that are">
             <a:extLst xmlns:a="http://schemas.openxmlformats.org/drawingml/2006/main">
               <a:ext uri="{FF2B5EF4-FFF2-40B4-BE49-F238E27FC236}">
-                <a16:creationId xmlns:a16="http://schemas.microsoft.com/office/drawing/2014/main" id="{F161DBA3-8492-48A3-910F-E28F1ABAC982}"/>
+                <a16:creationId xmlns:a16="http://schemas.microsoft.com/office/drawing/2014/main" id="{23E346B2-446A-4FBF-B209-56FF9FA08286}"/>
               </a:ext>
             </a:extLst>
           </p:cNvPr>
@@ -8951,7 +8951,7 @@
           <p:cNvPr id="5" name="likely to be unreliable?">
             <a:extLst xmlns:a="http://schemas.openxmlformats.org/drawingml/2006/main">
               <a:ext uri="{FF2B5EF4-FFF2-40B4-BE49-F238E27FC236}">
-                <a16:creationId xmlns:a16="http://schemas.microsoft.com/office/drawing/2014/main" id="{DF3F75C4-6677-46BB-A5F0-E50E66EDDA0A}"/>
+                <a16:creationId xmlns:a16="http://schemas.microsoft.com/office/drawing/2014/main" id="{093EEE56-96AD-483F-852D-0120EFAF311D}"/>
               </a:ext>
             </a:extLst>
           </p:cNvPr>
@@ -9008,7 +9008,7 @@
           <p:cNvPr id="6" name="The hypothesis">
             <a:extLst xmlns:a="http://schemas.openxmlformats.org/drawingml/2006/main">
               <a:ext uri="{FF2B5EF4-FFF2-40B4-BE49-F238E27FC236}">
-                <a16:creationId xmlns:a16="http://schemas.microsoft.com/office/drawing/2014/main" id="{F835D5A9-2E89-4696-8EAA-52CFEFDE60C8}"/>
+                <a16:creationId xmlns:a16="http://schemas.microsoft.com/office/drawing/2014/main" id="{8E3CEFDB-9DF9-4E77-951D-8CE880A1B3F1}"/>
               </a:ext>
             </a:extLst>
           </p:cNvPr>
@@ -9065,7 +9065,7 @@
           <p:cNvPr id="7" name="Confidence history may help predict errors after a">
             <a:extLst xmlns:a="http://schemas.openxmlformats.org/drawingml/2006/main">
               <a:ext uri="{FF2B5EF4-FFF2-40B4-BE49-F238E27FC236}">
-                <a16:creationId xmlns:a16="http://schemas.microsoft.com/office/drawing/2014/main" id="{C1AB28BC-775F-46FB-9A3D-6EF2B27242A3}"/>
+                <a16:creationId xmlns:a16="http://schemas.microsoft.com/office/drawing/2014/main" id="{D558C46F-29B2-47A8-A35C-512CF5D5F24E}"/>
               </a:ext>
             </a:extLst>
           </p:cNvPr>
@@ -9122,7 +9122,7 @@
           <p:cNvPr id="8" name="The A/B/C comparison isolates each additional sour">
             <a:extLst xmlns:a="http://schemas.openxmlformats.org/drawingml/2006/main">
               <a:ext uri="{FF2B5EF4-FFF2-40B4-BE49-F238E27FC236}">
-                <a16:creationId xmlns:a16="http://schemas.microsoft.com/office/drawing/2014/main" id="{117AFA38-F36A-4210-A6D0-BA7450770410}"/>
+                <a16:creationId xmlns:a16="http://schemas.microsoft.com/office/drawing/2014/main" id="{0ADEA8BE-F461-4334-9F18-37F2360EE21A}"/>
               </a:ext>
             </a:extLst>
           </p:cNvPr>
@@ -9177,7 +9177,7 @@
     </p:spTree>
     <p:extLst>
       <p:ext uri="{BB962C8B-B14F-4D97-AF65-F5344CB8AC3E}">
-        <p14:creationId xmlns:p14="http://schemas.microsoft.com/office/powerpoint/2010/main" val="2005935989"/>
+        <p14:creationId xmlns:p14="http://schemas.microsoft.com/office/powerpoint/2010/main" val="184059780"/>
       </p:ext>
     </p:extLst>
   </p:cSld>
@@ -9208,7 +9208,7 @@
           <p:cNvPr id="13" name="Task and dataset">
             <a:extLst xmlns:a="http://schemas.openxmlformats.org/drawingml/2006/main">
               <a:ext uri="{FF2B5EF4-FFF2-40B4-BE49-F238E27FC236}">
-                <a16:creationId xmlns:a16="http://schemas.microsoft.com/office/drawing/2014/main" id="{9723426D-D435-4463-B4A0-F90BC5EFE064}"/>
+                <a16:creationId xmlns:a16="http://schemas.microsoft.com/office/drawing/2014/main" id="{D2479BE3-0DE3-4189-9B8C-AF53A65D2419}"/>
               </a:ext>
             </a:extLst>
           </p:cNvPr>
@@ -9265,7 +9265,7 @@
           <p:cNvPr id="2" name="04">
             <a:extLst xmlns:a="http://schemas.openxmlformats.org/drawingml/2006/main">
               <a:ext uri="{FF2B5EF4-FFF2-40B4-BE49-F238E27FC236}">
-                <a16:creationId xmlns:a16="http://schemas.microsoft.com/office/drawing/2014/main" id="{7723F7D9-4AAA-4529-AD3F-CEA87D1A6481}"/>
+                <a16:creationId xmlns:a16="http://schemas.microsoft.com/office/drawing/2014/main" id="{F8E87241-623A-490E-A1CF-24647D545F20}"/>
               </a:ext>
             </a:extLst>
           </p:cNvPr>
@@ -9322,7 +9322,7 @@
           <p:cNvPr id="3" name="1,754">
             <a:extLst xmlns:a="http://schemas.openxmlformats.org/drawingml/2006/main">
               <a:ext uri="{FF2B5EF4-FFF2-40B4-BE49-F238E27FC236}">
-                <a16:creationId xmlns:a16="http://schemas.microsoft.com/office/drawing/2014/main" id="{34E24C4E-74A8-4276-A076-8294081E97DA}"/>
+                <a16:creationId xmlns:a16="http://schemas.microsoft.com/office/drawing/2014/main" id="{7836D0F5-0886-4262-A913-ECB473029D6D}"/>
               </a:ext>
             </a:extLst>
           </p:cNvPr>
@@ -9379,7 +9379,7 @@
           <p:cNvPr id="4" name="documents from 20 Newsgroups">
             <a:extLst xmlns:a="http://schemas.openxmlformats.org/drawingml/2006/main">
               <a:ext uri="{FF2B5EF4-FFF2-40B4-BE49-F238E27FC236}">
-                <a16:creationId xmlns:a16="http://schemas.microsoft.com/office/drawing/2014/main" id="{779814A4-D773-4417-9A9C-8A404BC8B3DF}"/>
+                <a16:creationId xmlns:a16="http://schemas.microsoft.com/office/drawing/2014/main" id="{CF93DDE4-53C3-4DD5-94EE-2202D6147D0C}"/>
               </a:ext>
             </a:extLst>
           </p:cNvPr>
@@ -9436,7 +9436,7 @@
           <p:cNvPr id="5" name="1,315 training / 439 test">
             <a:extLst xmlns:a="http://schemas.openxmlformats.org/drawingml/2006/main">
               <a:ext uri="{FF2B5EF4-FFF2-40B4-BE49-F238E27FC236}">
-                <a16:creationId xmlns:a16="http://schemas.microsoft.com/office/drawing/2014/main" id="{91EBB7E2-3D79-4E43-A9DD-17B2BA14B7BF}"/>
+                <a16:creationId xmlns:a16="http://schemas.microsoft.com/office/drawing/2014/main" id="{C4B99F11-BD5A-4D4E-BB32-ACC8BDDD454B}"/>
               </a:ext>
             </a:extLst>
           </p:cNvPr>
@@ -9493,7 +9493,7 @@
           <p:cNvPr id="6" name="Stratified split&#10;44.4% / 55.6% class balance">
             <a:extLst xmlns:a="http://schemas.openxmlformats.org/drawingml/2006/main">
               <a:ext uri="{FF2B5EF4-FFF2-40B4-BE49-F238E27FC236}">
-                <a16:creationId xmlns:a16="http://schemas.microsoft.com/office/drawing/2014/main" id="{08CC263A-817C-4374-9E75-A543CC5D7EF9}"/>
+                <a16:creationId xmlns:a16="http://schemas.microsoft.com/office/drawing/2014/main" id="{038A4AE5-9767-406B-BB78-FC6B3C2C3693}"/>
               </a:ext>
             </a:extLst>
           </p:cNvPr>
@@ -9573,7 +9573,7 @@
           <p:cNvPr id="7" name="Binary text classification">
             <a:extLst xmlns:a="http://schemas.openxmlformats.org/drawingml/2006/main">
               <a:ext uri="{FF2B5EF4-FFF2-40B4-BE49-F238E27FC236}">
-                <a16:creationId xmlns:a16="http://schemas.microsoft.com/office/drawing/2014/main" id="{B6B357A2-1FDD-4249-8A2E-3F874EBAF6C5}"/>
+                <a16:creationId xmlns:a16="http://schemas.microsoft.com/office/drawing/2014/main" id="{F2EFE2ED-FC92-4A84-A743-8D491D907E18}"/>
               </a:ext>
             </a:extLst>
           </p:cNvPr>
@@ -9630,7 +9630,7 @@
           <p:cNvPr id="8" name="alt.atheism&#10;soc.religion.christian">
             <a:extLst xmlns:a="http://schemas.openxmlformats.org/drawingml/2006/main">
               <a:ext uri="{FF2B5EF4-FFF2-40B4-BE49-F238E27FC236}">
-                <a16:creationId xmlns:a16="http://schemas.microsoft.com/office/drawing/2014/main" id="{EFC9EA04-5F21-4732-A2F1-95F14A5094B7}"/>
+                <a16:creationId xmlns:a16="http://schemas.microsoft.com/office/drawing/2014/main" id="{A7936AE6-2FE2-4D73-BC05-405151D77390}"/>
               </a:ext>
             </a:extLst>
           </p:cNvPr>
@@ -9710,7 +9710,7 @@
           <p:cNvPr id="9" name="Overlapping vocabulary makes the task less trivial">
             <a:extLst xmlns:a="http://schemas.openxmlformats.org/drawingml/2006/main">
               <a:ext uri="{FF2B5EF4-FFF2-40B4-BE49-F238E27FC236}">
-                <a16:creationId xmlns:a16="http://schemas.microsoft.com/office/drawing/2014/main" id="{ABC5FA3A-932D-4D5C-AE4B-37BEDB651BEE}"/>
+                <a16:creationId xmlns:a16="http://schemas.microsoft.com/office/drawing/2014/main" id="{81B8A87B-3208-49AD-9B04-C416982FEA19}"/>
               </a:ext>
             </a:extLst>
           </p:cNvPr>
@@ -9767,7 +9767,7 @@
           <p:cNvPr id="10" name="Headers, footers and quoted text removed to reduce">
             <a:extLst xmlns:a="http://schemas.openxmlformats.org/drawingml/2006/main">
               <a:ext uri="{FF2B5EF4-FFF2-40B4-BE49-F238E27FC236}">
-                <a16:creationId xmlns:a16="http://schemas.microsoft.com/office/drawing/2014/main" id="{74C55CBA-3E35-411D-A4AA-80DF8A2C8F09}"/>
+                <a16:creationId xmlns:a16="http://schemas.microsoft.com/office/drawing/2014/main" id="{020B8458-D3CA-4DC7-8145-3B492011585E}"/>
               </a:ext>
             </a:extLst>
           </p:cNvPr>
@@ -9824,7 +9824,7 @@
           <p:cNvPr id="11" name="Ground truth: the newsgroup that published each po">
             <a:extLst xmlns:a="http://schemas.openxmlformats.org/drawingml/2006/main">
               <a:ext uri="{FF2B5EF4-FFF2-40B4-BE49-F238E27FC236}">
-                <a16:creationId xmlns:a16="http://schemas.microsoft.com/office/drawing/2014/main" id="{7FF1EBD2-E4CE-465D-8835-820F345F7E82}"/>
+                <a16:creationId xmlns:a16="http://schemas.microsoft.com/office/drawing/2014/main" id="{588B0FCD-15F8-43C4-A043-4CC3AC6F3C35}"/>
               </a:ext>
             </a:extLst>
           </p:cNvPr>
@@ -9881,7 +9881,7 @@
           <p:cNvPr id="12" name="Source: scikit-learn’s official 20 Newsgroups mirr">
             <a:extLst xmlns:a="http://schemas.openxmlformats.org/drawingml/2006/main">
               <a:ext uri="{FF2B5EF4-FFF2-40B4-BE49-F238E27FC236}">
-                <a16:creationId xmlns:a16="http://schemas.microsoft.com/office/drawing/2014/main" id="{42FC575E-7573-4DAB-A4A4-FAB15A37504F}"/>
+                <a16:creationId xmlns:a16="http://schemas.microsoft.com/office/drawing/2014/main" id="{6CE91A94-1098-447B-8661-DD33C71A2E64}"/>
               </a:ext>
             </a:extLst>
           </p:cNvPr>
@@ -9936,7 +9936,7 @@
     </p:spTree>
     <p:extLst>
       <p:ext uri="{BB962C8B-B14F-4D97-AF65-F5344CB8AC3E}">
-        <p14:creationId xmlns:p14="http://schemas.microsoft.com/office/powerpoint/2010/main" val="1333328300"/>
+        <p14:creationId xmlns:p14="http://schemas.microsoft.com/office/powerpoint/2010/main" val="1540259215"/>
       </p:ext>
     </p:extLst>
   </p:cSld>
@@ -9967,7 +9967,7 @@
           <p:cNvPr id="18" name="The research pipeline">
             <a:extLst xmlns:a="http://schemas.openxmlformats.org/drawingml/2006/main">
               <a:ext uri="{FF2B5EF4-FFF2-40B4-BE49-F238E27FC236}">
-                <a16:creationId xmlns:a16="http://schemas.microsoft.com/office/drawing/2014/main" id="{64EF3B96-2822-403D-9C5B-91712B88142D}"/>
+                <a16:creationId xmlns:a16="http://schemas.microsoft.com/office/drawing/2014/main" id="{BA1C75B5-2054-4EBB-8FC4-4C8C351D7A2A}"/>
               </a:ext>
             </a:extLst>
           </p:cNvPr>
@@ -10024,7 +10024,7 @@
           <p:cNvPr id="2" name="05">
             <a:extLst xmlns:a="http://schemas.openxmlformats.org/drawingml/2006/main">
               <a:ext uri="{FF2B5EF4-FFF2-40B4-BE49-F238E27FC236}">
-                <a16:creationId xmlns:a16="http://schemas.microsoft.com/office/drawing/2014/main" id="{B84B378B-955C-4137-BE81-75B227815866}"/>
+                <a16:creationId xmlns:a16="http://schemas.microsoft.com/office/drawing/2014/main" id="{50254A2F-D584-4012-AD57-D76D0C084C05}"/>
               </a:ext>
             </a:extLst>
           </p:cNvPr>
@@ -10081,7 +10081,7 @@
           <p:cNvPr id="3" name="01">
             <a:extLst xmlns:a="http://schemas.openxmlformats.org/drawingml/2006/main">
               <a:ext uri="{FF2B5EF4-FFF2-40B4-BE49-F238E27FC236}">
-                <a16:creationId xmlns:a16="http://schemas.microsoft.com/office/drawing/2014/main" id="{66FD7112-DCC3-4EB7-8289-33C4D29C745E}"/>
+                <a16:creationId xmlns:a16="http://schemas.microsoft.com/office/drawing/2014/main" id="{29CACF53-D3BA-48BF-89BA-37DBCBB2D4E9}"/>
               </a:ext>
             </a:extLst>
           </p:cNvPr>
@@ -10138,7 +10138,7 @@
           <p:cNvPr id="4" name="Train the base classifier">
             <a:extLst xmlns:a="http://schemas.openxmlformats.org/drawingml/2006/main">
               <a:ext uri="{FF2B5EF4-FFF2-40B4-BE49-F238E27FC236}">
-                <a16:creationId xmlns:a16="http://schemas.microsoft.com/office/drawing/2014/main" id="{8F9687CD-C0F7-4D92-A288-53FD0E6EA4A3}"/>
+                <a16:creationId xmlns:a16="http://schemas.microsoft.com/office/drawing/2014/main" id="{EDB2E9DD-3677-4533-94C5-3BA5A6401E7E}"/>
               </a:ext>
             </a:extLst>
           </p:cNvPr>
@@ -10195,7 +10195,7 @@
           <p:cNvPr id="5" name="TF-IDF + Logistic Regression for text classificati">
             <a:extLst xmlns:a="http://schemas.openxmlformats.org/drawingml/2006/main">
               <a:ext uri="{FF2B5EF4-FFF2-40B4-BE49-F238E27FC236}">
-                <a16:creationId xmlns:a16="http://schemas.microsoft.com/office/drawing/2014/main" id="{7ACD0602-A6FD-44C5-9025-1958232E6C87}"/>
+                <a16:creationId xmlns:a16="http://schemas.microsoft.com/office/drawing/2014/main" id="{DABD8C5A-71A2-44C6-B66E-646A6EA7BF35}"/>
               </a:ext>
             </a:extLst>
           </p:cNvPr>
@@ -10252,7 +10252,7 @@
           <p:cNvPr id="6" name="02">
             <a:extLst xmlns:a="http://schemas.openxmlformats.org/drawingml/2006/main">
               <a:ext uri="{FF2B5EF4-FFF2-40B4-BE49-F238E27FC236}">
-                <a16:creationId xmlns:a16="http://schemas.microsoft.com/office/drawing/2014/main" id="{B8774D1B-D4AE-4B50-84FF-A05B8528AB11}"/>
+                <a16:creationId xmlns:a16="http://schemas.microsoft.com/office/drawing/2014/main" id="{3717B9A7-FF26-4A96-B9DE-626A91253845}"/>
               </a:ext>
             </a:extLst>
           </p:cNvPr>
@@ -10309,7 +10309,7 @@
           <p:cNvPr id="7" name="Generate confidence sequences">
             <a:extLst xmlns:a="http://schemas.openxmlformats.org/drawingml/2006/main">
               <a:ext uri="{FF2B5EF4-FFF2-40B4-BE49-F238E27FC236}">
-                <a16:creationId xmlns:a16="http://schemas.microsoft.com/office/drawing/2014/main" id="{0D737C94-CC54-4318-87D9-BE12EF866087}"/>
+                <a16:creationId xmlns:a16="http://schemas.microsoft.com/office/drawing/2014/main" id="{86E00576-0C47-4273-ABFA-9A8C153F6255}"/>
               </a:ext>
             </a:extLst>
           </p:cNvPr>
@@ -10366,7 +10366,7 @@
           <p:cNvPr id="8" name="Re-classify each test document at six corruption l">
             <a:extLst xmlns:a="http://schemas.openxmlformats.org/drawingml/2006/main">
               <a:ext uri="{FF2B5EF4-FFF2-40B4-BE49-F238E27FC236}">
-                <a16:creationId xmlns:a16="http://schemas.microsoft.com/office/drawing/2014/main" id="{1C6FCEE6-6A23-4DFF-B8B6-603E1153691D}"/>
+                <a16:creationId xmlns:a16="http://schemas.microsoft.com/office/drawing/2014/main" id="{063DBAD6-CC1F-4835-8B54-38803F3786CD}"/>
               </a:ext>
             </a:extLst>
           </p:cNvPr>
@@ -10423,7 +10423,7 @@
           <p:cNvPr id="9" name="03">
             <a:extLst xmlns:a="http://schemas.openxmlformats.org/drawingml/2006/main">
               <a:ext uri="{FF2B5EF4-FFF2-40B4-BE49-F238E27FC236}">
-                <a16:creationId xmlns:a16="http://schemas.microsoft.com/office/drawing/2014/main" id="{4EBB4723-6061-4FBC-A92F-D82DE1CA41F6}"/>
+                <a16:creationId xmlns:a16="http://schemas.microsoft.com/office/drawing/2014/main" id="{64F98C74-F0B1-4B30-8E52-228FB752EDF0}"/>
               </a:ext>
             </a:extLst>
           </p:cNvPr>
@@ -10480,7 +10480,7 @@
           <p:cNvPr id="10" name="Engineer drift features">
             <a:extLst xmlns:a="http://schemas.openxmlformats.org/drawingml/2006/main">
               <a:ext uri="{FF2B5EF4-FFF2-40B4-BE49-F238E27FC236}">
-                <a16:creationId xmlns:a16="http://schemas.microsoft.com/office/drawing/2014/main" id="{14FF3D1C-4D16-4E56-B8DD-6A8DEFF05A7F}"/>
+                <a16:creationId xmlns:a16="http://schemas.microsoft.com/office/drawing/2014/main" id="{F9AC82F7-F82B-4F9A-B7EF-25C2A715F440}"/>
               </a:ext>
             </a:extLst>
           </p:cNvPr>
@@ -10537,7 +10537,7 @@
           <p:cNvPr id="11" name="Moving statistics, deltas, consecutive drops and m">
             <a:extLst xmlns:a="http://schemas.openxmlformats.org/drawingml/2006/main">
               <a:ext uri="{FF2B5EF4-FFF2-40B4-BE49-F238E27FC236}">
-                <a16:creationId xmlns:a16="http://schemas.microsoft.com/office/drawing/2014/main" id="{61C3F93F-7346-4936-B571-73143F36E4E2}"/>
+                <a16:creationId xmlns:a16="http://schemas.microsoft.com/office/drawing/2014/main" id="{91896094-D077-4A34-A88F-015D00ADE009}"/>
               </a:ext>
             </a:extLst>
           </p:cNvPr>
@@ -10594,7 +10594,7 @@
           <p:cNvPr id="12" name="04">
             <a:extLst xmlns:a="http://schemas.openxmlformats.org/drawingml/2006/main">
               <a:ext uri="{FF2B5EF4-FFF2-40B4-BE49-F238E27FC236}">
-                <a16:creationId xmlns:a16="http://schemas.microsoft.com/office/drawing/2014/main" id="{86E40138-5C14-4A6E-8847-16A072D6713E}"/>
+                <a16:creationId xmlns:a16="http://schemas.microsoft.com/office/drawing/2014/main" id="{0C436AE3-DABB-4F82-A297-ADAD75E379D1}"/>
               </a:ext>
             </a:extLst>
           </p:cNvPr>
@@ -10651,7 +10651,7 @@
           <p:cNvPr id="13" name="Train a second model">
             <a:extLst xmlns:a="http://schemas.openxmlformats.org/drawingml/2006/main">
               <a:ext uri="{FF2B5EF4-FFF2-40B4-BE49-F238E27FC236}">
-                <a16:creationId xmlns:a16="http://schemas.microsoft.com/office/drawing/2014/main" id="{092E855D-DB44-4FF5-9898-0A612ADECB33}"/>
+                <a16:creationId xmlns:a16="http://schemas.microsoft.com/office/drawing/2014/main" id="{2BFBD160-1D01-4D92-93BC-B84E4C2CBE74}"/>
               </a:ext>
             </a:extLst>
           </p:cNvPr>
@@ -10708,7 +10708,7 @@
           <p:cNvPr id="14" name="Predict whether a classification is unreliable.">
             <a:extLst xmlns:a="http://schemas.openxmlformats.org/drawingml/2006/main">
               <a:ext uri="{FF2B5EF4-FFF2-40B4-BE49-F238E27FC236}">
-                <a16:creationId xmlns:a16="http://schemas.microsoft.com/office/drawing/2014/main" id="{FC0525D4-04D0-4E27-95E4-54E1CA7F25F2}"/>
+                <a16:creationId xmlns:a16="http://schemas.microsoft.com/office/drawing/2014/main" id="{F0159E9C-7051-4854-AD7F-0C51B4EEEE9E}"/>
               </a:ext>
             </a:extLst>
           </p:cNvPr>
@@ -10765,7 +10765,7 @@
           <p:cNvPr id="15" name="05">
             <a:extLst xmlns:a="http://schemas.openxmlformats.org/drawingml/2006/main">
               <a:ext uri="{FF2B5EF4-FFF2-40B4-BE49-F238E27FC236}">
-                <a16:creationId xmlns:a16="http://schemas.microsoft.com/office/drawing/2014/main" id="{D613EDE1-89D9-40C6-8F51-FB00F307C0FE}"/>
+                <a16:creationId xmlns:a16="http://schemas.microsoft.com/office/drawing/2014/main" id="{F4C5BE3F-E388-403C-ADB5-B8D16FA97114}"/>
               </a:ext>
             </a:extLst>
           </p:cNvPr>
@@ -10822,7 +10822,7 @@
           <p:cNvPr id="16" name="Evaluate the detector">
             <a:extLst xmlns:a="http://schemas.openxmlformats.org/drawingml/2006/main">
               <a:ext uri="{FF2B5EF4-FFF2-40B4-BE49-F238E27FC236}">
-                <a16:creationId xmlns:a16="http://schemas.microsoft.com/office/drawing/2014/main" id="{9CF83BE2-B548-4D8A-9C05-7F2D1B25BA75}"/>
+                <a16:creationId xmlns:a16="http://schemas.microsoft.com/office/drawing/2014/main" id="{7B57767A-ADE8-4598-8328-1A9946A5EC23}"/>
               </a:ext>
             </a:extLst>
           </p:cNvPr>
@@ -10879,7 +10879,7 @@
           <p:cNvPr id="17" name="Calibration, high-confidence errors and an A/B/C c">
             <a:extLst xmlns:a="http://schemas.openxmlformats.org/drawingml/2006/main">
               <a:ext uri="{FF2B5EF4-FFF2-40B4-BE49-F238E27FC236}">
-                <a16:creationId xmlns:a16="http://schemas.microsoft.com/office/drawing/2014/main" id="{3F7A34DB-0594-4FDB-941B-FD498EAE8A7D}"/>
+                <a16:creationId xmlns:a16="http://schemas.microsoft.com/office/drawing/2014/main" id="{85A2B197-5486-4629-8012-C9A7CC320872}"/>
               </a:ext>
             </a:extLst>
           </p:cNvPr>
@@ -10934,7 +10934,7 @@
     </p:spTree>
     <p:extLst>
       <p:ext uri="{BB962C8B-B14F-4D97-AF65-F5344CB8AC3E}">
-        <p14:creationId xmlns:p14="http://schemas.microsoft.com/office/powerpoint/2010/main" val="1469816286"/>
+        <p14:creationId xmlns:p14="http://schemas.microsoft.com/office/powerpoint/2010/main" val="1788209782"/>
       </p:ext>
     </p:extLst>
   </p:cSld>
@@ -10965,7 +10965,7 @@
           <p:cNvPr id="12" name="How confidence changes">
             <a:extLst xmlns:a="http://schemas.openxmlformats.org/drawingml/2006/main">
               <a:ext uri="{FF2B5EF4-FFF2-40B4-BE49-F238E27FC236}">
-                <a16:creationId xmlns:a16="http://schemas.microsoft.com/office/drawing/2014/main" id="{45B4F50A-730E-4E4A-8FC1-F5F0A2A90C54}"/>
+                <a16:creationId xmlns:a16="http://schemas.microsoft.com/office/drawing/2014/main" id="{6B8B20E9-A271-452F-86DB-B3E66775F619}"/>
               </a:ext>
             </a:extLst>
           </p:cNvPr>
@@ -11022,7 +11022,7 @@
           <p:cNvPr id="2" name="06">
             <a:extLst xmlns:a="http://schemas.openxmlformats.org/drawingml/2006/main">
               <a:ext uri="{FF2B5EF4-FFF2-40B4-BE49-F238E27FC236}">
-                <a16:creationId xmlns:a16="http://schemas.microsoft.com/office/drawing/2014/main" id="{5DF74729-A8CD-42D8-B1D5-3CAEEBE81C8B}"/>
+                <a16:creationId xmlns:a16="http://schemas.microsoft.com/office/drawing/2014/main" id="{E60B5DBE-3E47-4206-A647-28CDC0A16DCA}"/>
               </a:ext>
             </a:extLst>
           </p:cNvPr>
@@ -11079,7 +11079,7 @@
           <p:cNvPr id="3" name="Six levels, from 0% to 50% of words removed and sh">
             <a:extLst xmlns:a="http://schemas.openxmlformats.org/drawingml/2006/main">
               <a:ext uri="{FF2B5EF4-FFF2-40B4-BE49-F238E27FC236}">
-                <a16:creationId xmlns:a16="http://schemas.microsoft.com/office/drawing/2014/main" id="{0473F4C1-BCDC-454C-8366-C390C4F57F77}"/>
+                <a16:creationId xmlns:a16="http://schemas.microsoft.com/office/drawing/2014/main" id="{8DA14C6D-8653-45E6-AB69-85B962A69EC7}"/>
               </a:ext>
             </a:extLst>
           </p:cNvPr>
@@ -11136,7 +11136,7 @@
           <p:cNvPr id="4" name="Two contrasting examples">
             <a:extLst xmlns:a="http://schemas.openxmlformats.org/drawingml/2006/main">
               <a:ext uri="{FF2B5EF4-FFF2-40B4-BE49-F238E27FC236}">
-                <a16:creationId xmlns:a16="http://schemas.microsoft.com/office/drawing/2014/main" id="{13339BE5-429D-438E-B3C0-E46EFD430A15}"/>
+                <a16:creationId xmlns:a16="http://schemas.microsoft.com/office/drawing/2014/main" id="{B61330A4-8D47-494C-B3B1-474E7B8B535A}"/>
               </a:ext>
             </a:extLst>
           </p:cNvPr>
@@ -11776,7 +11776,7 @@
           <p:cNvPr id="6" name="Stayed wrong">
             <a:extLst xmlns:a="http://schemas.openxmlformats.org/drawingml/2006/main">
               <a:ext uri="{FF2B5EF4-FFF2-40B4-BE49-F238E27FC236}">
-                <a16:creationId xmlns:a16="http://schemas.microsoft.com/office/drawing/2014/main" id="{70E3991C-61CC-4CE0-86BF-5B6C0FB2F605}"/>
+                <a16:creationId xmlns:a16="http://schemas.microsoft.com/office/drawing/2014/main" id="{6B8F4928-6F78-404F-9340-76AF4E135986}"/>
               </a:ext>
             </a:extLst>
           </p:cNvPr>
@@ -11833,7 +11833,7 @@
           <p:cNvPr id="7" name="Stayed correct">
             <a:extLst xmlns:a="http://schemas.openxmlformats.org/drawingml/2006/main">
               <a:ext uri="{FF2B5EF4-FFF2-40B4-BE49-F238E27FC236}">
-                <a16:creationId xmlns:a16="http://schemas.microsoft.com/office/drawing/2014/main" id="{C3D30089-A8CD-421D-A775-0E9A11E7F2AC}"/>
+                <a16:creationId xmlns:a16="http://schemas.microsoft.com/office/drawing/2014/main" id="{F731E95B-0F03-4343-B59F-1B3AA8ABC591}"/>
               </a:ext>
             </a:extLst>
           </p:cNvPr>
@@ -11890,7 +11890,7 @@
           <p:cNvPr id="8" name="Confidence">
             <a:extLst xmlns:a="http://schemas.openxmlformats.org/drawingml/2006/main">
               <a:ext uri="{FF2B5EF4-FFF2-40B4-BE49-F238E27FC236}">
-                <a16:creationId xmlns:a16="http://schemas.microsoft.com/office/drawing/2014/main" id="{3C9A08FB-6BDB-468F-B7DC-64297599F872}"/>
+                <a16:creationId xmlns:a16="http://schemas.microsoft.com/office/drawing/2014/main" id="{A1030F70-C158-4C53-9036-EBC0461D72B9}"/>
               </a:ext>
             </a:extLst>
           </p:cNvPr>
@@ -11954,7 +11954,7 @@
         </p:xfrm>
         <a:graphic xmlns:a="http://schemas.openxmlformats.org/drawingml/2006/main">
           <a:graphicData uri="http://schemas.openxmlformats.org/drawingml/2006/chart">
-            <c:chart xmlns:r="http://schemas.openxmlformats.org/officeDocument/2006/relationships" xmlns:c="http://schemas.openxmlformats.org/drawingml/2006/chart" r:id="Rf42209b59aee4f6b"/>
+            <c:chart xmlns:r="http://schemas.openxmlformats.org/officeDocument/2006/relationships" xmlns:c="http://schemas.openxmlformats.org/drawingml/2006/chart" r:id="R149896512c7d4b01"/>
           </a:graphicData>
         </a:graphic>
       </p:graphicFrame>
@@ -11963,7 +11963,7 @@
           <p:cNvPr id="10" name="12 test documents. Green: correct at the final ste">
             <a:extLst xmlns:a="http://schemas.openxmlformats.org/drawingml/2006/main">
               <a:ext uri="{FF2B5EF4-FFF2-40B4-BE49-F238E27FC236}">
-                <a16:creationId xmlns:a16="http://schemas.microsoft.com/office/drawing/2014/main" id="{90D55853-655C-4DB7-B74B-04D64E6B9B36}"/>
+                <a16:creationId xmlns:a16="http://schemas.microsoft.com/office/drawing/2014/main" id="{A0DF926F-7B70-4989-ADA1-C4643A89F397}"/>
               </a:ext>
             </a:extLst>
           </p:cNvPr>
@@ -12020,7 +12020,7 @@
           <p:cNvPr id="11" name="Sequences simulate repeated predictions through te">
             <a:extLst xmlns:a="http://schemas.openxmlformats.org/drawingml/2006/main">
               <a:ext uri="{FF2B5EF4-FFF2-40B4-BE49-F238E27FC236}">
-                <a16:creationId xmlns:a16="http://schemas.microsoft.com/office/drawing/2014/main" id="{250D3194-7C6B-47BA-88D4-42671313BE5A}"/>
+                <a16:creationId xmlns:a16="http://schemas.microsoft.com/office/drawing/2014/main" id="{FB940171-0A88-4955-AD56-91F4CBC3243F}"/>
               </a:ext>
             </a:extLst>
           </p:cNvPr>
@@ -12075,7 +12075,7 @@
     </p:spTree>
     <p:extLst>
       <p:ext uri="{BB962C8B-B14F-4D97-AF65-F5344CB8AC3E}">
-        <p14:creationId xmlns:p14="http://schemas.microsoft.com/office/powerpoint/2010/main" val="537329521"/>
+        <p14:creationId xmlns:p14="http://schemas.microsoft.com/office/powerpoint/2010/main" val="635889961"/>
       </p:ext>
     </p:extLst>
   </p:cSld>
@@ -12106,7 +12106,7 @@
           <p:cNvPr id="5" name="Anatomy of a confidence sequence">
             <a:extLst xmlns:a="http://schemas.openxmlformats.org/drawingml/2006/main">
               <a:ext uri="{FF2B5EF4-FFF2-40B4-BE49-F238E27FC236}">
-                <a16:creationId xmlns:a16="http://schemas.microsoft.com/office/drawing/2014/main" id="{E96F04CE-64B2-4968-BEAC-C11B97C4CAC8}"/>
+                <a16:creationId xmlns:a16="http://schemas.microsoft.com/office/drawing/2014/main" id="{85AB06E6-13AE-4F60-8E7D-6DCC5C5FDA83}"/>
               </a:ext>
             </a:extLst>
           </p:cNvPr>
@@ -12163,7 +12163,7 @@
           <p:cNvPr id="2" name="07">
             <a:extLst xmlns:a="http://schemas.openxmlformats.org/drawingml/2006/main">
               <a:ext uri="{FF2B5EF4-FFF2-40B4-BE49-F238E27FC236}">
-                <a16:creationId xmlns:a16="http://schemas.microsoft.com/office/drawing/2014/main" id="{42F2F7F6-E73B-448E-9CED-673EAF60BBB9}"/>
+                <a16:creationId xmlns:a16="http://schemas.microsoft.com/office/drawing/2014/main" id="{6E20C1A7-88B4-4E16-9BFF-294E1E18E5D7}"/>
               </a:ext>
             </a:extLst>
           </p:cNvPr>
@@ -12220,7 +12220,7 @@
           <p:cNvPr id="3" name="13 features, compared with simpler baselines in th">
             <a:extLst xmlns:a="http://schemas.openxmlformats.org/drawingml/2006/main">
               <a:ext uri="{FF2B5EF4-FFF2-40B4-BE49-F238E27FC236}">
-                <a16:creationId xmlns:a16="http://schemas.microsoft.com/office/drawing/2014/main" id="{1C916293-6DEF-4C9A-A3CD-BFAF8FB7D871}"/>
+                <a16:creationId xmlns:a16="http://schemas.microsoft.com/office/drawing/2014/main" id="{0F409EE8-164E-4130-BB6D-BC7AE46A4573}"/>
               </a:ext>
             </a:extLst>
           </p:cNvPr>
@@ -12593,7 +12593,7 @@
     </p:spTree>
     <p:extLst>
       <p:ext uri="{BB962C8B-B14F-4D97-AF65-F5344CB8AC3E}">
-        <p14:creationId xmlns:p14="http://schemas.microsoft.com/office/powerpoint/2010/main" val="107394275"/>
+        <p14:creationId xmlns:p14="http://schemas.microsoft.com/office/powerpoint/2010/main" val="999914729"/>
       </p:ext>
     </p:extLst>
   </p:cSld>
@@ -12624,7 +12624,7 @@
           <p:cNvPr id="7" name="Confidence carries signal">
             <a:extLst xmlns:a="http://schemas.openxmlformats.org/drawingml/2006/main">
               <a:ext uri="{FF2B5EF4-FFF2-40B4-BE49-F238E27FC236}">
-                <a16:creationId xmlns:a16="http://schemas.microsoft.com/office/drawing/2014/main" id="{43946350-C3BF-4804-B1F5-A6CB3F3C1B5D}"/>
+                <a16:creationId xmlns:a16="http://schemas.microsoft.com/office/drawing/2014/main" id="{5AFFAB4E-1395-42C3-B6B7-BB0007AEB5B2}"/>
               </a:ext>
             </a:extLst>
           </p:cNvPr>
@@ -12681,7 +12681,7 @@
           <p:cNvPr id="2" name="08">
             <a:extLst xmlns:a="http://schemas.openxmlformats.org/drawingml/2006/main">
               <a:ext uri="{FF2B5EF4-FFF2-40B4-BE49-F238E27FC236}">
-                <a16:creationId xmlns:a16="http://schemas.microsoft.com/office/drawing/2014/main" id="{3BFBF29E-947A-46E4-BE26-496A7644C909}"/>
+                <a16:creationId xmlns:a16="http://schemas.microsoft.com/office/drawing/2014/main" id="{BBEE5295-9367-44E3-AE2C-9541577955D3}"/>
               </a:ext>
             </a:extLst>
           </p:cNvPr>
@@ -12738,7 +12738,7 @@
           <p:cNvPr id="3" name="Accuracy across 439 uncorrupted test predictions">
             <a:extLst xmlns:a="http://schemas.openxmlformats.org/drawingml/2006/main">
               <a:ext uri="{FF2B5EF4-FFF2-40B4-BE49-F238E27FC236}">
-                <a16:creationId xmlns:a16="http://schemas.microsoft.com/office/drawing/2014/main" id="{E9C1DAB3-FD46-4A95-AE91-86BDE6A7670D}"/>
+                <a16:creationId xmlns:a16="http://schemas.microsoft.com/office/drawing/2014/main" id="{272BDF23-2D50-487E-B4FD-2253DDE63272}"/>
               </a:ext>
             </a:extLst>
           </p:cNvPr>
@@ -12802,7 +12802,7 @@
         </p:xfrm>
         <a:graphic xmlns:a="http://schemas.openxmlformats.org/drawingml/2006/main">
           <a:graphicData uri="http://schemas.openxmlformats.org/drawingml/2006/chart">
-            <c:chart xmlns:r="http://schemas.openxmlformats.org/officeDocument/2006/relationships" xmlns:c="http://schemas.openxmlformats.org/drawingml/2006/chart" r:id="Re0a2de3c257849d2"/>
+            <c:chart xmlns:r="http://schemas.openxmlformats.org/officeDocument/2006/relationships" xmlns:c="http://schemas.openxmlformats.org/drawingml/2006/chart" r:id="Rd3981c917bbf4443"/>
           </a:graphicData>
         </a:graphic>
       </p:graphicFrame>
@@ -13154,7 +13154,7 @@
           <p:cNvPr id="6" name="Confidence carries signal, but calibration remains">
             <a:extLst xmlns:a="http://schemas.openxmlformats.org/drawingml/2006/main">
               <a:ext uri="{FF2B5EF4-FFF2-40B4-BE49-F238E27FC236}">
-                <a16:creationId xmlns:a16="http://schemas.microsoft.com/office/drawing/2014/main" id="{F53062C9-02AE-41F9-A89C-4F3A208600FF}"/>
+                <a16:creationId xmlns:a16="http://schemas.microsoft.com/office/drawing/2014/main" id="{76BF509B-373D-406B-BEF7-66FC564A764B}"/>
               </a:ext>
             </a:extLst>
           </p:cNvPr>
@@ -13209,7 +13209,7 @@
     </p:spTree>
     <p:extLst>
       <p:ext uri="{BB962C8B-B14F-4D97-AF65-F5344CB8AC3E}">
-        <p14:creationId xmlns:p14="http://schemas.microsoft.com/office/powerpoint/2010/main" val="1045404719"/>
+        <p14:creationId xmlns:p14="http://schemas.microsoft.com/office/powerpoint/2010/main" val="669702002"/>
       </p:ext>
     </p:extLst>
   </p:cSld>
@@ -13240,7 +13240,7 @@
           <p:cNvPr id="12" name="The calibration gap">
             <a:extLst xmlns:a="http://schemas.openxmlformats.org/drawingml/2006/main">
               <a:ext uri="{FF2B5EF4-FFF2-40B4-BE49-F238E27FC236}">
-                <a16:creationId xmlns:a16="http://schemas.microsoft.com/office/drawing/2014/main" id="{D76204E0-DB84-4FA4-B626-F5F217A583DF}"/>
+                <a16:creationId xmlns:a16="http://schemas.microsoft.com/office/drawing/2014/main" id="{201379CF-6D14-4158-AB18-A28F7AE1BD96}"/>
               </a:ext>
             </a:extLst>
           </p:cNvPr>
@@ -13297,7 +13297,7 @@
           <p:cNvPr id="2" name="09">
             <a:extLst xmlns:a="http://schemas.openxmlformats.org/drawingml/2006/main">
               <a:ext uri="{FF2B5EF4-FFF2-40B4-BE49-F238E27FC236}">
-                <a16:creationId xmlns:a16="http://schemas.microsoft.com/office/drawing/2014/main" id="{E1B9E5D0-D874-4709-88FC-487A29FE534A}"/>
+                <a16:creationId xmlns:a16="http://schemas.microsoft.com/office/drawing/2014/main" id="{4711BE1E-E071-4C73-AD74-A0618834A156}"/>
               </a:ext>
             </a:extLst>
           </p:cNvPr>
@@ -13354,7 +13354,7 @@
           <p:cNvPr id="3" name="Reliability diagram for uncorrupted test predictio">
             <a:extLst xmlns:a="http://schemas.openxmlformats.org/drawingml/2006/main">
               <a:ext uri="{FF2B5EF4-FFF2-40B4-BE49-F238E27FC236}">
-                <a16:creationId xmlns:a16="http://schemas.microsoft.com/office/drawing/2014/main" id="{8321F386-8EB3-41E9-8A92-6EA3B52BED66}"/>
+                <a16:creationId xmlns:a16="http://schemas.microsoft.com/office/drawing/2014/main" id="{C1362DB0-0BD7-404F-8B17-67D43AB51ABF}"/>
               </a:ext>
             </a:extLst>
           </p:cNvPr>
@@ -13418,7 +13418,7 @@
         </p:xfrm>
         <a:graphic xmlns:a="http://schemas.openxmlformats.org/drawingml/2006/main">
           <a:graphicData uri="http://schemas.openxmlformats.org/drawingml/2006/chart">
-            <c:chart xmlns:r="http://schemas.openxmlformats.org/officeDocument/2006/relationships" xmlns:c="http://schemas.openxmlformats.org/drawingml/2006/chart" r:id="Rbf71e881d7934c67"/>
+            <c:chart xmlns:r="http://schemas.openxmlformats.org/officeDocument/2006/relationships" xmlns:c="http://schemas.openxmlformats.org/drawingml/2006/chart" r:id="Rb089bb00399e4e99"/>
           </a:graphicData>
         </a:graphic>
       </p:graphicFrame>
@@ -13427,7 +13427,7 @@
           <p:cNvPr id="5" name="0.153">
             <a:extLst xmlns:a="http://schemas.openxmlformats.org/drawingml/2006/main">
               <a:ext uri="{FF2B5EF4-FFF2-40B4-BE49-F238E27FC236}">
-                <a16:creationId xmlns:a16="http://schemas.microsoft.com/office/drawing/2014/main" id="{D76D3B2D-520C-4E0E-89B9-F04EF9CD0B63}"/>
+                <a16:creationId xmlns:a16="http://schemas.microsoft.com/office/drawing/2014/main" id="{E562B968-EA88-464E-B327-297850C0480C}"/>
               </a:ext>
             </a:extLst>
           </p:cNvPr>
@@ -13484,7 +13484,7 @@
           <p:cNvPr id="6" name="0.160">
             <a:extLst xmlns:a="http://schemas.openxmlformats.org/drawingml/2006/main">
               <a:ext uri="{FF2B5EF4-FFF2-40B4-BE49-F238E27FC236}">
-                <a16:creationId xmlns:a16="http://schemas.microsoft.com/office/drawing/2014/main" id="{99553CC2-7F62-4C96-8EA7-4EA6A718416A}"/>
+                <a16:creationId xmlns:a16="http://schemas.microsoft.com/office/drawing/2014/main" id="{66767E2F-F106-40FA-8019-869730710E85}"/>
               </a:ext>
             </a:extLst>
           </p:cNvPr>
@@ -13541,7 +13541,7 @@
           <p:cNvPr id="7" name="Calibration error">
             <a:extLst xmlns:a="http://schemas.openxmlformats.org/drawingml/2006/main">
               <a:ext uri="{FF2B5EF4-FFF2-40B4-BE49-F238E27FC236}">
-                <a16:creationId xmlns:a16="http://schemas.microsoft.com/office/drawing/2014/main" id="{09C57C2B-3AF9-49FF-BCC9-2DF25EAA9B88}"/>
+                <a16:creationId xmlns:a16="http://schemas.microsoft.com/office/drawing/2014/main" id="{F4F6ADF4-4A58-470D-BC2F-5890FA826E8D}"/>
               </a:ext>
             </a:extLst>
           </p:cNvPr>
@@ -13598,7 +13598,7 @@
           <p:cNvPr id="8" name="Brier score">
             <a:extLst xmlns:a="http://schemas.openxmlformats.org/drawingml/2006/main">
               <a:ext uri="{FF2B5EF4-FFF2-40B4-BE49-F238E27FC236}">
-                <a16:creationId xmlns:a16="http://schemas.microsoft.com/office/drawing/2014/main" id="{016DF768-F2E6-43E6-96A8-3B395BE34FE1}"/>
+                <a16:creationId xmlns:a16="http://schemas.microsoft.com/office/drawing/2014/main" id="{0417515C-2E78-469E-9431-07352E216C5F}"/>
               </a:ext>
             </a:extLst>
           </p:cNvPr>
@@ -13655,7 +13655,7 @@
           <p:cNvPr id="9" name="Under-confident at 0.6–0.9">
             <a:extLst xmlns:a="http://schemas.openxmlformats.org/drawingml/2006/main">
               <a:ext uri="{FF2B5EF4-FFF2-40B4-BE49-F238E27FC236}">
-                <a16:creationId xmlns:a16="http://schemas.microsoft.com/office/drawing/2014/main" id="{53598615-2936-4B01-98E9-ED882814D105}"/>
+                <a16:creationId xmlns:a16="http://schemas.microsoft.com/office/drawing/2014/main" id="{8D9403F5-7AC0-47F9-AE16-7EF6B012C891}"/>
               </a:ext>
             </a:extLst>
           </p:cNvPr>
@@ -13712,7 +13712,7 @@
           <p:cNvPr id="10" name="Observed accuracy exceeds stated confidence in thi">
             <a:extLst xmlns:a="http://schemas.openxmlformats.org/drawingml/2006/main">
               <a:ext uri="{FF2B5EF4-FFF2-40B4-BE49-F238E27FC236}">
-                <a16:creationId xmlns:a16="http://schemas.microsoft.com/office/drawing/2014/main" id="{2784F026-A670-4C25-92BE-3F9D01DF2013}"/>
+                <a16:creationId xmlns:a16="http://schemas.microsoft.com/office/drawing/2014/main" id="{2F029C52-B8B5-44B9-89AF-2D33E84B0702}"/>
               </a:ext>
             </a:extLst>
           </p:cNvPr>
@@ -13769,7 +13769,7 @@
           <p:cNvPr id="11" name="The top bin has only 10 samples: 80% accuracy, ver">
             <a:extLst xmlns:a="http://schemas.openxmlformats.org/drawingml/2006/main">
               <a:ext uri="{FF2B5EF4-FFF2-40B4-BE49-F238E27FC236}">
-                <a16:creationId xmlns:a16="http://schemas.microsoft.com/office/drawing/2014/main" id="{7D626259-80E2-4076-91BF-6D0CAEF92264}"/>
+                <a16:creationId xmlns:a16="http://schemas.microsoft.com/office/drawing/2014/main" id="{A982D772-DFC8-431C-8C07-844202E9C040}"/>
               </a:ext>
             </a:extLst>
           </p:cNvPr>
@@ -13824,7 +13824,7 @@
     </p:spTree>
     <p:extLst>
       <p:ext uri="{BB962C8B-B14F-4D97-AF65-F5344CB8AC3E}">
-        <p14:creationId xmlns:p14="http://schemas.microsoft.com/office/powerpoint/2010/main" val="127335551"/>
+        <p14:creationId xmlns:p14="http://schemas.microsoft.com/office/powerpoint/2010/main" val="641024116"/>
       </p:ext>
     </p:extLst>
   </p:cSld>

</xml_diff>

<commit_message>
Make sequence detector scoring reproducible and report validated limits
</commit_message>
<xml_diff>
--- a/reports/presentation/AI_Confidence_Drift_Presentation.pptx
+++ b/reports/presentation/AI_Confidence_Drift_Presentation.pptx
@@ -2,26 +2,26 @@
 <file path=ppt/presentation.xml><?xml version="1.0" encoding="utf-8"?>
 <p:presentation xmlns:p="http://schemas.openxmlformats.org/presentationml/2006/main">
   <p:sldMasterIdLst>
-    <p:sldMasterId xmlns:r="http://schemas.openxmlformats.org/officeDocument/2006/relationships" id="2147483648" r:id="R66e401c8be0e49ff"/>
+    <p:sldMasterId xmlns:r="http://schemas.openxmlformats.org/officeDocument/2006/relationships" id="2147483648" r:id="R23a9f649c1e44f32"/>
   </p:sldMasterIdLst>
   <p:notesMasterIdLst>
-    <p:notesMasterId xmlns:r="http://schemas.openxmlformats.org/officeDocument/2006/relationships" r:id="R6266f7ca77b542f8"/>
+    <p:notesMasterId xmlns:r="http://schemas.openxmlformats.org/officeDocument/2006/relationships" r:id="R300291e3629141c6"/>
   </p:notesMasterIdLst>
   <p:sldIdLst>
-    <p:sldId xmlns:r="http://schemas.openxmlformats.org/officeDocument/2006/relationships" id="256" r:id="Re9b6a42d583f4bab"/>
-    <p:sldId xmlns:r="http://schemas.openxmlformats.org/officeDocument/2006/relationships" id="257" r:id="R07e3c6f4489b4bdd"/>
-    <p:sldId xmlns:r="http://schemas.openxmlformats.org/officeDocument/2006/relationships" id="258" r:id="R41455d954ad54732"/>
-    <p:sldId xmlns:r="http://schemas.openxmlformats.org/officeDocument/2006/relationships" id="259" r:id="R90eb2d64fc3e4a00"/>
-    <p:sldId xmlns:r="http://schemas.openxmlformats.org/officeDocument/2006/relationships" id="260" r:id="R0fe644e7549040eb"/>
-    <p:sldId xmlns:r="http://schemas.openxmlformats.org/officeDocument/2006/relationships" id="261" r:id="R725dadb58e7d4f35"/>
-    <p:sldId xmlns:r="http://schemas.openxmlformats.org/officeDocument/2006/relationships" id="262" r:id="R1ebbce98d86d4d5d"/>
-    <p:sldId xmlns:r="http://schemas.openxmlformats.org/officeDocument/2006/relationships" id="263" r:id="Rfcafa25e1ac74dac"/>
-    <p:sldId xmlns:r="http://schemas.openxmlformats.org/officeDocument/2006/relationships" id="264" r:id="Rdacf977131a948f3"/>
-    <p:sldId xmlns:r="http://schemas.openxmlformats.org/officeDocument/2006/relationships" id="265" r:id="R05f9aaed2b6a4e12"/>
-    <p:sldId xmlns:r="http://schemas.openxmlformats.org/officeDocument/2006/relationships" id="266" r:id="R245609117c4349ce"/>
-    <p:sldId xmlns:r="http://schemas.openxmlformats.org/officeDocument/2006/relationships" id="267" r:id="R3a1b7eddeded48d4"/>
-    <p:sldId xmlns:r="http://schemas.openxmlformats.org/officeDocument/2006/relationships" id="268" r:id="R4407b838237342d8"/>
-    <p:sldId xmlns:r="http://schemas.openxmlformats.org/officeDocument/2006/relationships" id="269" r:id="Raf39a42b54d34a25"/>
+    <p:sldId xmlns:r="http://schemas.openxmlformats.org/officeDocument/2006/relationships" id="256" r:id="R6ff3c2ded7744066"/>
+    <p:sldId xmlns:r="http://schemas.openxmlformats.org/officeDocument/2006/relationships" id="257" r:id="R6af4965a183344ce"/>
+    <p:sldId xmlns:r="http://schemas.openxmlformats.org/officeDocument/2006/relationships" id="258" r:id="R027f5cb4c6cb4130"/>
+    <p:sldId xmlns:r="http://schemas.openxmlformats.org/officeDocument/2006/relationships" id="259" r:id="Rc78691d67d2d43a4"/>
+    <p:sldId xmlns:r="http://schemas.openxmlformats.org/officeDocument/2006/relationships" id="260" r:id="Rf585f4b1b684420a"/>
+    <p:sldId xmlns:r="http://schemas.openxmlformats.org/officeDocument/2006/relationships" id="261" r:id="Rbc1851f792fa4c7e"/>
+    <p:sldId xmlns:r="http://schemas.openxmlformats.org/officeDocument/2006/relationships" id="262" r:id="Re268a733d8804fbb"/>
+    <p:sldId xmlns:r="http://schemas.openxmlformats.org/officeDocument/2006/relationships" id="263" r:id="Re43442f6f9ef4dd6"/>
+    <p:sldId xmlns:r="http://schemas.openxmlformats.org/officeDocument/2006/relationships" id="264" r:id="R124d19f5a5d647f9"/>
+    <p:sldId xmlns:r="http://schemas.openxmlformats.org/officeDocument/2006/relationships" id="265" r:id="R1df82704af7844c3"/>
+    <p:sldId xmlns:r="http://schemas.openxmlformats.org/officeDocument/2006/relationships" id="266" r:id="R23ac0338c90b4555"/>
+    <p:sldId xmlns:r="http://schemas.openxmlformats.org/officeDocument/2006/relationships" id="267" r:id="R00be9d45f0064b99"/>
+    <p:sldId xmlns:r="http://schemas.openxmlformats.org/officeDocument/2006/relationships" id="268" r:id="R9663662c6ff44e83"/>
+    <p:sldId xmlns:r="http://schemas.openxmlformats.org/officeDocument/2006/relationships" id="269" r:id="R28d63d8d2c464002"/>
   </p:sldIdLst>
   <p:sldSz cx="12192000" cy="6858000"/>
   <p:notesSz cx="6858000" cy="9144000"/>
@@ -525,7 +525,7 @@
           <a:lstStyle xmlns:a="http://schemas.openxmlformats.org/drawingml/2006/main"/>
           <a:p xmlns:a="http://schemas.openxmlformats.org/drawingml/2006/main">
             <a:r>
-              <a:t>The original per-step C detector caught 0/6 at the uncorrupted step. A separate sequence-level Logistic Regression model predicts original correctness after six deterministic text probes. It was fitted on out-of-fold base-model sequences from the 1,315 base-training documents and flagged 6/6 high-confidence errors plus 50 correct cases on the 439-document test set. A start-only ablation flagged 5/6 plus 43 correct cases. This is retrospective and needs a new dataset. See results/metrics/sequence_error_detector_analysis.json.</a:t>
+              <a:t>The original per-step C detector caught 0/6 at the uncorrupted step. A separate sequence-level Logistic Regression model predicts original correctness after six deterministic text probes. Probes are seeded by text so caller IDs cannot alter the score. It was fitted on out-of-fold base-model sequences from the 1,315 base-training documents and flagged 5/6 high-confidence errors plus 44 correct cases on the 439-document test set. Nested validation flagged 4/6 plus 108 correct cases. A start-only ablation flagged 5/6 plus 43 correct cases. This is retrospective and not deployment-ready. See results/metrics/sequence_error_detector_analysis.json.</a:t>
             </a:r>
           </a:p>
         </p:txBody>
@@ -1433,7 +1433,7 @@
   </p:cSld>
   <p:clrMap bg1="lt1" tx1="dk1" bg2="lt2" tx2="dk2" accent1="accent1" accent2="accent2" accent3="accent3" accent4="accent4" accent5="accent5" accent6="accent6" hlink="hlink" folHlink="folHlink"/>
   <p:sldLayoutIdLst>
-    <p:sldLayoutId xmlns:r="http://schemas.openxmlformats.org/officeDocument/2006/relationships" id="2147483649" r:id="Rd93fdf05cb0a4ca4"/>
+    <p:sldLayoutId xmlns:r="http://schemas.openxmlformats.org/officeDocument/2006/relationships" id="2147483649" r:id="R64deaa5966d54831"/>
   </p:sldLayoutIdLst>
   <p:txStyles>
     <p:titleStyle>
@@ -3680,7 +3680,7 @@
           <p:cNvPr id="11" name="01">
             <a:extLst xmlns:a="http://schemas.openxmlformats.org/drawingml/2006/main">
               <a:ext uri="{FF2B5EF4-FFF2-40B4-BE49-F238E27FC236}">
-                <a16:creationId xmlns:a16="http://schemas.microsoft.com/office/drawing/2014/main" id="{71D16FAE-2BB8-4E3E-92BD-4D468AEC1EBF}"/>
+                <a16:creationId xmlns:a16="http://schemas.microsoft.com/office/drawing/2014/main" id="{D9A364F6-67B1-43DA-BEFC-673347AF10BA}"/>
               </a:ext>
             </a:extLst>
           </p:cNvPr>
@@ -3737,7 +3737,7 @@
           <p:cNvPr id="2" name="PRANAVX LABS">
             <a:extLst xmlns:a="http://schemas.openxmlformats.org/drawingml/2006/main">
               <a:ext uri="{FF2B5EF4-FFF2-40B4-BE49-F238E27FC236}">
-                <a16:creationId xmlns:a16="http://schemas.microsoft.com/office/drawing/2014/main" id="{7C38DCCF-01AF-4EBA-AD56-BE554E93E66C}"/>
+                <a16:creationId xmlns:a16="http://schemas.microsoft.com/office/drawing/2014/main" id="{97BE44EF-D675-40C5-93C4-CFE22C322942}"/>
               </a:ext>
             </a:extLst>
           </p:cNvPr>
@@ -3794,7 +3794,7 @@
           <p:cNvPr id="3" name="AI/ML Internship">
             <a:extLst xmlns:a="http://schemas.openxmlformats.org/drawingml/2006/main">
               <a:ext uri="{FF2B5EF4-FFF2-40B4-BE49-F238E27FC236}">
-                <a16:creationId xmlns:a16="http://schemas.microsoft.com/office/drawing/2014/main" id="{66325646-0385-42BC-9C9C-31E306CF3471}"/>
+                <a16:creationId xmlns:a16="http://schemas.microsoft.com/office/drawing/2014/main" id="{AA2F46AB-6DFD-44D0-8EDA-DCF17E5F028B}"/>
               </a:ext>
             </a:extLst>
           </p:cNvPr>
@@ -3851,7 +3851,7 @@
           <p:cNvPr id="4" name="AI Confidence">
             <a:extLst xmlns:a="http://schemas.openxmlformats.org/drawingml/2006/main">
               <a:ext uri="{FF2B5EF4-FFF2-40B4-BE49-F238E27FC236}">
-                <a16:creationId xmlns:a16="http://schemas.microsoft.com/office/drawing/2014/main" id="{971773B8-40F4-44A8-A813-A48F566C6584}"/>
+                <a16:creationId xmlns:a16="http://schemas.microsoft.com/office/drawing/2014/main" id="{84141D15-93D9-4067-9C40-CC1D3DF6A582}"/>
               </a:ext>
             </a:extLst>
           </p:cNvPr>
@@ -3908,7 +3908,7 @@
           <p:cNvPr id="5" name="Drift Detection">
             <a:extLst xmlns:a="http://schemas.openxmlformats.org/drawingml/2006/main">
               <a:ext uri="{FF2B5EF4-FFF2-40B4-BE49-F238E27FC236}">
-                <a16:creationId xmlns:a16="http://schemas.microsoft.com/office/drawing/2014/main" id="{41340B23-BD18-4F92-8DEB-ADC8131EDE60}"/>
+                <a16:creationId xmlns:a16="http://schemas.microsoft.com/office/drawing/2014/main" id="{D43F7A28-C7C3-450C-9A87-F25C35B25C5F}"/>
               </a:ext>
             </a:extLst>
           </p:cNvPr>
@@ -3965,7 +3965,7 @@
           <p:cNvPr id="6" name="Using machine learning">
             <a:extLst xmlns:a="http://schemas.openxmlformats.org/drawingml/2006/main">
               <a:ext uri="{FF2B5EF4-FFF2-40B4-BE49-F238E27FC236}">
-                <a16:creationId xmlns:a16="http://schemas.microsoft.com/office/drawing/2014/main" id="{86AF68D6-7CEE-4D80-9964-4E7598E8BF06}"/>
+                <a16:creationId xmlns:a16="http://schemas.microsoft.com/office/drawing/2014/main" id="{D778D7A0-C5D5-429E-86A2-C0AC51C9B3B7}"/>
               </a:ext>
             </a:extLst>
           </p:cNvPr>
@@ -4022,7 +4022,7 @@
           <p:cNvPr id="7" name="Can changes in confidence help identify&#10;unreliable">
             <a:extLst xmlns:a="http://schemas.openxmlformats.org/drawingml/2006/main">
               <a:ext uri="{FF2B5EF4-FFF2-40B4-BE49-F238E27FC236}">
-                <a16:creationId xmlns:a16="http://schemas.microsoft.com/office/drawing/2014/main" id="{1E21ECE7-DE29-4C49-90C0-14B79EE48FCA}"/>
+                <a16:creationId xmlns:a16="http://schemas.microsoft.com/office/drawing/2014/main" id="{E02018BD-D590-476D-B983-FD989B6E58AC}"/>
               </a:ext>
             </a:extLst>
           </p:cNvPr>
@@ -4102,7 +4102,7 @@
           <p:cNvPr id="8" name="Research project">
             <a:extLst xmlns:a="http://schemas.openxmlformats.org/drawingml/2006/main">
               <a:ext uri="{FF2B5EF4-FFF2-40B4-BE49-F238E27FC236}">
-                <a16:creationId xmlns:a16="http://schemas.microsoft.com/office/drawing/2014/main" id="{D457C1BB-DC61-401C-9A17-AD4C3F274048}"/>
+                <a16:creationId xmlns:a16="http://schemas.microsoft.com/office/drawing/2014/main" id="{2D53987D-8786-4BF5-9832-F498983744C6}"/>
               </a:ext>
             </a:extLst>
           </p:cNvPr>
@@ -4159,7 +4159,7 @@
           <p:cNvPr id="9" name="Prepared by Ahan">
             <a:extLst xmlns:a="http://schemas.openxmlformats.org/drawingml/2006/main">
               <a:ext uri="{FF2B5EF4-FFF2-40B4-BE49-F238E27FC236}">
-                <a16:creationId xmlns:a16="http://schemas.microsoft.com/office/drawing/2014/main" id="{543238AF-6750-4F70-99C0-4F4C94F36E12}"/>
+                <a16:creationId xmlns:a16="http://schemas.microsoft.com/office/drawing/2014/main" id="{A243DBA8-807E-445A-B2C7-A347AE94BDD6}"/>
               </a:ext>
             </a:extLst>
           </p:cNvPr>
@@ -4216,7 +4216,7 @@
           <p:cNvPr id="10" name="github.com/ahansardar/ai-confidence-drift">
             <a:extLst xmlns:a="http://schemas.openxmlformats.org/drawingml/2006/main">
               <a:ext uri="{FF2B5EF4-FFF2-40B4-BE49-F238E27FC236}">
-                <a16:creationId xmlns:a16="http://schemas.microsoft.com/office/drawing/2014/main" id="{53344CDC-C192-47E0-B90E-03023C0A98DF}"/>
+                <a16:creationId xmlns:a16="http://schemas.microsoft.com/office/drawing/2014/main" id="{C0A65E04-296F-41DF-AF83-F3EA576764B9}"/>
               </a:ext>
             </a:extLst>
           </p:cNvPr>
@@ -4262,7 +4262,7 @@
                 <a:latin typeface="Calibri"/>
                 <a:ea typeface="Calibri"/>
                 <a:cs typeface="Calibri"/>
-                <a:hlinkClick xmlns:r="http://schemas.openxmlformats.org/officeDocument/2006/relationships" r:id="R0761bea4929e49f7"/>
+                <a:hlinkClick xmlns:r="http://schemas.openxmlformats.org/officeDocument/2006/relationships" r:id="R7d6f8a6d23204b16"/>
               </a:rPr>
               <a:t>github.com/ahansardar/ai-confidence-drift</a:t>
             </a:r>
@@ -4272,7 +4272,7 @@
     </p:spTree>
     <p:extLst>
       <p:ext uri="{BB962C8B-B14F-4D97-AF65-F5344CB8AC3E}">
-        <p14:creationId xmlns:p14="http://schemas.microsoft.com/office/powerpoint/2010/main" val="1371038004"/>
+        <p14:creationId xmlns:p14="http://schemas.microsoft.com/office/powerpoint/2010/main" val="771036782"/>
       </p:ext>
     </p:extLst>
   </p:cSld>
@@ -4303,7 +4303,7 @@
           <p:cNvPr id="10" name="Confident errors">
             <a:extLst xmlns:a="http://schemas.openxmlformats.org/drawingml/2006/main">
               <a:ext uri="{FF2B5EF4-FFF2-40B4-BE49-F238E27FC236}">
-                <a16:creationId xmlns:a16="http://schemas.microsoft.com/office/drawing/2014/main" id="{958F3A03-041C-416F-BFAF-1F869AA2E3E1}"/>
+                <a16:creationId xmlns:a16="http://schemas.microsoft.com/office/drawing/2014/main" id="{964292E8-2C89-448E-B7EA-C05DC9A4B2AE}"/>
               </a:ext>
             </a:extLst>
           </p:cNvPr>
@@ -4360,7 +4360,7 @@
           <p:cNvPr id="2" name="10">
             <a:extLst xmlns:a="http://schemas.openxmlformats.org/drawingml/2006/main">
               <a:ext uri="{FF2B5EF4-FFF2-40B4-BE49-F238E27FC236}">
-                <a16:creationId xmlns:a16="http://schemas.microsoft.com/office/drawing/2014/main" id="{9BDDEBCE-345E-4011-A834-BD1F439834F1}"/>
+                <a16:creationId xmlns:a16="http://schemas.microsoft.com/office/drawing/2014/main" id="{6708BE12-9FA5-4272-8318-43D950E66347}"/>
               </a:ext>
             </a:extLst>
           </p:cNvPr>
@@ -4417,7 +4417,7 @@
           <p:cNvPr id="3" name="6 of 100">
             <a:extLst xmlns:a="http://schemas.openxmlformats.org/drawingml/2006/main">
               <a:ext uri="{FF2B5EF4-FFF2-40B4-BE49-F238E27FC236}">
-                <a16:creationId xmlns:a16="http://schemas.microsoft.com/office/drawing/2014/main" id="{D3C508C3-6B39-41D1-81F4-295562576A25}"/>
+                <a16:creationId xmlns:a16="http://schemas.microsoft.com/office/drawing/2014/main" id="{9F6B9CE5-5362-43BF-B20D-9815F56DB6E7}"/>
               </a:ext>
             </a:extLst>
           </p:cNvPr>
@@ -4474,7 +4474,7 @@
           <p:cNvPr id="4" name="high-confidence predictions were wrong">
             <a:extLst xmlns:a="http://schemas.openxmlformats.org/drawingml/2006/main">
               <a:ext uri="{FF2B5EF4-FFF2-40B4-BE49-F238E27FC236}">
-                <a16:creationId xmlns:a16="http://schemas.microsoft.com/office/drawing/2014/main" id="{38A5EFAA-DECD-45E5-8FD6-21244CF6D20D}"/>
+                <a16:creationId xmlns:a16="http://schemas.microsoft.com/office/drawing/2014/main" id="{C3D8A04E-E683-475A-BD67-0F46C8DDCDC4}"/>
               </a:ext>
             </a:extLst>
           </p:cNvPr>
@@ -4531,7 +4531,7 @@
           <p:cNvPr id="5" name="100 of 439 predictions reached at least 75% confid">
             <a:extLst xmlns:a="http://schemas.openxmlformats.org/drawingml/2006/main">
               <a:ext uri="{FF2B5EF4-FFF2-40B4-BE49-F238E27FC236}">
-                <a16:creationId xmlns:a16="http://schemas.microsoft.com/office/drawing/2014/main" id="{6AECEEB9-0DD1-481E-9995-E1F501E98ABE}"/>
+                <a16:creationId xmlns:a16="http://schemas.microsoft.com/office/drawing/2014/main" id="{9D3CBF64-CE36-44A7-A22E-78C90B84DBCC}"/>
               </a:ext>
             </a:extLst>
           </p:cNvPr>
@@ -4611,7 +4611,7 @@
           <p:cNvPr id="6" name="At step 0: 0/6">
             <a:extLst xmlns:a="http://schemas.openxmlformats.org/drawingml/2006/main">
               <a:ext uri="{FF2B5EF4-FFF2-40B4-BE49-F238E27FC236}">
-                <a16:creationId xmlns:a16="http://schemas.microsoft.com/office/drawing/2014/main" id="{E0F02FC8-8CCA-4A11-AA93-E0E91004757F}"/>
+                <a16:creationId xmlns:a16="http://schemas.microsoft.com/office/drawing/2014/main" id="{E6A95567-D6F5-49FC-8C96-C1D396565043}"/>
               </a:ext>
             </a:extLst>
           </p:cNvPr>
@@ -4668,7 +4668,7 @@
           <p:cNvPr id="7" name="The per-step model has no history yet.&#10;It flagged ">
             <a:extLst xmlns:a="http://schemas.openxmlformats.org/drawingml/2006/main">
               <a:ext uri="{FF2B5EF4-FFF2-40B4-BE49-F238E27FC236}">
-                <a16:creationId xmlns:a16="http://schemas.microsoft.com/office/drawing/2014/main" id="{55F3FC1F-D317-4186-9F1B-C069CC5BEE0A}"/>
+                <a16:creationId xmlns:a16="http://schemas.microsoft.com/office/drawing/2014/main" id="{9723BD48-C750-47D3-9662-8735EC626D33}"/>
               </a:ext>
             </a:extLst>
           </p:cNvPr>
@@ -4745,10 +4745,10 @@
       </p:sp>
       <p:sp>
         <p:nvSpPr>
-          <p:cNvPr id="8" name="After six probes: 6/6">
+          <p:cNvPr id="8" name="After six probes: 5/6">
             <a:extLst xmlns:a="http://schemas.openxmlformats.org/drawingml/2006/main">
               <a:ext uri="{FF2B5EF4-FFF2-40B4-BE49-F238E27FC236}">
-                <a16:creationId xmlns:a16="http://schemas.microsoft.com/office/drawing/2014/main" id="{D132E2A3-A496-4910-BE74-92E5007DC039}"/>
+                <a16:creationId xmlns:a16="http://schemas.microsoft.com/office/drawing/2014/main" id="{CFA6D513-871A-49B7-BCEB-FE363A1C0254}"/>
               </a:ext>
             </a:extLst>
           </p:cNvPr>
@@ -4795,17 +4795,17 @@
                 <a:ea typeface="Calibri"/>
                 <a:cs typeface="Calibri"/>
               </a:rPr>
-              <a:t>After six probes: 6/6</a:t>
-            </a:r>
-          </a:p>
-        </p:txBody>
-      </p:sp>
-      <p:sp>
-        <p:nvSpPr>
-          <p:cNvPr id="9" name="The sequence model flagged all six,&#10;plus 50 correc">
+              <a:t>After six probes: 5/6</a:t>
+            </a:r>
+          </a:p>
+        </p:txBody>
+      </p:sp>
+      <p:sp>
+        <p:nvSpPr>
+          <p:cNvPr id="9" name="The sequence model missed one,&#10;plus 44 correct cas">
             <a:extLst xmlns:a="http://schemas.openxmlformats.org/drawingml/2006/main">
               <a:ext uri="{FF2B5EF4-FFF2-40B4-BE49-F238E27FC236}">
-                <a16:creationId xmlns:a16="http://schemas.microsoft.com/office/drawing/2014/main" id="{4E754E4D-D830-4B5E-B185-89E177020996}"/>
+                <a16:creationId xmlns:a16="http://schemas.microsoft.com/office/drawing/2014/main" id="{CA3EA85D-A079-4444-92B3-01438E28BE97}"/>
               </a:ext>
             </a:extLst>
           </p:cNvPr>
@@ -4852,7 +4852,7 @@
                 <a:ea typeface="Calibri"/>
                 <a:cs typeface="Calibri"/>
               </a:rPr>
-              <a:t>The sequence model flagged all six,</a:t>
+              <a:t>The sequence model missed one,</a:t>
             </a:r>
           </a:p>
           <a:p xmlns:a="http://schemas.openxmlformats.org/drawingml/2006/main">
@@ -4875,7 +4875,7 @@
                 <a:ea typeface="Calibri"/>
                 <a:cs typeface="Calibri"/>
               </a:rPr>
-              <a:t>plus 50 correct predictions.</a:t>
+              <a:t>plus 44 correct cases were flagged.</a:t>
             </a:r>
           </a:p>
         </p:txBody>
@@ -4883,7 +4883,7 @@
     </p:spTree>
     <p:extLst>
       <p:ext uri="{BB962C8B-B14F-4D97-AF65-F5344CB8AC3E}">
-        <p14:creationId xmlns:p14="http://schemas.microsoft.com/office/powerpoint/2010/main" val="1680052171"/>
+        <p14:creationId xmlns:p14="http://schemas.microsoft.com/office/powerpoint/2010/main" val="168743345"/>
       </p:ext>
     </p:extLst>
   </p:cSld>
@@ -4914,7 +4914,7 @@
           <p:cNvPr id="11" name="What drift features add">
             <a:extLst xmlns:a="http://schemas.openxmlformats.org/drawingml/2006/main">
               <a:ext uri="{FF2B5EF4-FFF2-40B4-BE49-F238E27FC236}">
-                <a16:creationId xmlns:a16="http://schemas.microsoft.com/office/drawing/2014/main" id="{BB373C25-33E4-4723-99A2-D272B79B9F74}"/>
+                <a16:creationId xmlns:a16="http://schemas.microsoft.com/office/drawing/2014/main" id="{B738F9D1-5EF2-4CB6-8286-B86C1FE00648}"/>
               </a:ext>
             </a:extLst>
           </p:cNvPr>
@@ -4971,7 +4971,7 @@
           <p:cNvPr id="2" name="11">
             <a:extLst xmlns:a="http://schemas.openxmlformats.org/drawingml/2006/main">
               <a:ext uri="{FF2B5EF4-FFF2-40B4-BE49-F238E27FC236}">
-                <a16:creationId xmlns:a16="http://schemas.microsoft.com/office/drawing/2014/main" id="{B123AEDE-5889-4B66-B38D-4C5A8F835F33}"/>
+                <a16:creationId xmlns:a16="http://schemas.microsoft.com/office/drawing/2014/main" id="{D02060E2-5367-41C8-9A3A-5252FDDFD4B5}"/>
               </a:ext>
             </a:extLst>
           </p:cNvPr>
@@ -5028,7 +5028,7 @@
           <p:cNvPr id="3" name="Pooled out-of-fold results · five document-grouped">
             <a:extLst xmlns:a="http://schemas.openxmlformats.org/drawingml/2006/main">
               <a:ext uri="{FF2B5EF4-FFF2-40B4-BE49-F238E27FC236}">
-                <a16:creationId xmlns:a16="http://schemas.microsoft.com/office/drawing/2014/main" id="{5A83598A-00AD-4F98-95E2-A0EE86F037B8}"/>
+                <a16:creationId xmlns:a16="http://schemas.microsoft.com/office/drawing/2014/main" id="{09294972-1C10-469C-843E-D5999852BD71}"/>
               </a:ext>
             </a:extLst>
           </p:cNvPr>
@@ -5533,7 +5533,7 @@
           <p:cNvPr id="5" name="+0.040">
             <a:extLst xmlns:a="http://schemas.openxmlformats.org/drawingml/2006/main">
               <a:ext uri="{FF2B5EF4-FFF2-40B4-BE49-F238E27FC236}">
-                <a16:creationId xmlns:a16="http://schemas.microsoft.com/office/drawing/2014/main" id="{53DE2980-C15B-4AF6-90B4-71357953D18C}"/>
+                <a16:creationId xmlns:a16="http://schemas.microsoft.com/office/drawing/2014/main" id="{9153D2A6-D1C0-4A98-8B2E-9BDD7C8A93BB}"/>
               </a:ext>
             </a:extLst>
           </p:cNvPr>
@@ -5590,7 +5590,7 @@
           <p:cNvPr id="6" name="F1 improvement, B to C">
             <a:extLst xmlns:a="http://schemas.openxmlformats.org/drawingml/2006/main">
               <a:ext uri="{FF2B5EF4-FFF2-40B4-BE49-F238E27FC236}">
-                <a16:creationId xmlns:a16="http://schemas.microsoft.com/office/drawing/2014/main" id="{B828A482-2628-4D6A-8FB3-64013686DC67}"/>
+                <a16:creationId xmlns:a16="http://schemas.microsoft.com/office/drawing/2014/main" id="{65C5C942-0344-4EBA-B112-0AD75167FCCF}"/>
               </a:ext>
             </a:extLst>
           </p:cNvPr>
@@ -5647,7 +5647,7 @@
           <p:cNvPr id="7" name="+0.034">
             <a:extLst xmlns:a="http://schemas.openxmlformats.org/drawingml/2006/main">
               <a:ext uri="{FF2B5EF4-FFF2-40B4-BE49-F238E27FC236}">
-                <a16:creationId xmlns:a16="http://schemas.microsoft.com/office/drawing/2014/main" id="{C9EA730C-1EE7-47AA-8905-E39AED8898E2}"/>
+                <a16:creationId xmlns:a16="http://schemas.microsoft.com/office/drawing/2014/main" id="{DE663D9C-C58F-4937-84F5-26AA72356FEE}"/>
               </a:ext>
             </a:extLst>
           </p:cNvPr>
@@ -5704,7 +5704,7 @@
           <p:cNvPr id="8" name="ROC-AUC improvement, B to C">
             <a:extLst xmlns:a="http://schemas.openxmlformats.org/drawingml/2006/main">
               <a:ext uri="{FF2B5EF4-FFF2-40B4-BE49-F238E27FC236}">
-                <a16:creationId xmlns:a16="http://schemas.microsoft.com/office/drawing/2014/main" id="{1EB1D9A2-B3EB-4671-AC48-08DC9EA16280}"/>
+                <a16:creationId xmlns:a16="http://schemas.microsoft.com/office/drawing/2014/main" id="{CA560D3B-F369-4C85-ADBD-F7709BD6BD4F}"/>
               </a:ext>
             </a:extLst>
           </p:cNvPr>
@@ -5761,7 +5761,7 @@
           <p:cNvPr id="9" name="History adds a&#10;modest gain.">
             <a:extLst xmlns:a="http://schemas.openxmlformats.org/drawingml/2006/main">
               <a:ext uri="{FF2B5EF4-FFF2-40B4-BE49-F238E27FC236}">
-                <a16:creationId xmlns:a16="http://schemas.microsoft.com/office/drawing/2014/main" id="{ACE29775-13FC-46F4-9808-F9B783549C2E}"/>
+                <a16:creationId xmlns:a16="http://schemas.microsoft.com/office/drawing/2014/main" id="{957D4C89-0208-43F3-8AF7-71F3359106E2}"/>
               </a:ext>
             </a:extLst>
           </p:cNvPr>
@@ -5841,7 +5841,7 @@
           <p:cNvPr id="10" name="The separate 110-document holdout showed a smaller">
             <a:extLst xmlns:a="http://schemas.openxmlformats.org/drawingml/2006/main">
               <a:ext uri="{FF2B5EF4-FFF2-40B4-BE49-F238E27FC236}">
-                <a16:creationId xmlns:a16="http://schemas.microsoft.com/office/drawing/2014/main" id="{A172E6BA-2579-41E2-B685-7D19BB2FC8AC}"/>
+                <a16:creationId xmlns:a16="http://schemas.microsoft.com/office/drawing/2014/main" id="{A7F6872E-8BB4-44E8-B9F8-9BD7509FED94}"/>
               </a:ext>
             </a:extLst>
           </p:cNvPr>
@@ -5896,7 +5896,7 @@
     </p:spTree>
     <p:extLst>
       <p:ext uri="{BB962C8B-B14F-4D97-AF65-F5344CB8AC3E}">
-        <p14:creationId xmlns:p14="http://schemas.microsoft.com/office/powerpoint/2010/main" val="860137954"/>
+        <p14:creationId xmlns:p14="http://schemas.microsoft.com/office/powerpoint/2010/main" val="628968554"/>
       </p:ext>
     </p:extLst>
   </p:cSld>
@@ -5927,7 +5927,7 @@
           <p:cNvPr id="15" name="Four findings">
             <a:extLst xmlns:a="http://schemas.openxmlformats.org/drawingml/2006/main">
               <a:ext uri="{FF2B5EF4-FFF2-40B4-BE49-F238E27FC236}">
-                <a16:creationId xmlns:a16="http://schemas.microsoft.com/office/drawing/2014/main" id="{269D3555-16B9-4604-8BE5-3C7923B77B04}"/>
+                <a16:creationId xmlns:a16="http://schemas.microsoft.com/office/drawing/2014/main" id="{7CD3A7B5-7876-4D7B-A459-8D9BC909044B}"/>
               </a:ext>
             </a:extLst>
           </p:cNvPr>
@@ -5984,7 +5984,7 @@
           <p:cNvPr id="2" name="12">
             <a:extLst xmlns:a="http://schemas.openxmlformats.org/drawingml/2006/main">
               <a:ext uri="{FF2B5EF4-FFF2-40B4-BE49-F238E27FC236}">
-                <a16:creationId xmlns:a16="http://schemas.microsoft.com/office/drawing/2014/main" id="{4B701A13-EC3C-4D81-85A7-21A17311C33A}"/>
+                <a16:creationId xmlns:a16="http://schemas.microsoft.com/office/drawing/2014/main" id="{6EA15D4E-8273-401A-A520-B10C84A88563}"/>
               </a:ext>
             </a:extLst>
           </p:cNvPr>
@@ -6041,7 +6041,7 @@
           <p:cNvPr id="3" name="63.5–93.3%">
             <a:extLst xmlns:a="http://schemas.openxmlformats.org/drawingml/2006/main">
               <a:ext uri="{FF2B5EF4-FFF2-40B4-BE49-F238E27FC236}">
-                <a16:creationId xmlns:a16="http://schemas.microsoft.com/office/drawing/2014/main" id="{CABA10A6-A2A3-4AEC-91F0-16BC116D5301}"/>
+                <a16:creationId xmlns:a16="http://schemas.microsoft.com/office/drawing/2014/main" id="{08C46B3C-45E4-4A0B-953C-E352859C9CD7}"/>
               </a:ext>
             </a:extLst>
           </p:cNvPr>
@@ -6098,7 +6098,7 @@
           <p:cNvPr id="4" name="Confidence carries useful signal">
             <a:extLst xmlns:a="http://schemas.openxmlformats.org/drawingml/2006/main">
               <a:ext uri="{FF2B5EF4-FFF2-40B4-BE49-F238E27FC236}">
-                <a16:creationId xmlns:a16="http://schemas.microsoft.com/office/drawing/2014/main" id="{34B4BE10-DE11-4E5A-8924-D250EB7D8E6C}"/>
+                <a16:creationId xmlns:a16="http://schemas.microsoft.com/office/drawing/2014/main" id="{50599D64-1C1E-4A1D-A692-BC87922BB60F}"/>
               </a:ext>
             </a:extLst>
           </p:cNvPr>
@@ -6155,7 +6155,7 @@
           <p:cNvPr id="5" name="Accuracy rises across the confidence bins.">
             <a:extLst xmlns:a="http://schemas.openxmlformats.org/drawingml/2006/main">
               <a:ext uri="{FF2B5EF4-FFF2-40B4-BE49-F238E27FC236}">
-                <a16:creationId xmlns:a16="http://schemas.microsoft.com/office/drawing/2014/main" id="{680F4911-19B6-4114-93A1-78FB7AD51D1A}"/>
+                <a16:creationId xmlns:a16="http://schemas.microsoft.com/office/drawing/2014/main" id="{92F66974-73A0-426C-A8EB-329C31B5B29B}"/>
               </a:ext>
             </a:extLst>
           </p:cNvPr>
@@ -6212,7 +6212,7 @@
           <p:cNvPr id="6" name="6 of 100">
             <a:extLst xmlns:a="http://schemas.openxmlformats.org/drawingml/2006/main">
               <a:ext uri="{FF2B5EF4-FFF2-40B4-BE49-F238E27FC236}">
-                <a16:creationId xmlns:a16="http://schemas.microsoft.com/office/drawing/2014/main" id="{3B9992A8-D5EA-412F-829A-B6163E6A75C6}"/>
+                <a16:creationId xmlns:a16="http://schemas.microsoft.com/office/drawing/2014/main" id="{502CF519-7750-46D1-8E2A-872C15CD245C}"/>
               </a:ext>
             </a:extLst>
           </p:cNvPr>
@@ -6269,7 +6269,7 @@
           <p:cNvPr id="7" name="High confidence can still be wrong">
             <a:extLst xmlns:a="http://schemas.openxmlformats.org/drawingml/2006/main">
               <a:ext uri="{FF2B5EF4-FFF2-40B4-BE49-F238E27FC236}">
-                <a16:creationId xmlns:a16="http://schemas.microsoft.com/office/drawing/2014/main" id="{C2ABE0DC-FAC6-42C1-963C-0B47D6297624}"/>
+                <a16:creationId xmlns:a16="http://schemas.microsoft.com/office/drawing/2014/main" id="{AD176176-52A7-4AA9-808E-EDEABCB2F264}"/>
               </a:ext>
             </a:extLst>
           </p:cNvPr>
@@ -6323,10 +6323,10 @@
       </p:sp>
       <p:sp>
         <p:nvSpPr>
-          <p:cNvPr id="8" name="After six probes: 6 flagged, with 50 false alarms.">
+          <p:cNvPr id="8" name="After six probes: 5 flagged, 1 missed, 44 false al">
             <a:extLst xmlns:a="http://schemas.openxmlformats.org/drawingml/2006/main">
               <a:ext uri="{FF2B5EF4-FFF2-40B4-BE49-F238E27FC236}">
-                <a16:creationId xmlns:a16="http://schemas.microsoft.com/office/drawing/2014/main" id="{37CF480C-CFFA-43C4-A797-74BD8428AAF0}"/>
+                <a16:creationId xmlns:a16="http://schemas.microsoft.com/office/drawing/2014/main" id="{7E1F4C21-A8C0-49E5-9795-39A688368B5D}"/>
               </a:ext>
             </a:extLst>
           </p:cNvPr>
@@ -6373,7 +6373,7 @@
                 <a:ea typeface="Calibri"/>
                 <a:cs typeface="Calibri"/>
               </a:rPr>
-              <a:t>After six probes: 6 flagged, with 50 false alarms.</a:t>
+              <a:t>After six probes: 5 flagged, 1 missed, 44 false alarms.</a:t>
             </a:r>
           </a:p>
         </p:txBody>
@@ -6383,7 +6383,7 @@
           <p:cNvPr id="9" name="r = 0.09">
             <a:extLst xmlns:a="http://schemas.openxmlformats.org/drawingml/2006/main">
               <a:ext uri="{FF2B5EF4-FFF2-40B4-BE49-F238E27FC236}">
-                <a16:creationId xmlns:a16="http://schemas.microsoft.com/office/drawing/2014/main" id="{5A14CB2A-2337-46D4-AAF0-B4F75DC4F7DC}"/>
+                <a16:creationId xmlns:a16="http://schemas.microsoft.com/office/drawing/2014/main" id="{CFFF786B-F3EE-41E4-B74F-67D5F45D8E95}"/>
               </a:ext>
             </a:extLst>
           </p:cNvPr>
@@ -6440,7 +6440,7 @@
           <p:cNvPr id="10" name="Net drift is a weak predictor">
             <a:extLst xmlns:a="http://schemas.openxmlformats.org/drawingml/2006/main">
               <a:ext uri="{FF2B5EF4-FFF2-40B4-BE49-F238E27FC236}">
-                <a16:creationId xmlns:a16="http://schemas.microsoft.com/office/drawing/2014/main" id="{34112BB8-64C9-473B-AB87-161B77B82746}"/>
+                <a16:creationId xmlns:a16="http://schemas.microsoft.com/office/drawing/2014/main" id="{21E86BC3-CEBA-4451-B5A9-2527B8FCFC73}"/>
               </a:ext>
             </a:extLst>
           </p:cNvPr>
@@ -6497,7 +6497,7 @@
           <p:cNvPr id="11" name="Correlation with becoming incorrect is small.">
             <a:extLst xmlns:a="http://schemas.openxmlformats.org/drawingml/2006/main">
               <a:ext uri="{FF2B5EF4-FFF2-40B4-BE49-F238E27FC236}">
-                <a16:creationId xmlns:a16="http://schemas.microsoft.com/office/drawing/2014/main" id="{602B133E-085B-4209-9B7D-35120235DFED}"/>
+                <a16:creationId xmlns:a16="http://schemas.microsoft.com/office/drawing/2014/main" id="{C8B99039-E72C-47FA-B44E-E69A705FAEC5}"/>
               </a:ext>
             </a:extLst>
           </p:cNvPr>
@@ -6554,7 +6554,7 @@
           <p:cNvPr id="12" name="+0.040 F1">
             <a:extLst xmlns:a="http://schemas.openxmlformats.org/drawingml/2006/main">
               <a:ext uri="{FF2B5EF4-FFF2-40B4-BE49-F238E27FC236}">
-                <a16:creationId xmlns:a16="http://schemas.microsoft.com/office/drawing/2014/main" id="{C4574EAF-2EB9-4CB4-9431-005E462F15B3}"/>
+                <a16:creationId xmlns:a16="http://schemas.microsoft.com/office/drawing/2014/main" id="{AD8F5B85-DCDC-4719-8C97-29C751EEDE36}"/>
               </a:ext>
             </a:extLst>
           </p:cNvPr>
@@ -6611,7 +6611,7 @@
           <p:cNvPr id="13" name="History adds a modest gain">
             <a:extLst xmlns:a="http://schemas.openxmlformats.org/drawingml/2006/main">
               <a:ext uri="{FF2B5EF4-FFF2-40B4-BE49-F238E27FC236}">
-                <a16:creationId xmlns:a16="http://schemas.microsoft.com/office/drawing/2014/main" id="{66D77C71-6F5E-425A-8503-9AEA035DA09C}"/>
+                <a16:creationId xmlns:a16="http://schemas.microsoft.com/office/drawing/2014/main" id="{88A4A5A9-5EB4-4F1A-BCB0-7B80200E77FA}"/>
               </a:ext>
             </a:extLst>
           </p:cNvPr>
@@ -6668,7 +6668,7 @@
           <p:cNvPr id="14" name="F1 rises from 0.468 to 0.508 after current confide">
             <a:extLst xmlns:a="http://schemas.openxmlformats.org/drawingml/2006/main">
               <a:ext uri="{FF2B5EF4-FFF2-40B4-BE49-F238E27FC236}">
-                <a16:creationId xmlns:a16="http://schemas.microsoft.com/office/drawing/2014/main" id="{3A5AEF10-0905-413B-AFA2-330130630C29}"/>
+                <a16:creationId xmlns:a16="http://schemas.microsoft.com/office/drawing/2014/main" id="{BE3F1D7E-DDDF-453A-B042-4F99971693CD}"/>
               </a:ext>
             </a:extLst>
           </p:cNvPr>
@@ -6723,7 +6723,7 @@
     </p:spTree>
     <p:extLst>
       <p:ext uri="{BB962C8B-B14F-4D97-AF65-F5344CB8AC3E}">
-        <p14:creationId xmlns:p14="http://schemas.microsoft.com/office/powerpoint/2010/main" val="1912111692"/>
+        <p14:creationId xmlns:p14="http://schemas.microsoft.com/office/powerpoint/2010/main" val="1058599968"/>
       </p:ext>
     </p:extLst>
   </p:cSld>
@@ -6754,7 +6754,7 @@
           <p:cNvPr id="13" name="Limitations and next steps">
             <a:extLst xmlns:a="http://schemas.openxmlformats.org/drawingml/2006/main">
               <a:ext uri="{FF2B5EF4-FFF2-40B4-BE49-F238E27FC236}">
-                <a16:creationId xmlns:a16="http://schemas.microsoft.com/office/drawing/2014/main" id="{6C154B8C-CB83-45BF-B76B-0E9D0D614849}"/>
+                <a16:creationId xmlns:a16="http://schemas.microsoft.com/office/drawing/2014/main" id="{EC7AE442-F442-4382-B17D-27932F9379D9}"/>
               </a:ext>
             </a:extLst>
           </p:cNvPr>
@@ -6811,7 +6811,7 @@
           <p:cNvPr id="2" name="13">
             <a:extLst xmlns:a="http://schemas.openxmlformats.org/drawingml/2006/main">
               <a:ext uri="{FF2B5EF4-FFF2-40B4-BE49-F238E27FC236}">
-                <a16:creationId xmlns:a16="http://schemas.microsoft.com/office/drawing/2014/main" id="{AC08C0FA-301D-4B24-BE59-86C0306E8F38}"/>
+                <a16:creationId xmlns:a16="http://schemas.microsoft.com/office/drawing/2014/main" id="{821303DC-DF56-46D3-A00A-ADD76200AAA9}"/>
               </a:ext>
             </a:extLst>
           </p:cNvPr>
@@ -6868,7 +6868,7 @@
           <p:cNvPr id="3" name="Limits of this study">
             <a:extLst xmlns:a="http://schemas.openxmlformats.org/drawingml/2006/main">
               <a:ext uri="{FF2B5EF4-FFF2-40B4-BE49-F238E27FC236}">
-                <a16:creationId xmlns:a16="http://schemas.microsoft.com/office/drawing/2014/main" id="{3BFAF0D3-178D-45F1-8B28-1CDA434BAA2D}"/>
+                <a16:creationId xmlns:a16="http://schemas.microsoft.com/office/drawing/2014/main" id="{4D24BE57-9CF9-4146-8EFB-20604A626C43}"/>
               </a:ext>
             </a:extLst>
           </p:cNvPr>
@@ -6925,7 +6925,7 @@
           <p:cNvPr id="4" name="What I would test next">
             <a:extLst xmlns:a="http://schemas.openxmlformats.org/drawingml/2006/main">
               <a:ext uri="{FF2B5EF4-FFF2-40B4-BE49-F238E27FC236}">
-                <a16:creationId xmlns:a16="http://schemas.microsoft.com/office/drawing/2014/main" id="{4BF09ADE-D448-4B04-BCAA-445E5862A1FD}"/>
+                <a16:creationId xmlns:a16="http://schemas.microsoft.com/office/drawing/2014/main" id="{636AD2CF-7DD7-447D-866C-4800C11624A9}"/>
               </a:ext>
             </a:extLst>
           </p:cNvPr>
@@ -6982,7 +6982,7 @@
           <p:cNvPr id="5" name="Text corruption simulates repeated predictions. Re">
             <a:extLst xmlns:a="http://schemas.openxmlformats.org/drawingml/2006/main">
               <a:ext uri="{FF2B5EF4-FFF2-40B4-BE49-F238E27FC236}">
-                <a16:creationId xmlns:a16="http://schemas.microsoft.com/office/drawing/2014/main" id="{0CFAE954-250E-406B-9EB7-C93E9DD916E0}"/>
+                <a16:creationId xmlns:a16="http://schemas.microsoft.com/office/drawing/2014/main" id="{FFAC41B0-7452-4522-942B-CA2A61C6CA8A}"/>
               </a:ext>
             </a:extLst>
           </p:cNvPr>
@@ -7039,7 +7039,7 @@
           <p:cNvPr id="6" name="Only 439 test documents. The top calibration bin h">
             <a:extLst xmlns:a="http://schemas.openxmlformats.org/drawingml/2006/main">
               <a:ext uri="{FF2B5EF4-FFF2-40B4-BE49-F238E27FC236}">
-                <a16:creationId xmlns:a16="http://schemas.microsoft.com/office/drawing/2014/main" id="{8F4DD7E9-50F4-422C-ADC7-FEB053CC4EFC}"/>
+                <a16:creationId xmlns:a16="http://schemas.microsoft.com/office/drawing/2014/main" id="{542DDD44-70B1-4505-B885-C30B7D643286}"/>
               </a:ext>
             </a:extLst>
           </p:cNvPr>
@@ -7096,7 +7096,7 @@
           <p:cNvPr id="7" name="Two classes and one base model architecture.">
             <a:extLst xmlns:a="http://schemas.openxmlformats.org/drawingml/2006/main">
               <a:ext uri="{FF2B5EF4-FFF2-40B4-BE49-F238E27FC236}">
-                <a16:creationId xmlns:a16="http://schemas.microsoft.com/office/drawing/2014/main" id="{89211080-609A-4E89-846E-2D087192632E}"/>
+                <a16:creationId xmlns:a16="http://schemas.microsoft.com/office/drawing/2014/main" id="{1B34693F-E45F-4C20-BCB9-AB44350AFD37}"/>
               </a:ext>
             </a:extLst>
           </p:cNvPr>
@@ -7150,10 +7150,10 @@
       </p:sp>
       <p:sp>
         <p:nvSpPr>
-          <p:cNvPr id="8" name="Six probes are required; 50 correct high-confidenc">
+          <p:cNvPr id="8" name="Six probes missed one error and flagged 44 correct">
             <a:extLst xmlns:a="http://schemas.openxmlformats.org/drawingml/2006/main">
               <a:ext uri="{FF2B5EF4-FFF2-40B4-BE49-F238E27FC236}">
-                <a16:creationId xmlns:a16="http://schemas.microsoft.com/office/drawing/2014/main" id="{256FDDFB-CA49-469A-BC84-6ABC1B3D8EBF}"/>
+                <a16:creationId xmlns:a16="http://schemas.microsoft.com/office/drawing/2014/main" id="{93E98D21-68CA-4E85-AF2F-C69A1ED85FD5}"/>
               </a:ext>
             </a:extLst>
           </p:cNvPr>
@@ -7200,17 +7200,17 @@
                 <a:ea typeface="Calibri"/>
                 <a:cs typeface="Calibri"/>
               </a:rPr>
-              <a:t>Six probes are required; 50 correct high-confidence cases were flagged.</a:t>
-            </a:r>
-          </a:p>
-        </p:txBody>
-      </p:sp>
-      <p:sp>
-        <p:nvSpPr>
-          <p:cNvPr id="9" name="Reduce false alarms, then test on a new corpus.">
+              <a:t>Six probes missed one error and flagged 44 correct cases.</a:t>
+            </a:r>
+          </a:p>
+        </p:txBody>
+      </p:sp>
+      <p:sp>
+        <p:nvSpPr>
+          <p:cNvPr id="9" name="Test the frozen detector on a new labeled corpus.">
             <a:extLst xmlns:a="http://schemas.openxmlformats.org/drawingml/2006/main">
               <a:ext uri="{FF2B5EF4-FFF2-40B4-BE49-F238E27FC236}">
-                <a16:creationId xmlns:a16="http://schemas.microsoft.com/office/drawing/2014/main" id="{3060CFE0-9E05-4411-9688-266359647658}"/>
+                <a16:creationId xmlns:a16="http://schemas.microsoft.com/office/drawing/2014/main" id="{00CDB7D3-3462-4596-949F-EA0CBFD59B57}"/>
               </a:ext>
             </a:extLst>
           </p:cNvPr>
@@ -7257,7 +7257,7 @@
                 <a:ea typeface="Calibri"/>
                 <a:cs typeface="Calibri"/>
               </a:rPr>
-              <a:t>Reduce false alarms, then test on a new corpus.</a:t>
+              <a:t>Test the frozen detector on a new labeled corpus.</a:t>
             </a:r>
           </a:p>
         </p:txBody>
@@ -7267,7 +7267,7 @@
           <p:cNvPr id="10" name="Collect naturally repeated real-world queries when">
             <a:extLst xmlns:a="http://schemas.openxmlformats.org/drawingml/2006/main">
               <a:ext uri="{FF2B5EF4-FFF2-40B4-BE49-F238E27FC236}">
-                <a16:creationId xmlns:a16="http://schemas.microsoft.com/office/drawing/2014/main" id="{1096AB0C-B482-4BA6-95BB-5B1FD6B9E102}"/>
+                <a16:creationId xmlns:a16="http://schemas.microsoft.com/office/drawing/2014/main" id="{A4406602-A70F-413E-A690-08812095AA34}"/>
               </a:ext>
             </a:extLst>
           </p:cNvPr>
@@ -7321,10 +7321,10 @@
       </p:sp>
       <p:sp>
         <p:nvSpPr>
-          <p:cNvPr id="11" name="Apply temperature scaling and retest whether histo">
+          <p:cNvPr id="11" name="Reduce false alarms and set a practical review cap">
             <a:extLst xmlns:a="http://schemas.openxmlformats.org/drawingml/2006/main">
               <a:ext uri="{FF2B5EF4-FFF2-40B4-BE49-F238E27FC236}">
-                <a16:creationId xmlns:a16="http://schemas.microsoft.com/office/drawing/2014/main" id="{7145663E-050C-4363-B1BF-0A37719277A4}"/>
+                <a16:creationId xmlns:a16="http://schemas.microsoft.com/office/drawing/2014/main" id="{0D767537-0CB5-4D99-BE46-369200339BEC}"/>
               </a:ext>
             </a:extLst>
           </p:cNvPr>
@@ -7371,7 +7371,7 @@
                 <a:ea typeface="Calibri"/>
                 <a:cs typeface="Calibri"/>
               </a:rPr>
-              <a:t>Apply temperature scaling and retest whether history adds value.</a:t>
+              <a:t>Reduce false alarms and set a practical review capacity.</a:t>
             </a:r>
           </a:p>
         </p:txBody>
@@ -7381,7 +7381,7 @@
           <p:cNvPr id="12" name="Extend to multiple classes and another base model.">
             <a:extLst xmlns:a="http://schemas.openxmlformats.org/drawingml/2006/main">
               <a:ext uri="{FF2B5EF4-FFF2-40B4-BE49-F238E27FC236}">
-                <a16:creationId xmlns:a16="http://schemas.microsoft.com/office/drawing/2014/main" id="{3A04E935-0CB0-4D96-8ED5-2FA391C3D86F}"/>
+                <a16:creationId xmlns:a16="http://schemas.microsoft.com/office/drawing/2014/main" id="{F9C59A2D-1356-4DD8-97C7-844A42B69D15}"/>
               </a:ext>
             </a:extLst>
           </p:cNvPr>
@@ -7436,7 +7436,7 @@
     </p:spTree>
     <p:extLst>
       <p:ext uri="{BB962C8B-B14F-4D97-AF65-F5344CB8AC3E}">
-        <p14:creationId xmlns:p14="http://schemas.microsoft.com/office/powerpoint/2010/main" val="1724524872"/>
+        <p14:creationId xmlns:p14="http://schemas.microsoft.com/office/powerpoint/2010/main" val="334725139"/>
       </p:ext>
     </p:extLst>
   </p:cSld>
@@ -7467,7 +7467,7 @@
           <p:cNvPr id="10" name="14">
             <a:extLst xmlns:a="http://schemas.openxmlformats.org/drawingml/2006/main">
               <a:ext uri="{FF2B5EF4-FFF2-40B4-BE49-F238E27FC236}">
-                <a16:creationId xmlns:a16="http://schemas.microsoft.com/office/drawing/2014/main" id="{12511F6A-D921-42EC-90A1-957567BEEE88}"/>
+                <a16:creationId xmlns:a16="http://schemas.microsoft.com/office/drawing/2014/main" id="{ED27E1A9-ED87-4778-A574-3B5ECCF73693}"/>
               </a:ext>
             </a:extLst>
           </p:cNvPr>
@@ -7524,7 +7524,7 @@
           <p:cNvPr id="2" name="CONCLUSION">
             <a:extLst xmlns:a="http://schemas.openxmlformats.org/drawingml/2006/main">
               <a:ext uri="{FF2B5EF4-FFF2-40B4-BE49-F238E27FC236}">
-                <a16:creationId xmlns:a16="http://schemas.microsoft.com/office/drawing/2014/main" id="{21B70AED-C5E3-451C-B017-882C0D8A1500}"/>
+                <a16:creationId xmlns:a16="http://schemas.microsoft.com/office/drawing/2014/main" id="{5E3D68EB-62F6-47EE-B4C2-CA96F0D4E1AF}"/>
               </a:ext>
             </a:extLst>
           </p:cNvPr>
@@ -7581,7 +7581,7 @@
           <p:cNvPr id="3" name="Confidence history adds">
             <a:extLst xmlns:a="http://schemas.openxmlformats.org/drawingml/2006/main">
               <a:ext uri="{FF2B5EF4-FFF2-40B4-BE49-F238E27FC236}">
-                <a16:creationId xmlns:a16="http://schemas.microsoft.com/office/drawing/2014/main" id="{FEBFDEEA-65BA-459F-8B9E-4881C7E039B6}"/>
+                <a16:creationId xmlns:a16="http://schemas.microsoft.com/office/drawing/2014/main" id="{DC234933-6A29-4507-80A7-0A0BADF6B97C}"/>
               </a:ext>
             </a:extLst>
           </p:cNvPr>
@@ -7638,7 +7638,7 @@
           <p:cNvPr id="4" name="a modest signal.">
             <a:extLst xmlns:a="http://schemas.openxmlformats.org/drawingml/2006/main">
               <a:ext uri="{FF2B5EF4-FFF2-40B4-BE49-F238E27FC236}">
-                <a16:creationId xmlns:a16="http://schemas.microsoft.com/office/drawing/2014/main" id="{4517EFB3-3675-4AC3-B885-48DEDE673526}"/>
+                <a16:creationId xmlns:a16="http://schemas.microsoft.com/office/drawing/2014/main" id="{FC04827D-774A-4B2E-8D24-71A7B1BA4A1E}"/>
               </a:ext>
             </a:extLst>
           </p:cNvPr>
@@ -7692,10 +7692,10 @@
       </p:sp>
       <p:sp>
         <p:nvSpPr>
-          <p:cNvPr id="5" name="Six flagged. Fifty false alarms.">
+          <p:cNvPr id="5" name="Five flagged. One missed.">
             <a:extLst xmlns:a="http://schemas.openxmlformats.org/drawingml/2006/main">
               <a:ext uri="{FF2B5EF4-FFF2-40B4-BE49-F238E27FC236}">
-                <a16:creationId xmlns:a16="http://schemas.microsoft.com/office/drawing/2014/main" id="{F63B554E-9A39-428A-8ECB-ED195B279712}"/>
+                <a16:creationId xmlns:a16="http://schemas.microsoft.com/office/drawing/2014/main" id="{9F7F0A65-B2EC-42A9-A413-3E3EB7478442}"/>
               </a:ext>
             </a:extLst>
           </p:cNvPr>
@@ -7742,7 +7742,7 @@
                 <a:ea typeface="Georgia"/>
                 <a:cs typeface="Georgia"/>
               </a:rPr>
-              <a:t>Six flagged. Fifty false alarms.</a:t>
+              <a:t>Five flagged. One missed.</a:t>
             </a:r>
           </a:p>
         </p:txBody>
@@ -7752,7 +7752,7 @@
           <p:cNvPr id="6" name="The per-step detector missed all six at the first ">
             <a:extLst xmlns:a="http://schemas.openxmlformats.org/drawingml/2006/main">
               <a:ext uri="{FF2B5EF4-FFF2-40B4-BE49-F238E27FC236}">
-                <a16:creationId xmlns:a16="http://schemas.microsoft.com/office/drawing/2014/main" id="{23C3DDB9-9214-4A59-B653-5D711CF9FA3F}"/>
+                <a16:creationId xmlns:a16="http://schemas.microsoft.com/office/drawing/2014/main" id="{3C75DD1B-56AA-4A2A-9335-83DD4828D593}"/>
               </a:ext>
             </a:extLst>
           </p:cNvPr>
@@ -7822,7 +7822,7 @@
                 <a:ea typeface="Calibri"/>
                 <a:cs typeface="Calibri"/>
               </a:rPr>
-              <a:t>After six probes, the sequence model flagged all six plus 50 correct cases.</a:t>
+              <a:t>After six probes, the sequence model flagged five plus 44 correct cases.</a:t>
             </a:r>
           </a:p>
         </p:txBody>
@@ -7832,7 +7832,7 @@
           <p:cNvPr id="7" name="F1  0.468 to 0.508">
             <a:extLst xmlns:a="http://schemas.openxmlformats.org/drawingml/2006/main">
               <a:ext uri="{FF2B5EF4-FFF2-40B4-BE49-F238E27FC236}">
-                <a16:creationId xmlns:a16="http://schemas.microsoft.com/office/drawing/2014/main" id="{00A61AAA-C52D-4A42-B9B8-21D06A384D8B}"/>
+                <a16:creationId xmlns:a16="http://schemas.microsoft.com/office/drawing/2014/main" id="{2BB473E6-9AA1-452B-BC39-B96567B8AD59}"/>
               </a:ext>
             </a:extLst>
           </p:cNvPr>
@@ -7889,7 +7889,7 @@
           <p:cNvPr id="8" name="ROC-AUC  0.729 to 0.763">
             <a:extLst xmlns:a="http://schemas.openxmlformats.org/drawingml/2006/main">
               <a:ext uri="{FF2B5EF4-FFF2-40B4-BE49-F238E27FC236}">
-                <a16:creationId xmlns:a16="http://schemas.microsoft.com/office/drawing/2014/main" id="{7BA7C57E-50A9-4546-9069-80D4D6FD2123}"/>
+                <a16:creationId xmlns:a16="http://schemas.microsoft.com/office/drawing/2014/main" id="{C1A38455-1A76-4BBA-8E5B-467B1AA1BC4B}"/>
               </a:ext>
             </a:extLst>
           </p:cNvPr>
@@ -7946,7 +7946,7 @@
           <p:cNvPr id="9" name="Code, data, models and research report: github.com">
             <a:extLst xmlns:a="http://schemas.openxmlformats.org/drawingml/2006/main">
               <a:ext uri="{FF2B5EF4-FFF2-40B4-BE49-F238E27FC236}">
-                <a16:creationId xmlns:a16="http://schemas.microsoft.com/office/drawing/2014/main" id="{C463656E-6112-4BFC-B2FF-172DDA6DA137}"/>
+                <a16:creationId xmlns:a16="http://schemas.microsoft.com/office/drawing/2014/main" id="{960B761F-B7AF-401F-B7FF-97E8774B5D10}"/>
               </a:ext>
             </a:extLst>
           </p:cNvPr>
@@ -8003,7 +8003,7 @@
                 <a:latin typeface="Calibri"/>
                 <a:ea typeface="Calibri"/>
                 <a:cs typeface="Calibri"/>
-                <a:hlinkClick xmlns:r="http://schemas.openxmlformats.org/officeDocument/2006/relationships" r:id="R6ce4387a781d48f6"/>
+                <a:hlinkClick xmlns:r="http://schemas.openxmlformats.org/officeDocument/2006/relationships" r:id="R947ad014f48846af"/>
               </a:rPr>
               <a:t>github.com/ahansardar/ai-confidence-drift</a:t>
             </a:r>
@@ -8013,7 +8013,7 @@
     </p:spTree>
     <p:extLst>
       <p:ext uri="{BB962C8B-B14F-4D97-AF65-F5344CB8AC3E}">
-        <p14:creationId xmlns:p14="http://schemas.microsoft.com/office/powerpoint/2010/main" val="1477101725"/>
+        <p14:creationId xmlns:p14="http://schemas.microsoft.com/office/powerpoint/2010/main" val="1304881601"/>
       </p:ext>
     </p:extLst>
   </p:cSld>
@@ -8044,7 +8044,7 @@
           <p:cNvPr id="12" name="The confidence problem">
             <a:extLst xmlns:a="http://schemas.openxmlformats.org/drawingml/2006/main">
               <a:ext uri="{FF2B5EF4-FFF2-40B4-BE49-F238E27FC236}">
-                <a16:creationId xmlns:a16="http://schemas.microsoft.com/office/drawing/2014/main" id="{C544689A-B8FE-4722-9F6F-95C2FFF8E94A}"/>
+                <a16:creationId xmlns:a16="http://schemas.microsoft.com/office/drawing/2014/main" id="{16EF2900-7F0E-4913-97A4-AD78EDE2E92F}"/>
               </a:ext>
             </a:extLst>
           </p:cNvPr>
@@ -8101,7 +8101,7 @@
           <p:cNvPr id="2" name="02">
             <a:extLst xmlns:a="http://schemas.openxmlformats.org/drawingml/2006/main">
               <a:ext uri="{FF2B5EF4-FFF2-40B4-BE49-F238E27FC236}">
-                <a16:creationId xmlns:a16="http://schemas.microsoft.com/office/drawing/2014/main" id="{04771171-DA36-46E2-A6C6-EFCD7DB54845}"/>
+                <a16:creationId xmlns:a16="http://schemas.microsoft.com/office/drawing/2014/main" id="{FCBEA7BD-DE79-4D76-98BD-E892BB93E4DF}"/>
               </a:ext>
             </a:extLst>
           </p:cNvPr>
@@ -8158,7 +8158,7 @@
           <p:cNvPr id="3" name="96.3%">
             <a:extLst xmlns:a="http://schemas.openxmlformats.org/drawingml/2006/main">
               <a:ext uri="{FF2B5EF4-FFF2-40B4-BE49-F238E27FC236}">
-                <a16:creationId xmlns:a16="http://schemas.microsoft.com/office/drawing/2014/main" id="{FC012203-B4DD-41BB-BC0E-5204A78E1006}"/>
+                <a16:creationId xmlns:a16="http://schemas.microsoft.com/office/drawing/2014/main" id="{4B3DC3A4-5CAA-49FB-8C31-AC7064E326FE}"/>
               </a:ext>
             </a:extLst>
           </p:cNvPr>
@@ -8215,7 +8215,7 @@
           <p:cNvPr id="4" name="confident. Still wrong.">
             <a:extLst xmlns:a="http://schemas.openxmlformats.org/drawingml/2006/main">
               <a:ext uri="{FF2B5EF4-FFF2-40B4-BE49-F238E27FC236}">
-                <a16:creationId xmlns:a16="http://schemas.microsoft.com/office/drawing/2014/main" id="{735BC8AE-79F5-4A1F-BC83-1A5AF63ACA21}"/>
+                <a16:creationId xmlns:a16="http://schemas.microsoft.com/office/drawing/2014/main" id="{07CB1109-F377-4BCC-90C9-8094F15894D7}"/>
               </a:ext>
             </a:extLst>
           </p:cNvPr>
@@ -8272,7 +8272,7 @@
           <p:cNvPr id="5" name="One observed prediction&#10;Document doc_00750">
             <a:extLst xmlns:a="http://schemas.openxmlformats.org/drawingml/2006/main">
               <a:ext uri="{FF2B5EF4-FFF2-40B4-BE49-F238E27FC236}">
-                <a16:creationId xmlns:a16="http://schemas.microsoft.com/office/drawing/2014/main" id="{FF4EB140-F2A6-465F-9386-945927EB5CAA}"/>
+                <a16:creationId xmlns:a16="http://schemas.microsoft.com/office/drawing/2014/main" id="{A843C850-D544-4E1C-82FF-769AA9888FA2}"/>
               </a:ext>
             </a:extLst>
           </p:cNvPr>
@@ -8352,7 +8352,7 @@
           <p:cNvPr id="6" name="Confident errors">
             <a:extLst xmlns:a="http://schemas.openxmlformats.org/drawingml/2006/main">
               <a:ext uri="{FF2B5EF4-FFF2-40B4-BE49-F238E27FC236}">
-                <a16:creationId xmlns:a16="http://schemas.microsoft.com/office/drawing/2014/main" id="{344BC25B-0B37-4E20-B067-C03D0489772C}"/>
+                <a16:creationId xmlns:a16="http://schemas.microsoft.com/office/drawing/2014/main" id="{96905C6D-DF15-47E7-8FD6-843EC506F931}"/>
               </a:ext>
             </a:extLst>
           </p:cNvPr>
@@ -8409,7 +8409,7 @@
           <p:cNvPr id="7" name="A model can be highly confident about an incorrect">
             <a:extLst xmlns:a="http://schemas.openxmlformats.org/drawingml/2006/main">
               <a:ext uri="{FF2B5EF4-FFF2-40B4-BE49-F238E27FC236}">
-                <a16:creationId xmlns:a16="http://schemas.microsoft.com/office/drawing/2014/main" id="{72921DCB-CA45-49BB-830C-158CB7EF23E4}"/>
+                <a16:creationId xmlns:a16="http://schemas.microsoft.com/office/drawing/2014/main" id="{4C801739-58C2-4B68-9154-53F2AB6FCB51}"/>
               </a:ext>
             </a:extLst>
           </p:cNvPr>
@@ -8466,7 +8466,7 @@
           <p:cNvPr id="8" name="Unstable confidence">
             <a:extLst xmlns:a="http://schemas.openxmlformats.org/drawingml/2006/main">
               <a:ext uri="{FF2B5EF4-FFF2-40B4-BE49-F238E27FC236}">
-                <a16:creationId xmlns:a16="http://schemas.microsoft.com/office/drawing/2014/main" id="{D4154C3F-86E1-4754-A721-BD6FDB2FE7FE}"/>
+                <a16:creationId xmlns:a16="http://schemas.microsoft.com/office/drawing/2014/main" id="{04D4C340-B3B3-4C92-B388-5CC8F9F2B68D}"/>
               </a:ext>
             </a:extLst>
           </p:cNvPr>
@@ -8523,7 +8523,7 @@
           <p:cNvPr id="9" name="Confidence can change across similar inputs withou">
             <a:extLst xmlns:a="http://schemas.openxmlformats.org/drawingml/2006/main">
               <a:ext uri="{FF2B5EF4-FFF2-40B4-BE49-F238E27FC236}">
-                <a16:creationId xmlns:a16="http://schemas.microsoft.com/office/drawing/2014/main" id="{E373731F-A363-415E-AA8A-BE99BC712304}"/>
+                <a16:creationId xmlns:a16="http://schemas.microsoft.com/office/drawing/2014/main" id="{F4945A63-EC2C-4A93-80C3-47AB74EBBE56}"/>
               </a:ext>
             </a:extLst>
           </p:cNvPr>
@@ -8580,7 +8580,7 @@
           <p:cNvPr id="10" name="Increasing difficulty">
             <a:extLst xmlns:a="http://schemas.openxmlformats.org/drawingml/2006/main">
               <a:ext uri="{FF2B5EF4-FFF2-40B4-BE49-F238E27FC236}">
-                <a16:creationId xmlns:a16="http://schemas.microsoft.com/office/drawing/2014/main" id="{10851FBE-B36D-4E54-8D2C-8F0A287F4BB7}"/>
+                <a16:creationId xmlns:a16="http://schemas.microsoft.com/office/drawing/2014/main" id="{4B323598-6AD6-4F15-BD3B-092E182D8CAE}"/>
               </a:ext>
             </a:extLst>
           </p:cNvPr>
@@ -8637,7 +8637,7 @@
           <p:cNvPr id="11" name="Lower confidence may accompany harder inputs. The ">
             <a:extLst xmlns:a="http://schemas.openxmlformats.org/drawingml/2006/main">
               <a:ext uri="{FF2B5EF4-FFF2-40B4-BE49-F238E27FC236}">
-                <a16:creationId xmlns:a16="http://schemas.microsoft.com/office/drawing/2014/main" id="{0093AA87-1CFE-4891-BF20-31B6408AB7F6}"/>
+                <a16:creationId xmlns:a16="http://schemas.microsoft.com/office/drawing/2014/main" id="{61DF0B0F-E520-4A2C-9BF9-518316242AA5}"/>
               </a:ext>
             </a:extLst>
           </p:cNvPr>
@@ -8692,7 +8692,7 @@
     </p:spTree>
     <p:extLst>
       <p:ext uri="{BB962C8B-B14F-4D97-AF65-F5344CB8AC3E}">
-        <p14:creationId xmlns:p14="http://schemas.microsoft.com/office/powerpoint/2010/main" val="427418657"/>
+        <p14:creationId xmlns:p14="http://schemas.microsoft.com/office/powerpoint/2010/main" val="1886111908"/>
       </p:ext>
     </p:extLst>
   </p:cSld>
@@ -8723,7 +8723,7 @@
           <p:cNvPr id="9" name="Research question">
             <a:extLst xmlns:a="http://schemas.openxmlformats.org/drawingml/2006/main">
               <a:ext uri="{FF2B5EF4-FFF2-40B4-BE49-F238E27FC236}">
-                <a16:creationId xmlns:a16="http://schemas.microsoft.com/office/drawing/2014/main" id="{CBB5DDEB-E77B-4D13-97E7-2E0092522A49}"/>
+                <a16:creationId xmlns:a16="http://schemas.microsoft.com/office/drawing/2014/main" id="{58472348-87A7-442A-B72B-1E0D14E25DAA}"/>
               </a:ext>
             </a:extLst>
           </p:cNvPr>
@@ -8780,7 +8780,7 @@
           <p:cNvPr id="2" name="03">
             <a:extLst xmlns:a="http://schemas.openxmlformats.org/drawingml/2006/main">
               <a:ext uri="{FF2B5EF4-FFF2-40B4-BE49-F238E27FC236}">
-                <a16:creationId xmlns:a16="http://schemas.microsoft.com/office/drawing/2014/main" id="{E0D49C05-D6BC-4FBD-A956-462312659FB7}"/>
+                <a16:creationId xmlns:a16="http://schemas.microsoft.com/office/drawing/2014/main" id="{2492CE26-B41E-4238-859F-BCEAEE4350C2}"/>
               </a:ext>
             </a:extLst>
           </p:cNvPr>
@@ -8837,7 +8837,7 @@
           <p:cNvPr id="3" name="Can changes in a model’s confidence">
             <a:extLst xmlns:a="http://schemas.openxmlformats.org/drawingml/2006/main">
               <a:ext uri="{FF2B5EF4-FFF2-40B4-BE49-F238E27FC236}">
-                <a16:creationId xmlns:a16="http://schemas.microsoft.com/office/drawing/2014/main" id="{D44C6F25-E668-4590-897B-39AD320E4595}"/>
+                <a16:creationId xmlns:a16="http://schemas.microsoft.com/office/drawing/2014/main" id="{2DA0B79F-B4FC-4C17-AB4C-DC56A3A2D7B0}"/>
               </a:ext>
             </a:extLst>
           </p:cNvPr>
@@ -8894,7 +8894,7 @@
           <p:cNvPr id="4" name="help identify predictions that are">
             <a:extLst xmlns:a="http://schemas.openxmlformats.org/drawingml/2006/main">
               <a:ext uri="{FF2B5EF4-FFF2-40B4-BE49-F238E27FC236}">
-                <a16:creationId xmlns:a16="http://schemas.microsoft.com/office/drawing/2014/main" id="{23E346B2-446A-4FBF-B209-56FF9FA08286}"/>
+                <a16:creationId xmlns:a16="http://schemas.microsoft.com/office/drawing/2014/main" id="{8330DA6A-702D-4730-9322-39060E81E47D}"/>
               </a:ext>
             </a:extLst>
           </p:cNvPr>
@@ -8951,7 +8951,7 @@
           <p:cNvPr id="5" name="likely to be unreliable?">
             <a:extLst xmlns:a="http://schemas.openxmlformats.org/drawingml/2006/main">
               <a:ext uri="{FF2B5EF4-FFF2-40B4-BE49-F238E27FC236}">
-                <a16:creationId xmlns:a16="http://schemas.microsoft.com/office/drawing/2014/main" id="{093EEE56-96AD-483F-852D-0120EFAF311D}"/>
+                <a16:creationId xmlns:a16="http://schemas.microsoft.com/office/drawing/2014/main" id="{A083C766-66A7-42CC-826A-DDDF5B5A0D7B}"/>
               </a:ext>
             </a:extLst>
           </p:cNvPr>
@@ -9008,7 +9008,7 @@
           <p:cNvPr id="6" name="The hypothesis">
             <a:extLst xmlns:a="http://schemas.openxmlformats.org/drawingml/2006/main">
               <a:ext uri="{FF2B5EF4-FFF2-40B4-BE49-F238E27FC236}">
-                <a16:creationId xmlns:a16="http://schemas.microsoft.com/office/drawing/2014/main" id="{8E3CEFDB-9DF9-4E77-951D-8CE880A1B3F1}"/>
+                <a16:creationId xmlns:a16="http://schemas.microsoft.com/office/drawing/2014/main" id="{65785229-738F-498D-ACD9-0AFD26ED3AE3}"/>
               </a:ext>
             </a:extLst>
           </p:cNvPr>
@@ -9065,7 +9065,7 @@
           <p:cNvPr id="7" name="Confidence history may help predict errors after a">
             <a:extLst xmlns:a="http://schemas.openxmlformats.org/drawingml/2006/main">
               <a:ext uri="{FF2B5EF4-FFF2-40B4-BE49-F238E27FC236}">
-                <a16:creationId xmlns:a16="http://schemas.microsoft.com/office/drawing/2014/main" id="{D558C46F-29B2-47A8-A35C-512CF5D5F24E}"/>
+                <a16:creationId xmlns:a16="http://schemas.microsoft.com/office/drawing/2014/main" id="{78126482-5C37-4898-A5D2-F3BCBF5A2670}"/>
               </a:ext>
             </a:extLst>
           </p:cNvPr>
@@ -9122,7 +9122,7 @@
           <p:cNvPr id="8" name="The A/B/C comparison isolates each additional sour">
             <a:extLst xmlns:a="http://schemas.openxmlformats.org/drawingml/2006/main">
               <a:ext uri="{FF2B5EF4-FFF2-40B4-BE49-F238E27FC236}">
-                <a16:creationId xmlns:a16="http://schemas.microsoft.com/office/drawing/2014/main" id="{0ADEA8BE-F461-4334-9F18-37F2360EE21A}"/>
+                <a16:creationId xmlns:a16="http://schemas.microsoft.com/office/drawing/2014/main" id="{07292AEF-395B-4B60-AE39-2215E019BBFA}"/>
               </a:ext>
             </a:extLst>
           </p:cNvPr>
@@ -9177,7 +9177,7 @@
     </p:spTree>
     <p:extLst>
       <p:ext uri="{BB962C8B-B14F-4D97-AF65-F5344CB8AC3E}">
-        <p14:creationId xmlns:p14="http://schemas.microsoft.com/office/powerpoint/2010/main" val="184059780"/>
+        <p14:creationId xmlns:p14="http://schemas.microsoft.com/office/powerpoint/2010/main" val="1191062582"/>
       </p:ext>
     </p:extLst>
   </p:cSld>
@@ -9208,7 +9208,7 @@
           <p:cNvPr id="13" name="Task and dataset">
             <a:extLst xmlns:a="http://schemas.openxmlformats.org/drawingml/2006/main">
               <a:ext uri="{FF2B5EF4-FFF2-40B4-BE49-F238E27FC236}">
-                <a16:creationId xmlns:a16="http://schemas.microsoft.com/office/drawing/2014/main" id="{D2479BE3-0DE3-4189-9B8C-AF53A65D2419}"/>
+                <a16:creationId xmlns:a16="http://schemas.microsoft.com/office/drawing/2014/main" id="{21D03703-E13D-431C-95E7-EFAA3F8FAD6F}"/>
               </a:ext>
             </a:extLst>
           </p:cNvPr>
@@ -9265,7 +9265,7 @@
           <p:cNvPr id="2" name="04">
             <a:extLst xmlns:a="http://schemas.openxmlformats.org/drawingml/2006/main">
               <a:ext uri="{FF2B5EF4-FFF2-40B4-BE49-F238E27FC236}">
-                <a16:creationId xmlns:a16="http://schemas.microsoft.com/office/drawing/2014/main" id="{F8E87241-623A-490E-A1CF-24647D545F20}"/>
+                <a16:creationId xmlns:a16="http://schemas.microsoft.com/office/drawing/2014/main" id="{F9273FE0-B2BD-4401-8D20-B3FD9C4D6CE1}"/>
               </a:ext>
             </a:extLst>
           </p:cNvPr>
@@ -9322,7 +9322,7 @@
           <p:cNvPr id="3" name="1,754">
             <a:extLst xmlns:a="http://schemas.openxmlformats.org/drawingml/2006/main">
               <a:ext uri="{FF2B5EF4-FFF2-40B4-BE49-F238E27FC236}">
-                <a16:creationId xmlns:a16="http://schemas.microsoft.com/office/drawing/2014/main" id="{7836D0F5-0886-4262-A913-ECB473029D6D}"/>
+                <a16:creationId xmlns:a16="http://schemas.microsoft.com/office/drawing/2014/main" id="{293C3903-A7C2-476F-84D5-DA98B3BB9624}"/>
               </a:ext>
             </a:extLst>
           </p:cNvPr>
@@ -9379,7 +9379,7 @@
           <p:cNvPr id="4" name="documents from 20 Newsgroups">
             <a:extLst xmlns:a="http://schemas.openxmlformats.org/drawingml/2006/main">
               <a:ext uri="{FF2B5EF4-FFF2-40B4-BE49-F238E27FC236}">
-                <a16:creationId xmlns:a16="http://schemas.microsoft.com/office/drawing/2014/main" id="{CF93DDE4-53C3-4DD5-94EE-2202D6147D0C}"/>
+                <a16:creationId xmlns:a16="http://schemas.microsoft.com/office/drawing/2014/main" id="{F952F751-265E-4F97-A72D-7FA47E740316}"/>
               </a:ext>
             </a:extLst>
           </p:cNvPr>
@@ -9436,7 +9436,7 @@
           <p:cNvPr id="5" name="1,315 training / 439 test">
             <a:extLst xmlns:a="http://schemas.openxmlformats.org/drawingml/2006/main">
               <a:ext uri="{FF2B5EF4-FFF2-40B4-BE49-F238E27FC236}">
-                <a16:creationId xmlns:a16="http://schemas.microsoft.com/office/drawing/2014/main" id="{C4B99F11-BD5A-4D4E-BB32-ACC8BDDD454B}"/>
+                <a16:creationId xmlns:a16="http://schemas.microsoft.com/office/drawing/2014/main" id="{4A0199E0-95AC-4BBF-AA00-13A1BC44A695}"/>
               </a:ext>
             </a:extLst>
           </p:cNvPr>
@@ -9493,7 +9493,7 @@
           <p:cNvPr id="6" name="Stratified split&#10;44.4% / 55.6% class balance">
             <a:extLst xmlns:a="http://schemas.openxmlformats.org/drawingml/2006/main">
               <a:ext uri="{FF2B5EF4-FFF2-40B4-BE49-F238E27FC236}">
-                <a16:creationId xmlns:a16="http://schemas.microsoft.com/office/drawing/2014/main" id="{038A4AE5-9767-406B-BB78-FC6B3C2C3693}"/>
+                <a16:creationId xmlns:a16="http://schemas.microsoft.com/office/drawing/2014/main" id="{16921DC7-041F-4A89-8203-F7F940CA673B}"/>
               </a:ext>
             </a:extLst>
           </p:cNvPr>
@@ -9573,7 +9573,7 @@
           <p:cNvPr id="7" name="Binary text classification">
             <a:extLst xmlns:a="http://schemas.openxmlformats.org/drawingml/2006/main">
               <a:ext uri="{FF2B5EF4-FFF2-40B4-BE49-F238E27FC236}">
-                <a16:creationId xmlns:a16="http://schemas.microsoft.com/office/drawing/2014/main" id="{F2EFE2ED-FC92-4A84-A743-8D491D907E18}"/>
+                <a16:creationId xmlns:a16="http://schemas.microsoft.com/office/drawing/2014/main" id="{DB558CAD-41BB-4642-AB86-EC473F5725B8}"/>
               </a:ext>
             </a:extLst>
           </p:cNvPr>
@@ -9630,7 +9630,7 @@
           <p:cNvPr id="8" name="alt.atheism&#10;soc.religion.christian">
             <a:extLst xmlns:a="http://schemas.openxmlformats.org/drawingml/2006/main">
               <a:ext uri="{FF2B5EF4-FFF2-40B4-BE49-F238E27FC236}">
-                <a16:creationId xmlns:a16="http://schemas.microsoft.com/office/drawing/2014/main" id="{A7936AE6-2FE2-4D73-BC05-405151D77390}"/>
+                <a16:creationId xmlns:a16="http://schemas.microsoft.com/office/drawing/2014/main" id="{EBF882FD-3B21-47F5-8237-C96CB91617D1}"/>
               </a:ext>
             </a:extLst>
           </p:cNvPr>
@@ -9710,7 +9710,7 @@
           <p:cNvPr id="9" name="Overlapping vocabulary makes the task less trivial">
             <a:extLst xmlns:a="http://schemas.openxmlformats.org/drawingml/2006/main">
               <a:ext uri="{FF2B5EF4-FFF2-40B4-BE49-F238E27FC236}">
-                <a16:creationId xmlns:a16="http://schemas.microsoft.com/office/drawing/2014/main" id="{81B8A87B-3208-49AD-9B04-C416982FEA19}"/>
+                <a16:creationId xmlns:a16="http://schemas.microsoft.com/office/drawing/2014/main" id="{4E97AF2E-C98A-41DB-8796-FFC6B1BB7C4F}"/>
               </a:ext>
             </a:extLst>
           </p:cNvPr>
@@ -9767,7 +9767,7 @@
           <p:cNvPr id="10" name="Headers, footers and quoted text removed to reduce">
             <a:extLst xmlns:a="http://schemas.openxmlformats.org/drawingml/2006/main">
               <a:ext uri="{FF2B5EF4-FFF2-40B4-BE49-F238E27FC236}">
-                <a16:creationId xmlns:a16="http://schemas.microsoft.com/office/drawing/2014/main" id="{020B8458-D3CA-4DC7-8145-3B492011585E}"/>
+                <a16:creationId xmlns:a16="http://schemas.microsoft.com/office/drawing/2014/main" id="{F9B65DF1-82AA-483F-AA9F-8085E7F62892}"/>
               </a:ext>
             </a:extLst>
           </p:cNvPr>
@@ -9824,7 +9824,7 @@
           <p:cNvPr id="11" name="Ground truth: the newsgroup that published each po">
             <a:extLst xmlns:a="http://schemas.openxmlformats.org/drawingml/2006/main">
               <a:ext uri="{FF2B5EF4-FFF2-40B4-BE49-F238E27FC236}">
-                <a16:creationId xmlns:a16="http://schemas.microsoft.com/office/drawing/2014/main" id="{588B0FCD-15F8-43C4-A043-4CC3AC6F3C35}"/>
+                <a16:creationId xmlns:a16="http://schemas.microsoft.com/office/drawing/2014/main" id="{3D642DD1-5F8D-48C4-BCB3-CE734A66E63B}"/>
               </a:ext>
             </a:extLst>
           </p:cNvPr>
@@ -9881,7 +9881,7 @@
           <p:cNvPr id="12" name="Source: scikit-learn’s official 20 Newsgroups mirr">
             <a:extLst xmlns:a="http://schemas.openxmlformats.org/drawingml/2006/main">
               <a:ext uri="{FF2B5EF4-FFF2-40B4-BE49-F238E27FC236}">
-                <a16:creationId xmlns:a16="http://schemas.microsoft.com/office/drawing/2014/main" id="{6CE91A94-1098-447B-8661-DD33C71A2E64}"/>
+                <a16:creationId xmlns:a16="http://schemas.microsoft.com/office/drawing/2014/main" id="{91A9E6B5-CF52-43A2-B965-8B9713955378}"/>
               </a:ext>
             </a:extLst>
           </p:cNvPr>
@@ -9936,7 +9936,7 @@
     </p:spTree>
     <p:extLst>
       <p:ext uri="{BB962C8B-B14F-4D97-AF65-F5344CB8AC3E}">
-        <p14:creationId xmlns:p14="http://schemas.microsoft.com/office/powerpoint/2010/main" val="1540259215"/>
+        <p14:creationId xmlns:p14="http://schemas.microsoft.com/office/powerpoint/2010/main" val="1853422512"/>
       </p:ext>
     </p:extLst>
   </p:cSld>
@@ -9967,7 +9967,7 @@
           <p:cNvPr id="18" name="The research pipeline">
             <a:extLst xmlns:a="http://schemas.openxmlformats.org/drawingml/2006/main">
               <a:ext uri="{FF2B5EF4-FFF2-40B4-BE49-F238E27FC236}">
-                <a16:creationId xmlns:a16="http://schemas.microsoft.com/office/drawing/2014/main" id="{BA1C75B5-2054-4EBB-8FC4-4C8C351D7A2A}"/>
+                <a16:creationId xmlns:a16="http://schemas.microsoft.com/office/drawing/2014/main" id="{3970595B-8B48-4FFC-8335-4A9766F8ECD8}"/>
               </a:ext>
             </a:extLst>
           </p:cNvPr>
@@ -10024,7 +10024,7 @@
           <p:cNvPr id="2" name="05">
             <a:extLst xmlns:a="http://schemas.openxmlformats.org/drawingml/2006/main">
               <a:ext uri="{FF2B5EF4-FFF2-40B4-BE49-F238E27FC236}">
-                <a16:creationId xmlns:a16="http://schemas.microsoft.com/office/drawing/2014/main" id="{50254A2F-D584-4012-AD57-D76D0C084C05}"/>
+                <a16:creationId xmlns:a16="http://schemas.microsoft.com/office/drawing/2014/main" id="{0994DDC9-3CBF-45D7-A0ED-26B908E3FC86}"/>
               </a:ext>
             </a:extLst>
           </p:cNvPr>
@@ -10081,7 +10081,7 @@
           <p:cNvPr id="3" name="01">
             <a:extLst xmlns:a="http://schemas.openxmlformats.org/drawingml/2006/main">
               <a:ext uri="{FF2B5EF4-FFF2-40B4-BE49-F238E27FC236}">
-                <a16:creationId xmlns:a16="http://schemas.microsoft.com/office/drawing/2014/main" id="{29CACF53-D3BA-48BF-89BA-37DBCBB2D4E9}"/>
+                <a16:creationId xmlns:a16="http://schemas.microsoft.com/office/drawing/2014/main" id="{2C8E6E76-AA4C-4132-971C-D8C239A2CB0A}"/>
               </a:ext>
             </a:extLst>
           </p:cNvPr>
@@ -10138,7 +10138,7 @@
           <p:cNvPr id="4" name="Train the base classifier">
             <a:extLst xmlns:a="http://schemas.openxmlformats.org/drawingml/2006/main">
               <a:ext uri="{FF2B5EF4-FFF2-40B4-BE49-F238E27FC236}">
-                <a16:creationId xmlns:a16="http://schemas.microsoft.com/office/drawing/2014/main" id="{EDB2E9DD-3677-4533-94C5-3BA5A6401E7E}"/>
+                <a16:creationId xmlns:a16="http://schemas.microsoft.com/office/drawing/2014/main" id="{39BC151E-B7A4-4A3E-B397-576F84898600}"/>
               </a:ext>
             </a:extLst>
           </p:cNvPr>
@@ -10195,7 +10195,7 @@
           <p:cNvPr id="5" name="TF-IDF + Logistic Regression for text classificati">
             <a:extLst xmlns:a="http://schemas.openxmlformats.org/drawingml/2006/main">
               <a:ext uri="{FF2B5EF4-FFF2-40B4-BE49-F238E27FC236}">
-                <a16:creationId xmlns:a16="http://schemas.microsoft.com/office/drawing/2014/main" id="{DABD8C5A-71A2-44C6-B66E-646A6EA7BF35}"/>
+                <a16:creationId xmlns:a16="http://schemas.microsoft.com/office/drawing/2014/main" id="{586BBE23-7739-43CA-978D-66BA25CA9E8F}"/>
               </a:ext>
             </a:extLst>
           </p:cNvPr>
@@ -10252,7 +10252,7 @@
           <p:cNvPr id="6" name="02">
             <a:extLst xmlns:a="http://schemas.openxmlformats.org/drawingml/2006/main">
               <a:ext uri="{FF2B5EF4-FFF2-40B4-BE49-F238E27FC236}">
-                <a16:creationId xmlns:a16="http://schemas.microsoft.com/office/drawing/2014/main" id="{3717B9A7-FF26-4A96-B9DE-626A91253845}"/>
+                <a16:creationId xmlns:a16="http://schemas.microsoft.com/office/drawing/2014/main" id="{EA27FC8B-D369-45AC-AFE6-BAF8F4E2B6F5}"/>
               </a:ext>
             </a:extLst>
           </p:cNvPr>
@@ -10309,7 +10309,7 @@
           <p:cNvPr id="7" name="Generate confidence sequences">
             <a:extLst xmlns:a="http://schemas.openxmlformats.org/drawingml/2006/main">
               <a:ext uri="{FF2B5EF4-FFF2-40B4-BE49-F238E27FC236}">
-                <a16:creationId xmlns:a16="http://schemas.microsoft.com/office/drawing/2014/main" id="{86E00576-0C47-4273-ABFA-9A8C153F6255}"/>
+                <a16:creationId xmlns:a16="http://schemas.microsoft.com/office/drawing/2014/main" id="{9D91D879-8C29-4438-8427-AF06389CD2CF}"/>
               </a:ext>
             </a:extLst>
           </p:cNvPr>
@@ -10366,7 +10366,7 @@
           <p:cNvPr id="8" name="Re-classify each test document at six corruption l">
             <a:extLst xmlns:a="http://schemas.openxmlformats.org/drawingml/2006/main">
               <a:ext uri="{FF2B5EF4-FFF2-40B4-BE49-F238E27FC236}">
-                <a16:creationId xmlns:a16="http://schemas.microsoft.com/office/drawing/2014/main" id="{063DBAD6-CC1F-4835-8B54-38803F3786CD}"/>
+                <a16:creationId xmlns:a16="http://schemas.microsoft.com/office/drawing/2014/main" id="{EBE5FB04-B099-41DF-A324-53E519DB16F8}"/>
               </a:ext>
             </a:extLst>
           </p:cNvPr>
@@ -10423,7 +10423,7 @@
           <p:cNvPr id="9" name="03">
             <a:extLst xmlns:a="http://schemas.openxmlformats.org/drawingml/2006/main">
               <a:ext uri="{FF2B5EF4-FFF2-40B4-BE49-F238E27FC236}">
-                <a16:creationId xmlns:a16="http://schemas.microsoft.com/office/drawing/2014/main" id="{64F98C74-F0B1-4B30-8E52-228FB752EDF0}"/>
+                <a16:creationId xmlns:a16="http://schemas.microsoft.com/office/drawing/2014/main" id="{552224B7-B064-48A8-B2C4-1B5E82E1BF81}"/>
               </a:ext>
             </a:extLst>
           </p:cNvPr>
@@ -10480,7 +10480,7 @@
           <p:cNvPr id="10" name="Engineer drift features">
             <a:extLst xmlns:a="http://schemas.openxmlformats.org/drawingml/2006/main">
               <a:ext uri="{FF2B5EF4-FFF2-40B4-BE49-F238E27FC236}">
-                <a16:creationId xmlns:a16="http://schemas.microsoft.com/office/drawing/2014/main" id="{F9AC82F7-F82B-4F9A-B7EF-25C2A715F440}"/>
+                <a16:creationId xmlns:a16="http://schemas.microsoft.com/office/drawing/2014/main" id="{7F41644A-8E22-43A3-92D3-B09CC5861EC2}"/>
               </a:ext>
             </a:extLst>
           </p:cNvPr>
@@ -10537,7 +10537,7 @@
           <p:cNvPr id="11" name="Moving statistics, deltas, consecutive drops and m">
             <a:extLst xmlns:a="http://schemas.openxmlformats.org/drawingml/2006/main">
               <a:ext uri="{FF2B5EF4-FFF2-40B4-BE49-F238E27FC236}">
-                <a16:creationId xmlns:a16="http://schemas.microsoft.com/office/drawing/2014/main" id="{91896094-D077-4A34-A88F-015D00ADE009}"/>
+                <a16:creationId xmlns:a16="http://schemas.microsoft.com/office/drawing/2014/main" id="{99F4AEC2-F9CD-4301-A1FB-471047F20A4D}"/>
               </a:ext>
             </a:extLst>
           </p:cNvPr>
@@ -10594,7 +10594,7 @@
           <p:cNvPr id="12" name="04">
             <a:extLst xmlns:a="http://schemas.openxmlformats.org/drawingml/2006/main">
               <a:ext uri="{FF2B5EF4-FFF2-40B4-BE49-F238E27FC236}">
-                <a16:creationId xmlns:a16="http://schemas.microsoft.com/office/drawing/2014/main" id="{0C436AE3-DABB-4F82-A297-ADAD75E379D1}"/>
+                <a16:creationId xmlns:a16="http://schemas.microsoft.com/office/drawing/2014/main" id="{2961C820-C2C9-49CD-ACDF-9A2BF4A08A0B}"/>
               </a:ext>
             </a:extLst>
           </p:cNvPr>
@@ -10651,7 +10651,7 @@
           <p:cNvPr id="13" name="Train a second model">
             <a:extLst xmlns:a="http://schemas.openxmlformats.org/drawingml/2006/main">
               <a:ext uri="{FF2B5EF4-FFF2-40B4-BE49-F238E27FC236}">
-                <a16:creationId xmlns:a16="http://schemas.microsoft.com/office/drawing/2014/main" id="{2BFBD160-1D01-4D92-93BC-B84E4C2CBE74}"/>
+                <a16:creationId xmlns:a16="http://schemas.microsoft.com/office/drawing/2014/main" id="{20DDF2FB-0041-4694-B286-842145EA3B65}"/>
               </a:ext>
             </a:extLst>
           </p:cNvPr>
@@ -10708,7 +10708,7 @@
           <p:cNvPr id="14" name="Predict whether a classification is unreliable.">
             <a:extLst xmlns:a="http://schemas.openxmlformats.org/drawingml/2006/main">
               <a:ext uri="{FF2B5EF4-FFF2-40B4-BE49-F238E27FC236}">
-                <a16:creationId xmlns:a16="http://schemas.microsoft.com/office/drawing/2014/main" id="{F0159E9C-7051-4854-AD7F-0C51B4EEEE9E}"/>
+                <a16:creationId xmlns:a16="http://schemas.microsoft.com/office/drawing/2014/main" id="{43BC1943-42CF-4000-944F-26B46CB39F11}"/>
               </a:ext>
             </a:extLst>
           </p:cNvPr>
@@ -10765,7 +10765,7 @@
           <p:cNvPr id="15" name="05">
             <a:extLst xmlns:a="http://schemas.openxmlformats.org/drawingml/2006/main">
               <a:ext uri="{FF2B5EF4-FFF2-40B4-BE49-F238E27FC236}">
-                <a16:creationId xmlns:a16="http://schemas.microsoft.com/office/drawing/2014/main" id="{F4C5BE3F-E388-403C-ADB5-B8D16FA97114}"/>
+                <a16:creationId xmlns:a16="http://schemas.microsoft.com/office/drawing/2014/main" id="{88861118-81EE-4DB7-AF15-5A09F2560CEB}"/>
               </a:ext>
             </a:extLst>
           </p:cNvPr>
@@ -10822,7 +10822,7 @@
           <p:cNvPr id="16" name="Evaluate the detector">
             <a:extLst xmlns:a="http://schemas.openxmlformats.org/drawingml/2006/main">
               <a:ext uri="{FF2B5EF4-FFF2-40B4-BE49-F238E27FC236}">
-                <a16:creationId xmlns:a16="http://schemas.microsoft.com/office/drawing/2014/main" id="{7B57767A-ADE8-4598-8328-1A9946A5EC23}"/>
+                <a16:creationId xmlns:a16="http://schemas.microsoft.com/office/drawing/2014/main" id="{8BB219B4-3CAD-4115-A69D-756BB5133953}"/>
               </a:ext>
             </a:extLst>
           </p:cNvPr>
@@ -10879,7 +10879,7 @@
           <p:cNvPr id="17" name="Calibration, high-confidence errors and an A/B/C c">
             <a:extLst xmlns:a="http://schemas.openxmlformats.org/drawingml/2006/main">
               <a:ext uri="{FF2B5EF4-FFF2-40B4-BE49-F238E27FC236}">
-                <a16:creationId xmlns:a16="http://schemas.microsoft.com/office/drawing/2014/main" id="{85A2B197-5486-4629-8012-C9A7CC320872}"/>
+                <a16:creationId xmlns:a16="http://schemas.microsoft.com/office/drawing/2014/main" id="{46C07F64-E499-44C0-B8F1-34911C29EA20}"/>
               </a:ext>
             </a:extLst>
           </p:cNvPr>
@@ -10934,7 +10934,7 @@
     </p:spTree>
     <p:extLst>
       <p:ext uri="{BB962C8B-B14F-4D97-AF65-F5344CB8AC3E}">
-        <p14:creationId xmlns:p14="http://schemas.microsoft.com/office/powerpoint/2010/main" val="1788209782"/>
+        <p14:creationId xmlns:p14="http://schemas.microsoft.com/office/powerpoint/2010/main" val="724521734"/>
       </p:ext>
     </p:extLst>
   </p:cSld>
@@ -10965,7 +10965,7 @@
           <p:cNvPr id="12" name="How confidence changes">
             <a:extLst xmlns:a="http://schemas.openxmlformats.org/drawingml/2006/main">
               <a:ext uri="{FF2B5EF4-FFF2-40B4-BE49-F238E27FC236}">
-                <a16:creationId xmlns:a16="http://schemas.microsoft.com/office/drawing/2014/main" id="{6B8B20E9-A271-452F-86DB-B3E66775F619}"/>
+                <a16:creationId xmlns:a16="http://schemas.microsoft.com/office/drawing/2014/main" id="{213D2C44-1100-4771-BEDC-3C557F53BAE9}"/>
               </a:ext>
             </a:extLst>
           </p:cNvPr>
@@ -11022,7 +11022,7 @@
           <p:cNvPr id="2" name="06">
             <a:extLst xmlns:a="http://schemas.openxmlformats.org/drawingml/2006/main">
               <a:ext uri="{FF2B5EF4-FFF2-40B4-BE49-F238E27FC236}">
-                <a16:creationId xmlns:a16="http://schemas.microsoft.com/office/drawing/2014/main" id="{E60B5DBE-3E47-4206-A647-28CDC0A16DCA}"/>
+                <a16:creationId xmlns:a16="http://schemas.microsoft.com/office/drawing/2014/main" id="{FA5547FF-FFC1-4299-858E-B3B2067D1DBB}"/>
               </a:ext>
             </a:extLst>
           </p:cNvPr>
@@ -11079,7 +11079,7 @@
           <p:cNvPr id="3" name="Six levels, from 0% to 50% of words removed and sh">
             <a:extLst xmlns:a="http://schemas.openxmlformats.org/drawingml/2006/main">
               <a:ext uri="{FF2B5EF4-FFF2-40B4-BE49-F238E27FC236}">
-                <a16:creationId xmlns:a16="http://schemas.microsoft.com/office/drawing/2014/main" id="{8DA14C6D-8653-45E6-AB69-85B962A69EC7}"/>
+                <a16:creationId xmlns:a16="http://schemas.microsoft.com/office/drawing/2014/main" id="{0534498B-4CB9-44DD-9E17-990450EF3817}"/>
               </a:ext>
             </a:extLst>
           </p:cNvPr>
@@ -11136,7 +11136,7 @@
           <p:cNvPr id="4" name="Two contrasting examples">
             <a:extLst xmlns:a="http://schemas.openxmlformats.org/drawingml/2006/main">
               <a:ext uri="{FF2B5EF4-FFF2-40B4-BE49-F238E27FC236}">
-                <a16:creationId xmlns:a16="http://schemas.microsoft.com/office/drawing/2014/main" id="{B61330A4-8D47-494C-B3B1-474E7B8B535A}"/>
+                <a16:creationId xmlns:a16="http://schemas.microsoft.com/office/drawing/2014/main" id="{3D594434-4F1B-4524-B962-E05727188478}"/>
               </a:ext>
             </a:extLst>
           </p:cNvPr>
@@ -11776,7 +11776,7 @@
           <p:cNvPr id="6" name="Stayed wrong">
             <a:extLst xmlns:a="http://schemas.openxmlformats.org/drawingml/2006/main">
               <a:ext uri="{FF2B5EF4-FFF2-40B4-BE49-F238E27FC236}">
-                <a16:creationId xmlns:a16="http://schemas.microsoft.com/office/drawing/2014/main" id="{6B8F4928-6F78-404F-9340-76AF4E135986}"/>
+                <a16:creationId xmlns:a16="http://schemas.microsoft.com/office/drawing/2014/main" id="{29D5E26A-3BA4-490B-AB92-E2AB48F76161}"/>
               </a:ext>
             </a:extLst>
           </p:cNvPr>
@@ -11833,7 +11833,7 @@
           <p:cNvPr id="7" name="Stayed correct">
             <a:extLst xmlns:a="http://schemas.openxmlformats.org/drawingml/2006/main">
               <a:ext uri="{FF2B5EF4-FFF2-40B4-BE49-F238E27FC236}">
-                <a16:creationId xmlns:a16="http://schemas.microsoft.com/office/drawing/2014/main" id="{F731E95B-0F03-4343-B59F-1B3AA8ABC591}"/>
+                <a16:creationId xmlns:a16="http://schemas.microsoft.com/office/drawing/2014/main" id="{DE1EFE2A-C78A-44D0-88F2-E006403A4948}"/>
               </a:ext>
             </a:extLst>
           </p:cNvPr>
@@ -11890,7 +11890,7 @@
           <p:cNvPr id="8" name="Confidence">
             <a:extLst xmlns:a="http://schemas.openxmlformats.org/drawingml/2006/main">
               <a:ext uri="{FF2B5EF4-FFF2-40B4-BE49-F238E27FC236}">
-                <a16:creationId xmlns:a16="http://schemas.microsoft.com/office/drawing/2014/main" id="{A1030F70-C158-4C53-9036-EBC0461D72B9}"/>
+                <a16:creationId xmlns:a16="http://schemas.microsoft.com/office/drawing/2014/main" id="{6BC2F43A-B588-4C70-821E-9A9B1594F9DC}"/>
               </a:ext>
             </a:extLst>
           </p:cNvPr>
@@ -11954,7 +11954,7 @@
         </p:xfrm>
         <a:graphic xmlns:a="http://schemas.openxmlformats.org/drawingml/2006/main">
           <a:graphicData uri="http://schemas.openxmlformats.org/drawingml/2006/chart">
-            <c:chart xmlns:r="http://schemas.openxmlformats.org/officeDocument/2006/relationships" xmlns:c="http://schemas.openxmlformats.org/drawingml/2006/chart" r:id="R149896512c7d4b01"/>
+            <c:chart xmlns:r="http://schemas.openxmlformats.org/officeDocument/2006/relationships" xmlns:c="http://schemas.openxmlformats.org/drawingml/2006/chart" r:id="R4c69fd283f3248d0"/>
           </a:graphicData>
         </a:graphic>
       </p:graphicFrame>
@@ -11963,7 +11963,7 @@
           <p:cNvPr id="10" name="12 test documents. Green: correct at the final ste">
             <a:extLst xmlns:a="http://schemas.openxmlformats.org/drawingml/2006/main">
               <a:ext uri="{FF2B5EF4-FFF2-40B4-BE49-F238E27FC236}">
-                <a16:creationId xmlns:a16="http://schemas.microsoft.com/office/drawing/2014/main" id="{A0DF926F-7B70-4989-ADA1-C4643A89F397}"/>
+                <a16:creationId xmlns:a16="http://schemas.microsoft.com/office/drawing/2014/main" id="{33959C52-CF5A-485E-91E2-0559FBB7FB8F}"/>
               </a:ext>
             </a:extLst>
           </p:cNvPr>
@@ -12020,7 +12020,7 @@
           <p:cNvPr id="11" name="Sequences simulate repeated predictions through te">
             <a:extLst xmlns:a="http://schemas.openxmlformats.org/drawingml/2006/main">
               <a:ext uri="{FF2B5EF4-FFF2-40B4-BE49-F238E27FC236}">
-                <a16:creationId xmlns:a16="http://schemas.microsoft.com/office/drawing/2014/main" id="{FB940171-0A88-4955-AD56-91F4CBC3243F}"/>
+                <a16:creationId xmlns:a16="http://schemas.microsoft.com/office/drawing/2014/main" id="{57DCE6D2-4E69-4185-B422-388F92771ADE}"/>
               </a:ext>
             </a:extLst>
           </p:cNvPr>
@@ -12075,7 +12075,7 @@
     </p:spTree>
     <p:extLst>
       <p:ext uri="{BB962C8B-B14F-4D97-AF65-F5344CB8AC3E}">
-        <p14:creationId xmlns:p14="http://schemas.microsoft.com/office/powerpoint/2010/main" val="635889961"/>
+        <p14:creationId xmlns:p14="http://schemas.microsoft.com/office/powerpoint/2010/main" val="1588539703"/>
       </p:ext>
     </p:extLst>
   </p:cSld>
@@ -12106,7 +12106,7 @@
           <p:cNvPr id="5" name="Anatomy of a confidence sequence">
             <a:extLst xmlns:a="http://schemas.openxmlformats.org/drawingml/2006/main">
               <a:ext uri="{FF2B5EF4-FFF2-40B4-BE49-F238E27FC236}">
-                <a16:creationId xmlns:a16="http://schemas.microsoft.com/office/drawing/2014/main" id="{85AB06E6-13AE-4F60-8E7D-6DCC5C5FDA83}"/>
+                <a16:creationId xmlns:a16="http://schemas.microsoft.com/office/drawing/2014/main" id="{AAC6C9A2-32C8-4907-AF70-2830B04B810C}"/>
               </a:ext>
             </a:extLst>
           </p:cNvPr>
@@ -12163,7 +12163,7 @@
           <p:cNvPr id="2" name="07">
             <a:extLst xmlns:a="http://schemas.openxmlformats.org/drawingml/2006/main">
               <a:ext uri="{FF2B5EF4-FFF2-40B4-BE49-F238E27FC236}">
-                <a16:creationId xmlns:a16="http://schemas.microsoft.com/office/drawing/2014/main" id="{6E20C1A7-88B4-4E16-9BFF-294E1E18E5D7}"/>
+                <a16:creationId xmlns:a16="http://schemas.microsoft.com/office/drawing/2014/main" id="{D2D3D905-240F-4C80-920B-CE139155DC70}"/>
               </a:ext>
             </a:extLst>
           </p:cNvPr>
@@ -12220,7 +12220,7 @@
           <p:cNvPr id="3" name="13 features, compared with simpler baselines in th">
             <a:extLst xmlns:a="http://schemas.openxmlformats.org/drawingml/2006/main">
               <a:ext uri="{FF2B5EF4-FFF2-40B4-BE49-F238E27FC236}">
-                <a16:creationId xmlns:a16="http://schemas.microsoft.com/office/drawing/2014/main" id="{0F409EE8-164E-4130-BB6D-BC7AE46A4573}"/>
+                <a16:creationId xmlns:a16="http://schemas.microsoft.com/office/drawing/2014/main" id="{AAC05166-F06E-432F-AC9E-EB57D9BADD35}"/>
               </a:ext>
             </a:extLst>
           </p:cNvPr>
@@ -12593,7 +12593,7 @@
     </p:spTree>
     <p:extLst>
       <p:ext uri="{BB962C8B-B14F-4D97-AF65-F5344CB8AC3E}">
-        <p14:creationId xmlns:p14="http://schemas.microsoft.com/office/powerpoint/2010/main" val="999914729"/>
+        <p14:creationId xmlns:p14="http://schemas.microsoft.com/office/powerpoint/2010/main" val="229657840"/>
       </p:ext>
     </p:extLst>
   </p:cSld>
@@ -12624,7 +12624,7 @@
           <p:cNvPr id="7" name="Confidence carries signal">
             <a:extLst xmlns:a="http://schemas.openxmlformats.org/drawingml/2006/main">
               <a:ext uri="{FF2B5EF4-FFF2-40B4-BE49-F238E27FC236}">
-                <a16:creationId xmlns:a16="http://schemas.microsoft.com/office/drawing/2014/main" id="{5AFFAB4E-1395-42C3-B6B7-BB0007AEB5B2}"/>
+                <a16:creationId xmlns:a16="http://schemas.microsoft.com/office/drawing/2014/main" id="{A95A3679-0278-4B0F-A4C5-24CFF40E009B}"/>
               </a:ext>
             </a:extLst>
           </p:cNvPr>
@@ -12681,7 +12681,7 @@
           <p:cNvPr id="2" name="08">
             <a:extLst xmlns:a="http://schemas.openxmlformats.org/drawingml/2006/main">
               <a:ext uri="{FF2B5EF4-FFF2-40B4-BE49-F238E27FC236}">
-                <a16:creationId xmlns:a16="http://schemas.microsoft.com/office/drawing/2014/main" id="{BBEE5295-9367-44E3-AE2C-9541577955D3}"/>
+                <a16:creationId xmlns:a16="http://schemas.microsoft.com/office/drawing/2014/main" id="{D66B9833-8274-4A48-B62A-37972DD8BB07}"/>
               </a:ext>
             </a:extLst>
           </p:cNvPr>
@@ -12738,7 +12738,7 @@
           <p:cNvPr id="3" name="Accuracy across 439 uncorrupted test predictions">
             <a:extLst xmlns:a="http://schemas.openxmlformats.org/drawingml/2006/main">
               <a:ext uri="{FF2B5EF4-FFF2-40B4-BE49-F238E27FC236}">
-                <a16:creationId xmlns:a16="http://schemas.microsoft.com/office/drawing/2014/main" id="{272BDF23-2D50-487E-B4FD-2253DDE63272}"/>
+                <a16:creationId xmlns:a16="http://schemas.microsoft.com/office/drawing/2014/main" id="{EAE97B35-993B-49BA-AC22-8A2BF0BF4A44}"/>
               </a:ext>
             </a:extLst>
           </p:cNvPr>
@@ -12802,7 +12802,7 @@
         </p:xfrm>
         <a:graphic xmlns:a="http://schemas.openxmlformats.org/drawingml/2006/main">
           <a:graphicData uri="http://schemas.openxmlformats.org/drawingml/2006/chart">
-            <c:chart xmlns:r="http://schemas.openxmlformats.org/officeDocument/2006/relationships" xmlns:c="http://schemas.openxmlformats.org/drawingml/2006/chart" r:id="Rd3981c917bbf4443"/>
+            <c:chart xmlns:r="http://schemas.openxmlformats.org/officeDocument/2006/relationships" xmlns:c="http://schemas.openxmlformats.org/drawingml/2006/chart" r:id="R7f040855daaa47a6"/>
           </a:graphicData>
         </a:graphic>
       </p:graphicFrame>
@@ -13154,7 +13154,7 @@
           <p:cNvPr id="6" name="Confidence carries signal, but calibration remains">
             <a:extLst xmlns:a="http://schemas.openxmlformats.org/drawingml/2006/main">
               <a:ext uri="{FF2B5EF4-FFF2-40B4-BE49-F238E27FC236}">
-                <a16:creationId xmlns:a16="http://schemas.microsoft.com/office/drawing/2014/main" id="{76BF509B-373D-406B-BEF7-66FC564A764B}"/>
+                <a16:creationId xmlns:a16="http://schemas.microsoft.com/office/drawing/2014/main" id="{66D4B36E-C3F7-47CE-95D1-E55AFB0E9EF6}"/>
               </a:ext>
             </a:extLst>
           </p:cNvPr>
@@ -13209,7 +13209,7 @@
     </p:spTree>
     <p:extLst>
       <p:ext uri="{BB962C8B-B14F-4D97-AF65-F5344CB8AC3E}">
-        <p14:creationId xmlns:p14="http://schemas.microsoft.com/office/powerpoint/2010/main" val="669702002"/>
+        <p14:creationId xmlns:p14="http://schemas.microsoft.com/office/powerpoint/2010/main" val="1220952119"/>
       </p:ext>
     </p:extLst>
   </p:cSld>
@@ -13240,7 +13240,7 @@
           <p:cNvPr id="12" name="The calibration gap">
             <a:extLst xmlns:a="http://schemas.openxmlformats.org/drawingml/2006/main">
               <a:ext uri="{FF2B5EF4-FFF2-40B4-BE49-F238E27FC236}">
-                <a16:creationId xmlns:a16="http://schemas.microsoft.com/office/drawing/2014/main" id="{201379CF-6D14-4158-AB18-A28F7AE1BD96}"/>
+                <a16:creationId xmlns:a16="http://schemas.microsoft.com/office/drawing/2014/main" id="{D19D27C3-18A8-4573-854B-222F8E53D4B2}"/>
               </a:ext>
             </a:extLst>
           </p:cNvPr>
@@ -13297,7 +13297,7 @@
           <p:cNvPr id="2" name="09">
             <a:extLst xmlns:a="http://schemas.openxmlformats.org/drawingml/2006/main">
               <a:ext uri="{FF2B5EF4-FFF2-40B4-BE49-F238E27FC236}">
-                <a16:creationId xmlns:a16="http://schemas.microsoft.com/office/drawing/2014/main" id="{4711BE1E-E071-4C73-AD74-A0618834A156}"/>
+                <a16:creationId xmlns:a16="http://schemas.microsoft.com/office/drawing/2014/main" id="{13AA1B26-1A63-4599-AC84-10BB2AB7039F}"/>
               </a:ext>
             </a:extLst>
           </p:cNvPr>
@@ -13354,7 +13354,7 @@
           <p:cNvPr id="3" name="Reliability diagram for uncorrupted test predictio">
             <a:extLst xmlns:a="http://schemas.openxmlformats.org/drawingml/2006/main">
               <a:ext uri="{FF2B5EF4-FFF2-40B4-BE49-F238E27FC236}">
-                <a16:creationId xmlns:a16="http://schemas.microsoft.com/office/drawing/2014/main" id="{C1362DB0-0BD7-404F-8B17-67D43AB51ABF}"/>
+                <a16:creationId xmlns:a16="http://schemas.microsoft.com/office/drawing/2014/main" id="{5773BBE6-EC46-4C0D-8E0E-05D43DBF38C5}"/>
               </a:ext>
             </a:extLst>
           </p:cNvPr>
@@ -13418,7 +13418,7 @@
         </p:xfrm>
         <a:graphic xmlns:a="http://schemas.openxmlformats.org/drawingml/2006/main">
           <a:graphicData uri="http://schemas.openxmlformats.org/drawingml/2006/chart">
-            <c:chart xmlns:r="http://schemas.openxmlformats.org/officeDocument/2006/relationships" xmlns:c="http://schemas.openxmlformats.org/drawingml/2006/chart" r:id="Rb089bb00399e4e99"/>
+            <c:chart xmlns:r="http://schemas.openxmlformats.org/officeDocument/2006/relationships" xmlns:c="http://schemas.openxmlformats.org/drawingml/2006/chart" r:id="R7360cf08c5ed40e0"/>
           </a:graphicData>
         </a:graphic>
       </p:graphicFrame>
@@ -13427,7 +13427,7 @@
           <p:cNvPr id="5" name="0.153">
             <a:extLst xmlns:a="http://schemas.openxmlformats.org/drawingml/2006/main">
               <a:ext uri="{FF2B5EF4-FFF2-40B4-BE49-F238E27FC236}">
-                <a16:creationId xmlns:a16="http://schemas.microsoft.com/office/drawing/2014/main" id="{E562B968-EA88-464E-B327-297850C0480C}"/>
+                <a16:creationId xmlns:a16="http://schemas.microsoft.com/office/drawing/2014/main" id="{8748499B-BA7A-40C9-805C-62CB6F859C3B}"/>
               </a:ext>
             </a:extLst>
           </p:cNvPr>
@@ -13484,7 +13484,7 @@
           <p:cNvPr id="6" name="0.160">
             <a:extLst xmlns:a="http://schemas.openxmlformats.org/drawingml/2006/main">
               <a:ext uri="{FF2B5EF4-FFF2-40B4-BE49-F238E27FC236}">
-                <a16:creationId xmlns:a16="http://schemas.microsoft.com/office/drawing/2014/main" id="{66767E2F-F106-40FA-8019-869730710E85}"/>
+                <a16:creationId xmlns:a16="http://schemas.microsoft.com/office/drawing/2014/main" id="{31B7C9D2-35B3-4F00-810E-E35168A220E1}"/>
               </a:ext>
             </a:extLst>
           </p:cNvPr>
@@ -13541,7 +13541,7 @@
           <p:cNvPr id="7" name="Calibration error">
             <a:extLst xmlns:a="http://schemas.openxmlformats.org/drawingml/2006/main">
               <a:ext uri="{FF2B5EF4-FFF2-40B4-BE49-F238E27FC236}">
-                <a16:creationId xmlns:a16="http://schemas.microsoft.com/office/drawing/2014/main" id="{F4F6ADF4-4A58-470D-BC2F-5890FA826E8D}"/>
+                <a16:creationId xmlns:a16="http://schemas.microsoft.com/office/drawing/2014/main" id="{98950572-BA9E-492A-9EA6-75EC5F0DC788}"/>
               </a:ext>
             </a:extLst>
           </p:cNvPr>
@@ -13598,7 +13598,7 @@
           <p:cNvPr id="8" name="Brier score">
             <a:extLst xmlns:a="http://schemas.openxmlformats.org/drawingml/2006/main">
               <a:ext uri="{FF2B5EF4-FFF2-40B4-BE49-F238E27FC236}">
-                <a16:creationId xmlns:a16="http://schemas.microsoft.com/office/drawing/2014/main" id="{0417515C-2E78-469E-9431-07352E216C5F}"/>
+                <a16:creationId xmlns:a16="http://schemas.microsoft.com/office/drawing/2014/main" id="{CED297A7-87B8-4A7E-BD75-B80541138C27}"/>
               </a:ext>
             </a:extLst>
           </p:cNvPr>
@@ -13655,7 +13655,7 @@
           <p:cNvPr id="9" name="Under-confident at 0.6–0.9">
             <a:extLst xmlns:a="http://schemas.openxmlformats.org/drawingml/2006/main">
               <a:ext uri="{FF2B5EF4-FFF2-40B4-BE49-F238E27FC236}">
-                <a16:creationId xmlns:a16="http://schemas.microsoft.com/office/drawing/2014/main" id="{8D9403F5-7AC0-47F9-AE16-7EF6B012C891}"/>
+                <a16:creationId xmlns:a16="http://schemas.microsoft.com/office/drawing/2014/main" id="{412DC26B-9BD0-4ABF-A22D-A2146FE17A0E}"/>
               </a:ext>
             </a:extLst>
           </p:cNvPr>
@@ -13712,7 +13712,7 @@
           <p:cNvPr id="10" name="Observed accuracy exceeds stated confidence in thi">
             <a:extLst xmlns:a="http://schemas.openxmlformats.org/drawingml/2006/main">
               <a:ext uri="{FF2B5EF4-FFF2-40B4-BE49-F238E27FC236}">
-                <a16:creationId xmlns:a16="http://schemas.microsoft.com/office/drawing/2014/main" id="{2F029C52-B8B5-44B9-89AF-2D33E84B0702}"/>
+                <a16:creationId xmlns:a16="http://schemas.microsoft.com/office/drawing/2014/main" id="{E8F4C03B-F2F7-4644-9BAD-91A948AC0015}"/>
               </a:ext>
             </a:extLst>
           </p:cNvPr>
@@ -13769,7 +13769,7 @@
           <p:cNvPr id="11" name="The top bin has only 10 samples: 80% accuracy, ver">
             <a:extLst xmlns:a="http://schemas.openxmlformats.org/drawingml/2006/main">
               <a:ext uri="{FF2B5EF4-FFF2-40B4-BE49-F238E27FC236}">
-                <a16:creationId xmlns:a16="http://schemas.microsoft.com/office/drawing/2014/main" id="{A982D772-DFC8-431C-8C07-844202E9C040}"/>
+                <a16:creationId xmlns:a16="http://schemas.microsoft.com/office/drawing/2014/main" id="{5ADF6026-92D4-47CC-B096-4840AD31F133}"/>
               </a:ext>
             </a:extLst>
           </p:cNvPr>
@@ -13824,7 +13824,7 @@
     </p:spTree>
     <p:extLst>
       <p:ext uri="{BB962C8B-B14F-4D97-AF65-F5344CB8AC3E}">
-        <p14:creationId xmlns:p14="http://schemas.microsoft.com/office/powerpoint/2010/main" val="641024116"/>
+        <p14:creationId xmlns:p14="http://schemas.microsoft.com/office/powerpoint/2010/main" val="439614910"/>
       </p:ext>
     </p:extLst>
   </p:cSld>

</xml_diff>